<commit_message>
Weekly review: process deliverables moved to the weekend per 30 Sep call
On the 30 Sep call the ranking plan was put first and the ad-type plan
(Bamboo first) and frameworks for the other products moved to 3-4 Oct.
Status changes from at risk to moved; cover counts and next week follow.

Co-Authored-By: Claude Opus 5.5 <noreply@anthropic.com>
Claude-Session: https://claude.ai/code/session_017KBX8sQPKzAVHK5pu1jizF
</commit_message>
<xml_diff>
--- a/deliverables/PPC_Weekly_Review_Sep28-Oct2.pptx
+++ b/deliverables/PPC_Weekly_Review_Sep28-Oct2.pptx
@@ -1944,7 +1944,7 @@
                 <a:ea typeface="Cambria" pitchFamily="34" charset="-122"/>
                 <a:cs typeface="Cambria" pitchFamily="34" charset="-120"/>
               </a:rPr>
-              <a:t>1</a:t>
+              <a:t>2</a:t>
             </a:r>
             <a:endParaRPr lang="en-US" sz="3600" dirty="0"/>
           </a:p>
@@ -2042,7 +2042,7 @@
                 <a:ea typeface="Cambria" pitchFamily="34" charset="-122"/>
                 <a:cs typeface="Cambria" pitchFamily="34" charset="-120"/>
               </a:rPr>
-              <a:t>2</a:t>
+              <a:t>1</a:t>
             </a:r>
             <a:endParaRPr lang="en-US" sz="3600" dirty="0"/>
           </a:p>
@@ -3474,7 +3474,7 @@
                           <a:ea typeface="Calibri" pitchFamily="34" charset="-122"/>
                           <a:cs typeface="Calibri" pitchFamily="34" charset="-120"/>
                         </a:rPr>
-                        <a:t>Campaign-type list Wednesday, ad-type framework Friday, stabilisation proposal by end of week</a:t>
+                        <a:t>Campaign-type list Wednesday, ad-type framework Friday, stabilisation proposal by end of week. Re-set on the 30 Sep call: ranking plan first, ad-type plan and frameworks over the weekend</a:t>
                       </a:r>
                       <a:endParaRPr lang="en-US" sz="1200" dirty="0">
                         <a:latin typeface="Calibri" charset="0"/>
@@ -3521,7 +3521,7 @@
                           <a:ea typeface="Calibri" pitchFamily="34" charset="-122"/>
                           <a:cs typeface="Calibri" pitchFamily="34" charset="-120"/>
                         </a:rPr>
-                        <a:t>None circulated. SB, SBV and SD campaigns are built but held for creative, so the 1 Oct API launch did not happen</a:t>
+                        <a:t>Ranking plan sent 1 Oct as agreed. Ad-type plan (Bamboo first) and frameworks for the other products due 3–4 Oct. SB, SBV and SD built but held for creative, so the 1 Oct API launch did not happen</a:t>
                       </a:r>
                       <a:endParaRPr lang="en-US" sz="1200" dirty="0">
                         <a:latin typeface="Calibri" charset="0"/>
@@ -3562,13 +3562,13 @@
                       <a:r>
                         <a:rPr lang="en-US" sz="1200" b="1" dirty="0">
                           <a:solidFill>
-                            <a:srgbClr val="9C3D31"/>
-                          </a:solidFill>
-                          <a:latin typeface="Calibri" pitchFamily="34" charset="0"/>
-                          <a:ea typeface="Calibri" pitchFamily="34" charset="-122"/>
-                          <a:cs typeface="Calibri" pitchFamily="34" charset="-120"/>
-                        </a:rPr>
-                        <a:t>0 of 4</a:t>
+                            <a:srgbClr val="6E4A0F"/>
+                          </a:solidFill>
+                          <a:latin typeface="Calibri" pitchFamily="34" charset="0"/>
+                          <a:ea typeface="Calibri" pitchFamily="34" charset="-122"/>
+                          <a:cs typeface="Calibri" pitchFamily="34" charset="-120"/>
+                        </a:rPr>
+                        <a:t>Moved to weekend</a:t>
                       </a:r>
                       <a:endParaRPr lang="en-US" sz="1200" dirty="0">
                         <a:latin typeface="Calibri" charset="0"/>
@@ -3597,7 +3597,7 @@
                       <a:tailEnd type="none" w="med" len="med"/>
                     </a:lnB>
                     <a:solidFill>
-                      <a:srgbClr val="FAE9E6"/>
+                      <a:srgbClr val="FBF0DC"/>
                     </a:solidFill>
                   </a:tcPr>
                 </a:tc>
@@ -4067,7 +4067,7 @@
                 <a:ea typeface="Calibri" pitchFamily="34" charset="-122"/>
                 <a:cs typeface="Calibri" pitchFamily="34" charset="-120"/>
               </a:rPr>
-              <a:t>Source: #ppc-internal-channel, #ppc-managers-only, #amazon-ppc (Keyword Story thread) and #ppc-leadership, 28 Sep to 2 Oct, read against the PPC Weekly Plan v5 of 28 Sep · pulled 2026-10-02</a:t>
+              <a:t>Source: #ppc-internal-channel, #ppc-managers-only, #amazon-ppc (Keyword Story thread), #ppc-leadership and the 30 Sep call with Erik and Joseph, 28 Sep to 2 Oct, read against the PPC Weekly Plan v5 of 28 Sep · pulled 2026-10-02</a:t>
             </a:r>
             <a:endParaRPr lang="en-US" sz="950" dirty="0"/>
           </a:p>
@@ -9526,7 +9526,7 @@
                           <a:ea typeface="Calibri" pitchFamily="34" charset="-122"/>
                           <a:cs typeface="Calibri" pitchFamily="34" charset="-120"/>
                         </a:rPr>
-                        <a:t>Brief creative for the held SB, SBV and SD campaigns, then launch them through the API</a:t>
+                        <a:t>Send the ad-type plan for Bamboo and the frameworks for the other products (agreed on the 30 Sep call), brief creative for the held SB, SBV and SD campaigns, then launch them through the API</a:t>
                       </a:r>
                       <a:endParaRPr lang="en-US" sz="1200" dirty="0">
                         <a:latin typeface="Calibri" charset="0"/>
@@ -9573,7 +9573,7 @@
                           <a:ea typeface="Calibri" pitchFamily="34" charset="-122"/>
                           <a:cs typeface="Calibri" pitchFamily="34" charset="-120"/>
                         </a:rPr>
-                        <a:t>TBC Mon</a:t>
+                        <a:t>Plan Oct 3–4 · launch TBC Mon</a:t>
                       </a:r>
                       <a:endParaRPr lang="en-US" sz="1200" dirty="0">
                         <a:latin typeface="Calibri" charset="0"/>

</xml_diff>

<commit_message>
Weekly review: all process deliverables due end of week
Campaign-type list and stabilisation proposal join the ad-type plan and
frameworks at end of week (3-4 Oct), per the 30 Sep call.

Co-Authored-By: Claude Opus 5.5 <noreply@anthropic.com>
Claude-Session: https://claude.ai/code/session_017KBX8sQPKzAVHK5pu1jizF
</commit_message>
<xml_diff>
--- a/deliverables/PPC_Weekly_Review_Sep28-Oct2.pptx
+++ b/deliverables/PPC_Weekly_Review_Sep28-Oct2.pptx
@@ -3474,7 +3474,7 @@
                           <a:ea typeface="Calibri" pitchFamily="34" charset="-122"/>
                           <a:cs typeface="Calibri" pitchFamily="34" charset="-120"/>
                         </a:rPr>
-                        <a:t>Campaign-type list Wednesday, ad-type framework Friday, stabilisation proposal by end of week. Re-set on the 30 Sep call: ranking plan first, ad-type plan and frameworks over the weekend</a:t>
+                        <a:t>Campaign-type list Wednesday, ad-type framework Friday, stabilisation proposal by end of week. Re-set on the 30 Sep call: ranking plan first, the rest by end of week</a:t>
                       </a:r>
                       <a:endParaRPr lang="en-US" sz="1200" dirty="0">
                         <a:latin typeface="Calibri" charset="0"/>
@@ -3521,7 +3521,7 @@
                           <a:ea typeface="Calibri" pitchFamily="34" charset="-122"/>
                           <a:cs typeface="Calibri" pitchFamily="34" charset="-120"/>
                         </a:rPr>
-                        <a:t>Ranking plan sent 1 Oct as agreed. Ad-type plan (Bamboo first) and frameworks for the other products due 3–4 Oct. SB, SBV and SD built but held for creative, so the 1 Oct API launch did not happen</a:t>
+                        <a:t>Ranking plan sent 1 Oct as agreed. Campaign-type list, ad-type plan (Bamboo first), frameworks and stabilisation proposal due end of week, 3–4 Oct. SB, SBV and SD held for creative, so the 1 Oct API launch did not happen</a:t>
                       </a:r>
                       <a:endParaRPr lang="en-US" sz="1200" dirty="0">
                         <a:latin typeface="Calibri" charset="0"/>
@@ -3568,7 +3568,7 @@
                           <a:ea typeface="Calibri" pitchFamily="34" charset="-122"/>
                           <a:cs typeface="Calibri" pitchFamily="34" charset="-120"/>
                         </a:rPr>
-                        <a:t>Moved to weekend</a:t>
+                        <a:t>Due end of week</a:t>
                       </a:r>
                       <a:endParaRPr lang="en-US" sz="1200" dirty="0">
                         <a:latin typeface="Calibri" charset="0"/>
@@ -9526,7 +9526,7 @@
                           <a:ea typeface="Calibri" pitchFamily="34" charset="-122"/>
                           <a:cs typeface="Calibri" pitchFamily="34" charset="-120"/>
                         </a:rPr>
-                        <a:t>Send the ad-type plan for Bamboo and the frameworks for the other products (agreed on the 30 Sep call), brief creative for the held SB, SBV and SD campaigns, then launch them through the API</a:t>
+                        <a:t>Send the campaign-type list, the ad-type plan for Bamboo and the frameworks for the other products (agreed on the 30 Sep call), brief creative for the held SB, SBV and SD campaigns, then launch them through the API</a:t>
                       </a:r>
                       <a:endParaRPr lang="en-US" sz="1200" dirty="0">
                         <a:latin typeface="Calibri" charset="0"/>
@@ -9573,7 +9573,7 @@
                           <a:ea typeface="Calibri" pitchFamily="34" charset="-122"/>
                           <a:cs typeface="Calibri" pitchFamily="34" charset="-120"/>
                         </a:rPr>
-                        <a:t>Plan Oct 3–4 · launch TBC Mon</a:t>
+                        <a:t>End of week, Oct 3–4 · launch TBC Mon</a:t>
                       </a:r>
                       <a:endParaRPr lang="en-US" sz="1200" dirty="0">
                         <a:latin typeface="Calibri" charset="0"/>
@@ -9784,7 +9784,7 @@
                           <a:ea typeface="Calibri" pitchFamily="34" charset="-122"/>
                           <a:cs typeface="Calibri" pitchFamily="34" charset="-120"/>
                         </a:rPr>
-                        <a:t>Deliver catalog prioritisation, team structure, the finalised cadence and the development list</a:t>
+                        <a:t>Deliver catalog prioritisation, team structure, the finalised cadence and the development list, with priorities and due dates as Erik asked on 30 Sep</a:t>
                       </a:r>
                       <a:endParaRPr lang="en-US" sz="1200" dirty="0">
                         <a:latin typeface="Calibri" charset="0"/>
@@ -9831,7 +9831,7 @@
                           <a:ea typeface="Calibri" pitchFamily="34" charset="-122"/>
                           <a:cs typeface="Calibri" pitchFamily="34" charset="-120"/>
                         </a:rPr>
-                        <a:t>Mon, Oct 5</a:t>
+                        <a:t>End of week, Oct 3–4</a:t>
                       </a:r>
                       <a:endParaRPr lang="en-US" sz="1200" dirty="0">
                         <a:latin typeface="Calibri" charset="0"/>

</xml_diff>

<commit_message>
Weekly review: CooLinens Pillowcase goes live today
The listing goes live on Amazon on 2 Oct with its PPC launch; adds the
first live week to next week's plan and a line on the cover.

Co-Authored-By: Claude Opus 5.5 <noreply@anthropic.com>
Claude-Session: https://claude.ai/code/session_017KBX8sQPKzAVHK5pu1jizF
</commit_message>
<xml_diff>
--- a/deliverables/PPC_Weekly_Review_Sep28-Oct2.pptx
+++ b/deliverables/PPC_Weekly_Review_Sep28-Oct2.pptx
@@ -1709,7 +1709,7 @@
                 <a:ea typeface="Calibri" pitchFamily="34" charset="-122"/>
                 <a:cs typeface="Calibri" pitchFamily="34" charset="-120"/>
               </a:rPr>
-              <a:t>Bamboo ranking plans for B4 and B6 are final and wait on three sign-offs. Prime Big Deal Days on 6–7 Oct is the first test of the week ahead.</a:t>
+              <a:t>CooLinens Cooling Pillowcase goes live on Amazon today with its PPC launch. Bamboo ranking plans for B4 and B6 are final and wait on three sign-offs. Prime Big Deal Days on 6–7 Oct is the first test of the week ahead.</a:t>
             </a:r>
             <a:endParaRPr lang="en-US" sz="1600" dirty="0"/>
           </a:p>
@@ -2756,7 +2756,7 @@
                         <a:buNone/>
                       </a:pPr>
                       <a:r>
-                        <a:rPr lang="en-US" sz="1200" b="1" dirty="0">
+                        <a:rPr lang="en-US" sz="1150" b="1" dirty="0">
                           <a:solidFill>
                             <a:srgbClr val="111C24"/>
                           </a:solidFill>
@@ -2766,18 +2766,18 @@
                         </a:rPr>
                         <a:t>Nine-product audit cycle</a:t>
                       </a:r>
-                      <a:endParaRPr lang="en-US" sz="1200" dirty="0">
-                        <a:latin typeface="Calibri" charset="0"/>
-                        <a:ea typeface="Calibri" charset="0"/>
-                        <a:cs typeface="Calibri" charset="0"/>
-                      </a:endParaRPr>
-                    </a:p>
-                    <a:p>
-                      <a:pPr indent="0" marL="0">
-                        <a:buNone/>
-                      </a:pPr>
-                      <a:r>
-                        <a:rPr lang="en-US" sz="1100" dirty="0">
+                      <a:endParaRPr lang="en-US" sz="1150" dirty="0">
+                        <a:latin typeface="Calibri" charset="0"/>
+                        <a:ea typeface="Calibri" charset="0"/>
+                        <a:cs typeface="Calibri" charset="0"/>
+                      </a:endParaRPr>
+                    </a:p>
+                    <a:p>
+                      <a:pPr indent="0" marL="0">
+                        <a:buNone/>
+                      </a:pPr>
+                      <a:r>
+                        <a:rPr lang="en-US" sz="1050" dirty="0">
                           <a:solidFill>
                             <a:srgbClr val="4E5A64"/>
                           </a:solidFill>
@@ -2787,44 +2787,44 @@
                         </a:rPr>
                         <a:t>All three · weekly cycle · P0</a:t>
                       </a:r>
-                      <a:endParaRPr lang="en-US" sz="1200" dirty="0">
-                        <a:latin typeface="Calibri" charset="0"/>
-                        <a:ea typeface="Calibri" charset="0"/>
-                        <a:cs typeface="Calibri" charset="0"/>
-                      </a:endParaRPr>
-                    </a:p>
-                  </a:txBody>
-                  <a:tcPr marL="64008" marR="64008" marT="73152" marB="73152" anchor="ctr">
-                    <a:lnL w="0" cap="flat" cmpd="sng" algn="ctr">
-                      <a:noFill/>
-                    </a:lnL>
-                    <a:lnR w="0" cap="flat" cmpd="sng" algn="ctr">
-                      <a:noFill/>
-                    </a:lnR>
-                    <a:lnT w="0" cap="flat" cmpd="sng" algn="ctr">
-                      <a:noFill/>
-                    </a:lnT>
-                    <a:lnB w="9525" cap="flat" cmpd="sng" algn="ctr">
-                      <a:solidFill>
-                        <a:srgbClr val="BFCAD3"/>
-                      </a:solidFill>
-                      <a:prstDash val="solid"/>
-                      <a:round/>
-                      <a:headEnd type="none" w="med" len="med"/>
-                      <a:tailEnd type="none" w="med" len="med"/>
-                    </a:lnB>
-                  </a:tcPr>
-                </a:tc>
-                <a:tc>
-                  <a:txBody>
-                    <a:bodyPr/>
-                    <a:lstStyle/>
-                    <a:p>
-                      <a:pPr indent="0" marL="0">
-                        <a:buNone/>
-                      </a:pPr>
-                      <a:r>
-                        <a:rPr lang="en-US" sz="1200" dirty="0">
+                      <a:endParaRPr lang="en-US" sz="1150" dirty="0">
+                        <a:latin typeface="Calibri" charset="0"/>
+                        <a:ea typeface="Calibri" charset="0"/>
+                        <a:cs typeface="Calibri" charset="0"/>
+                      </a:endParaRPr>
+                    </a:p>
+                  </a:txBody>
+                  <a:tcPr marL="64008" marR="64008" marT="73152" marB="73152" anchor="ctr">
+                    <a:lnL w="0" cap="flat" cmpd="sng" algn="ctr">
+                      <a:noFill/>
+                    </a:lnL>
+                    <a:lnR w="0" cap="flat" cmpd="sng" algn="ctr">
+                      <a:noFill/>
+                    </a:lnR>
+                    <a:lnT w="0" cap="flat" cmpd="sng" algn="ctr">
+                      <a:noFill/>
+                    </a:lnT>
+                    <a:lnB w="9525" cap="flat" cmpd="sng" algn="ctr">
+                      <a:solidFill>
+                        <a:srgbClr val="BFCAD3"/>
+                      </a:solidFill>
+                      <a:prstDash val="solid"/>
+                      <a:round/>
+                      <a:headEnd type="none" w="med" len="med"/>
+                      <a:tailEnd type="none" w="med" len="med"/>
+                    </a:lnB>
+                  </a:tcPr>
+                </a:tc>
+                <a:tc>
+                  <a:txBody>
+                    <a:bodyPr/>
+                    <a:lstStyle/>
+                    <a:p>
+                      <a:pPr indent="0" marL="0">
+                        <a:buNone/>
+                      </a:pPr>
+                      <a:r>
+                        <a:rPr lang="en-US" sz="1150" dirty="0">
                           <a:solidFill>
                             <a:srgbClr val="111C24"/>
                           </a:solidFill>
@@ -2834,44 +2834,44 @@
                         </a:rPr>
                         <a:t>All nine audited, reviewed by all three and executed through the app. Bamboo Monday, the rest Tuesday</a:t>
                       </a:r>
-                      <a:endParaRPr lang="en-US" sz="1200" dirty="0">
-                        <a:latin typeface="Calibri" charset="0"/>
-                        <a:ea typeface="Calibri" charset="0"/>
-                        <a:cs typeface="Calibri" charset="0"/>
-                      </a:endParaRPr>
-                    </a:p>
-                  </a:txBody>
-                  <a:tcPr marL="64008" marR="64008" marT="73152" marB="73152" anchor="ctr">
-                    <a:lnL w="0" cap="flat" cmpd="sng" algn="ctr">
-                      <a:noFill/>
-                    </a:lnL>
-                    <a:lnR w="0" cap="flat" cmpd="sng" algn="ctr">
-                      <a:noFill/>
-                    </a:lnR>
-                    <a:lnT w="0" cap="flat" cmpd="sng" algn="ctr">
-                      <a:noFill/>
-                    </a:lnT>
-                    <a:lnB w="9525" cap="flat" cmpd="sng" algn="ctr">
-                      <a:solidFill>
-                        <a:srgbClr val="BFCAD3"/>
-                      </a:solidFill>
-                      <a:prstDash val="solid"/>
-                      <a:round/>
-                      <a:headEnd type="none" w="med" len="med"/>
-                      <a:tailEnd type="none" w="med" len="med"/>
-                    </a:lnB>
-                  </a:tcPr>
-                </a:tc>
-                <a:tc>
-                  <a:txBody>
-                    <a:bodyPr/>
-                    <a:lstStyle/>
-                    <a:p>
-                      <a:pPr indent="0" marL="0">
-                        <a:buNone/>
-                      </a:pPr>
-                      <a:r>
-                        <a:rPr lang="en-US" sz="1200" dirty="0">
+                      <a:endParaRPr lang="en-US" sz="1150" dirty="0">
+                        <a:latin typeface="Calibri" charset="0"/>
+                        <a:ea typeface="Calibri" charset="0"/>
+                        <a:cs typeface="Calibri" charset="0"/>
+                      </a:endParaRPr>
+                    </a:p>
+                  </a:txBody>
+                  <a:tcPr marL="64008" marR="64008" marT="73152" marB="73152" anchor="ctr">
+                    <a:lnL w="0" cap="flat" cmpd="sng" algn="ctr">
+                      <a:noFill/>
+                    </a:lnL>
+                    <a:lnR w="0" cap="flat" cmpd="sng" algn="ctr">
+                      <a:noFill/>
+                    </a:lnR>
+                    <a:lnT w="0" cap="flat" cmpd="sng" algn="ctr">
+                      <a:noFill/>
+                    </a:lnT>
+                    <a:lnB w="9525" cap="flat" cmpd="sng" algn="ctr">
+                      <a:solidFill>
+                        <a:srgbClr val="BFCAD3"/>
+                      </a:solidFill>
+                      <a:prstDash val="solid"/>
+                      <a:round/>
+                      <a:headEnd type="none" w="med" len="med"/>
+                      <a:tailEnd type="none" w="med" len="med"/>
+                    </a:lnB>
+                  </a:tcPr>
+                </a:tc>
+                <a:tc>
+                  <a:txBody>
+                    <a:bodyPr/>
+                    <a:lstStyle/>
+                    <a:p>
+                      <a:pPr indent="0" marL="0">
+                        <a:buNone/>
+                      </a:pPr>
+                      <a:r>
+                        <a:rPr lang="en-US" sz="1150" dirty="0">
                           <a:solidFill>
                             <a:srgbClr val="111C24"/>
                           </a:solidFill>
@@ -2881,44 +2881,44 @@
                         </a:rPr>
                         <a:t>Feedback posted on six: B4, B6, S4, S6, Satin Fitted, SS-S4. Cooling Sheets 4-PC drafted today. Bamboo Fitted and Cooling Fitted not posted</a:t>
                       </a:r>
-                      <a:endParaRPr lang="en-US" sz="1200" dirty="0">
-                        <a:latin typeface="Calibri" charset="0"/>
-                        <a:ea typeface="Calibri" charset="0"/>
-                        <a:cs typeface="Calibri" charset="0"/>
-                      </a:endParaRPr>
-                    </a:p>
-                  </a:txBody>
-                  <a:tcPr marL="64008" marR="64008" marT="73152" marB="73152" anchor="ctr">
-                    <a:lnL w="0" cap="flat" cmpd="sng" algn="ctr">
-                      <a:noFill/>
-                    </a:lnL>
-                    <a:lnR w="0" cap="flat" cmpd="sng" algn="ctr">
-                      <a:noFill/>
-                    </a:lnR>
-                    <a:lnT w="0" cap="flat" cmpd="sng" algn="ctr">
-                      <a:noFill/>
-                    </a:lnT>
-                    <a:lnB w="9525" cap="flat" cmpd="sng" algn="ctr">
-                      <a:solidFill>
-                        <a:srgbClr val="BFCAD3"/>
-                      </a:solidFill>
-                      <a:prstDash val="solid"/>
-                      <a:round/>
-                      <a:headEnd type="none" w="med" len="med"/>
-                      <a:tailEnd type="none" w="med" len="med"/>
-                    </a:lnB>
-                  </a:tcPr>
-                </a:tc>
-                <a:tc>
-                  <a:txBody>
-                    <a:bodyPr/>
-                    <a:lstStyle/>
-                    <a:p>
-                      <a:pPr indent="0" marL="0">
-                        <a:buNone/>
-                      </a:pPr>
-                      <a:r>
-                        <a:rPr lang="en-US" sz="1200" b="1" dirty="0">
+                      <a:endParaRPr lang="en-US" sz="1150" dirty="0">
+                        <a:latin typeface="Calibri" charset="0"/>
+                        <a:ea typeface="Calibri" charset="0"/>
+                        <a:cs typeface="Calibri" charset="0"/>
+                      </a:endParaRPr>
+                    </a:p>
+                  </a:txBody>
+                  <a:tcPr marL="64008" marR="64008" marT="73152" marB="73152" anchor="ctr">
+                    <a:lnL w="0" cap="flat" cmpd="sng" algn="ctr">
+                      <a:noFill/>
+                    </a:lnL>
+                    <a:lnR w="0" cap="flat" cmpd="sng" algn="ctr">
+                      <a:noFill/>
+                    </a:lnR>
+                    <a:lnT w="0" cap="flat" cmpd="sng" algn="ctr">
+                      <a:noFill/>
+                    </a:lnT>
+                    <a:lnB w="9525" cap="flat" cmpd="sng" algn="ctr">
+                      <a:solidFill>
+                        <a:srgbClr val="BFCAD3"/>
+                      </a:solidFill>
+                      <a:prstDash val="solid"/>
+                      <a:round/>
+                      <a:headEnd type="none" w="med" len="med"/>
+                      <a:tailEnd type="none" w="med" len="med"/>
+                    </a:lnB>
+                  </a:tcPr>
+                </a:tc>
+                <a:tc>
+                  <a:txBody>
+                    <a:bodyPr/>
+                    <a:lstStyle/>
+                    <a:p>
+                      <a:pPr indent="0" marL="0">
+                        <a:buNone/>
+                      </a:pPr>
+                      <a:r>
+                        <a:rPr lang="en-US" sz="1150" b="1" dirty="0">
                           <a:solidFill>
                             <a:srgbClr val="6E4A0F"/>
                           </a:solidFill>
@@ -2928,7 +2928,7 @@
                         </a:rPr>
                         <a:t>6 of 9</a:t>
                       </a:r>
-                      <a:endParaRPr lang="en-US" sz="1200" dirty="0">
+                      <a:endParaRPr lang="en-US" sz="1150" dirty="0">
                         <a:latin typeface="Calibri" charset="0"/>
                         <a:ea typeface="Calibri" charset="0"/>
                         <a:cs typeface="Calibri" charset="0"/>
@@ -2970,7 +2970,7 @@
                         <a:buNone/>
                       </a:pPr>
                       <a:r>
-                        <a:rPr lang="en-US" sz="1200" b="1" dirty="0">
+                        <a:rPr lang="en-US" sz="1150" b="1" dirty="0">
                           <a:solidFill>
                             <a:srgbClr val="111C24"/>
                           </a:solidFill>
@@ -2980,18 +2980,18 @@
                         </a:rPr>
                         <a:t>Engine corrections &amp; feedback</a:t>
                       </a:r>
-                      <a:endParaRPr lang="en-US" sz="1200" dirty="0">
-                        <a:latin typeface="Calibri" charset="0"/>
-                        <a:ea typeface="Calibri" charset="0"/>
-                        <a:cs typeface="Calibri" charset="0"/>
-                      </a:endParaRPr>
-                    </a:p>
-                    <a:p>
-                      <a:pPr indent="0" marL="0">
-                        <a:buNone/>
-                      </a:pPr>
-                      <a:r>
-                        <a:rPr lang="en-US" sz="1100" dirty="0">
+                      <a:endParaRPr lang="en-US" sz="1150" dirty="0">
+                        <a:latin typeface="Calibri" charset="0"/>
+                        <a:ea typeface="Calibri" charset="0"/>
+                        <a:cs typeface="Calibri" charset="0"/>
+                      </a:endParaRPr>
+                    </a:p>
+                    <a:p>
+                      <a:pPr indent="0" marL="0">
+                        <a:buNone/>
+                      </a:pPr>
+                      <a:r>
+                        <a:rPr lang="en-US" sz="1050" dirty="0">
                           <a:solidFill>
                             <a:srgbClr val="4E5A64"/>
                           </a:solidFill>
@@ -3001,44 +3001,44 @@
                         </a:rPr>
                         <a:t>Joseph with PPC review · P0</a:t>
                       </a:r>
-                      <a:endParaRPr lang="en-US" sz="1200" dirty="0">
-                        <a:latin typeface="Calibri" charset="0"/>
-                        <a:ea typeface="Calibri" charset="0"/>
-                        <a:cs typeface="Calibri" charset="0"/>
-                      </a:endParaRPr>
-                    </a:p>
-                  </a:txBody>
-                  <a:tcPr marL="64008" marR="64008" marT="73152" marB="73152" anchor="ctr">
-                    <a:lnL w="0" cap="flat" cmpd="sng" algn="ctr">
-                      <a:noFill/>
-                    </a:lnL>
-                    <a:lnR w="0" cap="flat" cmpd="sng" algn="ctr">
-                      <a:noFill/>
-                    </a:lnR>
-                    <a:lnT w="0" cap="flat" cmpd="sng" algn="ctr">
-                      <a:noFill/>
-                    </a:lnT>
-                    <a:lnB w="9525" cap="flat" cmpd="sng" algn="ctr">
-                      <a:solidFill>
-                        <a:srgbClr val="BFCAD3"/>
-                      </a:solidFill>
-                      <a:prstDash val="solid"/>
-                      <a:round/>
-                      <a:headEnd type="none" w="med" len="med"/>
-                      <a:tailEnd type="none" w="med" len="med"/>
-                    </a:lnB>
-                  </a:tcPr>
-                </a:tc>
-                <a:tc>
-                  <a:txBody>
-                    <a:bodyPr/>
-                    <a:lstStyle/>
-                    <a:p>
-                      <a:pPr indent="0" marL="0">
-                        <a:buNone/>
-                      </a:pPr>
-                      <a:r>
-                        <a:rPr lang="en-US" sz="1200" dirty="0">
+                      <a:endParaRPr lang="en-US" sz="1150" dirty="0">
+                        <a:latin typeface="Calibri" charset="0"/>
+                        <a:ea typeface="Calibri" charset="0"/>
+                        <a:cs typeface="Calibri" charset="0"/>
+                      </a:endParaRPr>
+                    </a:p>
+                  </a:txBody>
+                  <a:tcPr marL="64008" marR="64008" marT="73152" marB="73152" anchor="ctr">
+                    <a:lnL w="0" cap="flat" cmpd="sng" algn="ctr">
+                      <a:noFill/>
+                    </a:lnL>
+                    <a:lnR w="0" cap="flat" cmpd="sng" algn="ctr">
+                      <a:noFill/>
+                    </a:lnR>
+                    <a:lnT w="0" cap="flat" cmpd="sng" algn="ctr">
+                      <a:noFill/>
+                    </a:lnT>
+                    <a:lnB w="9525" cap="flat" cmpd="sng" algn="ctr">
+                      <a:solidFill>
+                        <a:srgbClr val="BFCAD3"/>
+                      </a:solidFill>
+                      <a:prstDash val="solid"/>
+                      <a:round/>
+                      <a:headEnd type="none" w="med" len="med"/>
+                      <a:tailEnd type="none" w="med" len="med"/>
+                    </a:lnB>
+                  </a:tcPr>
+                </a:tc>
+                <a:tc>
+                  <a:txBody>
+                    <a:bodyPr/>
+                    <a:lstStyle/>
+                    <a:p>
+                      <a:pPr indent="0" marL="0">
+                        <a:buNone/>
+                      </a:pPr>
+                      <a:r>
+                        <a:rPr lang="en-US" sz="1150" dirty="0">
                           <a:solidFill>
                             <a:srgbClr val="111C24"/>
                           </a:solidFill>
@@ -3048,44 +3048,44 @@
                         </a:rPr>
                         <a:t>One consolidated note per product to Joseph, engine fixed and the audits re-run on the corrections</a:t>
                       </a:r>
-                      <a:endParaRPr lang="en-US" sz="1200" dirty="0">
-                        <a:latin typeface="Calibri" charset="0"/>
-                        <a:ea typeface="Calibri" charset="0"/>
-                        <a:cs typeface="Calibri" charset="0"/>
-                      </a:endParaRPr>
-                    </a:p>
-                  </a:txBody>
-                  <a:tcPr marL="64008" marR="64008" marT="73152" marB="73152" anchor="ctr">
-                    <a:lnL w="0" cap="flat" cmpd="sng" algn="ctr">
-                      <a:noFill/>
-                    </a:lnL>
-                    <a:lnR w="0" cap="flat" cmpd="sng" algn="ctr">
-                      <a:noFill/>
-                    </a:lnR>
-                    <a:lnT w="0" cap="flat" cmpd="sng" algn="ctr">
-                      <a:noFill/>
-                    </a:lnT>
-                    <a:lnB w="9525" cap="flat" cmpd="sng" algn="ctr">
-                      <a:solidFill>
-                        <a:srgbClr val="BFCAD3"/>
-                      </a:solidFill>
-                      <a:prstDash val="solid"/>
-                      <a:round/>
-                      <a:headEnd type="none" w="med" len="med"/>
-                      <a:tailEnd type="none" w="med" len="med"/>
-                    </a:lnB>
-                  </a:tcPr>
-                </a:tc>
-                <a:tc>
-                  <a:txBody>
-                    <a:bodyPr/>
-                    <a:lstStyle/>
-                    <a:p>
-                      <a:pPr indent="0" marL="0">
-                        <a:buNone/>
-                      </a:pPr>
-                      <a:r>
-                        <a:rPr lang="en-US" sz="1200" dirty="0">
+                      <a:endParaRPr lang="en-US" sz="1150" dirty="0">
+                        <a:latin typeface="Calibri" charset="0"/>
+                        <a:ea typeface="Calibri" charset="0"/>
+                        <a:cs typeface="Calibri" charset="0"/>
+                      </a:endParaRPr>
+                    </a:p>
+                  </a:txBody>
+                  <a:tcPr marL="64008" marR="64008" marT="73152" marB="73152" anchor="ctr">
+                    <a:lnL w="0" cap="flat" cmpd="sng" algn="ctr">
+                      <a:noFill/>
+                    </a:lnL>
+                    <a:lnR w="0" cap="flat" cmpd="sng" algn="ctr">
+                      <a:noFill/>
+                    </a:lnR>
+                    <a:lnT w="0" cap="flat" cmpd="sng" algn="ctr">
+                      <a:noFill/>
+                    </a:lnT>
+                    <a:lnB w="9525" cap="flat" cmpd="sng" algn="ctr">
+                      <a:solidFill>
+                        <a:srgbClr val="BFCAD3"/>
+                      </a:solidFill>
+                      <a:prstDash val="solid"/>
+                      <a:round/>
+                      <a:headEnd type="none" w="med" len="med"/>
+                      <a:tailEnd type="none" w="med" len="med"/>
+                    </a:lnB>
+                  </a:tcPr>
+                </a:tc>
+                <a:tc>
+                  <a:txBody>
+                    <a:bodyPr/>
+                    <a:lstStyle/>
+                    <a:p>
+                      <a:pPr indent="0" marL="0">
+                        <a:buNone/>
+                      </a:pPr>
+                      <a:r>
+                        <a:rPr lang="en-US" sz="1150" dirty="0">
                           <a:solidFill>
                             <a:srgbClr val="111C24"/>
                           </a:solidFill>
@@ -3095,44 +3095,44 @@
                         </a:rPr>
                         <a:t>B4 and B6 corrections applied and re-audited 29 Sep, the first clean 218/218 pass. Engine feedback doc and issue register delivered today</a:t>
                       </a:r>
-                      <a:endParaRPr lang="en-US" sz="1200" dirty="0">
-                        <a:latin typeface="Calibri" charset="0"/>
-                        <a:ea typeface="Calibri" charset="0"/>
-                        <a:cs typeface="Calibri" charset="0"/>
-                      </a:endParaRPr>
-                    </a:p>
-                  </a:txBody>
-                  <a:tcPr marL="64008" marR="64008" marT="73152" marB="73152" anchor="ctr">
-                    <a:lnL w="0" cap="flat" cmpd="sng" algn="ctr">
-                      <a:noFill/>
-                    </a:lnL>
-                    <a:lnR w="0" cap="flat" cmpd="sng" algn="ctr">
-                      <a:noFill/>
-                    </a:lnR>
-                    <a:lnT w="0" cap="flat" cmpd="sng" algn="ctr">
-                      <a:noFill/>
-                    </a:lnT>
-                    <a:lnB w="9525" cap="flat" cmpd="sng" algn="ctr">
-                      <a:solidFill>
-                        <a:srgbClr val="BFCAD3"/>
-                      </a:solidFill>
-                      <a:prstDash val="solid"/>
-                      <a:round/>
-                      <a:headEnd type="none" w="med" len="med"/>
-                      <a:tailEnd type="none" w="med" len="med"/>
-                    </a:lnB>
-                  </a:tcPr>
-                </a:tc>
-                <a:tc>
-                  <a:txBody>
-                    <a:bodyPr/>
-                    <a:lstStyle/>
-                    <a:p>
-                      <a:pPr indent="0" marL="0">
-                        <a:buNone/>
-                      </a:pPr>
-                      <a:r>
-                        <a:rPr lang="en-US" sz="1200" b="1" dirty="0">
+                      <a:endParaRPr lang="en-US" sz="1150" dirty="0">
+                        <a:latin typeface="Calibri" charset="0"/>
+                        <a:ea typeface="Calibri" charset="0"/>
+                        <a:cs typeface="Calibri" charset="0"/>
+                      </a:endParaRPr>
+                    </a:p>
+                  </a:txBody>
+                  <a:tcPr marL="64008" marR="64008" marT="73152" marB="73152" anchor="ctr">
+                    <a:lnL w="0" cap="flat" cmpd="sng" algn="ctr">
+                      <a:noFill/>
+                    </a:lnL>
+                    <a:lnR w="0" cap="flat" cmpd="sng" algn="ctr">
+                      <a:noFill/>
+                    </a:lnR>
+                    <a:lnT w="0" cap="flat" cmpd="sng" algn="ctr">
+                      <a:noFill/>
+                    </a:lnT>
+                    <a:lnB w="9525" cap="flat" cmpd="sng" algn="ctr">
+                      <a:solidFill>
+                        <a:srgbClr val="BFCAD3"/>
+                      </a:solidFill>
+                      <a:prstDash val="solid"/>
+                      <a:round/>
+                      <a:headEnd type="none" w="med" len="med"/>
+                      <a:tailEnd type="none" w="med" len="med"/>
+                    </a:lnB>
+                  </a:tcPr>
+                </a:tc>
+                <a:tc>
+                  <a:txBody>
+                    <a:bodyPr/>
+                    <a:lstStyle/>
+                    <a:p>
+                      <a:pPr indent="0" marL="0">
+                        <a:buNone/>
+                      </a:pPr>
+                      <a:r>
+                        <a:rPr lang="en-US" sz="1150" b="1" dirty="0">
                           <a:solidFill>
                             <a:srgbClr val="176B41"/>
                           </a:solidFill>
@@ -3142,7 +3142,7 @@
                         </a:rPr>
                         <a:t>Done</a:t>
                       </a:r>
-                      <a:endParaRPr lang="en-US" sz="1200" dirty="0">
+                      <a:endParaRPr lang="en-US" sz="1150" dirty="0">
                         <a:latin typeface="Calibri" charset="0"/>
                         <a:ea typeface="Calibri" charset="0"/>
                         <a:cs typeface="Calibri" charset="0"/>
@@ -3184,7 +3184,7 @@
                         <a:buNone/>
                       </a:pPr>
                       <a:r>
-                        <a:rPr lang="en-US" sz="1200" b="1" dirty="0">
+                        <a:rPr lang="en-US" sz="1150" b="1" dirty="0">
                           <a:solidFill>
                             <a:srgbClr val="111C24"/>
                           </a:solidFill>
@@ -3194,18 +3194,18 @@
                         </a:rPr>
                         <a:t>Bamboo ranking push (B4, B6)</a:t>
                       </a:r>
-                      <a:endParaRPr lang="en-US" sz="1200" dirty="0">
-                        <a:latin typeface="Calibri" charset="0"/>
-                        <a:ea typeface="Calibri" charset="0"/>
-                        <a:cs typeface="Calibri" charset="0"/>
-                      </a:endParaRPr>
-                    </a:p>
-                    <a:p>
-                      <a:pPr indent="0" marL="0">
-                        <a:buNone/>
-                      </a:pPr>
-                      <a:r>
-                        <a:rPr lang="en-US" sz="1100" dirty="0">
+                      <a:endParaRPr lang="en-US" sz="1150" dirty="0">
+                        <a:latin typeface="Calibri" charset="0"/>
+                        <a:ea typeface="Calibri" charset="0"/>
+                        <a:cs typeface="Calibri" charset="0"/>
+                      </a:endParaRPr>
+                    </a:p>
+                    <a:p>
+                      <a:pPr indent="0" marL="0">
+                        <a:buNone/>
+                      </a:pPr>
+                      <a:r>
+                        <a:rPr lang="en-US" sz="1050" dirty="0">
                           <a:solidFill>
                             <a:srgbClr val="4E5A64"/>
                           </a:solidFill>
@@ -3215,44 +3215,44 @@
                         </a:rPr>
                         <a:t>Shayan T with Joseph · P0</a:t>
                       </a:r>
-                      <a:endParaRPr lang="en-US" sz="1200" dirty="0">
-                        <a:latin typeface="Calibri" charset="0"/>
-                        <a:ea typeface="Calibri" charset="0"/>
-                        <a:cs typeface="Calibri" charset="0"/>
-                      </a:endParaRPr>
-                    </a:p>
-                  </a:txBody>
-                  <a:tcPr marL="64008" marR="64008" marT="73152" marB="73152" anchor="ctr">
-                    <a:lnL w="0" cap="flat" cmpd="sng" algn="ctr">
-                      <a:noFill/>
-                    </a:lnL>
-                    <a:lnR w="0" cap="flat" cmpd="sng" algn="ctr">
-                      <a:noFill/>
-                    </a:lnR>
-                    <a:lnT w="0" cap="flat" cmpd="sng" algn="ctr">
-                      <a:noFill/>
-                    </a:lnT>
-                    <a:lnB w="9525" cap="flat" cmpd="sng" algn="ctr">
-                      <a:solidFill>
-                        <a:srgbClr val="BFCAD3"/>
-                      </a:solidFill>
-                      <a:prstDash val="solid"/>
-                      <a:round/>
-                      <a:headEnd type="none" w="med" len="med"/>
-                      <a:tailEnd type="none" w="med" len="med"/>
-                    </a:lnB>
-                  </a:tcPr>
-                </a:tc>
-                <a:tc>
-                  <a:txBody>
-                    <a:bodyPr/>
-                    <a:lstStyle/>
-                    <a:p>
-                      <a:pPr indent="0" marL="0">
-                        <a:buNone/>
-                      </a:pPr>
-                      <a:r>
-                        <a:rPr lang="en-US" sz="1200" dirty="0">
+                      <a:endParaRPr lang="en-US" sz="1150" dirty="0">
+                        <a:latin typeface="Calibri" charset="0"/>
+                        <a:ea typeface="Calibri" charset="0"/>
+                        <a:cs typeface="Calibri" charset="0"/>
+                      </a:endParaRPr>
+                    </a:p>
+                  </a:txBody>
+                  <a:tcPr marL="64008" marR="64008" marT="73152" marB="73152" anchor="ctr">
+                    <a:lnL w="0" cap="flat" cmpd="sng" algn="ctr">
+                      <a:noFill/>
+                    </a:lnL>
+                    <a:lnR w="0" cap="flat" cmpd="sng" algn="ctr">
+                      <a:noFill/>
+                    </a:lnR>
+                    <a:lnT w="0" cap="flat" cmpd="sng" algn="ctr">
+                      <a:noFill/>
+                    </a:lnT>
+                    <a:lnB w="9525" cap="flat" cmpd="sng" algn="ctr">
+                      <a:solidFill>
+                        <a:srgbClr val="BFCAD3"/>
+                      </a:solidFill>
+                      <a:prstDash val="solid"/>
+                      <a:round/>
+                      <a:headEnd type="none" w="med" len="med"/>
+                      <a:tailEnd type="none" w="med" len="med"/>
+                    </a:lnB>
+                  </a:tcPr>
+                </a:tc>
+                <a:tc>
+                  <a:txBody>
+                    <a:bodyPr/>
+                    <a:lstStyle/>
+                    <a:p>
+                      <a:pPr indent="0" marL="0">
+                        <a:buNone/>
+                      </a:pPr>
+                      <a:r>
+                        <a:rPr lang="en-US" sz="1150" dirty="0">
                           <a:solidFill>
                             <a:srgbClr val="111C24"/>
                           </a:solidFill>
@@ -3262,44 +3262,44 @@
                         </a:rPr>
                         <a:t>One ranking plan per listing, matched to Joseph's keyword story and plan of attack, before the pushes start</a:t>
                       </a:r>
-                      <a:endParaRPr lang="en-US" sz="1200" dirty="0">
-                        <a:latin typeface="Calibri" charset="0"/>
-                        <a:ea typeface="Calibri" charset="0"/>
-                        <a:cs typeface="Calibri" charset="0"/>
-                      </a:endParaRPr>
-                    </a:p>
-                  </a:txBody>
-                  <a:tcPr marL="64008" marR="64008" marT="73152" marB="73152" anchor="ctr">
-                    <a:lnL w="0" cap="flat" cmpd="sng" algn="ctr">
-                      <a:noFill/>
-                    </a:lnL>
-                    <a:lnR w="0" cap="flat" cmpd="sng" algn="ctr">
-                      <a:noFill/>
-                    </a:lnR>
-                    <a:lnT w="0" cap="flat" cmpd="sng" algn="ctr">
-                      <a:noFill/>
-                    </a:lnT>
-                    <a:lnB w="9525" cap="flat" cmpd="sng" algn="ctr">
-                      <a:solidFill>
-                        <a:srgbClr val="BFCAD3"/>
-                      </a:solidFill>
-                      <a:prstDash val="solid"/>
-                      <a:round/>
-                      <a:headEnd type="none" w="med" len="med"/>
-                      <a:tailEnd type="none" w="med" len="med"/>
-                    </a:lnB>
-                  </a:tcPr>
-                </a:tc>
-                <a:tc>
-                  <a:txBody>
-                    <a:bodyPr/>
-                    <a:lstStyle/>
-                    <a:p>
-                      <a:pPr indent="0" marL="0">
-                        <a:buNone/>
-                      </a:pPr>
-                      <a:r>
-                        <a:rPr lang="en-US" sz="1200" dirty="0">
+                      <a:endParaRPr lang="en-US" sz="1150" dirty="0">
+                        <a:latin typeface="Calibri" charset="0"/>
+                        <a:ea typeface="Calibri" charset="0"/>
+                        <a:cs typeface="Calibri" charset="0"/>
+                      </a:endParaRPr>
+                    </a:p>
+                  </a:txBody>
+                  <a:tcPr marL="64008" marR="64008" marT="73152" marB="73152" anchor="ctr">
+                    <a:lnL w="0" cap="flat" cmpd="sng" algn="ctr">
+                      <a:noFill/>
+                    </a:lnL>
+                    <a:lnR w="0" cap="flat" cmpd="sng" algn="ctr">
+                      <a:noFill/>
+                    </a:lnR>
+                    <a:lnT w="0" cap="flat" cmpd="sng" algn="ctr">
+                      <a:noFill/>
+                    </a:lnT>
+                    <a:lnB w="9525" cap="flat" cmpd="sng" algn="ctr">
+                      <a:solidFill>
+                        <a:srgbClr val="BFCAD3"/>
+                      </a:solidFill>
+                      <a:prstDash val="solid"/>
+                      <a:round/>
+                      <a:headEnd type="none" w="med" len="med"/>
+                      <a:tailEnd type="none" w="med" len="med"/>
+                    </a:lnB>
+                  </a:tcPr>
+                </a:tc>
+                <a:tc>
+                  <a:txBody>
+                    <a:bodyPr/>
+                    <a:lstStyle/>
+                    <a:p>
+                      <a:pPr indent="0" marL="0">
+                        <a:buNone/>
+                      </a:pPr>
+                      <a:r>
+                        <a:rPr lang="en-US" sz="1150" dirty="0">
                           <a:solidFill>
                             <a:srgbClr val="111C24"/>
                           </a:solidFill>
@@ -3309,44 +3309,44 @@
                         </a:rPr>
                         <a:t>Plan of attack shared 1 Oct. B4 and B6 plans finalised 2 Oct: B4 follows its start dates and colours by size; B6 replaces the 30 Sep plan. Erik's 2 Oct points built in</a:t>
                       </a:r>
-                      <a:endParaRPr lang="en-US" sz="1200" dirty="0">
-                        <a:latin typeface="Calibri" charset="0"/>
-                        <a:ea typeface="Calibri" charset="0"/>
-                        <a:cs typeface="Calibri" charset="0"/>
-                      </a:endParaRPr>
-                    </a:p>
-                  </a:txBody>
-                  <a:tcPr marL="64008" marR="64008" marT="73152" marB="73152" anchor="ctr">
-                    <a:lnL w="0" cap="flat" cmpd="sng" algn="ctr">
-                      <a:noFill/>
-                    </a:lnL>
-                    <a:lnR w="0" cap="flat" cmpd="sng" algn="ctr">
-                      <a:noFill/>
-                    </a:lnR>
-                    <a:lnT w="0" cap="flat" cmpd="sng" algn="ctr">
-                      <a:noFill/>
-                    </a:lnT>
-                    <a:lnB w="9525" cap="flat" cmpd="sng" algn="ctr">
-                      <a:solidFill>
-                        <a:srgbClr val="BFCAD3"/>
-                      </a:solidFill>
-                      <a:prstDash val="solid"/>
-                      <a:round/>
-                      <a:headEnd type="none" w="med" len="med"/>
-                      <a:tailEnd type="none" w="med" len="med"/>
-                    </a:lnB>
-                  </a:tcPr>
-                </a:tc>
-                <a:tc>
-                  <a:txBody>
-                    <a:bodyPr/>
-                    <a:lstStyle/>
-                    <a:p>
-                      <a:pPr indent="0" marL="0">
-                        <a:buNone/>
-                      </a:pPr>
-                      <a:r>
-                        <a:rPr lang="en-US" sz="1200" b="1" dirty="0">
+                      <a:endParaRPr lang="en-US" sz="1150" dirty="0">
+                        <a:latin typeface="Calibri" charset="0"/>
+                        <a:ea typeface="Calibri" charset="0"/>
+                        <a:cs typeface="Calibri" charset="0"/>
+                      </a:endParaRPr>
+                    </a:p>
+                  </a:txBody>
+                  <a:tcPr marL="64008" marR="64008" marT="73152" marB="73152" anchor="ctr">
+                    <a:lnL w="0" cap="flat" cmpd="sng" algn="ctr">
+                      <a:noFill/>
+                    </a:lnL>
+                    <a:lnR w="0" cap="flat" cmpd="sng" algn="ctr">
+                      <a:noFill/>
+                    </a:lnR>
+                    <a:lnT w="0" cap="flat" cmpd="sng" algn="ctr">
+                      <a:noFill/>
+                    </a:lnT>
+                    <a:lnB w="9525" cap="flat" cmpd="sng" algn="ctr">
+                      <a:solidFill>
+                        <a:srgbClr val="BFCAD3"/>
+                      </a:solidFill>
+                      <a:prstDash val="solid"/>
+                      <a:round/>
+                      <a:headEnd type="none" w="med" len="med"/>
+                      <a:tailEnd type="none" w="med" len="med"/>
+                    </a:lnB>
+                  </a:tcPr>
+                </a:tc>
+                <a:tc>
+                  <a:txBody>
+                    <a:bodyPr/>
+                    <a:lstStyle/>
+                    <a:p>
+                      <a:pPr indent="0" marL="0">
+                        <a:buNone/>
+                      </a:pPr>
+                      <a:r>
+                        <a:rPr lang="en-US" sz="1150" b="1" dirty="0">
                           <a:solidFill>
                             <a:srgbClr val="176B41"/>
                           </a:solidFill>
@@ -3356,7 +3356,7 @@
                         </a:rPr>
                         <a:t>Plans final</a:t>
                       </a:r>
-                      <a:endParaRPr lang="en-US" sz="1200" dirty="0">
+                      <a:endParaRPr lang="en-US" sz="1150" dirty="0">
                         <a:latin typeface="Calibri" charset="0"/>
                         <a:ea typeface="Calibri" charset="0"/>
                         <a:cs typeface="Calibri" charset="0"/>
@@ -3398,7 +3398,7 @@
                         <a:buNone/>
                       </a:pPr>
                       <a:r>
-                        <a:rPr lang="en-US" sz="1200" b="1" dirty="0">
+                        <a:rPr lang="en-US" sz="1150" b="1" dirty="0">
                           <a:solidFill>
                             <a:srgbClr val="111C24"/>
                           </a:solidFill>
@@ -3408,18 +3408,18 @@
                         </a:rPr>
                         <a:t>Process deliverables</a:t>
                       </a:r>
-                      <a:endParaRPr lang="en-US" sz="1200" dirty="0">
-                        <a:latin typeface="Calibri" charset="0"/>
-                        <a:ea typeface="Calibri" charset="0"/>
-                        <a:cs typeface="Calibri" charset="0"/>
-                      </a:endParaRPr>
-                    </a:p>
-                    <a:p>
-                      <a:pPr indent="0" marL="0">
-                        <a:buNone/>
-                      </a:pPr>
-                      <a:r>
-                        <a:rPr lang="en-US" sz="1100" dirty="0">
+                      <a:endParaRPr lang="en-US" sz="1150" dirty="0">
+                        <a:latin typeface="Calibri" charset="0"/>
+                        <a:ea typeface="Calibri" charset="0"/>
+                        <a:cs typeface="Calibri" charset="0"/>
+                      </a:endParaRPr>
+                    </a:p>
+                    <a:p>
+                      <a:pPr indent="0" marL="0">
+                        <a:buNone/>
+                      </a:pPr>
+                      <a:r>
+                        <a:rPr lang="en-US" sz="1050" dirty="0">
                           <a:solidFill>
                             <a:srgbClr val="4E5A64"/>
                           </a:solidFill>
@@ -3429,44 +3429,44 @@
                         </a:rPr>
                         <a:t>Shayan T · one-off · P0</a:t>
                       </a:r>
-                      <a:endParaRPr lang="en-US" sz="1200" dirty="0">
-                        <a:latin typeface="Calibri" charset="0"/>
-                        <a:ea typeface="Calibri" charset="0"/>
-                        <a:cs typeface="Calibri" charset="0"/>
-                      </a:endParaRPr>
-                    </a:p>
-                  </a:txBody>
-                  <a:tcPr marL="64008" marR="64008" marT="73152" marB="73152" anchor="ctr">
-                    <a:lnL w="0" cap="flat" cmpd="sng" algn="ctr">
-                      <a:noFill/>
-                    </a:lnL>
-                    <a:lnR w="0" cap="flat" cmpd="sng" algn="ctr">
-                      <a:noFill/>
-                    </a:lnR>
-                    <a:lnT w="0" cap="flat" cmpd="sng" algn="ctr">
-                      <a:noFill/>
-                    </a:lnT>
-                    <a:lnB w="9525" cap="flat" cmpd="sng" algn="ctr">
-                      <a:solidFill>
-                        <a:srgbClr val="BFCAD3"/>
-                      </a:solidFill>
-                      <a:prstDash val="solid"/>
-                      <a:round/>
-                      <a:headEnd type="none" w="med" len="med"/>
-                      <a:tailEnd type="none" w="med" len="med"/>
-                    </a:lnB>
-                  </a:tcPr>
-                </a:tc>
-                <a:tc>
-                  <a:txBody>
-                    <a:bodyPr/>
-                    <a:lstStyle/>
-                    <a:p>
-                      <a:pPr indent="0" marL="0">
-                        <a:buNone/>
-                      </a:pPr>
-                      <a:r>
-                        <a:rPr lang="en-US" sz="1200" dirty="0">
+                      <a:endParaRPr lang="en-US" sz="1150" dirty="0">
+                        <a:latin typeface="Calibri" charset="0"/>
+                        <a:ea typeface="Calibri" charset="0"/>
+                        <a:cs typeface="Calibri" charset="0"/>
+                      </a:endParaRPr>
+                    </a:p>
+                  </a:txBody>
+                  <a:tcPr marL="64008" marR="64008" marT="73152" marB="73152" anchor="ctr">
+                    <a:lnL w="0" cap="flat" cmpd="sng" algn="ctr">
+                      <a:noFill/>
+                    </a:lnL>
+                    <a:lnR w="0" cap="flat" cmpd="sng" algn="ctr">
+                      <a:noFill/>
+                    </a:lnR>
+                    <a:lnT w="0" cap="flat" cmpd="sng" algn="ctr">
+                      <a:noFill/>
+                    </a:lnT>
+                    <a:lnB w="9525" cap="flat" cmpd="sng" algn="ctr">
+                      <a:solidFill>
+                        <a:srgbClr val="BFCAD3"/>
+                      </a:solidFill>
+                      <a:prstDash val="solid"/>
+                      <a:round/>
+                      <a:headEnd type="none" w="med" len="med"/>
+                      <a:tailEnd type="none" w="med" len="med"/>
+                    </a:lnB>
+                  </a:tcPr>
+                </a:tc>
+                <a:tc>
+                  <a:txBody>
+                    <a:bodyPr/>
+                    <a:lstStyle/>
+                    <a:p>
+                      <a:pPr indent="0" marL="0">
+                        <a:buNone/>
+                      </a:pPr>
+                      <a:r>
+                        <a:rPr lang="en-US" sz="1150" dirty="0">
                           <a:solidFill>
                             <a:srgbClr val="111C24"/>
                           </a:solidFill>
@@ -3476,44 +3476,44 @@
                         </a:rPr>
                         <a:t>Campaign-type list Wednesday, ad-type framework Friday, stabilisation proposal by end of week. Re-set on the 30 Sep call: ranking plan first, the rest by end of week</a:t>
                       </a:r>
-                      <a:endParaRPr lang="en-US" sz="1200" dirty="0">
-                        <a:latin typeface="Calibri" charset="0"/>
-                        <a:ea typeface="Calibri" charset="0"/>
-                        <a:cs typeface="Calibri" charset="0"/>
-                      </a:endParaRPr>
-                    </a:p>
-                  </a:txBody>
-                  <a:tcPr marL="64008" marR="64008" marT="73152" marB="73152" anchor="ctr">
-                    <a:lnL w="0" cap="flat" cmpd="sng" algn="ctr">
-                      <a:noFill/>
-                    </a:lnL>
-                    <a:lnR w="0" cap="flat" cmpd="sng" algn="ctr">
-                      <a:noFill/>
-                    </a:lnR>
-                    <a:lnT w="0" cap="flat" cmpd="sng" algn="ctr">
-                      <a:noFill/>
-                    </a:lnT>
-                    <a:lnB w="9525" cap="flat" cmpd="sng" algn="ctr">
-                      <a:solidFill>
-                        <a:srgbClr val="BFCAD3"/>
-                      </a:solidFill>
-                      <a:prstDash val="solid"/>
-                      <a:round/>
-                      <a:headEnd type="none" w="med" len="med"/>
-                      <a:tailEnd type="none" w="med" len="med"/>
-                    </a:lnB>
-                  </a:tcPr>
-                </a:tc>
-                <a:tc>
-                  <a:txBody>
-                    <a:bodyPr/>
-                    <a:lstStyle/>
-                    <a:p>
-                      <a:pPr indent="0" marL="0">
-                        <a:buNone/>
-                      </a:pPr>
-                      <a:r>
-                        <a:rPr lang="en-US" sz="1200" dirty="0">
+                      <a:endParaRPr lang="en-US" sz="1150" dirty="0">
+                        <a:latin typeface="Calibri" charset="0"/>
+                        <a:ea typeface="Calibri" charset="0"/>
+                        <a:cs typeface="Calibri" charset="0"/>
+                      </a:endParaRPr>
+                    </a:p>
+                  </a:txBody>
+                  <a:tcPr marL="64008" marR="64008" marT="73152" marB="73152" anchor="ctr">
+                    <a:lnL w="0" cap="flat" cmpd="sng" algn="ctr">
+                      <a:noFill/>
+                    </a:lnL>
+                    <a:lnR w="0" cap="flat" cmpd="sng" algn="ctr">
+                      <a:noFill/>
+                    </a:lnR>
+                    <a:lnT w="0" cap="flat" cmpd="sng" algn="ctr">
+                      <a:noFill/>
+                    </a:lnT>
+                    <a:lnB w="9525" cap="flat" cmpd="sng" algn="ctr">
+                      <a:solidFill>
+                        <a:srgbClr val="BFCAD3"/>
+                      </a:solidFill>
+                      <a:prstDash val="solid"/>
+                      <a:round/>
+                      <a:headEnd type="none" w="med" len="med"/>
+                      <a:tailEnd type="none" w="med" len="med"/>
+                    </a:lnB>
+                  </a:tcPr>
+                </a:tc>
+                <a:tc>
+                  <a:txBody>
+                    <a:bodyPr/>
+                    <a:lstStyle/>
+                    <a:p>
+                      <a:pPr indent="0" marL="0">
+                        <a:buNone/>
+                      </a:pPr>
+                      <a:r>
+                        <a:rPr lang="en-US" sz="1150" dirty="0">
                           <a:solidFill>
                             <a:srgbClr val="111C24"/>
                           </a:solidFill>
@@ -3523,44 +3523,44 @@
                         </a:rPr>
                         <a:t>Ranking plan sent 1 Oct as agreed. Campaign-type list, ad-type plan (Bamboo first), frameworks and stabilisation proposal due end of week, 3–4 Oct. SB, SBV and SD held for creative, so the 1 Oct API launch did not happen</a:t>
                       </a:r>
-                      <a:endParaRPr lang="en-US" sz="1200" dirty="0">
-                        <a:latin typeface="Calibri" charset="0"/>
-                        <a:ea typeface="Calibri" charset="0"/>
-                        <a:cs typeface="Calibri" charset="0"/>
-                      </a:endParaRPr>
-                    </a:p>
-                  </a:txBody>
-                  <a:tcPr marL="64008" marR="64008" marT="73152" marB="73152" anchor="ctr">
-                    <a:lnL w="0" cap="flat" cmpd="sng" algn="ctr">
-                      <a:noFill/>
-                    </a:lnL>
-                    <a:lnR w="0" cap="flat" cmpd="sng" algn="ctr">
-                      <a:noFill/>
-                    </a:lnR>
-                    <a:lnT w="0" cap="flat" cmpd="sng" algn="ctr">
-                      <a:noFill/>
-                    </a:lnT>
-                    <a:lnB w="9525" cap="flat" cmpd="sng" algn="ctr">
-                      <a:solidFill>
-                        <a:srgbClr val="BFCAD3"/>
-                      </a:solidFill>
-                      <a:prstDash val="solid"/>
-                      <a:round/>
-                      <a:headEnd type="none" w="med" len="med"/>
-                      <a:tailEnd type="none" w="med" len="med"/>
-                    </a:lnB>
-                  </a:tcPr>
-                </a:tc>
-                <a:tc>
-                  <a:txBody>
-                    <a:bodyPr/>
-                    <a:lstStyle/>
-                    <a:p>
-                      <a:pPr indent="0" marL="0">
-                        <a:buNone/>
-                      </a:pPr>
-                      <a:r>
-                        <a:rPr lang="en-US" sz="1200" b="1" dirty="0">
+                      <a:endParaRPr lang="en-US" sz="1150" dirty="0">
+                        <a:latin typeface="Calibri" charset="0"/>
+                        <a:ea typeface="Calibri" charset="0"/>
+                        <a:cs typeface="Calibri" charset="0"/>
+                      </a:endParaRPr>
+                    </a:p>
+                  </a:txBody>
+                  <a:tcPr marL="64008" marR="64008" marT="73152" marB="73152" anchor="ctr">
+                    <a:lnL w="0" cap="flat" cmpd="sng" algn="ctr">
+                      <a:noFill/>
+                    </a:lnL>
+                    <a:lnR w="0" cap="flat" cmpd="sng" algn="ctr">
+                      <a:noFill/>
+                    </a:lnR>
+                    <a:lnT w="0" cap="flat" cmpd="sng" algn="ctr">
+                      <a:noFill/>
+                    </a:lnT>
+                    <a:lnB w="9525" cap="flat" cmpd="sng" algn="ctr">
+                      <a:solidFill>
+                        <a:srgbClr val="BFCAD3"/>
+                      </a:solidFill>
+                      <a:prstDash val="solid"/>
+                      <a:round/>
+                      <a:headEnd type="none" w="med" len="med"/>
+                      <a:tailEnd type="none" w="med" len="med"/>
+                    </a:lnB>
+                  </a:tcPr>
+                </a:tc>
+                <a:tc>
+                  <a:txBody>
+                    <a:bodyPr/>
+                    <a:lstStyle/>
+                    <a:p>
+                      <a:pPr indent="0" marL="0">
+                        <a:buNone/>
+                      </a:pPr>
+                      <a:r>
+                        <a:rPr lang="en-US" sz="1150" b="1" dirty="0">
                           <a:solidFill>
                             <a:srgbClr val="6E4A0F"/>
                           </a:solidFill>
@@ -3570,7 +3570,7 @@
                         </a:rPr>
                         <a:t>Due end of week</a:t>
                       </a:r>
-                      <a:endParaRPr lang="en-US" sz="1200" dirty="0">
+                      <a:endParaRPr lang="en-US" sz="1150" dirty="0">
                         <a:latin typeface="Calibri" charset="0"/>
                         <a:ea typeface="Calibri" charset="0"/>
                         <a:cs typeface="Calibri" charset="0"/>
@@ -3612,7 +3612,7 @@
                         <a:buNone/>
                       </a:pPr>
                       <a:r>
-                        <a:rPr lang="en-US" sz="1200" b="1" dirty="0">
+                        <a:rPr lang="en-US" sz="1150" b="1" dirty="0">
                           <a:solidFill>
                             <a:srgbClr val="111C24"/>
                           </a:solidFill>
@@ -3622,18 +3622,18 @@
                         </a:rPr>
                         <a:t>CooLinens Pillowcase launch</a:t>
                       </a:r>
-                      <a:endParaRPr lang="en-US" sz="1200" dirty="0">
-                        <a:latin typeface="Calibri" charset="0"/>
-                        <a:ea typeface="Calibri" charset="0"/>
-                        <a:cs typeface="Calibri" charset="0"/>
-                      </a:endParaRPr>
-                    </a:p>
-                    <a:p>
-                      <a:pPr indent="0" marL="0">
-                        <a:buNone/>
-                      </a:pPr>
-                      <a:r>
-                        <a:rPr lang="en-US" sz="1100" dirty="0">
+                      <a:endParaRPr lang="en-US" sz="1150" dirty="0">
+                        <a:latin typeface="Calibri" charset="0"/>
+                        <a:ea typeface="Calibri" charset="0"/>
+                        <a:cs typeface="Calibri" charset="0"/>
+                      </a:endParaRPr>
+                    </a:p>
+                    <a:p>
+                      <a:pPr indent="0" marL="0">
+                        <a:buNone/>
+                      </a:pPr>
+                      <a:r>
+                        <a:rPr lang="en-US" sz="1050" dirty="0">
                           <a:solidFill>
                             <a:srgbClr val="4E5A64"/>
                           </a:solidFill>
@@ -3643,44 +3643,44 @@
                         </a:rPr>
                         <a:t>Shayan T · one-off · P0</a:t>
                       </a:r>
-                      <a:endParaRPr lang="en-US" sz="1200" dirty="0">
-                        <a:latin typeface="Calibri" charset="0"/>
-                        <a:ea typeface="Calibri" charset="0"/>
-                        <a:cs typeface="Calibri" charset="0"/>
-                      </a:endParaRPr>
-                    </a:p>
-                  </a:txBody>
-                  <a:tcPr marL="64008" marR="64008" marT="73152" marB="73152" anchor="ctr">
-                    <a:lnL w="0" cap="flat" cmpd="sng" algn="ctr">
-                      <a:noFill/>
-                    </a:lnL>
-                    <a:lnR w="0" cap="flat" cmpd="sng" algn="ctr">
-                      <a:noFill/>
-                    </a:lnR>
-                    <a:lnT w="0" cap="flat" cmpd="sng" algn="ctr">
-                      <a:noFill/>
-                    </a:lnT>
-                    <a:lnB w="9525" cap="flat" cmpd="sng" algn="ctr">
-                      <a:solidFill>
-                        <a:srgbClr val="BFCAD3"/>
-                      </a:solidFill>
-                      <a:prstDash val="solid"/>
-                      <a:round/>
-                      <a:headEnd type="none" w="med" len="med"/>
-                      <a:tailEnd type="none" w="med" len="med"/>
-                    </a:lnB>
-                  </a:tcPr>
-                </a:tc>
-                <a:tc>
-                  <a:txBody>
-                    <a:bodyPr/>
-                    <a:lstStyle/>
-                    <a:p>
-                      <a:pPr indent="0" marL="0">
-                        <a:buNone/>
-                      </a:pPr>
-                      <a:r>
-                        <a:rPr lang="en-US" sz="1200" dirty="0">
+                      <a:endParaRPr lang="en-US" sz="1150" dirty="0">
+                        <a:latin typeface="Calibri" charset="0"/>
+                        <a:ea typeface="Calibri" charset="0"/>
+                        <a:cs typeface="Calibri" charset="0"/>
+                      </a:endParaRPr>
+                    </a:p>
+                  </a:txBody>
+                  <a:tcPr marL="64008" marR="64008" marT="73152" marB="73152" anchor="ctr">
+                    <a:lnL w="0" cap="flat" cmpd="sng" algn="ctr">
+                      <a:noFill/>
+                    </a:lnL>
+                    <a:lnR w="0" cap="flat" cmpd="sng" algn="ctr">
+                      <a:noFill/>
+                    </a:lnR>
+                    <a:lnT w="0" cap="flat" cmpd="sng" algn="ctr">
+                      <a:noFill/>
+                    </a:lnT>
+                    <a:lnB w="9525" cap="flat" cmpd="sng" algn="ctr">
+                      <a:solidFill>
+                        <a:srgbClr val="BFCAD3"/>
+                      </a:solidFill>
+                      <a:prstDash val="solid"/>
+                      <a:round/>
+                      <a:headEnd type="none" w="med" len="med"/>
+                      <a:tailEnd type="none" w="med" len="med"/>
+                    </a:lnB>
+                  </a:tcPr>
+                </a:tc>
+                <a:tc>
+                  <a:txBody>
+                    <a:bodyPr/>
+                    <a:lstStyle/>
+                    <a:p>
+                      <a:pPr indent="0" marL="0">
+                        <a:buNone/>
+                      </a:pPr>
+                      <a:r>
+                        <a:rPr lang="en-US" sz="1150" dirty="0">
                           <a:solidFill>
                             <a:srgbClr val="111C24"/>
                           </a:solidFill>
@@ -3688,46 +3688,46 @@
                           <a:ea typeface="Calibri" pitchFamily="34" charset="-122"/>
                           <a:cs typeface="Calibri" pitchFamily="34" charset="-120"/>
                         </a:rPr>
-                        <a:t>PPC launch strategy delivered Monday 28 Sep for the launch</a:t>
-                      </a:r>
-                      <a:endParaRPr lang="en-US" sz="1200" dirty="0">
-                        <a:latin typeface="Calibri" charset="0"/>
-                        <a:ea typeface="Calibri" charset="0"/>
-                        <a:cs typeface="Calibri" charset="0"/>
-                      </a:endParaRPr>
-                    </a:p>
-                  </a:txBody>
-                  <a:tcPr marL="64008" marR="64008" marT="73152" marB="73152" anchor="ctr">
-                    <a:lnL w="0" cap="flat" cmpd="sng" algn="ctr">
-                      <a:noFill/>
-                    </a:lnL>
-                    <a:lnR w="0" cap="flat" cmpd="sng" algn="ctr">
-                      <a:noFill/>
-                    </a:lnR>
-                    <a:lnT w="0" cap="flat" cmpd="sng" algn="ctr">
-                      <a:noFill/>
-                    </a:lnT>
-                    <a:lnB w="9525" cap="flat" cmpd="sng" algn="ctr">
-                      <a:solidFill>
-                        <a:srgbClr val="BFCAD3"/>
-                      </a:solidFill>
-                      <a:prstDash val="solid"/>
-                      <a:round/>
-                      <a:headEnd type="none" w="med" len="med"/>
-                      <a:tailEnd type="none" w="med" len="med"/>
-                    </a:lnB>
-                  </a:tcPr>
-                </a:tc>
-                <a:tc>
-                  <a:txBody>
-                    <a:bodyPr/>
-                    <a:lstStyle/>
-                    <a:p>
-                      <a:pPr indent="0" marL="0">
-                        <a:buNone/>
-                      </a:pPr>
-                      <a:r>
-                        <a:rPr lang="en-US" sz="1200" dirty="0">
+                        <a:t>PPC launch strategy delivered Monday 28 Sep, campaigns live with the listing</a:t>
+                      </a:r>
+                      <a:endParaRPr lang="en-US" sz="1150" dirty="0">
+                        <a:latin typeface="Calibri" charset="0"/>
+                        <a:ea typeface="Calibri" charset="0"/>
+                        <a:cs typeface="Calibri" charset="0"/>
+                      </a:endParaRPr>
+                    </a:p>
+                  </a:txBody>
+                  <a:tcPr marL="64008" marR="64008" marT="73152" marB="73152" anchor="ctr">
+                    <a:lnL w="0" cap="flat" cmpd="sng" algn="ctr">
+                      <a:noFill/>
+                    </a:lnL>
+                    <a:lnR w="0" cap="flat" cmpd="sng" algn="ctr">
+                      <a:noFill/>
+                    </a:lnR>
+                    <a:lnT w="0" cap="flat" cmpd="sng" algn="ctr">
+                      <a:noFill/>
+                    </a:lnT>
+                    <a:lnB w="9525" cap="flat" cmpd="sng" algn="ctr">
+                      <a:solidFill>
+                        <a:srgbClr val="BFCAD3"/>
+                      </a:solidFill>
+                      <a:prstDash val="solid"/>
+                      <a:round/>
+                      <a:headEnd type="none" w="med" len="med"/>
+                      <a:tailEnd type="none" w="med" len="med"/>
+                    </a:lnB>
+                  </a:tcPr>
+                </a:tc>
+                <a:tc>
+                  <a:txBody>
+                    <a:bodyPr/>
+                    <a:lstStyle/>
+                    <a:p>
+                      <a:pPr indent="0" marL="0">
+                        <a:buNone/>
+                      </a:pPr>
+                      <a:r>
+                        <a:rPr lang="en-US" sz="1150" dirty="0">
                           <a:solidFill>
                             <a:srgbClr val="111C24"/>
                           </a:solidFill>
@@ -3735,46 +3735,46 @@
                           <a:ea typeface="Calibri" pitchFamily="34" charset="-122"/>
                           <a:cs typeface="Calibri" pitchFamily="34" charset="-120"/>
                         </a:rPr>
-                        <a:t>Launch plan shared the same day. PAT additions asked of Shayan R</a:t>
-                      </a:r>
-                      <a:endParaRPr lang="en-US" sz="1200" dirty="0">
-                        <a:latin typeface="Calibri" charset="0"/>
-                        <a:ea typeface="Calibri" charset="0"/>
-                        <a:cs typeface="Calibri" charset="0"/>
-                      </a:endParaRPr>
-                    </a:p>
-                  </a:txBody>
-                  <a:tcPr marL="64008" marR="64008" marT="73152" marB="73152" anchor="ctr">
-                    <a:lnL w="0" cap="flat" cmpd="sng" algn="ctr">
-                      <a:noFill/>
-                    </a:lnL>
-                    <a:lnR w="0" cap="flat" cmpd="sng" algn="ctr">
-                      <a:noFill/>
-                    </a:lnR>
-                    <a:lnT w="0" cap="flat" cmpd="sng" algn="ctr">
-                      <a:noFill/>
-                    </a:lnT>
-                    <a:lnB w="9525" cap="flat" cmpd="sng" algn="ctr">
-                      <a:solidFill>
-                        <a:srgbClr val="BFCAD3"/>
-                      </a:solidFill>
-                      <a:prstDash val="solid"/>
-                      <a:round/>
-                      <a:headEnd type="none" w="med" len="med"/>
-                      <a:tailEnd type="none" w="med" len="med"/>
-                    </a:lnB>
-                  </a:tcPr>
-                </a:tc>
-                <a:tc>
-                  <a:txBody>
-                    <a:bodyPr/>
-                    <a:lstStyle/>
-                    <a:p>
-                      <a:pPr indent="0" marL="0">
-                        <a:buNone/>
-                      </a:pPr>
-                      <a:r>
-                        <a:rPr lang="en-US" sz="1200" b="1" dirty="0">
+                        <a:t>Launch workbook shared 28 Sep, revised with a strategy doc on Erik's feedback 29 Sep. Listing goes live on Amazon today, 2 Oct, and PPC launches with it</a:t>
+                      </a:r>
+                      <a:endParaRPr lang="en-US" sz="1150" dirty="0">
+                        <a:latin typeface="Calibri" charset="0"/>
+                        <a:ea typeface="Calibri" charset="0"/>
+                        <a:cs typeface="Calibri" charset="0"/>
+                      </a:endParaRPr>
+                    </a:p>
+                  </a:txBody>
+                  <a:tcPr marL="64008" marR="64008" marT="73152" marB="73152" anchor="ctr">
+                    <a:lnL w="0" cap="flat" cmpd="sng" algn="ctr">
+                      <a:noFill/>
+                    </a:lnL>
+                    <a:lnR w="0" cap="flat" cmpd="sng" algn="ctr">
+                      <a:noFill/>
+                    </a:lnR>
+                    <a:lnT w="0" cap="flat" cmpd="sng" algn="ctr">
+                      <a:noFill/>
+                    </a:lnT>
+                    <a:lnB w="9525" cap="flat" cmpd="sng" algn="ctr">
+                      <a:solidFill>
+                        <a:srgbClr val="BFCAD3"/>
+                      </a:solidFill>
+                      <a:prstDash val="solid"/>
+                      <a:round/>
+                      <a:headEnd type="none" w="med" len="med"/>
+                      <a:tailEnd type="none" w="med" len="med"/>
+                    </a:lnB>
+                  </a:tcPr>
+                </a:tc>
+                <a:tc>
+                  <a:txBody>
+                    <a:bodyPr/>
+                    <a:lstStyle/>
+                    <a:p>
+                      <a:pPr indent="0" marL="0">
+                        <a:buNone/>
+                      </a:pPr>
+                      <a:r>
+                        <a:rPr lang="en-US" sz="1150" b="1" dirty="0">
                           <a:solidFill>
                             <a:srgbClr val="176B41"/>
                           </a:solidFill>
@@ -3782,9 +3782,9 @@
                           <a:ea typeface="Calibri" pitchFamily="34" charset="-122"/>
                           <a:cs typeface="Calibri" pitchFamily="34" charset="-120"/>
                         </a:rPr>
-                        <a:t>Done</a:t>
-                      </a:r>
-                      <a:endParaRPr lang="en-US" sz="1200" dirty="0">
+                        <a:t>Launching today</a:t>
+                      </a:r>
+                      <a:endParaRPr lang="en-US" sz="1150" dirty="0">
                         <a:latin typeface="Calibri" charset="0"/>
                         <a:ea typeface="Calibri" charset="0"/>
                         <a:cs typeface="Calibri" charset="0"/>
@@ -3826,7 +3826,7 @@
                         <a:buNone/>
                       </a:pPr>
                       <a:r>
-                        <a:rPr lang="en-US" sz="1200" b="1" dirty="0">
+                        <a:rPr lang="en-US" sz="1150" b="1" dirty="0">
                           <a:solidFill>
                             <a:srgbClr val="111C24"/>
                           </a:solidFill>
@@ -3836,18 +3836,18 @@
                         </a:rPr>
                         <a:t>Cadence &amp; daily oversight</a:t>
                       </a:r>
-                      <a:endParaRPr lang="en-US" sz="1200" dirty="0">
-                        <a:latin typeface="Calibri" charset="0"/>
-                        <a:ea typeface="Calibri" charset="0"/>
-                        <a:cs typeface="Calibri" charset="0"/>
-                      </a:endParaRPr>
-                    </a:p>
-                    <a:p>
-                      <a:pPr indent="0" marL="0">
-                        <a:buNone/>
-                      </a:pPr>
-                      <a:r>
-                        <a:rPr lang="en-US" sz="1100" dirty="0">
+                      <a:endParaRPr lang="en-US" sz="1150" dirty="0">
+                        <a:latin typeface="Calibri" charset="0"/>
+                        <a:ea typeface="Calibri" charset="0"/>
+                        <a:cs typeface="Calibri" charset="0"/>
+                      </a:endParaRPr>
+                    </a:p>
+                    <a:p>
+                      <a:pPr indent="0" marL="0">
+                        <a:buNone/>
+                      </a:pPr>
+                      <a:r>
+                        <a:rPr lang="en-US" sz="1050" dirty="0">
                           <a:solidFill>
                             <a:srgbClr val="4E5A64"/>
                           </a:solidFill>
@@ -3857,44 +3857,44 @@
                         </a:rPr>
                         <a:t>All owners · daily · P1</a:t>
                       </a:r>
-                      <a:endParaRPr lang="en-US" sz="1200" dirty="0">
-                        <a:latin typeface="Calibri" charset="0"/>
-                        <a:ea typeface="Calibri" charset="0"/>
-                        <a:cs typeface="Calibri" charset="0"/>
-                      </a:endParaRPr>
-                    </a:p>
-                  </a:txBody>
-                  <a:tcPr marL="64008" marR="64008" marT="73152" marB="73152" anchor="ctr">
-                    <a:lnL w="0" cap="flat" cmpd="sng" algn="ctr">
-                      <a:noFill/>
-                    </a:lnL>
-                    <a:lnR w="0" cap="flat" cmpd="sng" algn="ctr">
-                      <a:noFill/>
-                    </a:lnR>
-                    <a:lnT w="0" cap="flat" cmpd="sng" algn="ctr">
-                      <a:noFill/>
-                    </a:lnT>
-                    <a:lnB w="9525" cap="flat" cmpd="sng" algn="ctr">
-                      <a:solidFill>
-                        <a:srgbClr val="BFCAD3"/>
-                      </a:solidFill>
-                      <a:prstDash val="solid"/>
-                      <a:round/>
-                      <a:headEnd type="none" w="med" len="med"/>
-                      <a:tailEnd type="none" w="med" len="med"/>
-                    </a:lnB>
-                  </a:tcPr>
-                </a:tc>
-                <a:tc>
-                  <a:txBody>
-                    <a:bodyPr/>
-                    <a:lstStyle/>
-                    <a:p>
-                      <a:pPr indent="0" marL="0">
-                        <a:buNone/>
-                      </a:pPr>
-                      <a:r>
-                        <a:rPr lang="en-US" sz="1200" dirty="0">
+                      <a:endParaRPr lang="en-US" sz="1150" dirty="0">
+                        <a:latin typeface="Calibri" charset="0"/>
+                        <a:ea typeface="Calibri" charset="0"/>
+                        <a:cs typeface="Calibri" charset="0"/>
+                      </a:endParaRPr>
+                    </a:p>
+                  </a:txBody>
+                  <a:tcPr marL="64008" marR="64008" marT="73152" marB="73152" anchor="ctr">
+                    <a:lnL w="0" cap="flat" cmpd="sng" algn="ctr">
+                      <a:noFill/>
+                    </a:lnL>
+                    <a:lnR w="0" cap="flat" cmpd="sng" algn="ctr">
+                      <a:noFill/>
+                    </a:lnR>
+                    <a:lnT w="0" cap="flat" cmpd="sng" algn="ctr">
+                      <a:noFill/>
+                    </a:lnT>
+                    <a:lnB w="9525" cap="flat" cmpd="sng" algn="ctr">
+                      <a:solidFill>
+                        <a:srgbClr val="BFCAD3"/>
+                      </a:solidFill>
+                      <a:prstDash val="solid"/>
+                      <a:round/>
+                      <a:headEnd type="none" w="med" len="med"/>
+                      <a:tailEnd type="none" w="med" len="med"/>
+                    </a:lnB>
+                  </a:tcPr>
+                </a:tc>
+                <a:tc>
+                  <a:txBody>
+                    <a:bodyPr/>
+                    <a:lstStyle/>
+                    <a:p>
+                      <a:pPr indent="0" marL="0">
+                        <a:buNone/>
+                      </a:pPr>
+                      <a:r>
+                        <a:rPr lang="en-US" sz="1150" dirty="0">
                           <a:solidFill>
                             <a:srgbClr val="111C24"/>
                           </a:solidFill>
@@ -3904,44 +3904,44 @@
                         </a:rPr>
                         <a:t>Daily spend check on the top 20% of campaigns, Tuesday to Friday</a:t>
                       </a:r>
-                      <a:endParaRPr lang="en-US" sz="1200" dirty="0">
-                        <a:latin typeface="Calibri" charset="0"/>
-                        <a:ea typeface="Calibri" charset="0"/>
-                        <a:cs typeface="Calibri" charset="0"/>
-                      </a:endParaRPr>
-                    </a:p>
-                  </a:txBody>
-                  <a:tcPr marL="64008" marR="64008" marT="73152" marB="73152" anchor="ctr">
-                    <a:lnL w="0" cap="flat" cmpd="sng" algn="ctr">
-                      <a:noFill/>
-                    </a:lnL>
-                    <a:lnR w="0" cap="flat" cmpd="sng" algn="ctr">
-                      <a:noFill/>
-                    </a:lnR>
-                    <a:lnT w="0" cap="flat" cmpd="sng" algn="ctr">
-                      <a:noFill/>
-                    </a:lnT>
-                    <a:lnB w="9525" cap="flat" cmpd="sng" algn="ctr">
-                      <a:solidFill>
-                        <a:srgbClr val="BFCAD3"/>
-                      </a:solidFill>
-                      <a:prstDash val="solid"/>
-                      <a:round/>
-                      <a:headEnd type="none" w="med" len="med"/>
-                      <a:tailEnd type="none" w="med" len="med"/>
-                    </a:lnB>
-                  </a:tcPr>
-                </a:tc>
-                <a:tc>
-                  <a:txBody>
-                    <a:bodyPr/>
-                    <a:lstStyle/>
-                    <a:p>
-                      <a:pPr indent="0" marL="0">
-                        <a:buNone/>
-                      </a:pPr>
-                      <a:r>
-                        <a:rPr lang="en-US" sz="1200" dirty="0">
+                      <a:endParaRPr lang="en-US" sz="1150" dirty="0">
+                        <a:latin typeface="Calibri" charset="0"/>
+                        <a:ea typeface="Calibri" charset="0"/>
+                        <a:cs typeface="Calibri" charset="0"/>
+                      </a:endParaRPr>
+                    </a:p>
+                  </a:txBody>
+                  <a:tcPr marL="64008" marR="64008" marT="73152" marB="73152" anchor="ctr">
+                    <a:lnL w="0" cap="flat" cmpd="sng" algn="ctr">
+                      <a:noFill/>
+                    </a:lnL>
+                    <a:lnR w="0" cap="flat" cmpd="sng" algn="ctr">
+                      <a:noFill/>
+                    </a:lnR>
+                    <a:lnT w="0" cap="flat" cmpd="sng" algn="ctr">
+                      <a:noFill/>
+                    </a:lnT>
+                    <a:lnB w="9525" cap="flat" cmpd="sng" algn="ctr">
+                      <a:solidFill>
+                        <a:srgbClr val="BFCAD3"/>
+                      </a:solidFill>
+                      <a:prstDash val="solid"/>
+                      <a:round/>
+                      <a:headEnd type="none" w="med" len="med"/>
+                      <a:tailEnd type="none" w="med" len="med"/>
+                    </a:lnB>
+                  </a:tcPr>
+                </a:tc>
+                <a:tc>
+                  <a:txBody>
+                    <a:bodyPr/>
+                    <a:lstStyle/>
+                    <a:p>
+                      <a:pPr indent="0" marL="0">
+                        <a:buNone/>
+                      </a:pPr>
+                      <a:r>
+                        <a:rPr lang="en-US" sz="1150" dirty="0">
                           <a:solidFill>
                             <a:srgbClr val="111C24"/>
                           </a:solidFill>
@@ -3951,44 +3951,44 @@
                         </a:rPr>
                         <a:t>Daily huddles ran. No spend-check or change-log records posted. Monday meeting dropped; two Joseph calls cancelled</a:t>
                       </a:r>
-                      <a:endParaRPr lang="en-US" sz="1200" dirty="0">
-                        <a:latin typeface="Calibri" charset="0"/>
-                        <a:ea typeface="Calibri" charset="0"/>
-                        <a:cs typeface="Calibri" charset="0"/>
-                      </a:endParaRPr>
-                    </a:p>
-                  </a:txBody>
-                  <a:tcPr marL="64008" marR="64008" marT="73152" marB="73152" anchor="ctr">
-                    <a:lnL w="0" cap="flat" cmpd="sng" algn="ctr">
-                      <a:noFill/>
-                    </a:lnL>
-                    <a:lnR w="0" cap="flat" cmpd="sng" algn="ctr">
-                      <a:noFill/>
-                    </a:lnR>
-                    <a:lnT w="0" cap="flat" cmpd="sng" algn="ctr">
-                      <a:noFill/>
-                    </a:lnT>
-                    <a:lnB w="9525" cap="flat" cmpd="sng" algn="ctr">
-                      <a:solidFill>
-                        <a:srgbClr val="BFCAD3"/>
-                      </a:solidFill>
-                      <a:prstDash val="solid"/>
-                      <a:round/>
-                      <a:headEnd type="none" w="med" len="med"/>
-                      <a:tailEnd type="none" w="med" len="med"/>
-                    </a:lnB>
-                  </a:tcPr>
-                </a:tc>
-                <a:tc>
-                  <a:txBody>
-                    <a:bodyPr/>
-                    <a:lstStyle/>
-                    <a:p>
-                      <a:pPr indent="0" marL="0">
-                        <a:buNone/>
-                      </a:pPr>
-                      <a:r>
-                        <a:rPr lang="en-US" sz="1200" b="1" dirty="0">
+                      <a:endParaRPr lang="en-US" sz="1150" dirty="0">
+                        <a:latin typeface="Calibri" charset="0"/>
+                        <a:ea typeface="Calibri" charset="0"/>
+                        <a:cs typeface="Calibri" charset="0"/>
+                      </a:endParaRPr>
+                    </a:p>
+                  </a:txBody>
+                  <a:tcPr marL="64008" marR="64008" marT="73152" marB="73152" anchor="ctr">
+                    <a:lnL w="0" cap="flat" cmpd="sng" algn="ctr">
+                      <a:noFill/>
+                    </a:lnL>
+                    <a:lnR w="0" cap="flat" cmpd="sng" algn="ctr">
+                      <a:noFill/>
+                    </a:lnR>
+                    <a:lnT w="0" cap="flat" cmpd="sng" algn="ctr">
+                      <a:noFill/>
+                    </a:lnT>
+                    <a:lnB w="9525" cap="flat" cmpd="sng" algn="ctr">
+                      <a:solidFill>
+                        <a:srgbClr val="BFCAD3"/>
+                      </a:solidFill>
+                      <a:prstDash val="solid"/>
+                      <a:round/>
+                      <a:headEnd type="none" w="med" len="med"/>
+                      <a:tailEnd type="none" w="med" len="med"/>
+                    </a:lnB>
+                  </a:tcPr>
+                </a:tc>
+                <a:tc>
+                  <a:txBody>
+                    <a:bodyPr/>
+                    <a:lstStyle/>
+                    <a:p>
+                      <a:pPr indent="0" marL="0">
+                        <a:buNone/>
+                      </a:pPr>
+                      <a:r>
+                        <a:rPr lang="en-US" sz="1150" b="1" dirty="0">
                           <a:solidFill>
                             <a:srgbClr val="9C3D31"/>
                           </a:solidFill>
@@ -3998,7 +3998,7 @@
                         </a:rPr>
                         <a:t>0 of 4 logged</a:t>
                       </a:r>
-                      <a:endParaRPr lang="en-US" sz="1200" dirty="0">
+                      <a:endParaRPr lang="en-US" sz="1150" dirty="0">
                         <a:latin typeface="Calibri" charset="0"/>
                         <a:ea typeface="Calibri" charset="0"/>
                         <a:cs typeface="Calibri" charset="0"/>
@@ -8418,7 +8418,7 @@
                         <a:buNone/>
                       </a:pPr>
                       <a:r>
-                        <a:rPr lang="en-US" sz="1200" b="1" dirty="0">
+                        <a:rPr lang="en-US" sz="1150" b="1" dirty="0">
                           <a:solidFill>
                             <a:srgbClr val="111C24"/>
                           </a:solidFill>
@@ -8428,18 +8428,18 @@
                         </a:rPr>
                         <a:t>Prime Big Deal Days</a:t>
                       </a:r>
-                      <a:endParaRPr lang="en-US" sz="1200" dirty="0">
-                        <a:latin typeface="Calibri" charset="0"/>
-                        <a:ea typeface="Calibri" charset="0"/>
-                        <a:cs typeface="Calibri" charset="0"/>
-                      </a:endParaRPr>
-                    </a:p>
-                    <a:p>
-                      <a:pPr indent="0" marL="0">
-                        <a:buNone/>
-                      </a:pPr>
-                      <a:r>
-                        <a:rPr lang="en-US" sz="1100" dirty="0">
+                      <a:endParaRPr lang="en-US" sz="1150" dirty="0">
+                        <a:latin typeface="Calibri" charset="0"/>
+                        <a:ea typeface="Calibri" charset="0"/>
+                        <a:cs typeface="Calibri" charset="0"/>
+                      </a:endParaRPr>
+                    </a:p>
+                    <a:p>
+                      <a:pPr indent="0" marL="0">
+                        <a:buNone/>
+                      </a:pPr>
+                      <a:r>
+                        <a:rPr lang="en-US" sz="1050" dirty="0">
                           <a:solidFill>
                             <a:srgbClr val="4E5A64"/>
                           </a:solidFill>
@@ -8449,44 +8449,44 @@
                         </a:rPr>
                         <a:t>Shayan T</a:t>
                       </a:r>
-                      <a:endParaRPr lang="en-US" sz="1200" dirty="0">
-                        <a:latin typeface="Calibri" charset="0"/>
-                        <a:ea typeface="Calibri" charset="0"/>
-                        <a:cs typeface="Calibri" charset="0"/>
-                      </a:endParaRPr>
-                    </a:p>
-                  </a:txBody>
-                  <a:tcPr marL="64008" marR="64008" marT="73152" marB="73152" anchor="ctr">
-                    <a:lnL w="0" cap="flat" cmpd="sng" algn="ctr">
-                      <a:noFill/>
-                    </a:lnL>
-                    <a:lnR w="0" cap="flat" cmpd="sng" algn="ctr">
-                      <a:noFill/>
-                    </a:lnR>
-                    <a:lnT w="0" cap="flat" cmpd="sng" algn="ctr">
-                      <a:noFill/>
-                    </a:lnT>
-                    <a:lnB w="9525" cap="flat" cmpd="sng" algn="ctr">
-                      <a:solidFill>
-                        <a:srgbClr val="BFCAD3"/>
-                      </a:solidFill>
-                      <a:prstDash val="solid"/>
-                      <a:round/>
-                      <a:headEnd type="none" w="med" len="med"/>
-                      <a:tailEnd type="none" w="med" len="med"/>
-                    </a:lnB>
-                  </a:tcPr>
-                </a:tc>
-                <a:tc>
-                  <a:txBody>
-                    <a:bodyPr/>
-                    <a:lstStyle/>
-                    <a:p>
-                      <a:pPr indent="0" marL="0">
-                        <a:buNone/>
-                      </a:pPr>
-                      <a:r>
-                        <a:rPr lang="en-US" sz="1200" dirty="0">
+                      <a:endParaRPr lang="en-US" sz="1150" dirty="0">
+                        <a:latin typeface="Calibri" charset="0"/>
+                        <a:ea typeface="Calibri" charset="0"/>
+                        <a:cs typeface="Calibri" charset="0"/>
+                      </a:endParaRPr>
+                    </a:p>
+                  </a:txBody>
+                  <a:tcPr marL="64008" marR="64008" marT="73152" marB="73152" anchor="ctr">
+                    <a:lnL w="0" cap="flat" cmpd="sng" algn="ctr">
+                      <a:noFill/>
+                    </a:lnL>
+                    <a:lnR w="0" cap="flat" cmpd="sng" algn="ctr">
+                      <a:noFill/>
+                    </a:lnR>
+                    <a:lnT w="0" cap="flat" cmpd="sng" algn="ctr">
+                      <a:noFill/>
+                    </a:lnT>
+                    <a:lnB w="9525" cap="flat" cmpd="sng" algn="ctr">
+                      <a:solidFill>
+                        <a:srgbClr val="BFCAD3"/>
+                      </a:solidFill>
+                      <a:prstDash val="solid"/>
+                      <a:round/>
+                      <a:headEnd type="none" w="med" len="med"/>
+                      <a:tailEnd type="none" w="med" len="med"/>
+                    </a:lnB>
+                  </a:tcPr>
+                </a:tc>
+                <a:tc>
+                  <a:txBody>
+                    <a:bodyPr/>
+                    <a:lstStyle/>
+                    <a:p>
+                      <a:pPr indent="0" marL="0">
+                        <a:buNone/>
+                      </a:pPr>
+                      <a:r>
+                        <a:rPr lang="en-US" sz="1150" dirty="0">
                           <a:solidFill>
                             <a:srgbClr val="111C24"/>
                           </a:solidFill>
@@ -8496,44 +8496,44 @@
                         </a:rPr>
                         <a:t>Run the Oct 6–7 event: deal-day budgets live, Amazon's own budget rules stripped, S4 deal issues cleared</a:t>
                       </a:r>
-                      <a:endParaRPr lang="en-US" sz="1200" dirty="0">
-                        <a:latin typeface="Calibri" charset="0"/>
-                        <a:ea typeface="Calibri" charset="0"/>
-                        <a:cs typeface="Calibri" charset="0"/>
-                      </a:endParaRPr>
-                    </a:p>
-                  </a:txBody>
-                  <a:tcPr marL="64008" marR="64008" marT="73152" marB="73152" anchor="ctr">
-                    <a:lnL w="0" cap="flat" cmpd="sng" algn="ctr">
-                      <a:noFill/>
-                    </a:lnL>
-                    <a:lnR w="0" cap="flat" cmpd="sng" algn="ctr">
-                      <a:noFill/>
-                    </a:lnR>
-                    <a:lnT w="0" cap="flat" cmpd="sng" algn="ctr">
-                      <a:noFill/>
-                    </a:lnT>
-                    <a:lnB w="9525" cap="flat" cmpd="sng" algn="ctr">
-                      <a:solidFill>
-                        <a:srgbClr val="BFCAD3"/>
-                      </a:solidFill>
-                      <a:prstDash val="solid"/>
-                      <a:round/>
-                      <a:headEnd type="none" w="med" len="med"/>
-                      <a:tailEnd type="none" w="med" len="med"/>
-                    </a:lnB>
-                  </a:tcPr>
-                </a:tc>
-                <a:tc>
-                  <a:txBody>
-                    <a:bodyPr/>
-                    <a:lstStyle/>
-                    <a:p>
-                      <a:pPr indent="0" marL="0">
-                        <a:buNone/>
-                      </a:pPr>
-                      <a:r>
-                        <a:rPr lang="en-US" sz="1200" dirty="0">
+                      <a:endParaRPr lang="en-US" sz="1150" dirty="0">
+                        <a:latin typeface="Calibri" charset="0"/>
+                        <a:ea typeface="Calibri" charset="0"/>
+                        <a:cs typeface="Calibri" charset="0"/>
+                      </a:endParaRPr>
+                    </a:p>
+                  </a:txBody>
+                  <a:tcPr marL="64008" marR="64008" marT="73152" marB="73152" anchor="ctr">
+                    <a:lnL w="0" cap="flat" cmpd="sng" algn="ctr">
+                      <a:noFill/>
+                    </a:lnL>
+                    <a:lnR w="0" cap="flat" cmpd="sng" algn="ctr">
+                      <a:noFill/>
+                    </a:lnR>
+                    <a:lnT w="0" cap="flat" cmpd="sng" algn="ctr">
+                      <a:noFill/>
+                    </a:lnT>
+                    <a:lnB w="9525" cap="flat" cmpd="sng" algn="ctr">
+                      <a:solidFill>
+                        <a:srgbClr val="BFCAD3"/>
+                      </a:solidFill>
+                      <a:prstDash val="solid"/>
+                      <a:round/>
+                      <a:headEnd type="none" w="med" len="med"/>
+                      <a:tailEnd type="none" w="med" len="med"/>
+                    </a:lnB>
+                  </a:tcPr>
+                </a:tc>
+                <a:tc>
+                  <a:txBody>
+                    <a:bodyPr/>
+                    <a:lstStyle/>
+                    <a:p>
+                      <a:pPr indent="0" marL="0">
+                        <a:buNone/>
+                      </a:pPr>
+                      <a:r>
+                        <a:rPr lang="en-US" sz="1150" dirty="0">
                           <a:solidFill>
                             <a:srgbClr val="111C24"/>
                           </a:solidFill>
@@ -8543,44 +8543,44 @@
                         </a:rPr>
                         <a:t>Mon, Oct 5</a:t>
                       </a:r>
-                      <a:endParaRPr lang="en-US" sz="1200" dirty="0">
-                        <a:latin typeface="Calibri" charset="0"/>
-                        <a:ea typeface="Calibri" charset="0"/>
-                        <a:cs typeface="Calibri" charset="0"/>
-                      </a:endParaRPr>
-                    </a:p>
-                  </a:txBody>
-                  <a:tcPr marL="64008" marR="64008" marT="73152" marB="73152" anchor="ctr">
-                    <a:lnL w="0" cap="flat" cmpd="sng" algn="ctr">
-                      <a:noFill/>
-                    </a:lnL>
-                    <a:lnR w="0" cap="flat" cmpd="sng" algn="ctr">
-                      <a:noFill/>
-                    </a:lnR>
-                    <a:lnT w="0" cap="flat" cmpd="sng" algn="ctr">
-                      <a:noFill/>
-                    </a:lnT>
-                    <a:lnB w="9525" cap="flat" cmpd="sng" algn="ctr">
-                      <a:solidFill>
-                        <a:srgbClr val="BFCAD3"/>
-                      </a:solidFill>
-                      <a:prstDash val="solid"/>
-                      <a:round/>
-                      <a:headEnd type="none" w="med" len="med"/>
-                      <a:tailEnd type="none" w="med" len="med"/>
-                    </a:lnB>
-                  </a:tcPr>
-                </a:tc>
-                <a:tc>
-                  <a:txBody>
-                    <a:bodyPr/>
-                    <a:lstStyle/>
-                    <a:p>
-                      <a:pPr indent="0" marL="0">
-                        <a:buNone/>
-                      </a:pPr>
-                      <a:r>
-                        <a:rPr lang="en-US" sz="1200" dirty="0">
+                      <a:endParaRPr lang="en-US" sz="1150" dirty="0">
+                        <a:latin typeface="Calibri" charset="0"/>
+                        <a:ea typeface="Calibri" charset="0"/>
+                        <a:cs typeface="Calibri" charset="0"/>
+                      </a:endParaRPr>
+                    </a:p>
+                  </a:txBody>
+                  <a:tcPr marL="64008" marR="64008" marT="73152" marB="73152" anchor="ctr">
+                    <a:lnL w="0" cap="flat" cmpd="sng" algn="ctr">
+                      <a:noFill/>
+                    </a:lnL>
+                    <a:lnR w="0" cap="flat" cmpd="sng" algn="ctr">
+                      <a:noFill/>
+                    </a:lnR>
+                    <a:lnT w="0" cap="flat" cmpd="sng" algn="ctr">
+                      <a:noFill/>
+                    </a:lnT>
+                    <a:lnB w="9525" cap="flat" cmpd="sng" algn="ctr">
+                      <a:solidFill>
+                        <a:srgbClr val="BFCAD3"/>
+                      </a:solidFill>
+                      <a:prstDash val="solid"/>
+                      <a:round/>
+                      <a:headEnd type="none" w="med" len="med"/>
+                      <a:tailEnd type="none" w="med" len="med"/>
+                    </a:lnB>
+                  </a:tcPr>
+                </a:tc>
+                <a:tc>
+                  <a:txBody>
+                    <a:bodyPr/>
+                    <a:lstStyle/>
+                    <a:p>
+                      <a:pPr indent="0" marL="0">
+                        <a:buNone/>
+                      </a:pPr>
+                      <a:r>
+                        <a:rPr lang="en-US" sz="1150" dirty="0">
                           <a:solidFill>
                             <a:srgbClr val="111C24"/>
                           </a:solidFill>
@@ -8590,44 +8590,44 @@
                         </a:rPr>
                         <a:t>P0</a:t>
                       </a:r>
-                      <a:endParaRPr lang="en-US" sz="1200" dirty="0">
-                        <a:latin typeface="Calibri" charset="0"/>
-                        <a:ea typeface="Calibri" charset="0"/>
-                        <a:cs typeface="Calibri" charset="0"/>
-                      </a:endParaRPr>
-                    </a:p>
-                  </a:txBody>
-                  <a:tcPr marL="64008" marR="64008" marT="73152" marB="73152" anchor="ctr">
-                    <a:lnL w="0" cap="flat" cmpd="sng" algn="ctr">
-                      <a:noFill/>
-                    </a:lnL>
-                    <a:lnR w="0" cap="flat" cmpd="sng" algn="ctr">
-                      <a:noFill/>
-                    </a:lnR>
-                    <a:lnT w="0" cap="flat" cmpd="sng" algn="ctr">
-                      <a:noFill/>
-                    </a:lnT>
-                    <a:lnB w="9525" cap="flat" cmpd="sng" algn="ctr">
-                      <a:solidFill>
-                        <a:srgbClr val="BFCAD3"/>
-                      </a:solidFill>
-                      <a:prstDash val="solid"/>
-                      <a:round/>
-                      <a:headEnd type="none" w="med" len="med"/>
-                      <a:tailEnd type="none" w="med" len="med"/>
-                    </a:lnB>
-                  </a:tcPr>
-                </a:tc>
-                <a:tc>
-                  <a:txBody>
-                    <a:bodyPr/>
-                    <a:lstStyle/>
-                    <a:p>
-                      <a:pPr indent="0" marL="0">
-                        <a:buNone/>
-                      </a:pPr>
-                      <a:r>
-                        <a:rPr lang="en-US" sz="1200" dirty="0">
+                      <a:endParaRPr lang="en-US" sz="1150" dirty="0">
+                        <a:latin typeface="Calibri" charset="0"/>
+                        <a:ea typeface="Calibri" charset="0"/>
+                        <a:cs typeface="Calibri" charset="0"/>
+                      </a:endParaRPr>
+                    </a:p>
+                  </a:txBody>
+                  <a:tcPr marL="64008" marR="64008" marT="73152" marB="73152" anchor="ctr">
+                    <a:lnL w="0" cap="flat" cmpd="sng" algn="ctr">
+                      <a:noFill/>
+                    </a:lnL>
+                    <a:lnR w="0" cap="flat" cmpd="sng" algn="ctr">
+                      <a:noFill/>
+                    </a:lnR>
+                    <a:lnT w="0" cap="flat" cmpd="sng" algn="ctr">
+                      <a:noFill/>
+                    </a:lnT>
+                    <a:lnB w="9525" cap="flat" cmpd="sng" algn="ctr">
+                      <a:solidFill>
+                        <a:srgbClr val="BFCAD3"/>
+                      </a:solidFill>
+                      <a:prstDash val="solid"/>
+                      <a:round/>
+                      <a:headEnd type="none" w="med" len="med"/>
+                      <a:tailEnd type="none" w="med" len="med"/>
+                    </a:lnB>
+                  </a:tcPr>
+                </a:tc>
+                <a:tc>
+                  <a:txBody>
+                    <a:bodyPr/>
+                    <a:lstStyle/>
+                    <a:p>
+                      <a:pPr indent="0" marL="0">
+                        <a:buNone/>
+                      </a:pPr>
+                      <a:r>
+                        <a:rPr lang="en-US" sz="1150" dirty="0">
                           <a:solidFill>
                             <a:srgbClr val="111C24"/>
                           </a:solidFill>
@@ -8637,7 +8637,7 @@
                         </a:rPr>
                         <a:t>N — new</a:t>
                       </a:r>
-                      <a:endParaRPr lang="en-US" sz="1200" dirty="0">
+                      <a:endParaRPr lang="en-US" sz="1150" dirty="0">
                         <a:latin typeface="Calibri" charset="0"/>
                         <a:ea typeface="Calibri" charset="0"/>
                         <a:cs typeface="Calibri" charset="0"/>
@@ -8676,7 +8676,7 @@
                         <a:buNone/>
                       </a:pPr>
                       <a:r>
-                        <a:rPr lang="en-US" sz="1200" b="1" dirty="0">
+                        <a:rPr lang="en-US" sz="1150" b="1" dirty="0">
                           <a:solidFill>
                             <a:srgbClr val="111C24"/>
                           </a:solidFill>
@@ -8686,18 +8686,18 @@
                         </a:rPr>
                         <a:t>Bamboo ranking push</a:t>
                       </a:r>
-                      <a:endParaRPr lang="en-US" sz="1200" dirty="0">
-                        <a:latin typeface="Calibri" charset="0"/>
-                        <a:ea typeface="Calibri" charset="0"/>
-                        <a:cs typeface="Calibri" charset="0"/>
-                      </a:endParaRPr>
-                    </a:p>
-                    <a:p>
-                      <a:pPr indent="0" marL="0">
-                        <a:buNone/>
-                      </a:pPr>
-                      <a:r>
-                        <a:rPr lang="en-US" sz="1100" dirty="0">
+                      <a:endParaRPr lang="en-US" sz="1150" dirty="0">
+                        <a:latin typeface="Calibri" charset="0"/>
+                        <a:ea typeface="Calibri" charset="0"/>
+                        <a:cs typeface="Calibri" charset="0"/>
+                      </a:endParaRPr>
+                    </a:p>
+                    <a:p>
+                      <a:pPr indent="0" marL="0">
+                        <a:buNone/>
+                      </a:pPr>
+                      <a:r>
+                        <a:rPr lang="en-US" sz="1050" dirty="0">
                           <a:solidFill>
                             <a:srgbClr val="4E5A64"/>
                           </a:solidFill>
@@ -8707,44 +8707,44 @@
                         </a:rPr>
                         <a:t>Shayan T with Joseph</a:t>
                       </a:r>
-                      <a:endParaRPr lang="en-US" sz="1200" dirty="0">
-                        <a:latin typeface="Calibri" charset="0"/>
-                        <a:ea typeface="Calibri" charset="0"/>
-                        <a:cs typeface="Calibri" charset="0"/>
-                      </a:endParaRPr>
-                    </a:p>
-                  </a:txBody>
-                  <a:tcPr marL="64008" marR="64008" marT="73152" marB="73152" anchor="ctr">
-                    <a:lnL w="0" cap="flat" cmpd="sng" algn="ctr">
-                      <a:noFill/>
-                    </a:lnL>
-                    <a:lnR w="0" cap="flat" cmpd="sng" algn="ctr">
-                      <a:noFill/>
-                    </a:lnR>
-                    <a:lnT w="0" cap="flat" cmpd="sng" algn="ctr">
-                      <a:noFill/>
-                    </a:lnT>
-                    <a:lnB w="9525" cap="flat" cmpd="sng" algn="ctr">
-                      <a:solidFill>
-                        <a:srgbClr val="BFCAD3"/>
-                      </a:solidFill>
-                      <a:prstDash val="solid"/>
-                      <a:round/>
-                      <a:headEnd type="none" w="med" len="med"/>
-                      <a:tailEnd type="none" w="med" len="med"/>
-                    </a:lnB>
-                  </a:tcPr>
-                </a:tc>
-                <a:tc>
-                  <a:txBody>
-                    <a:bodyPr/>
-                    <a:lstStyle/>
-                    <a:p>
-                      <a:pPr indent="0" marL="0">
-                        <a:buNone/>
-                      </a:pPr>
-                      <a:r>
-                        <a:rPr lang="en-US" sz="1200" dirty="0">
+                      <a:endParaRPr lang="en-US" sz="1150" dirty="0">
+                        <a:latin typeface="Calibri" charset="0"/>
+                        <a:ea typeface="Calibri" charset="0"/>
+                        <a:cs typeface="Calibri" charset="0"/>
+                      </a:endParaRPr>
+                    </a:p>
+                  </a:txBody>
+                  <a:tcPr marL="64008" marR="64008" marT="73152" marB="73152" anchor="ctr">
+                    <a:lnL w="0" cap="flat" cmpd="sng" algn="ctr">
+                      <a:noFill/>
+                    </a:lnL>
+                    <a:lnR w="0" cap="flat" cmpd="sng" algn="ctr">
+                      <a:noFill/>
+                    </a:lnR>
+                    <a:lnT w="0" cap="flat" cmpd="sng" algn="ctr">
+                      <a:noFill/>
+                    </a:lnT>
+                    <a:lnB w="9525" cap="flat" cmpd="sng" algn="ctr">
+                      <a:solidFill>
+                        <a:srgbClr val="BFCAD3"/>
+                      </a:solidFill>
+                      <a:prstDash val="solid"/>
+                      <a:round/>
+                      <a:headEnd type="none" w="med" len="med"/>
+                      <a:tailEnd type="none" w="med" len="med"/>
+                    </a:lnB>
+                  </a:tcPr>
+                </a:tc>
+                <a:tc>
+                  <a:txBody>
+                    <a:bodyPr/>
+                    <a:lstStyle/>
+                    <a:p>
+                      <a:pPr indent="0" marL="0">
+                        <a:buNone/>
+                      </a:pPr>
+                      <a:r>
+                        <a:rPr lang="en-US" sz="1150" dirty="0">
                           <a:solidFill>
                             <a:srgbClr val="111C24"/>
                           </a:solidFill>
@@ -8754,44 +8754,44 @@
                         </a:rPr>
                         <a:t>Get the sign-offs, write the rank goals to Target Setting and go live; day-7 reads 10 Oct (B6) and 11 Oct (B4), first 60-click trial reads 14 Oct</a:t>
                       </a:r>
-                      <a:endParaRPr lang="en-US" sz="1200" dirty="0">
-                        <a:latin typeface="Calibri" charset="0"/>
-                        <a:ea typeface="Calibri" charset="0"/>
-                        <a:cs typeface="Calibri" charset="0"/>
-                      </a:endParaRPr>
-                    </a:p>
-                  </a:txBody>
-                  <a:tcPr marL="64008" marR="64008" marT="73152" marB="73152" anchor="ctr">
-                    <a:lnL w="0" cap="flat" cmpd="sng" algn="ctr">
-                      <a:noFill/>
-                    </a:lnL>
-                    <a:lnR w="0" cap="flat" cmpd="sng" algn="ctr">
-                      <a:noFill/>
-                    </a:lnR>
-                    <a:lnT w="0" cap="flat" cmpd="sng" algn="ctr">
-                      <a:noFill/>
-                    </a:lnT>
-                    <a:lnB w="9525" cap="flat" cmpd="sng" algn="ctr">
-                      <a:solidFill>
-                        <a:srgbClr val="BFCAD3"/>
-                      </a:solidFill>
-                      <a:prstDash val="solid"/>
-                      <a:round/>
-                      <a:headEnd type="none" w="med" len="med"/>
-                      <a:tailEnd type="none" w="med" len="med"/>
-                    </a:lnB>
-                  </a:tcPr>
-                </a:tc>
-                <a:tc>
-                  <a:txBody>
-                    <a:bodyPr/>
-                    <a:lstStyle/>
-                    <a:p>
-                      <a:pPr indent="0" marL="0">
-                        <a:buNone/>
-                      </a:pPr>
-                      <a:r>
-                        <a:rPr lang="en-US" sz="1200" dirty="0">
+                      <a:endParaRPr lang="en-US" sz="1150" dirty="0">
+                        <a:latin typeface="Calibri" charset="0"/>
+                        <a:ea typeface="Calibri" charset="0"/>
+                        <a:cs typeface="Calibri" charset="0"/>
+                      </a:endParaRPr>
+                    </a:p>
+                  </a:txBody>
+                  <a:tcPr marL="64008" marR="64008" marT="73152" marB="73152" anchor="ctr">
+                    <a:lnL w="0" cap="flat" cmpd="sng" algn="ctr">
+                      <a:noFill/>
+                    </a:lnL>
+                    <a:lnR w="0" cap="flat" cmpd="sng" algn="ctr">
+                      <a:noFill/>
+                    </a:lnR>
+                    <a:lnT w="0" cap="flat" cmpd="sng" algn="ctr">
+                      <a:noFill/>
+                    </a:lnT>
+                    <a:lnB w="9525" cap="flat" cmpd="sng" algn="ctr">
+                      <a:solidFill>
+                        <a:srgbClr val="BFCAD3"/>
+                      </a:solidFill>
+                      <a:prstDash val="solid"/>
+                      <a:round/>
+                      <a:headEnd type="none" w="med" len="med"/>
+                      <a:tailEnd type="none" w="med" len="med"/>
+                    </a:lnB>
+                  </a:tcPr>
+                </a:tc>
+                <a:tc>
+                  <a:txBody>
+                    <a:bodyPr/>
+                    <a:lstStyle/>
+                    <a:p>
+                      <a:pPr indent="0" marL="0">
+                        <a:buNone/>
+                      </a:pPr>
+                      <a:r>
+                        <a:rPr lang="en-US" sz="1150" dirty="0">
                           <a:solidFill>
                             <a:srgbClr val="111C24"/>
                           </a:solidFill>
@@ -8801,44 +8801,44 @@
                         </a:rPr>
                         <a:t>Mon, Oct 5 · reads 10–14 Oct</a:t>
                       </a:r>
-                      <a:endParaRPr lang="en-US" sz="1200" dirty="0">
-                        <a:latin typeface="Calibri" charset="0"/>
-                        <a:ea typeface="Calibri" charset="0"/>
-                        <a:cs typeface="Calibri" charset="0"/>
-                      </a:endParaRPr>
-                    </a:p>
-                  </a:txBody>
-                  <a:tcPr marL="64008" marR="64008" marT="73152" marB="73152" anchor="ctr">
-                    <a:lnL w="0" cap="flat" cmpd="sng" algn="ctr">
-                      <a:noFill/>
-                    </a:lnL>
-                    <a:lnR w="0" cap="flat" cmpd="sng" algn="ctr">
-                      <a:noFill/>
-                    </a:lnR>
-                    <a:lnT w="0" cap="flat" cmpd="sng" algn="ctr">
-                      <a:noFill/>
-                    </a:lnT>
-                    <a:lnB w="9525" cap="flat" cmpd="sng" algn="ctr">
-                      <a:solidFill>
-                        <a:srgbClr val="BFCAD3"/>
-                      </a:solidFill>
-                      <a:prstDash val="solid"/>
-                      <a:round/>
-                      <a:headEnd type="none" w="med" len="med"/>
-                      <a:tailEnd type="none" w="med" len="med"/>
-                    </a:lnB>
-                  </a:tcPr>
-                </a:tc>
-                <a:tc>
-                  <a:txBody>
-                    <a:bodyPr/>
-                    <a:lstStyle/>
-                    <a:p>
-                      <a:pPr indent="0" marL="0">
-                        <a:buNone/>
-                      </a:pPr>
-                      <a:r>
-                        <a:rPr lang="en-US" sz="1200" dirty="0">
+                      <a:endParaRPr lang="en-US" sz="1150" dirty="0">
+                        <a:latin typeface="Calibri" charset="0"/>
+                        <a:ea typeface="Calibri" charset="0"/>
+                        <a:cs typeface="Calibri" charset="0"/>
+                      </a:endParaRPr>
+                    </a:p>
+                  </a:txBody>
+                  <a:tcPr marL="64008" marR="64008" marT="73152" marB="73152" anchor="ctr">
+                    <a:lnL w="0" cap="flat" cmpd="sng" algn="ctr">
+                      <a:noFill/>
+                    </a:lnL>
+                    <a:lnR w="0" cap="flat" cmpd="sng" algn="ctr">
+                      <a:noFill/>
+                    </a:lnR>
+                    <a:lnT w="0" cap="flat" cmpd="sng" algn="ctr">
+                      <a:noFill/>
+                    </a:lnT>
+                    <a:lnB w="9525" cap="flat" cmpd="sng" algn="ctr">
+                      <a:solidFill>
+                        <a:srgbClr val="BFCAD3"/>
+                      </a:solidFill>
+                      <a:prstDash val="solid"/>
+                      <a:round/>
+                      <a:headEnd type="none" w="med" len="med"/>
+                      <a:tailEnd type="none" w="med" len="med"/>
+                    </a:lnB>
+                  </a:tcPr>
+                </a:tc>
+                <a:tc>
+                  <a:txBody>
+                    <a:bodyPr/>
+                    <a:lstStyle/>
+                    <a:p>
+                      <a:pPr indent="0" marL="0">
+                        <a:buNone/>
+                      </a:pPr>
+                      <a:r>
+                        <a:rPr lang="en-US" sz="1150" dirty="0">
                           <a:solidFill>
                             <a:srgbClr val="111C24"/>
                           </a:solidFill>
@@ -8848,44 +8848,44 @@
                         </a:rPr>
                         <a:t>P0</a:t>
                       </a:r>
-                      <a:endParaRPr lang="en-US" sz="1200" dirty="0">
-                        <a:latin typeface="Calibri" charset="0"/>
-                        <a:ea typeface="Calibri" charset="0"/>
-                        <a:cs typeface="Calibri" charset="0"/>
-                      </a:endParaRPr>
-                    </a:p>
-                  </a:txBody>
-                  <a:tcPr marL="64008" marR="64008" marT="73152" marB="73152" anchor="ctr">
-                    <a:lnL w="0" cap="flat" cmpd="sng" algn="ctr">
-                      <a:noFill/>
-                    </a:lnL>
-                    <a:lnR w="0" cap="flat" cmpd="sng" algn="ctr">
-                      <a:noFill/>
-                    </a:lnR>
-                    <a:lnT w="0" cap="flat" cmpd="sng" algn="ctr">
-                      <a:noFill/>
-                    </a:lnT>
-                    <a:lnB w="9525" cap="flat" cmpd="sng" algn="ctr">
-                      <a:solidFill>
-                        <a:srgbClr val="BFCAD3"/>
-                      </a:solidFill>
-                      <a:prstDash val="solid"/>
-                      <a:round/>
-                      <a:headEnd type="none" w="med" len="med"/>
-                      <a:tailEnd type="none" w="med" len="med"/>
-                    </a:lnB>
-                  </a:tcPr>
-                </a:tc>
-                <a:tc>
-                  <a:txBody>
-                    <a:bodyPr/>
-                    <a:lstStyle/>
-                    <a:p>
-                      <a:pPr indent="0" marL="0">
-                        <a:buNone/>
-                      </a:pPr>
-                      <a:r>
-                        <a:rPr lang="en-US" sz="1200" dirty="0">
+                      <a:endParaRPr lang="en-US" sz="1150" dirty="0">
+                        <a:latin typeface="Calibri" charset="0"/>
+                        <a:ea typeface="Calibri" charset="0"/>
+                        <a:cs typeface="Calibri" charset="0"/>
+                      </a:endParaRPr>
+                    </a:p>
+                  </a:txBody>
+                  <a:tcPr marL="64008" marR="64008" marT="73152" marB="73152" anchor="ctr">
+                    <a:lnL w="0" cap="flat" cmpd="sng" algn="ctr">
+                      <a:noFill/>
+                    </a:lnL>
+                    <a:lnR w="0" cap="flat" cmpd="sng" algn="ctr">
+                      <a:noFill/>
+                    </a:lnR>
+                    <a:lnT w="0" cap="flat" cmpd="sng" algn="ctr">
+                      <a:noFill/>
+                    </a:lnT>
+                    <a:lnB w="9525" cap="flat" cmpd="sng" algn="ctr">
+                      <a:solidFill>
+                        <a:srgbClr val="BFCAD3"/>
+                      </a:solidFill>
+                      <a:prstDash val="solid"/>
+                      <a:round/>
+                      <a:headEnd type="none" w="med" len="med"/>
+                      <a:tailEnd type="none" w="med" len="med"/>
+                    </a:lnB>
+                  </a:tcPr>
+                </a:tc>
+                <a:tc>
+                  <a:txBody>
+                    <a:bodyPr/>
+                    <a:lstStyle/>
+                    <a:p>
+                      <a:pPr indent="0" marL="0">
+                        <a:buNone/>
+                      </a:pPr>
+                      <a:r>
+                        <a:rPr lang="en-US" sz="1150" dirty="0">
                           <a:solidFill>
                             <a:srgbClr val="111C24"/>
                           </a:solidFill>
@@ -8895,7 +8895,7 @@
                         </a:rPr>
                         <a:t>N — new</a:t>
                       </a:r>
-                      <a:endParaRPr lang="en-US" sz="1200" dirty="0">
+                      <a:endParaRPr lang="en-US" sz="1150" dirty="0">
                         <a:latin typeface="Calibri" charset="0"/>
                         <a:ea typeface="Calibri" charset="0"/>
                         <a:cs typeface="Calibri" charset="0"/>
@@ -8934,7 +8934,7 @@
                         <a:buNone/>
                       </a:pPr>
                       <a:r>
-                        <a:rPr lang="en-US" sz="1200" b="1" dirty="0">
+                        <a:rPr lang="en-US" sz="1150" b="1" dirty="0">
                           <a:solidFill>
                             <a:srgbClr val="111C24"/>
                           </a:solidFill>
@@ -8942,20 +8942,20 @@
                           <a:ea typeface="Calibri" pitchFamily="34" charset="-122"/>
                           <a:cs typeface="Calibri" pitchFamily="34" charset="-120"/>
                         </a:rPr>
-                        <a:t>Audit cycle</a:t>
-                      </a:r>
-                      <a:endParaRPr lang="en-US" sz="1200" dirty="0">
-                        <a:latin typeface="Calibri" charset="0"/>
-                        <a:ea typeface="Calibri" charset="0"/>
-                        <a:cs typeface="Calibri" charset="0"/>
-                      </a:endParaRPr>
-                    </a:p>
-                    <a:p>
-                      <a:pPr indent="0" marL="0">
-                        <a:buNone/>
-                      </a:pPr>
-                      <a:r>
-                        <a:rPr lang="en-US" sz="1100" dirty="0">
+                        <a:t>CooLinens Pillowcase</a:t>
+                      </a:r>
+                      <a:endParaRPr lang="en-US" sz="1150" dirty="0">
+                        <a:latin typeface="Calibri" charset="0"/>
+                        <a:ea typeface="Calibri" charset="0"/>
+                        <a:cs typeface="Calibri" charset="0"/>
+                      </a:endParaRPr>
+                    </a:p>
+                    <a:p>
+                      <a:pPr indent="0" marL="0">
+                        <a:buNone/>
+                      </a:pPr>
+                      <a:r>
+                        <a:rPr lang="en-US" sz="1050" dirty="0">
                           <a:solidFill>
                             <a:srgbClr val="4E5A64"/>
                           </a:solidFill>
@@ -8963,46 +8963,46 @@
                           <a:ea typeface="Calibri" pitchFamily="34" charset="-122"/>
                           <a:cs typeface="Calibri" pitchFamily="34" charset="-120"/>
                         </a:rPr>
-                        <a:t>All three</a:t>
-                      </a:r>
-                      <a:endParaRPr lang="en-US" sz="1200" dirty="0">
-                        <a:latin typeface="Calibri" charset="0"/>
-                        <a:ea typeface="Calibri" charset="0"/>
-                        <a:cs typeface="Calibri" charset="0"/>
-                      </a:endParaRPr>
-                    </a:p>
-                  </a:txBody>
-                  <a:tcPr marL="64008" marR="64008" marT="73152" marB="73152" anchor="ctr">
-                    <a:lnL w="0" cap="flat" cmpd="sng" algn="ctr">
-                      <a:noFill/>
-                    </a:lnL>
-                    <a:lnR w="0" cap="flat" cmpd="sng" algn="ctr">
-                      <a:noFill/>
-                    </a:lnR>
-                    <a:lnT w="0" cap="flat" cmpd="sng" algn="ctr">
-                      <a:noFill/>
-                    </a:lnT>
-                    <a:lnB w="9525" cap="flat" cmpd="sng" algn="ctr">
-                      <a:solidFill>
-                        <a:srgbClr val="BFCAD3"/>
-                      </a:solidFill>
-                      <a:prstDash val="solid"/>
-                      <a:round/>
-                      <a:headEnd type="none" w="med" len="med"/>
-                      <a:tailEnd type="none" w="med" len="med"/>
-                    </a:lnB>
-                  </a:tcPr>
-                </a:tc>
-                <a:tc>
-                  <a:txBody>
-                    <a:bodyPr/>
-                    <a:lstStyle/>
-                    <a:p>
-                      <a:pPr indent="0" marL="0">
-                        <a:buNone/>
-                      </a:pPr>
-                      <a:r>
-                        <a:rPr lang="en-US" sz="1200" dirty="0">
+                        <a:t>Shayan T</a:t>
+                      </a:r>
+                      <a:endParaRPr lang="en-US" sz="1150" dirty="0">
+                        <a:latin typeface="Calibri" charset="0"/>
+                        <a:ea typeface="Calibri" charset="0"/>
+                        <a:cs typeface="Calibri" charset="0"/>
+                      </a:endParaRPr>
+                    </a:p>
+                  </a:txBody>
+                  <a:tcPr marL="64008" marR="64008" marT="73152" marB="73152" anchor="ctr">
+                    <a:lnL w="0" cap="flat" cmpd="sng" algn="ctr">
+                      <a:noFill/>
+                    </a:lnL>
+                    <a:lnR w="0" cap="flat" cmpd="sng" algn="ctr">
+                      <a:noFill/>
+                    </a:lnR>
+                    <a:lnT w="0" cap="flat" cmpd="sng" algn="ctr">
+                      <a:noFill/>
+                    </a:lnT>
+                    <a:lnB w="9525" cap="flat" cmpd="sng" algn="ctr">
+                      <a:solidFill>
+                        <a:srgbClr val="BFCAD3"/>
+                      </a:solidFill>
+                      <a:prstDash val="solid"/>
+                      <a:round/>
+                      <a:headEnd type="none" w="med" len="med"/>
+                      <a:tailEnd type="none" w="med" len="med"/>
+                    </a:lnB>
+                  </a:tcPr>
+                </a:tc>
+                <a:tc>
+                  <a:txBody>
+                    <a:bodyPr/>
+                    <a:lstStyle/>
+                    <a:p>
+                      <a:pPr indent="0" marL="0">
+                        <a:buNone/>
+                      </a:pPr>
+                      <a:r>
+                        <a:rPr lang="en-US" sz="1150" dirty="0">
                           <a:solidFill>
                             <a:srgbClr val="111C24"/>
                           </a:solidFill>
@@ -9010,46 +9010,46 @@
                           <a:ea typeface="Calibri" pitchFamily="34" charset="-122"/>
                           <a:cs typeface="Calibri" pitchFamily="34" charset="-120"/>
                         </a:rPr>
-                        <a:t>Close Bamboo Fitted, Cooling Fitted and Cooling Sheets 4-PC, then run the next cycle on all nine</a:t>
-                      </a:r>
-                      <a:endParaRPr lang="en-US" sz="1200" dirty="0">
-                        <a:latin typeface="Calibri" charset="0"/>
-                        <a:ea typeface="Calibri" charset="0"/>
-                        <a:cs typeface="Calibri" charset="0"/>
-                      </a:endParaRPr>
-                    </a:p>
-                  </a:txBody>
-                  <a:tcPr marL="64008" marR="64008" marT="73152" marB="73152" anchor="ctr">
-                    <a:lnL w="0" cap="flat" cmpd="sng" algn="ctr">
-                      <a:noFill/>
-                    </a:lnL>
-                    <a:lnR w="0" cap="flat" cmpd="sng" algn="ctr">
-                      <a:noFill/>
-                    </a:lnR>
-                    <a:lnT w="0" cap="flat" cmpd="sng" algn="ctr">
-                      <a:noFill/>
-                    </a:lnT>
-                    <a:lnB w="9525" cap="flat" cmpd="sng" algn="ctr">
-                      <a:solidFill>
-                        <a:srgbClr val="BFCAD3"/>
-                      </a:solidFill>
-                      <a:prstDash val="solid"/>
-                      <a:round/>
-                      <a:headEnd type="none" w="med" len="med"/>
-                      <a:tailEnd type="none" w="med" len="med"/>
-                    </a:lnB>
-                  </a:tcPr>
-                </a:tc>
-                <a:tc>
-                  <a:txBody>
-                    <a:bodyPr/>
-                    <a:lstStyle/>
-                    <a:p>
-                      <a:pPr indent="0" marL="0">
-                        <a:buNone/>
-                      </a:pPr>
-                      <a:r>
-                        <a:rPr lang="en-US" sz="1200" dirty="0">
+                        <a:t>First live week: daily spend, search-term and conversion checks, PAT additions from Shayan R, launch read at the Friday close</a:t>
+                      </a:r>
+                      <a:endParaRPr lang="en-US" sz="1150" dirty="0">
+                        <a:latin typeface="Calibri" charset="0"/>
+                        <a:ea typeface="Calibri" charset="0"/>
+                        <a:cs typeface="Calibri" charset="0"/>
+                      </a:endParaRPr>
+                    </a:p>
+                  </a:txBody>
+                  <a:tcPr marL="64008" marR="64008" marT="73152" marB="73152" anchor="ctr">
+                    <a:lnL w="0" cap="flat" cmpd="sng" algn="ctr">
+                      <a:noFill/>
+                    </a:lnL>
+                    <a:lnR w="0" cap="flat" cmpd="sng" algn="ctr">
+                      <a:noFill/>
+                    </a:lnR>
+                    <a:lnT w="0" cap="flat" cmpd="sng" algn="ctr">
+                      <a:noFill/>
+                    </a:lnT>
+                    <a:lnB w="9525" cap="flat" cmpd="sng" algn="ctr">
+                      <a:solidFill>
+                        <a:srgbClr val="BFCAD3"/>
+                      </a:solidFill>
+                      <a:prstDash val="solid"/>
+                      <a:round/>
+                      <a:headEnd type="none" w="med" len="med"/>
+                      <a:tailEnd type="none" w="med" len="med"/>
+                    </a:lnB>
+                  </a:tcPr>
+                </a:tc>
+                <a:tc>
+                  <a:txBody>
+                    <a:bodyPr/>
+                    <a:lstStyle/>
+                    <a:p>
+                      <a:pPr indent="0" marL="0">
+                        <a:buNone/>
+                      </a:pPr>
+                      <a:r>
+                        <a:rPr lang="en-US" sz="1150" dirty="0">
                           <a:solidFill>
                             <a:srgbClr val="111C24"/>
                           </a:solidFill>
@@ -9057,46 +9057,46 @@
                           <a:ea typeface="Calibri" pitchFamily="34" charset="-122"/>
                           <a:cs typeface="Calibri" pitchFamily="34" charset="-120"/>
                         </a:rPr>
-                        <a:t>Mon, Oct 5</a:t>
-                      </a:r>
-                      <a:endParaRPr lang="en-US" sz="1200" dirty="0">
-                        <a:latin typeface="Calibri" charset="0"/>
-                        <a:ea typeface="Calibri" charset="0"/>
-                        <a:cs typeface="Calibri" charset="0"/>
-                      </a:endParaRPr>
-                    </a:p>
-                  </a:txBody>
-                  <a:tcPr marL="64008" marR="64008" marT="73152" marB="73152" anchor="ctr">
-                    <a:lnL w="0" cap="flat" cmpd="sng" algn="ctr">
-                      <a:noFill/>
-                    </a:lnL>
-                    <a:lnR w="0" cap="flat" cmpd="sng" algn="ctr">
-                      <a:noFill/>
-                    </a:lnR>
-                    <a:lnT w="0" cap="flat" cmpd="sng" algn="ctr">
-                      <a:noFill/>
-                    </a:lnT>
-                    <a:lnB w="9525" cap="flat" cmpd="sng" algn="ctr">
-                      <a:solidFill>
-                        <a:srgbClr val="BFCAD3"/>
-                      </a:solidFill>
-                      <a:prstDash val="solid"/>
-                      <a:round/>
-                      <a:headEnd type="none" w="med" len="med"/>
-                      <a:tailEnd type="none" w="med" len="med"/>
-                    </a:lnB>
-                  </a:tcPr>
-                </a:tc>
-                <a:tc>
-                  <a:txBody>
-                    <a:bodyPr/>
-                    <a:lstStyle/>
-                    <a:p>
-                      <a:pPr indent="0" marL="0">
-                        <a:buNone/>
-                      </a:pPr>
-                      <a:r>
-                        <a:rPr lang="en-US" sz="1200" dirty="0">
+                        <a:t>Daily · read Fri, Oct 9</a:t>
+                      </a:r>
+                      <a:endParaRPr lang="en-US" sz="1150" dirty="0">
+                        <a:latin typeface="Calibri" charset="0"/>
+                        <a:ea typeface="Calibri" charset="0"/>
+                        <a:cs typeface="Calibri" charset="0"/>
+                      </a:endParaRPr>
+                    </a:p>
+                  </a:txBody>
+                  <a:tcPr marL="64008" marR="64008" marT="73152" marB="73152" anchor="ctr">
+                    <a:lnL w="0" cap="flat" cmpd="sng" algn="ctr">
+                      <a:noFill/>
+                    </a:lnL>
+                    <a:lnR w="0" cap="flat" cmpd="sng" algn="ctr">
+                      <a:noFill/>
+                    </a:lnR>
+                    <a:lnT w="0" cap="flat" cmpd="sng" algn="ctr">
+                      <a:noFill/>
+                    </a:lnT>
+                    <a:lnB w="9525" cap="flat" cmpd="sng" algn="ctr">
+                      <a:solidFill>
+                        <a:srgbClr val="BFCAD3"/>
+                      </a:solidFill>
+                      <a:prstDash val="solid"/>
+                      <a:round/>
+                      <a:headEnd type="none" w="med" len="med"/>
+                      <a:tailEnd type="none" w="med" len="med"/>
+                    </a:lnB>
+                  </a:tcPr>
+                </a:tc>
+                <a:tc>
+                  <a:txBody>
+                    <a:bodyPr/>
+                    <a:lstStyle/>
+                    <a:p>
+                      <a:pPr indent="0" marL="0">
+                        <a:buNone/>
+                      </a:pPr>
+                      <a:r>
+                        <a:rPr lang="en-US" sz="1150" dirty="0">
                           <a:solidFill>
                             <a:srgbClr val="111C24"/>
                           </a:solidFill>
@@ -9106,44 +9106,44 @@
                         </a:rPr>
                         <a:t>P0</a:t>
                       </a:r>
-                      <a:endParaRPr lang="en-US" sz="1200" dirty="0">
-                        <a:latin typeface="Calibri" charset="0"/>
-                        <a:ea typeface="Calibri" charset="0"/>
-                        <a:cs typeface="Calibri" charset="0"/>
-                      </a:endParaRPr>
-                    </a:p>
-                  </a:txBody>
-                  <a:tcPr marL="64008" marR="64008" marT="73152" marB="73152" anchor="ctr">
-                    <a:lnL w="0" cap="flat" cmpd="sng" algn="ctr">
-                      <a:noFill/>
-                    </a:lnL>
-                    <a:lnR w="0" cap="flat" cmpd="sng" algn="ctr">
-                      <a:noFill/>
-                    </a:lnR>
-                    <a:lnT w="0" cap="flat" cmpd="sng" algn="ctr">
-                      <a:noFill/>
-                    </a:lnT>
-                    <a:lnB w="9525" cap="flat" cmpd="sng" algn="ctr">
-                      <a:solidFill>
-                        <a:srgbClr val="BFCAD3"/>
-                      </a:solidFill>
-                      <a:prstDash val="solid"/>
-                      <a:round/>
-                      <a:headEnd type="none" w="med" len="med"/>
-                      <a:tailEnd type="none" w="med" len="med"/>
-                    </a:lnB>
-                  </a:tcPr>
-                </a:tc>
-                <a:tc>
-                  <a:txBody>
-                    <a:bodyPr/>
-                    <a:lstStyle/>
-                    <a:p>
-                      <a:pPr indent="0" marL="0">
-                        <a:buNone/>
-                      </a:pPr>
-                      <a:r>
-                        <a:rPr lang="en-US" sz="1200" dirty="0">
+                      <a:endParaRPr lang="en-US" sz="1150" dirty="0">
+                        <a:latin typeface="Calibri" charset="0"/>
+                        <a:ea typeface="Calibri" charset="0"/>
+                        <a:cs typeface="Calibri" charset="0"/>
+                      </a:endParaRPr>
+                    </a:p>
+                  </a:txBody>
+                  <a:tcPr marL="64008" marR="64008" marT="73152" marB="73152" anchor="ctr">
+                    <a:lnL w="0" cap="flat" cmpd="sng" algn="ctr">
+                      <a:noFill/>
+                    </a:lnL>
+                    <a:lnR w="0" cap="flat" cmpd="sng" algn="ctr">
+                      <a:noFill/>
+                    </a:lnR>
+                    <a:lnT w="0" cap="flat" cmpd="sng" algn="ctr">
+                      <a:noFill/>
+                    </a:lnT>
+                    <a:lnB w="9525" cap="flat" cmpd="sng" algn="ctr">
+                      <a:solidFill>
+                        <a:srgbClr val="BFCAD3"/>
+                      </a:solidFill>
+                      <a:prstDash val="solid"/>
+                      <a:round/>
+                      <a:headEnd type="none" w="med" len="med"/>
+                      <a:tailEnd type="none" w="med" len="med"/>
+                    </a:lnB>
+                  </a:tcPr>
+                </a:tc>
+                <a:tc>
+                  <a:txBody>
+                    <a:bodyPr/>
+                    <a:lstStyle/>
+                    <a:p>
+                      <a:pPr indent="0" marL="0">
+                        <a:buNone/>
+                      </a:pPr>
+                      <a:r>
+                        <a:rPr lang="en-US" sz="1150" dirty="0">
                           <a:solidFill>
                             <a:srgbClr val="111C24"/>
                           </a:solidFill>
@@ -9151,9 +9151,9 @@
                           <a:ea typeface="Calibri" pitchFamily="34" charset="-122"/>
                           <a:cs typeface="Calibri" pitchFamily="34" charset="-120"/>
                         </a:rPr>
-                        <a:t>Y — since Sep 28</a:t>
-                      </a:r>
-                      <a:endParaRPr lang="en-US" sz="1200" dirty="0">
+                        <a:t>N — new</a:t>
+                      </a:r>
+                      <a:endParaRPr lang="en-US" sz="1150" dirty="0">
                         <a:latin typeface="Calibri" charset="0"/>
                         <a:ea typeface="Calibri" charset="0"/>
                         <a:cs typeface="Calibri" charset="0"/>
@@ -9192,7 +9192,7 @@
                         <a:buNone/>
                       </a:pPr>
                       <a:r>
-                        <a:rPr lang="en-US" sz="1200" b="1" dirty="0">
+                        <a:rPr lang="en-US" sz="1150" b="1" dirty="0">
                           <a:solidFill>
                             <a:srgbClr val="111C24"/>
                           </a:solidFill>
@@ -9200,20 +9200,20 @@
                           <a:ea typeface="Calibri" pitchFamily="34" charset="-122"/>
                           <a:cs typeface="Calibri" pitchFamily="34" charset="-120"/>
                         </a:rPr>
-                        <a:t>Engine register</a:t>
-                      </a:r>
-                      <a:endParaRPr lang="en-US" sz="1200" dirty="0">
-                        <a:latin typeface="Calibri" charset="0"/>
-                        <a:ea typeface="Calibri" charset="0"/>
-                        <a:cs typeface="Calibri" charset="0"/>
-                      </a:endParaRPr>
-                    </a:p>
-                    <a:p>
-                      <a:pPr indent="0" marL="0">
-                        <a:buNone/>
-                      </a:pPr>
-                      <a:r>
-                        <a:rPr lang="en-US" sz="1100" dirty="0">
+                        <a:t>Audit cycle</a:t>
+                      </a:r>
+                      <a:endParaRPr lang="en-US" sz="1150" dirty="0">
+                        <a:latin typeface="Calibri" charset="0"/>
+                        <a:ea typeface="Calibri" charset="0"/>
+                        <a:cs typeface="Calibri" charset="0"/>
+                      </a:endParaRPr>
+                    </a:p>
+                    <a:p>
+                      <a:pPr indent="0" marL="0">
+                        <a:buNone/>
+                      </a:pPr>
+                      <a:r>
+                        <a:rPr lang="en-US" sz="1050" dirty="0">
                           <a:solidFill>
                             <a:srgbClr val="4E5A64"/>
                           </a:solidFill>
@@ -9221,46 +9221,46 @@
                           <a:ea typeface="Calibri" pitchFamily="34" charset="-122"/>
                           <a:cs typeface="Calibri" pitchFamily="34" charset="-120"/>
                         </a:rPr>
-                        <a:t>Zarlish</a:t>
-                      </a:r>
-                      <a:endParaRPr lang="en-US" sz="1200" dirty="0">
-                        <a:latin typeface="Calibri" charset="0"/>
-                        <a:ea typeface="Calibri" charset="0"/>
-                        <a:cs typeface="Calibri" charset="0"/>
-                      </a:endParaRPr>
-                    </a:p>
-                  </a:txBody>
-                  <a:tcPr marL="64008" marR="64008" marT="73152" marB="73152" anchor="ctr">
-                    <a:lnL w="0" cap="flat" cmpd="sng" algn="ctr">
-                      <a:noFill/>
-                    </a:lnL>
-                    <a:lnR w="0" cap="flat" cmpd="sng" algn="ctr">
-                      <a:noFill/>
-                    </a:lnR>
-                    <a:lnT w="0" cap="flat" cmpd="sng" algn="ctr">
-                      <a:noFill/>
-                    </a:lnT>
-                    <a:lnB w="9525" cap="flat" cmpd="sng" algn="ctr">
-                      <a:solidFill>
-                        <a:srgbClr val="BFCAD3"/>
-                      </a:solidFill>
-                      <a:prstDash val="solid"/>
-                      <a:round/>
-                      <a:headEnd type="none" w="med" len="med"/>
-                      <a:tailEnd type="none" w="med" len="med"/>
-                    </a:lnB>
-                  </a:tcPr>
-                </a:tc>
-                <a:tc>
-                  <a:txBody>
-                    <a:bodyPr/>
-                    <a:lstStyle/>
-                    <a:p>
-                      <a:pPr indent="0" marL="0">
-                        <a:buNone/>
-                      </a:pPr>
-                      <a:r>
-                        <a:rPr lang="en-US" sz="1200" dirty="0">
+                        <a:t>All three</a:t>
+                      </a:r>
+                      <a:endParaRPr lang="en-US" sz="1150" dirty="0">
+                        <a:latin typeface="Calibri" charset="0"/>
+                        <a:ea typeface="Calibri" charset="0"/>
+                        <a:cs typeface="Calibri" charset="0"/>
+                      </a:endParaRPr>
+                    </a:p>
+                  </a:txBody>
+                  <a:tcPr marL="64008" marR="64008" marT="73152" marB="73152" anchor="ctr">
+                    <a:lnL w="0" cap="flat" cmpd="sng" algn="ctr">
+                      <a:noFill/>
+                    </a:lnL>
+                    <a:lnR w="0" cap="flat" cmpd="sng" algn="ctr">
+                      <a:noFill/>
+                    </a:lnR>
+                    <a:lnT w="0" cap="flat" cmpd="sng" algn="ctr">
+                      <a:noFill/>
+                    </a:lnT>
+                    <a:lnB w="9525" cap="flat" cmpd="sng" algn="ctr">
+                      <a:solidFill>
+                        <a:srgbClr val="BFCAD3"/>
+                      </a:solidFill>
+                      <a:prstDash val="solid"/>
+                      <a:round/>
+                      <a:headEnd type="none" w="med" len="med"/>
+                      <a:tailEnd type="none" w="med" len="med"/>
+                    </a:lnB>
+                  </a:tcPr>
+                </a:tc>
+                <a:tc>
+                  <a:txBody>
+                    <a:bodyPr/>
+                    <a:lstStyle/>
+                    <a:p>
+                      <a:pPr indent="0" marL="0">
+                        <a:buNone/>
+                      </a:pPr>
+                      <a:r>
+                        <a:rPr lang="en-US" sz="1150" dirty="0">
                           <a:solidFill>
                             <a:srgbClr val="111C24"/>
                           </a:solidFill>
@@ -9268,46 +9268,46 @@
                           <a:ea typeface="Calibri" pitchFamily="34" charset="-122"/>
                           <a:cs typeface="Calibri" pitchFamily="34" charset="-120"/>
                         </a:rPr>
-                        <a:t>Move the register to changed-findings-only and get Section 7, Q1 and Q3 signed off</a:t>
-                      </a:r>
-                      <a:endParaRPr lang="en-US" sz="1200" dirty="0">
-                        <a:latin typeface="Calibri" charset="0"/>
-                        <a:ea typeface="Calibri" charset="0"/>
-                        <a:cs typeface="Calibri" charset="0"/>
-                      </a:endParaRPr>
-                    </a:p>
-                  </a:txBody>
-                  <a:tcPr marL="64008" marR="64008" marT="73152" marB="73152" anchor="ctr">
-                    <a:lnL w="0" cap="flat" cmpd="sng" algn="ctr">
-                      <a:noFill/>
-                    </a:lnL>
-                    <a:lnR w="0" cap="flat" cmpd="sng" algn="ctr">
-                      <a:noFill/>
-                    </a:lnR>
-                    <a:lnT w="0" cap="flat" cmpd="sng" algn="ctr">
-                      <a:noFill/>
-                    </a:lnT>
-                    <a:lnB w="9525" cap="flat" cmpd="sng" algn="ctr">
-                      <a:solidFill>
-                        <a:srgbClr val="BFCAD3"/>
-                      </a:solidFill>
-                      <a:prstDash val="solid"/>
-                      <a:round/>
-                      <a:headEnd type="none" w="med" len="med"/>
-                      <a:tailEnd type="none" w="med" len="med"/>
-                    </a:lnB>
-                  </a:tcPr>
-                </a:tc>
-                <a:tc>
-                  <a:txBody>
-                    <a:bodyPr/>
-                    <a:lstStyle/>
-                    <a:p>
-                      <a:pPr indent="0" marL="0">
-                        <a:buNone/>
-                      </a:pPr>
-                      <a:r>
-                        <a:rPr lang="en-US" sz="1200" dirty="0">
+                        <a:t>Close Bamboo Fitted, Cooling Fitted and Cooling Sheets 4-PC, then run the next cycle on all nine</a:t>
+                      </a:r>
+                      <a:endParaRPr lang="en-US" sz="1150" dirty="0">
+                        <a:latin typeface="Calibri" charset="0"/>
+                        <a:ea typeface="Calibri" charset="0"/>
+                        <a:cs typeface="Calibri" charset="0"/>
+                      </a:endParaRPr>
+                    </a:p>
+                  </a:txBody>
+                  <a:tcPr marL="64008" marR="64008" marT="73152" marB="73152" anchor="ctr">
+                    <a:lnL w="0" cap="flat" cmpd="sng" algn="ctr">
+                      <a:noFill/>
+                    </a:lnL>
+                    <a:lnR w="0" cap="flat" cmpd="sng" algn="ctr">
+                      <a:noFill/>
+                    </a:lnR>
+                    <a:lnT w="0" cap="flat" cmpd="sng" algn="ctr">
+                      <a:noFill/>
+                    </a:lnT>
+                    <a:lnB w="9525" cap="flat" cmpd="sng" algn="ctr">
+                      <a:solidFill>
+                        <a:srgbClr val="BFCAD3"/>
+                      </a:solidFill>
+                      <a:prstDash val="solid"/>
+                      <a:round/>
+                      <a:headEnd type="none" w="med" len="med"/>
+                      <a:tailEnd type="none" w="med" len="med"/>
+                    </a:lnB>
+                  </a:tcPr>
+                </a:tc>
+                <a:tc>
+                  <a:txBody>
+                    <a:bodyPr/>
+                    <a:lstStyle/>
+                    <a:p>
+                      <a:pPr indent="0" marL="0">
+                        <a:buNone/>
+                      </a:pPr>
+                      <a:r>
+                        <a:rPr lang="en-US" sz="1150" dirty="0">
                           <a:solidFill>
                             <a:srgbClr val="111C24"/>
                           </a:solidFill>
@@ -9317,44 +9317,44 @@
                         </a:rPr>
                         <a:t>Mon, Oct 5</a:t>
                       </a:r>
-                      <a:endParaRPr lang="en-US" sz="1200" dirty="0">
-                        <a:latin typeface="Calibri" charset="0"/>
-                        <a:ea typeface="Calibri" charset="0"/>
-                        <a:cs typeface="Calibri" charset="0"/>
-                      </a:endParaRPr>
-                    </a:p>
-                  </a:txBody>
-                  <a:tcPr marL="64008" marR="64008" marT="73152" marB="73152" anchor="ctr">
-                    <a:lnL w="0" cap="flat" cmpd="sng" algn="ctr">
-                      <a:noFill/>
-                    </a:lnL>
-                    <a:lnR w="0" cap="flat" cmpd="sng" algn="ctr">
-                      <a:noFill/>
-                    </a:lnR>
-                    <a:lnT w="0" cap="flat" cmpd="sng" algn="ctr">
-                      <a:noFill/>
-                    </a:lnT>
-                    <a:lnB w="9525" cap="flat" cmpd="sng" algn="ctr">
-                      <a:solidFill>
-                        <a:srgbClr val="BFCAD3"/>
-                      </a:solidFill>
-                      <a:prstDash val="solid"/>
-                      <a:round/>
-                      <a:headEnd type="none" w="med" len="med"/>
-                      <a:tailEnd type="none" w="med" len="med"/>
-                    </a:lnB>
-                  </a:tcPr>
-                </a:tc>
-                <a:tc>
-                  <a:txBody>
-                    <a:bodyPr/>
-                    <a:lstStyle/>
-                    <a:p>
-                      <a:pPr indent="0" marL="0">
-                        <a:buNone/>
-                      </a:pPr>
-                      <a:r>
-                        <a:rPr lang="en-US" sz="1200" dirty="0">
+                      <a:endParaRPr lang="en-US" sz="1150" dirty="0">
+                        <a:latin typeface="Calibri" charset="0"/>
+                        <a:ea typeface="Calibri" charset="0"/>
+                        <a:cs typeface="Calibri" charset="0"/>
+                      </a:endParaRPr>
+                    </a:p>
+                  </a:txBody>
+                  <a:tcPr marL="64008" marR="64008" marT="73152" marB="73152" anchor="ctr">
+                    <a:lnL w="0" cap="flat" cmpd="sng" algn="ctr">
+                      <a:noFill/>
+                    </a:lnL>
+                    <a:lnR w="0" cap="flat" cmpd="sng" algn="ctr">
+                      <a:noFill/>
+                    </a:lnR>
+                    <a:lnT w="0" cap="flat" cmpd="sng" algn="ctr">
+                      <a:noFill/>
+                    </a:lnT>
+                    <a:lnB w="9525" cap="flat" cmpd="sng" algn="ctr">
+                      <a:solidFill>
+                        <a:srgbClr val="BFCAD3"/>
+                      </a:solidFill>
+                      <a:prstDash val="solid"/>
+                      <a:round/>
+                      <a:headEnd type="none" w="med" len="med"/>
+                      <a:tailEnd type="none" w="med" len="med"/>
+                    </a:lnB>
+                  </a:tcPr>
+                </a:tc>
+                <a:tc>
+                  <a:txBody>
+                    <a:bodyPr/>
+                    <a:lstStyle/>
+                    <a:p>
+                      <a:pPr indent="0" marL="0">
+                        <a:buNone/>
+                      </a:pPr>
+                      <a:r>
+                        <a:rPr lang="en-US" sz="1150" dirty="0">
                           <a:solidFill>
                             <a:srgbClr val="111C24"/>
                           </a:solidFill>
@@ -9364,44 +9364,44 @@
                         </a:rPr>
                         <a:t>P0</a:t>
                       </a:r>
-                      <a:endParaRPr lang="en-US" sz="1200" dirty="0">
-                        <a:latin typeface="Calibri" charset="0"/>
-                        <a:ea typeface="Calibri" charset="0"/>
-                        <a:cs typeface="Calibri" charset="0"/>
-                      </a:endParaRPr>
-                    </a:p>
-                  </a:txBody>
-                  <a:tcPr marL="64008" marR="64008" marT="73152" marB="73152" anchor="ctr">
-                    <a:lnL w="0" cap="flat" cmpd="sng" algn="ctr">
-                      <a:noFill/>
-                    </a:lnL>
-                    <a:lnR w="0" cap="flat" cmpd="sng" algn="ctr">
-                      <a:noFill/>
-                    </a:lnR>
-                    <a:lnT w="0" cap="flat" cmpd="sng" algn="ctr">
-                      <a:noFill/>
-                    </a:lnT>
-                    <a:lnB w="9525" cap="flat" cmpd="sng" algn="ctr">
-                      <a:solidFill>
-                        <a:srgbClr val="BFCAD3"/>
-                      </a:solidFill>
-                      <a:prstDash val="solid"/>
-                      <a:round/>
-                      <a:headEnd type="none" w="med" len="med"/>
-                      <a:tailEnd type="none" w="med" len="med"/>
-                    </a:lnB>
-                  </a:tcPr>
-                </a:tc>
-                <a:tc>
-                  <a:txBody>
-                    <a:bodyPr/>
-                    <a:lstStyle/>
-                    <a:p>
-                      <a:pPr indent="0" marL="0">
-                        <a:buNone/>
-                      </a:pPr>
-                      <a:r>
-                        <a:rPr lang="en-US" sz="1200" dirty="0">
+                      <a:endParaRPr lang="en-US" sz="1150" dirty="0">
+                        <a:latin typeface="Calibri" charset="0"/>
+                        <a:ea typeface="Calibri" charset="0"/>
+                        <a:cs typeface="Calibri" charset="0"/>
+                      </a:endParaRPr>
+                    </a:p>
+                  </a:txBody>
+                  <a:tcPr marL="64008" marR="64008" marT="73152" marB="73152" anchor="ctr">
+                    <a:lnL w="0" cap="flat" cmpd="sng" algn="ctr">
+                      <a:noFill/>
+                    </a:lnL>
+                    <a:lnR w="0" cap="flat" cmpd="sng" algn="ctr">
+                      <a:noFill/>
+                    </a:lnR>
+                    <a:lnT w="0" cap="flat" cmpd="sng" algn="ctr">
+                      <a:noFill/>
+                    </a:lnT>
+                    <a:lnB w="9525" cap="flat" cmpd="sng" algn="ctr">
+                      <a:solidFill>
+                        <a:srgbClr val="BFCAD3"/>
+                      </a:solidFill>
+                      <a:prstDash val="solid"/>
+                      <a:round/>
+                      <a:headEnd type="none" w="med" len="med"/>
+                      <a:tailEnd type="none" w="med" len="med"/>
+                    </a:lnB>
+                  </a:tcPr>
+                </a:tc>
+                <a:tc>
+                  <a:txBody>
+                    <a:bodyPr/>
+                    <a:lstStyle/>
+                    <a:p>
+                      <a:pPr indent="0" marL="0">
+                        <a:buNone/>
+                      </a:pPr>
+                      <a:r>
+                        <a:rPr lang="en-US" sz="1150" dirty="0">
                           <a:solidFill>
                             <a:srgbClr val="111C24"/>
                           </a:solidFill>
@@ -9409,9 +9409,9 @@
                           <a:ea typeface="Calibri" pitchFamily="34" charset="-122"/>
                           <a:cs typeface="Calibri" pitchFamily="34" charset="-120"/>
                         </a:rPr>
-                        <a:t>Y — since Oct 2</a:t>
-                      </a:r>
-                      <a:endParaRPr lang="en-US" sz="1200" dirty="0">
+                        <a:t>Y — since Sep 28</a:t>
+                      </a:r>
+                      <a:endParaRPr lang="en-US" sz="1150" dirty="0">
                         <a:latin typeface="Calibri" charset="0"/>
                         <a:ea typeface="Calibri" charset="0"/>
                         <a:cs typeface="Calibri" charset="0"/>
@@ -9450,7 +9450,7 @@
                         <a:buNone/>
                       </a:pPr>
                       <a:r>
-                        <a:rPr lang="en-US" sz="1200" b="1" dirty="0">
+                        <a:rPr lang="en-US" sz="1150" b="1" dirty="0">
                           <a:solidFill>
                             <a:srgbClr val="111C24"/>
                           </a:solidFill>
@@ -9458,20 +9458,20 @@
                           <a:ea typeface="Calibri" pitchFamily="34" charset="-122"/>
                           <a:cs typeface="Calibri" pitchFamily="34" charset="-120"/>
                         </a:rPr>
-                        <a:t>Other campaign types</a:t>
-                      </a:r>
-                      <a:endParaRPr lang="en-US" sz="1200" dirty="0">
-                        <a:latin typeface="Calibri" charset="0"/>
-                        <a:ea typeface="Calibri" charset="0"/>
-                        <a:cs typeface="Calibri" charset="0"/>
-                      </a:endParaRPr>
-                    </a:p>
-                    <a:p>
-                      <a:pPr indent="0" marL="0">
-                        <a:buNone/>
-                      </a:pPr>
-                      <a:r>
-                        <a:rPr lang="en-US" sz="1100" dirty="0">
+                        <a:t>Engine register</a:t>
+                      </a:r>
+                      <a:endParaRPr lang="en-US" sz="1150" dirty="0">
+                        <a:latin typeface="Calibri" charset="0"/>
+                        <a:ea typeface="Calibri" charset="0"/>
+                        <a:cs typeface="Calibri" charset="0"/>
+                      </a:endParaRPr>
+                    </a:p>
+                    <a:p>
+                      <a:pPr indent="0" marL="0">
+                        <a:buNone/>
+                      </a:pPr>
+                      <a:r>
+                        <a:rPr lang="en-US" sz="1050" dirty="0">
                           <a:solidFill>
                             <a:srgbClr val="4E5A64"/>
                           </a:solidFill>
@@ -9479,46 +9479,46 @@
                           <a:ea typeface="Calibri" pitchFamily="34" charset="-122"/>
                           <a:cs typeface="Calibri" pitchFamily="34" charset="-120"/>
                         </a:rPr>
-                        <a:t>Shayan T</a:t>
-                      </a:r>
-                      <a:endParaRPr lang="en-US" sz="1200" dirty="0">
-                        <a:latin typeface="Calibri" charset="0"/>
-                        <a:ea typeface="Calibri" charset="0"/>
-                        <a:cs typeface="Calibri" charset="0"/>
-                      </a:endParaRPr>
-                    </a:p>
-                  </a:txBody>
-                  <a:tcPr marL="64008" marR="64008" marT="73152" marB="73152" anchor="ctr">
-                    <a:lnL w="0" cap="flat" cmpd="sng" algn="ctr">
-                      <a:noFill/>
-                    </a:lnL>
-                    <a:lnR w="0" cap="flat" cmpd="sng" algn="ctr">
-                      <a:noFill/>
-                    </a:lnR>
-                    <a:lnT w="0" cap="flat" cmpd="sng" algn="ctr">
-                      <a:noFill/>
-                    </a:lnT>
-                    <a:lnB w="9525" cap="flat" cmpd="sng" algn="ctr">
-                      <a:solidFill>
-                        <a:srgbClr val="BFCAD3"/>
-                      </a:solidFill>
-                      <a:prstDash val="solid"/>
-                      <a:round/>
-                      <a:headEnd type="none" w="med" len="med"/>
-                      <a:tailEnd type="none" w="med" len="med"/>
-                    </a:lnB>
-                  </a:tcPr>
-                </a:tc>
-                <a:tc>
-                  <a:txBody>
-                    <a:bodyPr/>
-                    <a:lstStyle/>
-                    <a:p>
-                      <a:pPr indent="0" marL="0">
-                        <a:buNone/>
-                      </a:pPr>
-                      <a:r>
-                        <a:rPr lang="en-US" sz="1200" dirty="0">
+                        <a:t>Zarlish</a:t>
+                      </a:r>
+                      <a:endParaRPr lang="en-US" sz="1150" dirty="0">
+                        <a:latin typeface="Calibri" charset="0"/>
+                        <a:ea typeface="Calibri" charset="0"/>
+                        <a:cs typeface="Calibri" charset="0"/>
+                      </a:endParaRPr>
+                    </a:p>
+                  </a:txBody>
+                  <a:tcPr marL="64008" marR="64008" marT="73152" marB="73152" anchor="ctr">
+                    <a:lnL w="0" cap="flat" cmpd="sng" algn="ctr">
+                      <a:noFill/>
+                    </a:lnL>
+                    <a:lnR w="0" cap="flat" cmpd="sng" algn="ctr">
+                      <a:noFill/>
+                    </a:lnR>
+                    <a:lnT w="0" cap="flat" cmpd="sng" algn="ctr">
+                      <a:noFill/>
+                    </a:lnT>
+                    <a:lnB w="9525" cap="flat" cmpd="sng" algn="ctr">
+                      <a:solidFill>
+                        <a:srgbClr val="BFCAD3"/>
+                      </a:solidFill>
+                      <a:prstDash val="solid"/>
+                      <a:round/>
+                      <a:headEnd type="none" w="med" len="med"/>
+                      <a:tailEnd type="none" w="med" len="med"/>
+                    </a:lnB>
+                  </a:tcPr>
+                </a:tc>
+                <a:tc>
+                  <a:txBody>
+                    <a:bodyPr/>
+                    <a:lstStyle/>
+                    <a:p>
+                      <a:pPr indent="0" marL="0">
+                        <a:buNone/>
+                      </a:pPr>
+                      <a:r>
+                        <a:rPr lang="en-US" sz="1150" dirty="0">
                           <a:solidFill>
                             <a:srgbClr val="111C24"/>
                           </a:solidFill>
@@ -9526,46 +9526,46 @@
                           <a:ea typeface="Calibri" pitchFamily="34" charset="-122"/>
                           <a:cs typeface="Calibri" pitchFamily="34" charset="-120"/>
                         </a:rPr>
-                        <a:t>Send the campaign-type list, the ad-type plan for Bamboo and the frameworks for the other products (agreed on the 30 Sep call), brief creative for the held SB, SBV and SD campaigns, then launch them through the API</a:t>
-                      </a:r>
-                      <a:endParaRPr lang="en-US" sz="1200" dirty="0">
-                        <a:latin typeface="Calibri" charset="0"/>
-                        <a:ea typeface="Calibri" charset="0"/>
-                        <a:cs typeface="Calibri" charset="0"/>
-                      </a:endParaRPr>
-                    </a:p>
-                  </a:txBody>
-                  <a:tcPr marL="64008" marR="64008" marT="73152" marB="73152" anchor="ctr">
-                    <a:lnL w="0" cap="flat" cmpd="sng" algn="ctr">
-                      <a:noFill/>
-                    </a:lnL>
-                    <a:lnR w="0" cap="flat" cmpd="sng" algn="ctr">
-                      <a:noFill/>
-                    </a:lnR>
-                    <a:lnT w="0" cap="flat" cmpd="sng" algn="ctr">
-                      <a:noFill/>
-                    </a:lnT>
-                    <a:lnB w="9525" cap="flat" cmpd="sng" algn="ctr">
-                      <a:solidFill>
-                        <a:srgbClr val="BFCAD3"/>
-                      </a:solidFill>
-                      <a:prstDash val="solid"/>
-                      <a:round/>
-                      <a:headEnd type="none" w="med" len="med"/>
-                      <a:tailEnd type="none" w="med" len="med"/>
-                    </a:lnB>
-                  </a:tcPr>
-                </a:tc>
-                <a:tc>
-                  <a:txBody>
-                    <a:bodyPr/>
-                    <a:lstStyle/>
-                    <a:p>
-                      <a:pPr indent="0" marL="0">
-                        <a:buNone/>
-                      </a:pPr>
-                      <a:r>
-                        <a:rPr lang="en-US" sz="1200" dirty="0">
+                        <a:t>Move the register to changed-findings-only and get Section 7, Q1 and Q3 signed off</a:t>
+                      </a:r>
+                      <a:endParaRPr lang="en-US" sz="1150" dirty="0">
+                        <a:latin typeface="Calibri" charset="0"/>
+                        <a:ea typeface="Calibri" charset="0"/>
+                        <a:cs typeface="Calibri" charset="0"/>
+                      </a:endParaRPr>
+                    </a:p>
+                  </a:txBody>
+                  <a:tcPr marL="64008" marR="64008" marT="73152" marB="73152" anchor="ctr">
+                    <a:lnL w="0" cap="flat" cmpd="sng" algn="ctr">
+                      <a:noFill/>
+                    </a:lnL>
+                    <a:lnR w="0" cap="flat" cmpd="sng" algn="ctr">
+                      <a:noFill/>
+                    </a:lnR>
+                    <a:lnT w="0" cap="flat" cmpd="sng" algn="ctr">
+                      <a:noFill/>
+                    </a:lnT>
+                    <a:lnB w="9525" cap="flat" cmpd="sng" algn="ctr">
+                      <a:solidFill>
+                        <a:srgbClr val="BFCAD3"/>
+                      </a:solidFill>
+                      <a:prstDash val="solid"/>
+                      <a:round/>
+                      <a:headEnd type="none" w="med" len="med"/>
+                      <a:tailEnd type="none" w="med" len="med"/>
+                    </a:lnB>
+                  </a:tcPr>
+                </a:tc>
+                <a:tc>
+                  <a:txBody>
+                    <a:bodyPr/>
+                    <a:lstStyle/>
+                    <a:p>
+                      <a:pPr indent="0" marL="0">
+                        <a:buNone/>
+                      </a:pPr>
+                      <a:r>
+                        <a:rPr lang="en-US" sz="1150" dirty="0">
                           <a:solidFill>
                             <a:srgbClr val="111C24"/>
                           </a:solidFill>
@@ -9573,46 +9573,46 @@
                           <a:ea typeface="Calibri" pitchFamily="34" charset="-122"/>
                           <a:cs typeface="Calibri" pitchFamily="34" charset="-120"/>
                         </a:rPr>
-                        <a:t>End of week, Oct 3–4 · launch TBC Mon</a:t>
-                      </a:r>
-                      <a:endParaRPr lang="en-US" sz="1200" dirty="0">
-                        <a:latin typeface="Calibri" charset="0"/>
-                        <a:ea typeface="Calibri" charset="0"/>
-                        <a:cs typeface="Calibri" charset="0"/>
-                      </a:endParaRPr>
-                    </a:p>
-                  </a:txBody>
-                  <a:tcPr marL="64008" marR="64008" marT="73152" marB="73152" anchor="ctr">
-                    <a:lnL w="0" cap="flat" cmpd="sng" algn="ctr">
-                      <a:noFill/>
-                    </a:lnL>
-                    <a:lnR w="0" cap="flat" cmpd="sng" algn="ctr">
-                      <a:noFill/>
-                    </a:lnR>
-                    <a:lnT w="0" cap="flat" cmpd="sng" algn="ctr">
-                      <a:noFill/>
-                    </a:lnT>
-                    <a:lnB w="9525" cap="flat" cmpd="sng" algn="ctr">
-                      <a:solidFill>
-                        <a:srgbClr val="BFCAD3"/>
-                      </a:solidFill>
-                      <a:prstDash val="solid"/>
-                      <a:round/>
-                      <a:headEnd type="none" w="med" len="med"/>
-                      <a:tailEnd type="none" w="med" len="med"/>
-                    </a:lnB>
-                  </a:tcPr>
-                </a:tc>
-                <a:tc>
-                  <a:txBody>
-                    <a:bodyPr/>
-                    <a:lstStyle/>
-                    <a:p>
-                      <a:pPr indent="0" marL="0">
-                        <a:buNone/>
-                      </a:pPr>
-                      <a:r>
-                        <a:rPr lang="en-US" sz="1200" dirty="0">
+                        <a:t>Mon, Oct 5</a:t>
+                      </a:r>
+                      <a:endParaRPr lang="en-US" sz="1150" dirty="0">
+                        <a:latin typeface="Calibri" charset="0"/>
+                        <a:ea typeface="Calibri" charset="0"/>
+                        <a:cs typeface="Calibri" charset="0"/>
+                      </a:endParaRPr>
+                    </a:p>
+                  </a:txBody>
+                  <a:tcPr marL="64008" marR="64008" marT="73152" marB="73152" anchor="ctr">
+                    <a:lnL w="0" cap="flat" cmpd="sng" algn="ctr">
+                      <a:noFill/>
+                    </a:lnL>
+                    <a:lnR w="0" cap="flat" cmpd="sng" algn="ctr">
+                      <a:noFill/>
+                    </a:lnR>
+                    <a:lnT w="0" cap="flat" cmpd="sng" algn="ctr">
+                      <a:noFill/>
+                    </a:lnT>
+                    <a:lnB w="9525" cap="flat" cmpd="sng" algn="ctr">
+                      <a:solidFill>
+                        <a:srgbClr val="BFCAD3"/>
+                      </a:solidFill>
+                      <a:prstDash val="solid"/>
+                      <a:round/>
+                      <a:headEnd type="none" w="med" len="med"/>
+                      <a:tailEnd type="none" w="med" len="med"/>
+                    </a:lnB>
+                  </a:tcPr>
+                </a:tc>
+                <a:tc>
+                  <a:txBody>
+                    <a:bodyPr/>
+                    <a:lstStyle/>
+                    <a:p>
+                      <a:pPr indent="0" marL="0">
+                        <a:buNone/>
+                      </a:pPr>
+                      <a:r>
+                        <a:rPr lang="en-US" sz="1150" dirty="0">
                           <a:solidFill>
                             <a:srgbClr val="111C24"/>
                           </a:solidFill>
@@ -9622,44 +9622,44 @@
                         </a:rPr>
                         <a:t>P0</a:t>
                       </a:r>
-                      <a:endParaRPr lang="en-US" sz="1200" dirty="0">
-                        <a:latin typeface="Calibri" charset="0"/>
-                        <a:ea typeface="Calibri" charset="0"/>
-                        <a:cs typeface="Calibri" charset="0"/>
-                      </a:endParaRPr>
-                    </a:p>
-                  </a:txBody>
-                  <a:tcPr marL="64008" marR="64008" marT="73152" marB="73152" anchor="ctr">
-                    <a:lnL w="0" cap="flat" cmpd="sng" algn="ctr">
-                      <a:noFill/>
-                    </a:lnL>
-                    <a:lnR w="0" cap="flat" cmpd="sng" algn="ctr">
-                      <a:noFill/>
-                    </a:lnR>
-                    <a:lnT w="0" cap="flat" cmpd="sng" algn="ctr">
-                      <a:noFill/>
-                    </a:lnT>
-                    <a:lnB w="9525" cap="flat" cmpd="sng" algn="ctr">
-                      <a:solidFill>
-                        <a:srgbClr val="BFCAD3"/>
-                      </a:solidFill>
-                      <a:prstDash val="solid"/>
-                      <a:round/>
-                      <a:headEnd type="none" w="med" len="med"/>
-                      <a:tailEnd type="none" w="med" len="med"/>
-                    </a:lnB>
-                  </a:tcPr>
-                </a:tc>
-                <a:tc>
-                  <a:txBody>
-                    <a:bodyPr/>
-                    <a:lstStyle/>
-                    <a:p>
-                      <a:pPr indent="0" marL="0">
-                        <a:buNone/>
-                      </a:pPr>
-                      <a:r>
-                        <a:rPr lang="en-US" sz="1200" dirty="0">
+                      <a:endParaRPr lang="en-US" sz="1150" dirty="0">
+                        <a:latin typeface="Calibri" charset="0"/>
+                        <a:ea typeface="Calibri" charset="0"/>
+                        <a:cs typeface="Calibri" charset="0"/>
+                      </a:endParaRPr>
+                    </a:p>
+                  </a:txBody>
+                  <a:tcPr marL="64008" marR="64008" marT="73152" marB="73152" anchor="ctr">
+                    <a:lnL w="0" cap="flat" cmpd="sng" algn="ctr">
+                      <a:noFill/>
+                    </a:lnL>
+                    <a:lnR w="0" cap="flat" cmpd="sng" algn="ctr">
+                      <a:noFill/>
+                    </a:lnR>
+                    <a:lnT w="0" cap="flat" cmpd="sng" algn="ctr">
+                      <a:noFill/>
+                    </a:lnT>
+                    <a:lnB w="9525" cap="flat" cmpd="sng" algn="ctr">
+                      <a:solidFill>
+                        <a:srgbClr val="BFCAD3"/>
+                      </a:solidFill>
+                      <a:prstDash val="solid"/>
+                      <a:round/>
+                      <a:headEnd type="none" w="med" len="med"/>
+                      <a:tailEnd type="none" w="med" len="med"/>
+                    </a:lnB>
+                  </a:tcPr>
+                </a:tc>
+                <a:tc>
+                  <a:txBody>
+                    <a:bodyPr/>
+                    <a:lstStyle/>
+                    <a:p>
+                      <a:pPr indent="0" marL="0">
+                        <a:buNone/>
+                      </a:pPr>
+                      <a:r>
+                        <a:rPr lang="en-US" sz="1150" dirty="0">
                           <a:solidFill>
                             <a:srgbClr val="111C24"/>
                           </a:solidFill>
@@ -9667,9 +9667,9 @@
                           <a:ea typeface="Calibri" pitchFamily="34" charset="-122"/>
                           <a:cs typeface="Calibri" pitchFamily="34" charset="-120"/>
                         </a:rPr>
-                        <a:t>Y — since Sep 30</a:t>
-                      </a:r>
-                      <a:endParaRPr lang="en-US" sz="1200" dirty="0">
+                        <a:t>Y — since Oct 2</a:t>
+                      </a:r>
+                      <a:endParaRPr lang="en-US" sz="1150" dirty="0">
                         <a:latin typeface="Calibri" charset="0"/>
                         <a:ea typeface="Calibri" charset="0"/>
                         <a:cs typeface="Calibri" charset="0"/>
@@ -9708,7 +9708,7 @@
                         <a:buNone/>
                       </a:pPr>
                       <a:r>
-                        <a:rPr lang="en-US" sz="1200" b="1" dirty="0">
+                        <a:rPr lang="en-US" sz="1150" b="1" dirty="0">
                           <a:solidFill>
                             <a:srgbClr val="111C24"/>
                           </a:solidFill>
@@ -9716,20 +9716,20 @@
                           <a:ea typeface="Calibri" pitchFamily="34" charset="-122"/>
                           <a:cs typeface="Calibri" pitchFamily="34" charset="-120"/>
                         </a:rPr>
-                        <a:t>Stabilisation proposal</a:t>
-                      </a:r>
-                      <a:endParaRPr lang="en-US" sz="1200" dirty="0">
-                        <a:latin typeface="Calibri" charset="0"/>
-                        <a:ea typeface="Calibri" charset="0"/>
-                        <a:cs typeface="Calibri" charset="0"/>
-                      </a:endParaRPr>
-                    </a:p>
-                    <a:p>
-                      <a:pPr indent="0" marL="0">
-                        <a:buNone/>
-                      </a:pPr>
-                      <a:r>
-                        <a:rPr lang="en-US" sz="1100" dirty="0">
+                        <a:t>Other campaign types</a:t>
+                      </a:r>
+                      <a:endParaRPr lang="en-US" sz="1150" dirty="0">
+                        <a:latin typeface="Calibri" charset="0"/>
+                        <a:ea typeface="Calibri" charset="0"/>
+                        <a:cs typeface="Calibri" charset="0"/>
+                      </a:endParaRPr>
+                    </a:p>
+                    <a:p>
+                      <a:pPr indent="0" marL="0">
+                        <a:buNone/>
+                      </a:pPr>
+                      <a:r>
+                        <a:rPr lang="en-US" sz="1050" dirty="0">
                           <a:solidFill>
                             <a:srgbClr val="4E5A64"/>
                           </a:solidFill>
@@ -9739,44 +9739,44 @@
                         </a:rPr>
                         <a:t>Shayan T</a:t>
                       </a:r>
-                      <a:endParaRPr lang="en-US" sz="1200" dirty="0">
-                        <a:latin typeface="Calibri" charset="0"/>
-                        <a:ea typeface="Calibri" charset="0"/>
-                        <a:cs typeface="Calibri" charset="0"/>
-                      </a:endParaRPr>
-                    </a:p>
-                  </a:txBody>
-                  <a:tcPr marL="64008" marR="64008" marT="73152" marB="73152" anchor="ctr">
-                    <a:lnL w="0" cap="flat" cmpd="sng" algn="ctr">
-                      <a:noFill/>
-                    </a:lnL>
-                    <a:lnR w="0" cap="flat" cmpd="sng" algn="ctr">
-                      <a:noFill/>
-                    </a:lnR>
-                    <a:lnT w="0" cap="flat" cmpd="sng" algn="ctr">
-                      <a:noFill/>
-                    </a:lnT>
-                    <a:lnB w="9525" cap="flat" cmpd="sng" algn="ctr">
-                      <a:solidFill>
-                        <a:srgbClr val="BFCAD3"/>
-                      </a:solidFill>
-                      <a:prstDash val="solid"/>
-                      <a:round/>
-                      <a:headEnd type="none" w="med" len="med"/>
-                      <a:tailEnd type="none" w="med" len="med"/>
-                    </a:lnB>
-                  </a:tcPr>
-                </a:tc>
-                <a:tc>
-                  <a:txBody>
-                    <a:bodyPr/>
-                    <a:lstStyle/>
-                    <a:p>
-                      <a:pPr indent="0" marL="0">
-                        <a:buNone/>
-                      </a:pPr>
-                      <a:r>
-                        <a:rPr lang="en-US" sz="1200" dirty="0">
+                      <a:endParaRPr lang="en-US" sz="1150" dirty="0">
+                        <a:latin typeface="Calibri" charset="0"/>
+                        <a:ea typeface="Calibri" charset="0"/>
+                        <a:cs typeface="Calibri" charset="0"/>
+                      </a:endParaRPr>
+                    </a:p>
+                  </a:txBody>
+                  <a:tcPr marL="64008" marR="64008" marT="73152" marB="73152" anchor="ctr">
+                    <a:lnL w="0" cap="flat" cmpd="sng" algn="ctr">
+                      <a:noFill/>
+                    </a:lnL>
+                    <a:lnR w="0" cap="flat" cmpd="sng" algn="ctr">
+                      <a:noFill/>
+                    </a:lnR>
+                    <a:lnT w="0" cap="flat" cmpd="sng" algn="ctr">
+                      <a:noFill/>
+                    </a:lnT>
+                    <a:lnB w="9525" cap="flat" cmpd="sng" algn="ctr">
+                      <a:solidFill>
+                        <a:srgbClr val="BFCAD3"/>
+                      </a:solidFill>
+                      <a:prstDash val="solid"/>
+                      <a:round/>
+                      <a:headEnd type="none" w="med" len="med"/>
+                      <a:tailEnd type="none" w="med" len="med"/>
+                    </a:lnB>
+                  </a:tcPr>
+                </a:tc>
+                <a:tc>
+                  <a:txBody>
+                    <a:bodyPr/>
+                    <a:lstStyle/>
+                    <a:p>
+                      <a:pPr indent="0" marL="0">
+                        <a:buNone/>
+                      </a:pPr>
+                      <a:r>
+                        <a:rPr lang="en-US" sz="1150" dirty="0">
                           <a:solidFill>
                             <a:srgbClr val="111C24"/>
                           </a:solidFill>
@@ -9784,46 +9784,46 @@
                           <a:ea typeface="Calibri" pitchFamily="34" charset="-122"/>
                           <a:cs typeface="Calibri" pitchFamily="34" charset="-120"/>
                         </a:rPr>
-                        <a:t>Deliver catalog prioritisation, team structure, the finalised cadence and the development list, with priorities and due dates as Erik asked on 30 Sep</a:t>
-                      </a:r>
-                      <a:endParaRPr lang="en-US" sz="1200" dirty="0">
-                        <a:latin typeface="Calibri" charset="0"/>
-                        <a:ea typeface="Calibri" charset="0"/>
-                        <a:cs typeface="Calibri" charset="0"/>
-                      </a:endParaRPr>
-                    </a:p>
-                  </a:txBody>
-                  <a:tcPr marL="64008" marR="64008" marT="73152" marB="73152" anchor="ctr">
-                    <a:lnL w="0" cap="flat" cmpd="sng" algn="ctr">
-                      <a:noFill/>
-                    </a:lnL>
-                    <a:lnR w="0" cap="flat" cmpd="sng" algn="ctr">
-                      <a:noFill/>
-                    </a:lnR>
-                    <a:lnT w="0" cap="flat" cmpd="sng" algn="ctr">
-                      <a:noFill/>
-                    </a:lnT>
-                    <a:lnB w="9525" cap="flat" cmpd="sng" algn="ctr">
-                      <a:solidFill>
-                        <a:srgbClr val="BFCAD3"/>
-                      </a:solidFill>
-                      <a:prstDash val="solid"/>
-                      <a:round/>
-                      <a:headEnd type="none" w="med" len="med"/>
-                      <a:tailEnd type="none" w="med" len="med"/>
-                    </a:lnB>
-                  </a:tcPr>
-                </a:tc>
-                <a:tc>
-                  <a:txBody>
-                    <a:bodyPr/>
-                    <a:lstStyle/>
-                    <a:p>
-                      <a:pPr indent="0" marL="0">
-                        <a:buNone/>
-                      </a:pPr>
-                      <a:r>
-                        <a:rPr lang="en-US" sz="1200" dirty="0">
+                        <a:t>Send the campaign-type list, the ad-type plan for Bamboo and the frameworks for the other products (agreed on the 30 Sep call), brief creative for the held SB, SBV and SD campaigns, then launch them through the API</a:t>
+                      </a:r>
+                      <a:endParaRPr lang="en-US" sz="1150" dirty="0">
+                        <a:latin typeface="Calibri" charset="0"/>
+                        <a:ea typeface="Calibri" charset="0"/>
+                        <a:cs typeface="Calibri" charset="0"/>
+                      </a:endParaRPr>
+                    </a:p>
+                  </a:txBody>
+                  <a:tcPr marL="64008" marR="64008" marT="73152" marB="73152" anchor="ctr">
+                    <a:lnL w="0" cap="flat" cmpd="sng" algn="ctr">
+                      <a:noFill/>
+                    </a:lnL>
+                    <a:lnR w="0" cap="flat" cmpd="sng" algn="ctr">
+                      <a:noFill/>
+                    </a:lnR>
+                    <a:lnT w="0" cap="flat" cmpd="sng" algn="ctr">
+                      <a:noFill/>
+                    </a:lnT>
+                    <a:lnB w="9525" cap="flat" cmpd="sng" algn="ctr">
+                      <a:solidFill>
+                        <a:srgbClr val="BFCAD3"/>
+                      </a:solidFill>
+                      <a:prstDash val="solid"/>
+                      <a:round/>
+                      <a:headEnd type="none" w="med" len="med"/>
+                      <a:tailEnd type="none" w="med" len="med"/>
+                    </a:lnB>
+                  </a:tcPr>
+                </a:tc>
+                <a:tc>
+                  <a:txBody>
+                    <a:bodyPr/>
+                    <a:lstStyle/>
+                    <a:p>
+                      <a:pPr indent="0" marL="0">
+                        <a:buNone/>
+                      </a:pPr>
+                      <a:r>
+                        <a:rPr lang="en-US" sz="1150" dirty="0">
                           <a:solidFill>
                             <a:srgbClr val="111C24"/>
                           </a:solidFill>
@@ -9831,46 +9831,46 @@
                           <a:ea typeface="Calibri" pitchFamily="34" charset="-122"/>
                           <a:cs typeface="Calibri" pitchFamily="34" charset="-120"/>
                         </a:rPr>
-                        <a:t>End of week, Oct 3–4</a:t>
-                      </a:r>
-                      <a:endParaRPr lang="en-US" sz="1200" dirty="0">
-                        <a:latin typeface="Calibri" charset="0"/>
-                        <a:ea typeface="Calibri" charset="0"/>
-                        <a:cs typeface="Calibri" charset="0"/>
-                      </a:endParaRPr>
-                    </a:p>
-                  </a:txBody>
-                  <a:tcPr marL="64008" marR="64008" marT="73152" marB="73152" anchor="ctr">
-                    <a:lnL w="0" cap="flat" cmpd="sng" algn="ctr">
-                      <a:noFill/>
-                    </a:lnL>
-                    <a:lnR w="0" cap="flat" cmpd="sng" algn="ctr">
-                      <a:noFill/>
-                    </a:lnR>
-                    <a:lnT w="0" cap="flat" cmpd="sng" algn="ctr">
-                      <a:noFill/>
-                    </a:lnT>
-                    <a:lnB w="9525" cap="flat" cmpd="sng" algn="ctr">
-                      <a:solidFill>
-                        <a:srgbClr val="BFCAD3"/>
-                      </a:solidFill>
-                      <a:prstDash val="solid"/>
-                      <a:round/>
-                      <a:headEnd type="none" w="med" len="med"/>
-                      <a:tailEnd type="none" w="med" len="med"/>
-                    </a:lnB>
-                  </a:tcPr>
-                </a:tc>
-                <a:tc>
-                  <a:txBody>
-                    <a:bodyPr/>
-                    <a:lstStyle/>
-                    <a:p>
-                      <a:pPr indent="0" marL="0">
-                        <a:buNone/>
-                      </a:pPr>
-                      <a:r>
-                        <a:rPr lang="en-US" sz="1200" dirty="0">
+                        <a:t>End of week, Oct 3–4 · launch TBC Mon</a:t>
+                      </a:r>
+                      <a:endParaRPr lang="en-US" sz="1150" dirty="0">
+                        <a:latin typeface="Calibri" charset="0"/>
+                        <a:ea typeface="Calibri" charset="0"/>
+                        <a:cs typeface="Calibri" charset="0"/>
+                      </a:endParaRPr>
+                    </a:p>
+                  </a:txBody>
+                  <a:tcPr marL="64008" marR="64008" marT="73152" marB="73152" anchor="ctr">
+                    <a:lnL w="0" cap="flat" cmpd="sng" algn="ctr">
+                      <a:noFill/>
+                    </a:lnL>
+                    <a:lnR w="0" cap="flat" cmpd="sng" algn="ctr">
+                      <a:noFill/>
+                    </a:lnR>
+                    <a:lnT w="0" cap="flat" cmpd="sng" algn="ctr">
+                      <a:noFill/>
+                    </a:lnT>
+                    <a:lnB w="9525" cap="flat" cmpd="sng" algn="ctr">
+                      <a:solidFill>
+                        <a:srgbClr val="BFCAD3"/>
+                      </a:solidFill>
+                      <a:prstDash val="solid"/>
+                      <a:round/>
+                      <a:headEnd type="none" w="med" len="med"/>
+                      <a:tailEnd type="none" w="med" len="med"/>
+                    </a:lnB>
+                  </a:tcPr>
+                </a:tc>
+                <a:tc>
+                  <a:txBody>
+                    <a:bodyPr/>
+                    <a:lstStyle/>
+                    <a:p>
+                      <a:pPr indent="0" marL="0">
+                        <a:buNone/>
+                      </a:pPr>
+                      <a:r>
+                        <a:rPr lang="en-US" sz="1150" dirty="0">
                           <a:solidFill>
                             <a:srgbClr val="111C24"/>
                           </a:solidFill>
@@ -9880,44 +9880,44 @@
                         </a:rPr>
                         <a:t>P0</a:t>
                       </a:r>
-                      <a:endParaRPr lang="en-US" sz="1200" dirty="0">
-                        <a:latin typeface="Calibri" charset="0"/>
-                        <a:ea typeface="Calibri" charset="0"/>
-                        <a:cs typeface="Calibri" charset="0"/>
-                      </a:endParaRPr>
-                    </a:p>
-                  </a:txBody>
-                  <a:tcPr marL="64008" marR="64008" marT="73152" marB="73152" anchor="ctr">
-                    <a:lnL w="0" cap="flat" cmpd="sng" algn="ctr">
-                      <a:noFill/>
-                    </a:lnL>
-                    <a:lnR w="0" cap="flat" cmpd="sng" algn="ctr">
-                      <a:noFill/>
-                    </a:lnR>
-                    <a:lnT w="0" cap="flat" cmpd="sng" algn="ctr">
-                      <a:noFill/>
-                    </a:lnT>
-                    <a:lnB w="9525" cap="flat" cmpd="sng" algn="ctr">
-                      <a:solidFill>
-                        <a:srgbClr val="BFCAD3"/>
-                      </a:solidFill>
-                      <a:prstDash val="solid"/>
-                      <a:round/>
-                      <a:headEnd type="none" w="med" len="med"/>
-                      <a:tailEnd type="none" w="med" len="med"/>
-                    </a:lnB>
-                  </a:tcPr>
-                </a:tc>
-                <a:tc>
-                  <a:txBody>
-                    <a:bodyPr/>
-                    <a:lstStyle/>
-                    <a:p>
-                      <a:pPr indent="0" marL="0">
-                        <a:buNone/>
-                      </a:pPr>
-                      <a:r>
-                        <a:rPr lang="en-US" sz="1200" dirty="0">
+                      <a:endParaRPr lang="en-US" sz="1150" dirty="0">
+                        <a:latin typeface="Calibri" charset="0"/>
+                        <a:ea typeface="Calibri" charset="0"/>
+                        <a:cs typeface="Calibri" charset="0"/>
+                      </a:endParaRPr>
+                    </a:p>
+                  </a:txBody>
+                  <a:tcPr marL="64008" marR="64008" marT="73152" marB="73152" anchor="ctr">
+                    <a:lnL w="0" cap="flat" cmpd="sng" algn="ctr">
+                      <a:noFill/>
+                    </a:lnL>
+                    <a:lnR w="0" cap="flat" cmpd="sng" algn="ctr">
+                      <a:noFill/>
+                    </a:lnR>
+                    <a:lnT w="0" cap="flat" cmpd="sng" algn="ctr">
+                      <a:noFill/>
+                    </a:lnT>
+                    <a:lnB w="9525" cap="flat" cmpd="sng" algn="ctr">
+                      <a:solidFill>
+                        <a:srgbClr val="BFCAD3"/>
+                      </a:solidFill>
+                      <a:prstDash val="solid"/>
+                      <a:round/>
+                      <a:headEnd type="none" w="med" len="med"/>
+                      <a:tailEnd type="none" w="med" len="med"/>
+                    </a:lnB>
+                  </a:tcPr>
+                </a:tc>
+                <a:tc>
+                  <a:txBody>
+                    <a:bodyPr/>
+                    <a:lstStyle/>
+                    <a:p>
+                      <a:pPr indent="0" marL="0">
+                        <a:buNone/>
+                      </a:pPr>
+                      <a:r>
+                        <a:rPr lang="en-US" sz="1150" dirty="0">
                           <a:solidFill>
                             <a:srgbClr val="111C24"/>
                           </a:solidFill>
@@ -9925,9 +9925,9 @@
                           <a:ea typeface="Calibri" pitchFamily="34" charset="-122"/>
                           <a:cs typeface="Calibri" pitchFamily="34" charset="-120"/>
                         </a:rPr>
-                        <a:t>Y — since Oct 2</a:t>
-                      </a:r>
-                      <a:endParaRPr lang="en-US" sz="1200" dirty="0">
+                        <a:t>Y — since Sep 30</a:t>
+                      </a:r>
+                      <a:endParaRPr lang="en-US" sz="1150" dirty="0">
                         <a:latin typeface="Calibri" charset="0"/>
                         <a:ea typeface="Calibri" charset="0"/>
                         <a:cs typeface="Calibri" charset="0"/>
@@ -9966,7 +9966,7 @@
                         <a:buNone/>
                       </a:pPr>
                       <a:r>
-                        <a:rPr lang="en-US" sz="1200" b="1" dirty="0">
+                        <a:rPr lang="en-US" sz="1150" b="1" dirty="0">
                           <a:solidFill>
                             <a:srgbClr val="111C24"/>
                           </a:solidFill>
@@ -9974,20 +9974,278 @@
                           <a:ea typeface="Calibri" pitchFamily="34" charset="-122"/>
                           <a:cs typeface="Calibri" pitchFamily="34" charset="-120"/>
                         </a:rPr>
+                        <a:t>Stabilisation proposal</a:t>
+                      </a:r>
+                      <a:endParaRPr lang="en-US" sz="1150" dirty="0">
+                        <a:latin typeface="Calibri" charset="0"/>
+                        <a:ea typeface="Calibri" charset="0"/>
+                        <a:cs typeface="Calibri" charset="0"/>
+                      </a:endParaRPr>
+                    </a:p>
+                    <a:p>
+                      <a:pPr indent="0" marL="0">
+                        <a:buNone/>
+                      </a:pPr>
+                      <a:r>
+                        <a:rPr lang="en-US" sz="1050" dirty="0">
+                          <a:solidFill>
+                            <a:srgbClr val="4E5A64"/>
+                          </a:solidFill>
+                          <a:latin typeface="Calibri" pitchFamily="34" charset="0"/>
+                          <a:ea typeface="Calibri" pitchFamily="34" charset="-122"/>
+                          <a:cs typeface="Calibri" pitchFamily="34" charset="-120"/>
+                        </a:rPr>
+                        <a:t>Shayan T</a:t>
+                      </a:r>
+                      <a:endParaRPr lang="en-US" sz="1150" dirty="0">
+                        <a:latin typeface="Calibri" charset="0"/>
+                        <a:ea typeface="Calibri" charset="0"/>
+                        <a:cs typeface="Calibri" charset="0"/>
+                      </a:endParaRPr>
+                    </a:p>
+                  </a:txBody>
+                  <a:tcPr marL="64008" marR="64008" marT="73152" marB="73152" anchor="ctr">
+                    <a:lnL w="0" cap="flat" cmpd="sng" algn="ctr">
+                      <a:noFill/>
+                    </a:lnL>
+                    <a:lnR w="0" cap="flat" cmpd="sng" algn="ctr">
+                      <a:noFill/>
+                    </a:lnR>
+                    <a:lnT w="0" cap="flat" cmpd="sng" algn="ctr">
+                      <a:noFill/>
+                    </a:lnT>
+                    <a:lnB w="9525" cap="flat" cmpd="sng" algn="ctr">
+                      <a:solidFill>
+                        <a:srgbClr val="BFCAD3"/>
+                      </a:solidFill>
+                      <a:prstDash val="solid"/>
+                      <a:round/>
+                      <a:headEnd type="none" w="med" len="med"/>
+                      <a:tailEnd type="none" w="med" len="med"/>
+                    </a:lnB>
+                  </a:tcPr>
+                </a:tc>
+                <a:tc>
+                  <a:txBody>
+                    <a:bodyPr/>
+                    <a:lstStyle/>
+                    <a:p>
+                      <a:pPr indent="0" marL="0">
+                        <a:buNone/>
+                      </a:pPr>
+                      <a:r>
+                        <a:rPr lang="en-US" sz="1150" dirty="0">
+                          <a:solidFill>
+                            <a:srgbClr val="111C24"/>
+                          </a:solidFill>
+                          <a:latin typeface="Calibri" pitchFamily="34" charset="0"/>
+                          <a:ea typeface="Calibri" pitchFamily="34" charset="-122"/>
+                          <a:cs typeface="Calibri" pitchFamily="34" charset="-120"/>
+                        </a:rPr>
+                        <a:t>Deliver catalog prioritisation, team structure, the finalised cadence and the development list, with priorities and due dates as Erik asked on 30 Sep</a:t>
+                      </a:r>
+                      <a:endParaRPr lang="en-US" sz="1150" dirty="0">
+                        <a:latin typeface="Calibri" charset="0"/>
+                        <a:ea typeface="Calibri" charset="0"/>
+                        <a:cs typeface="Calibri" charset="0"/>
+                      </a:endParaRPr>
+                    </a:p>
+                  </a:txBody>
+                  <a:tcPr marL="64008" marR="64008" marT="73152" marB="73152" anchor="ctr">
+                    <a:lnL w="0" cap="flat" cmpd="sng" algn="ctr">
+                      <a:noFill/>
+                    </a:lnL>
+                    <a:lnR w="0" cap="flat" cmpd="sng" algn="ctr">
+                      <a:noFill/>
+                    </a:lnR>
+                    <a:lnT w="0" cap="flat" cmpd="sng" algn="ctr">
+                      <a:noFill/>
+                    </a:lnT>
+                    <a:lnB w="9525" cap="flat" cmpd="sng" algn="ctr">
+                      <a:solidFill>
+                        <a:srgbClr val="BFCAD3"/>
+                      </a:solidFill>
+                      <a:prstDash val="solid"/>
+                      <a:round/>
+                      <a:headEnd type="none" w="med" len="med"/>
+                      <a:tailEnd type="none" w="med" len="med"/>
+                    </a:lnB>
+                  </a:tcPr>
+                </a:tc>
+                <a:tc>
+                  <a:txBody>
+                    <a:bodyPr/>
+                    <a:lstStyle/>
+                    <a:p>
+                      <a:pPr indent="0" marL="0">
+                        <a:buNone/>
+                      </a:pPr>
+                      <a:r>
+                        <a:rPr lang="en-US" sz="1150" dirty="0">
+                          <a:solidFill>
+                            <a:srgbClr val="111C24"/>
+                          </a:solidFill>
+                          <a:latin typeface="Calibri" pitchFamily="34" charset="0"/>
+                          <a:ea typeface="Calibri" pitchFamily="34" charset="-122"/>
+                          <a:cs typeface="Calibri" pitchFamily="34" charset="-120"/>
+                        </a:rPr>
+                        <a:t>End of week, Oct 3–4</a:t>
+                      </a:r>
+                      <a:endParaRPr lang="en-US" sz="1150" dirty="0">
+                        <a:latin typeface="Calibri" charset="0"/>
+                        <a:ea typeface="Calibri" charset="0"/>
+                        <a:cs typeface="Calibri" charset="0"/>
+                      </a:endParaRPr>
+                    </a:p>
+                  </a:txBody>
+                  <a:tcPr marL="64008" marR="64008" marT="73152" marB="73152" anchor="ctr">
+                    <a:lnL w="0" cap="flat" cmpd="sng" algn="ctr">
+                      <a:noFill/>
+                    </a:lnL>
+                    <a:lnR w="0" cap="flat" cmpd="sng" algn="ctr">
+                      <a:noFill/>
+                    </a:lnR>
+                    <a:lnT w="0" cap="flat" cmpd="sng" algn="ctr">
+                      <a:noFill/>
+                    </a:lnT>
+                    <a:lnB w="9525" cap="flat" cmpd="sng" algn="ctr">
+                      <a:solidFill>
+                        <a:srgbClr val="BFCAD3"/>
+                      </a:solidFill>
+                      <a:prstDash val="solid"/>
+                      <a:round/>
+                      <a:headEnd type="none" w="med" len="med"/>
+                      <a:tailEnd type="none" w="med" len="med"/>
+                    </a:lnB>
+                  </a:tcPr>
+                </a:tc>
+                <a:tc>
+                  <a:txBody>
+                    <a:bodyPr/>
+                    <a:lstStyle/>
+                    <a:p>
+                      <a:pPr indent="0" marL="0">
+                        <a:buNone/>
+                      </a:pPr>
+                      <a:r>
+                        <a:rPr lang="en-US" sz="1150" dirty="0">
+                          <a:solidFill>
+                            <a:srgbClr val="111C24"/>
+                          </a:solidFill>
+                          <a:latin typeface="Calibri" pitchFamily="34" charset="0"/>
+                          <a:ea typeface="Calibri" pitchFamily="34" charset="-122"/>
+                          <a:cs typeface="Calibri" pitchFamily="34" charset="-120"/>
+                        </a:rPr>
+                        <a:t>P0</a:t>
+                      </a:r>
+                      <a:endParaRPr lang="en-US" sz="1150" dirty="0">
+                        <a:latin typeface="Calibri" charset="0"/>
+                        <a:ea typeface="Calibri" charset="0"/>
+                        <a:cs typeface="Calibri" charset="0"/>
+                      </a:endParaRPr>
+                    </a:p>
+                  </a:txBody>
+                  <a:tcPr marL="64008" marR="64008" marT="73152" marB="73152" anchor="ctr">
+                    <a:lnL w="0" cap="flat" cmpd="sng" algn="ctr">
+                      <a:noFill/>
+                    </a:lnL>
+                    <a:lnR w="0" cap="flat" cmpd="sng" algn="ctr">
+                      <a:noFill/>
+                    </a:lnR>
+                    <a:lnT w="0" cap="flat" cmpd="sng" algn="ctr">
+                      <a:noFill/>
+                    </a:lnT>
+                    <a:lnB w="9525" cap="flat" cmpd="sng" algn="ctr">
+                      <a:solidFill>
+                        <a:srgbClr val="BFCAD3"/>
+                      </a:solidFill>
+                      <a:prstDash val="solid"/>
+                      <a:round/>
+                      <a:headEnd type="none" w="med" len="med"/>
+                      <a:tailEnd type="none" w="med" len="med"/>
+                    </a:lnB>
+                  </a:tcPr>
+                </a:tc>
+                <a:tc>
+                  <a:txBody>
+                    <a:bodyPr/>
+                    <a:lstStyle/>
+                    <a:p>
+                      <a:pPr indent="0" marL="0">
+                        <a:buNone/>
+                      </a:pPr>
+                      <a:r>
+                        <a:rPr lang="en-US" sz="1150" dirty="0">
+                          <a:solidFill>
+                            <a:srgbClr val="111C24"/>
+                          </a:solidFill>
+                          <a:latin typeface="Calibri" pitchFamily="34" charset="0"/>
+                          <a:ea typeface="Calibri" pitchFamily="34" charset="-122"/>
+                          <a:cs typeface="Calibri" pitchFamily="34" charset="-120"/>
+                        </a:rPr>
+                        <a:t>Y — since Oct 2</a:t>
+                      </a:r>
+                      <a:endParaRPr lang="en-US" sz="1150" dirty="0">
+                        <a:latin typeface="Calibri" charset="0"/>
+                        <a:ea typeface="Calibri" charset="0"/>
+                        <a:cs typeface="Calibri" charset="0"/>
+                      </a:endParaRPr>
+                    </a:p>
+                  </a:txBody>
+                  <a:tcPr marL="64008" marR="64008" marT="73152" marB="73152" anchor="ctr">
+                    <a:lnL w="0" cap="flat" cmpd="sng" algn="ctr">
+                      <a:noFill/>
+                    </a:lnL>
+                    <a:lnR w="0" cap="flat" cmpd="sng" algn="ctr">
+                      <a:noFill/>
+                    </a:lnR>
+                    <a:lnT w="0" cap="flat" cmpd="sng" algn="ctr">
+                      <a:noFill/>
+                    </a:lnT>
+                    <a:lnB w="9525" cap="flat" cmpd="sng" algn="ctr">
+                      <a:solidFill>
+                        <a:srgbClr val="BFCAD3"/>
+                      </a:solidFill>
+                      <a:prstDash val="solid"/>
+                      <a:round/>
+                      <a:headEnd type="none" w="med" len="med"/>
+                      <a:tailEnd type="none" w="med" len="med"/>
+                    </a:lnB>
+                  </a:tcPr>
+                </a:tc>
+              </a:tr>
+              <a:tr h="0">
+                <a:tc>
+                  <a:txBody>
+                    <a:bodyPr/>
+                    <a:lstStyle/>
+                    <a:p>
+                      <a:pPr indent="0" marL="0">
+                        <a:buNone/>
+                      </a:pPr>
+                      <a:r>
+                        <a:rPr lang="en-US" sz="1150" b="1" dirty="0">
+                          <a:solidFill>
+                            <a:srgbClr val="111C24"/>
+                          </a:solidFill>
+                          <a:latin typeface="Calibri" pitchFamily="34" charset="0"/>
+                          <a:ea typeface="Calibri" pitchFamily="34" charset="-122"/>
+                          <a:cs typeface="Calibri" pitchFamily="34" charset="-120"/>
+                        </a:rPr>
                         <a:t>Oversight &amp; onboarding</a:t>
                       </a:r>
-                      <a:endParaRPr lang="en-US" sz="1200" dirty="0">
-                        <a:latin typeface="Calibri" charset="0"/>
-                        <a:ea typeface="Calibri" charset="0"/>
-                        <a:cs typeface="Calibri" charset="0"/>
-                      </a:endParaRPr>
-                    </a:p>
-                    <a:p>
-                      <a:pPr indent="0" marL="0">
-                        <a:buNone/>
-                      </a:pPr>
-                      <a:r>
-                        <a:rPr lang="en-US" sz="1100" dirty="0">
+                      <a:endParaRPr lang="en-US" sz="1150" dirty="0">
+                        <a:latin typeface="Calibri" charset="0"/>
+                        <a:ea typeface="Calibri" charset="0"/>
+                        <a:cs typeface="Calibri" charset="0"/>
+                      </a:endParaRPr>
+                    </a:p>
+                    <a:p>
+                      <a:pPr indent="0" marL="0">
+                        <a:buNone/>
+                      </a:pPr>
+                      <a:r>
+                        <a:rPr lang="en-US" sz="1050" dirty="0">
                           <a:solidFill>
                             <a:srgbClr val="4E5A64"/>
                           </a:solidFill>
@@ -9997,44 +10255,44 @@
                         </a:rPr>
                         <a:t>All owners</a:t>
                       </a:r>
-                      <a:endParaRPr lang="en-US" sz="1200" dirty="0">
-                        <a:latin typeface="Calibri" charset="0"/>
-                        <a:ea typeface="Calibri" charset="0"/>
-                        <a:cs typeface="Calibri" charset="0"/>
-                      </a:endParaRPr>
-                    </a:p>
-                  </a:txBody>
-                  <a:tcPr marL="64008" marR="64008" marT="73152" marB="73152" anchor="ctr">
-                    <a:lnL w="0" cap="flat" cmpd="sng" algn="ctr">
-                      <a:noFill/>
-                    </a:lnL>
-                    <a:lnR w="0" cap="flat" cmpd="sng" algn="ctr">
-                      <a:noFill/>
-                    </a:lnR>
-                    <a:lnT w="0" cap="flat" cmpd="sng" algn="ctr">
-                      <a:noFill/>
-                    </a:lnT>
-                    <a:lnB w="9525" cap="flat" cmpd="sng" algn="ctr">
-                      <a:solidFill>
-                        <a:srgbClr val="BFCAD3"/>
-                      </a:solidFill>
-                      <a:prstDash val="solid"/>
-                      <a:round/>
-                      <a:headEnd type="none" w="med" len="med"/>
-                      <a:tailEnd type="none" w="med" len="med"/>
-                    </a:lnB>
-                  </a:tcPr>
-                </a:tc>
-                <a:tc>
-                  <a:txBody>
-                    <a:bodyPr/>
-                    <a:lstStyle/>
-                    <a:p>
-                      <a:pPr indent="0" marL="0">
-                        <a:buNone/>
-                      </a:pPr>
-                      <a:r>
-                        <a:rPr lang="en-US" sz="1200" dirty="0">
+                      <a:endParaRPr lang="en-US" sz="1150" dirty="0">
+                        <a:latin typeface="Calibri" charset="0"/>
+                        <a:ea typeface="Calibri" charset="0"/>
+                        <a:cs typeface="Calibri" charset="0"/>
+                      </a:endParaRPr>
+                    </a:p>
+                  </a:txBody>
+                  <a:tcPr marL="64008" marR="64008" marT="73152" marB="73152" anchor="ctr">
+                    <a:lnL w="0" cap="flat" cmpd="sng" algn="ctr">
+                      <a:noFill/>
+                    </a:lnL>
+                    <a:lnR w="0" cap="flat" cmpd="sng" algn="ctr">
+                      <a:noFill/>
+                    </a:lnR>
+                    <a:lnT w="0" cap="flat" cmpd="sng" algn="ctr">
+                      <a:noFill/>
+                    </a:lnT>
+                    <a:lnB w="9525" cap="flat" cmpd="sng" algn="ctr">
+                      <a:solidFill>
+                        <a:srgbClr val="BFCAD3"/>
+                      </a:solidFill>
+                      <a:prstDash val="solid"/>
+                      <a:round/>
+                      <a:headEnd type="none" w="med" len="med"/>
+                      <a:tailEnd type="none" w="med" len="med"/>
+                    </a:lnB>
+                  </a:tcPr>
+                </a:tc>
+                <a:tc>
+                  <a:txBody>
+                    <a:bodyPr/>
+                    <a:lstStyle/>
+                    <a:p>
+                      <a:pPr indent="0" marL="0">
+                        <a:buNone/>
+                      </a:pPr>
+                      <a:r>
+                        <a:rPr lang="en-US" sz="1150" dirty="0">
                           <a:solidFill>
                             <a:srgbClr val="111C24"/>
                           </a:solidFill>
@@ -10044,44 +10302,44 @@
                         </a:rPr>
                         <a:t>Log the daily spend checks, and run Ivan's first full week with EOD outputs</a:t>
                       </a:r>
-                      <a:endParaRPr lang="en-US" sz="1200" dirty="0">
-                        <a:latin typeface="Calibri" charset="0"/>
-                        <a:ea typeface="Calibri" charset="0"/>
-                        <a:cs typeface="Calibri" charset="0"/>
-                      </a:endParaRPr>
-                    </a:p>
-                  </a:txBody>
-                  <a:tcPr marL="64008" marR="64008" marT="73152" marB="73152" anchor="ctr">
-                    <a:lnL w="0" cap="flat" cmpd="sng" algn="ctr">
-                      <a:noFill/>
-                    </a:lnL>
-                    <a:lnR w="0" cap="flat" cmpd="sng" algn="ctr">
-                      <a:noFill/>
-                    </a:lnR>
-                    <a:lnT w="0" cap="flat" cmpd="sng" algn="ctr">
-                      <a:noFill/>
-                    </a:lnT>
-                    <a:lnB w="9525" cap="flat" cmpd="sng" algn="ctr">
-                      <a:solidFill>
-                        <a:srgbClr val="BFCAD3"/>
-                      </a:solidFill>
-                      <a:prstDash val="solid"/>
-                      <a:round/>
-                      <a:headEnd type="none" w="med" len="med"/>
-                      <a:tailEnd type="none" w="med" len="med"/>
-                    </a:lnB>
-                  </a:tcPr>
-                </a:tc>
-                <a:tc>
-                  <a:txBody>
-                    <a:bodyPr/>
-                    <a:lstStyle/>
-                    <a:p>
-                      <a:pPr indent="0" marL="0">
-                        <a:buNone/>
-                      </a:pPr>
-                      <a:r>
-                        <a:rPr lang="en-US" sz="1200" dirty="0">
+                      <a:endParaRPr lang="en-US" sz="1150" dirty="0">
+                        <a:latin typeface="Calibri" charset="0"/>
+                        <a:ea typeface="Calibri" charset="0"/>
+                        <a:cs typeface="Calibri" charset="0"/>
+                      </a:endParaRPr>
+                    </a:p>
+                  </a:txBody>
+                  <a:tcPr marL="64008" marR="64008" marT="73152" marB="73152" anchor="ctr">
+                    <a:lnL w="0" cap="flat" cmpd="sng" algn="ctr">
+                      <a:noFill/>
+                    </a:lnL>
+                    <a:lnR w="0" cap="flat" cmpd="sng" algn="ctr">
+                      <a:noFill/>
+                    </a:lnR>
+                    <a:lnT w="0" cap="flat" cmpd="sng" algn="ctr">
+                      <a:noFill/>
+                    </a:lnT>
+                    <a:lnB w="9525" cap="flat" cmpd="sng" algn="ctr">
+                      <a:solidFill>
+                        <a:srgbClr val="BFCAD3"/>
+                      </a:solidFill>
+                      <a:prstDash val="solid"/>
+                      <a:round/>
+                      <a:headEnd type="none" w="med" len="med"/>
+                      <a:tailEnd type="none" w="med" len="med"/>
+                    </a:lnB>
+                  </a:tcPr>
+                </a:tc>
+                <a:tc>
+                  <a:txBody>
+                    <a:bodyPr/>
+                    <a:lstStyle/>
+                    <a:p>
+                      <a:pPr indent="0" marL="0">
+                        <a:buNone/>
+                      </a:pPr>
+                      <a:r>
+                        <a:rPr lang="en-US" sz="1150" dirty="0">
                           <a:solidFill>
                             <a:srgbClr val="111C24"/>
                           </a:solidFill>
@@ -10091,44 +10349,44 @@
                         </a:rPr>
                         <a:t>Mon, Oct 5</a:t>
                       </a:r>
-                      <a:endParaRPr lang="en-US" sz="1200" dirty="0">
-                        <a:latin typeface="Calibri" charset="0"/>
-                        <a:ea typeface="Calibri" charset="0"/>
-                        <a:cs typeface="Calibri" charset="0"/>
-                      </a:endParaRPr>
-                    </a:p>
-                  </a:txBody>
-                  <a:tcPr marL="64008" marR="64008" marT="73152" marB="73152" anchor="ctr">
-                    <a:lnL w="0" cap="flat" cmpd="sng" algn="ctr">
-                      <a:noFill/>
-                    </a:lnL>
-                    <a:lnR w="0" cap="flat" cmpd="sng" algn="ctr">
-                      <a:noFill/>
-                    </a:lnR>
-                    <a:lnT w="0" cap="flat" cmpd="sng" algn="ctr">
-                      <a:noFill/>
-                    </a:lnT>
-                    <a:lnB w="9525" cap="flat" cmpd="sng" algn="ctr">
-                      <a:solidFill>
-                        <a:srgbClr val="BFCAD3"/>
-                      </a:solidFill>
-                      <a:prstDash val="solid"/>
-                      <a:round/>
-                      <a:headEnd type="none" w="med" len="med"/>
-                      <a:tailEnd type="none" w="med" len="med"/>
-                    </a:lnB>
-                  </a:tcPr>
-                </a:tc>
-                <a:tc>
-                  <a:txBody>
-                    <a:bodyPr/>
-                    <a:lstStyle/>
-                    <a:p>
-                      <a:pPr indent="0" marL="0">
-                        <a:buNone/>
-                      </a:pPr>
-                      <a:r>
-                        <a:rPr lang="en-US" sz="1200" dirty="0">
+                      <a:endParaRPr lang="en-US" sz="1150" dirty="0">
+                        <a:latin typeface="Calibri" charset="0"/>
+                        <a:ea typeface="Calibri" charset="0"/>
+                        <a:cs typeface="Calibri" charset="0"/>
+                      </a:endParaRPr>
+                    </a:p>
+                  </a:txBody>
+                  <a:tcPr marL="64008" marR="64008" marT="73152" marB="73152" anchor="ctr">
+                    <a:lnL w="0" cap="flat" cmpd="sng" algn="ctr">
+                      <a:noFill/>
+                    </a:lnL>
+                    <a:lnR w="0" cap="flat" cmpd="sng" algn="ctr">
+                      <a:noFill/>
+                    </a:lnR>
+                    <a:lnT w="0" cap="flat" cmpd="sng" algn="ctr">
+                      <a:noFill/>
+                    </a:lnT>
+                    <a:lnB w="9525" cap="flat" cmpd="sng" algn="ctr">
+                      <a:solidFill>
+                        <a:srgbClr val="BFCAD3"/>
+                      </a:solidFill>
+                      <a:prstDash val="solid"/>
+                      <a:round/>
+                      <a:headEnd type="none" w="med" len="med"/>
+                      <a:tailEnd type="none" w="med" len="med"/>
+                    </a:lnB>
+                  </a:tcPr>
+                </a:tc>
+                <a:tc>
+                  <a:txBody>
+                    <a:bodyPr/>
+                    <a:lstStyle/>
+                    <a:p>
+                      <a:pPr indent="0" marL="0">
+                        <a:buNone/>
+                      </a:pPr>
+                      <a:r>
+                        <a:rPr lang="en-US" sz="1150" dirty="0">
                           <a:solidFill>
                             <a:srgbClr val="111C24"/>
                           </a:solidFill>
@@ -10138,44 +10396,44 @@
                         </a:rPr>
                         <a:t>P1</a:t>
                       </a:r>
-                      <a:endParaRPr lang="en-US" sz="1200" dirty="0">
-                        <a:latin typeface="Calibri" charset="0"/>
-                        <a:ea typeface="Calibri" charset="0"/>
-                        <a:cs typeface="Calibri" charset="0"/>
-                      </a:endParaRPr>
-                    </a:p>
-                  </a:txBody>
-                  <a:tcPr marL="64008" marR="64008" marT="73152" marB="73152" anchor="ctr">
-                    <a:lnL w="0" cap="flat" cmpd="sng" algn="ctr">
-                      <a:noFill/>
-                    </a:lnL>
-                    <a:lnR w="0" cap="flat" cmpd="sng" algn="ctr">
-                      <a:noFill/>
-                    </a:lnR>
-                    <a:lnT w="0" cap="flat" cmpd="sng" algn="ctr">
-                      <a:noFill/>
-                    </a:lnT>
-                    <a:lnB w="9525" cap="flat" cmpd="sng" algn="ctr">
-                      <a:solidFill>
-                        <a:srgbClr val="BFCAD3"/>
-                      </a:solidFill>
-                      <a:prstDash val="solid"/>
-                      <a:round/>
-                      <a:headEnd type="none" w="med" len="med"/>
-                      <a:tailEnd type="none" w="med" len="med"/>
-                    </a:lnB>
-                  </a:tcPr>
-                </a:tc>
-                <a:tc>
-                  <a:txBody>
-                    <a:bodyPr/>
-                    <a:lstStyle/>
-                    <a:p>
-                      <a:pPr indent="0" marL="0">
-                        <a:buNone/>
-                      </a:pPr>
-                      <a:r>
-                        <a:rPr lang="en-US" sz="1200" dirty="0">
+                      <a:endParaRPr lang="en-US" sz="1150" dirty="0">
+                        <a:latin typeface="Calibri" charset="0"/>
+                        <a:ea typeface="Calibri" charset="0"/>
+                        <a:cs typeface="Calibri" charset="0"/>
+                      </a:endParaRPr>
+                    </a:p>
+                  </a:txBody>
+                  <a:tcPr marL="64008" marR="64008" marT="73152" marB="73152" anchor="ctr">
+                    <a:lnL w="0" cap="flat" cmpd="sng" algn="ctr">
+                      <a:noFill/>
+                    </a:lnL>
+                    <a:lnR w="0" cap="flat" cmpd="sng" algn="ctr">
+                      <a:noFill/>
+                    </a:lnR>
+                    <a:lnT w="0" cap="flat" cmpd="sng" algn="ctr">
+                      <a:noFill/>
+                    </a:lnT>
+                    <a:lnB w="9525" cap="flat" cmpd="sng" algn="ctr">
+                      <a:solidFill>
+                        <a:srgbClr val="BFCAD3"/>
+                      </a:solidFill>
+                      <a:prstDash val="solid"/>
+                      <a:round/>
+                      <a:headEnd type="none" w="med" len="med"/>
+                      <a:tailEnd type="none" w="med" len="med"/>
+                    </a:lnB>
+                  </a:tcPr>
+                </a:tc>
+                <a:tc>
+                  <a:txBody>
+                    <a:bodyPr/>
+                    <a:lstStyle/>
+                    <a:p>
+                      <a:pPr indent="0" marL="0">
+                        <a:buNone/>
+                      </a:pPr>
+                      <a:r>
+                        <a:rPr lang="en-US" sz="1150" dirty="0">
                           <a:solidFill>
                             <a:srgbClr val="111C24"/>
                           </a:solidFill>
@@ -10185,7 +10443,7 @@
                         </a:rPr>
                         <a:t>Y — since Sep 29</a:t>
                       </a:r>
-                      <a:endParaRPr lang="en-US" sz="1200" dirty="0">
+                      <a:endParaRPr lang="en-US" sz="1150" dirty="0">
                         <a:latin typeface="Calibri" charset="0"/>
                         <a:ea typeface="Calibri" charset="0"/>
                         <a:cs typeface="Calibri" charset="0"/>

</xml_diff>

<commit_message>
Weekly review: last three audit feedbacks close today
Cooling Sheets 4-PC, Bamboo Fitted and Cooling Fitted feedback is
completed today; they leave the carry-over list and next week starts a
new cycle.

Co-Authored-By: Claude Opus 5.5 <noreply@anthropic.com>
Claude-Session: https://claude.ai/code/session_017KBX8sQPKzAVHK5pu1jizF
</commit_message>
<xml_diff>
--- a/deliverables/PPC_Weekly_Review_Sep28-Oct2.pptx
+++ b/deliverables/PPC_Weekly_Review_Sep28-Oct2.pptx
@@ -2879,7 +2879,7 @@
                           <a:ea typeface="Calibri" pitchFamily="34" charset="-122"/>
                           <a:cs typeface="Calibri" pitchFamily="34" charset="-120"/>
                         </a:rPr>
-                        <a:t>Feedback posted on six: B4, B6, S4, S6, Satin Fitted, SS-S4. Cooling Sheets 4-PC drafted today. Bamboo Fitted and Cooling Fitted not posted</a:t>
+                        <a:t>Feedback posted on six: B4, B6, S4, S6, Satin Fitted, SS-S4. The remaining three, Cooling Sheets 4-PC, Bamboo Fitted and Cooling Fitted, are being completed today</a:t>
                       </a:r>
                       <a:endParaRPr lang="en-US" sz="1150" dirty="0">
                         <a:latin typeface="Calibri" charset="0"/>
@@ -2926,7 +2926,7 @@
                           <a:ea typeface="Calibri" pitchFamily="34" charset="-122"/>
                           <a:cs typeface="Calibri" pitchFamily="34" charset="-120"/>
                         </a:rPr>
-                        <a:t>6 of 9</a:t>
+                        <a:t>6 of 9 · 3 today</a:t>
                       </a:r>
                       <a:endParaRPr lang="en-US" sz="1150" dirty="0">
                         <a:latin typeface="Calibri" charset="0"/>
@@ -7522,7 +7522,7 @@
                 <a:ea typeface="Calibri" pitchFamily="34" charset="-122"/>
                 <a:cs typeface="Calibri" pitchFamily="34" charset="-120"/>
               </a:rPr>
-              <a:t>THE 18 OPEN ITEMS CARRIED INTO NEXT WEEK</a:t>
+              <a:t>THE 15 OPEN ITEMS CARRIED INTO NEXT WEEK</a:t>
             </a:r>
             <a:endParaRPr lang="en-US" sz="1050" dirty="0"/>
           </a:p>
@@ -7561,57 +7561,6 @@
                 <a:ea typeface="Calibri" pitchFamily="34" charset="-122"/>
                 <a:cs typeface="Calibri" pitchFamily="34" charset="-120"/>
               </a:rPr>
-              <a:t>Bamboo Fitted audit feedback</a:t>
-            </a:r>
-            <a:endParaRPr lang="en-US" sz="900" dirty="0"/>
-          </a:p>
-          <a:p>
-            <a:pPr indent="0" marL="0">
-              <a:buNone/>
-            </a:pPr>
-            <a:r>
-              <a:rPr lang="en-US" sz="900" dirty="0">
-                <a:solidFill>
-                  <a:srgbClr val="6E4A0F"/>
-                </a:solidFill>
-                <a:latin typeface="Calibri" pitchFamily="34" charset="0"/>
-                <a:ea typeface="Calibri" pitchFamily="34" charset="-122"/>
-                <a:cs typeface="Calibri" pitchFamily="34" charset="-120"/>
-              </a:rPr>
-              <a:t>Cooling Fitted audit feedback</a:t>
-            </a:r>
-            <a:endParaRPr lang="en-US" sz="900" dirty="0"/>
-          </a:p>
-          <a:p>
-            <a:pPr indent="0" marL="0">
-              <a:buNone/>
-            </a:pPr>
-            <a:r>
-              <a:rPr lang="en-US" sz="900" dirty="0">
-                <a:solidFill>
-                  <a:srgbClr val="6E4A0F"/>
-                </a:solidFill>
-                <a:latin typeface="Calibri" pitchFamily="34" charset="0"/>
-                <a:ea typeface="Calibri" pitchFamily="34" charset="-122"/>
-                <a:cs typeface="Calibri" pitchFamily="34" charset="-120"/>
-              </a:rPr>
-              <a:t>Cooling Sheets 4-PC feedback</a:t>
-            </a:r>
-            <a:endParaRPr lang="en-US" sz="900" dirty="0"/>
-          </a:p>
-          <a:p>
-            <a:pPr indent="0" marL="0">
-              <a:buNone/>
-            </a:pPr>
-            <a:r>
-              <a:rPr lang="en-US" sz="900" dirty="0">
-                <a:solidFill>
-                  <a:srgbClr val="6E4A0F"/>
-                </a:solidFill>
-                <a:latin typeface="Calibri" pitchFamily="34" charset="0"/>
-                <a:ea typeface="Calibri" pitchFamily="34" charset="-122"/>
-                <a:cs typeface="Calibri" pitchFamily="34" charset="-120"/>
-              </a:rPr>
               <a:t>Campaign-type list + screenshot</a:t>
             </a:r>
             <a:endParaRPr lang="en-US" sz="900" dirty="0"/>
@@ -7633,28 +7582,6 @@
             </a:r>
             <a:endParaRPr lang="en-US" sz="900" dirty="0"/>
           </a:p>
-        </p:txBody>
-      </p:sp>
-      <p:sp>
-        <p:nvSpPr>
-          <p:cNvPr id="10" name="Text 7"/>
-          <p:cNvSpPr txBox="1"/>
-          <p:nvPr/>
-        </p:nvSpPr>
-        <p:spPr>
-          <a:xfrm>
-            <a:off x="3566160" y="4992624"/>
-            <a:ext cx="2651760" cy="731520"/>
-          </a:xfrm>
-          <a:prstGeom prst="rect">
-            <a:avLst/>
-          </a:prstGeom>
-          <a:noFill/>
-          <a:ln/>
-        </p:spPr>
-        <p:txBody>
-          <a:bodyPr wrap="square" lIns="0" tIns="0" rIns="0" bIns="0" rtlCol="0" anchor="t"/>
-          <a:lstStyle/>
           <a:p>
             <a:pPr indent="0" marL="0">
               <a:buNone/>
@@ -7689,6 +7616,28 @@
             </a:r>
             <a:endParaRPr lang="en-US" sz="900" dirty="0"/>
           </a:p>
+        </p:txBody>
+      </p:sp>
+      <p:sp>
+        <p:nvSpPr>
+          <p:cNvPr id="10" name="Text 7"/>
+          <p:cNvSpPr txBox="1"/>
+          <p:nvPr/>
+        </p:nvSpPr>
+        <p:spPr>
+          <a:xfrm>
+            <a:off x="3566160" y="4992624"/>
+            <a:ext cx="2651760" cy="731520"/>
+          </a:xfrm>
+          <a:prstGeom prst="rect">
+            <a:avLst/>
+          </a:prstGeom>
+          <a:noFill/>
+          <a:ln/>
+        </p:spPr>
+        <p:txBody>
+          <a:bodyPr wrap="square" lIns="0" tIns="0" rIns="0" bIns="0" rtlCol="0" anchor="t"/>
+          <a:lstStyle/>
           <a:p>
             <a:pPr indent="0" marL="0">
               <a:buNone/>
@@ -7740,6 +7689,23 @@
             </a:r>
             <a:endParaRPr lang="en-US" sz="900" dirty="0"/>
           </a:p>
+          <a:p>
+            <a:pPr indent="0" marL="0">
+              <a:buNone/>
+            </a:pPr>
+            <a:r>
+              <a:rPr lang="en-US" sz="900" dirty="0">
+                <a:solidFill>
+                  <a:srgbClr val="6E4A0F"/>
+                </a:solidFill>
+                <a:latin typeface="Calibri" pitchFamily="34" charset="0"/>
+                <a:ea typeface="Calibri" pitchFamily="34" charset="-122"/>
+                <a:cs typeface="Calibri" pitchFamily="34" charset="-120"/>
+              </a:rPr>
+              <a:t>Q1 to Q8 engine decisions</a:t>
+            </a:r>
+            <a:endParaRPr lang="en-US" sz="900" dirty="0"/>
+          </a:p>
         </p:txBody>
       </p:sp>
       <p:sp>
@@ -7762,23 +7728,6 @@
         <p:txBody>
           <a:bodyPr wrap="square" lIns="0" tIns="0" rIns="0" bIns="0" rtlCol="0" anchor="t"/>
           <a:lstStyle/>
-          <a:p>
-            <a:pPr indent="0" marL="0">
-              <a:buNone/>
-            </a:pPr>
-            <a:r>
-              <a:rPr lang="en-US" sz="900" dirty="0">
-                <a:solidFill>
-                  <a:srgbClr val="6E4A0F"/>
-                </a:solidFill>
-                <a:latin typeface="Calibri" pitchFamily="34" charset="0"/>
-                <a:ea typeface="Calibri" pitchFamily="34" charset="-122"/>
-                <a:cs typeface="Calibri" pitchFamily="34" charset="-120"/>
-              </a:rPr>
-              <a:t>Q1 to Q8 engine decisions</a:t>
-            </a:r>
-            <a:endParaRPr lang="en-US" sz="900" dirty="0"/>
-          </a:p>
           <a:p>
             <a:pPr indent="0" marL="0">
               <a:buNone/>
@@ -9268,7 +9217,7 @@
                           <a:ea typeface="Calibri" pitchFamily="34" charset="-122"/>
                           <a:cs typeface="Calibri" pitchFamily="34" charset="-120"/>
                         </a:rPr>
-                        <a:t>Close Bamboo Fitted, Cooling Fitted and Cooling Sheets 4-PC, then run the next cycle on all nine</a:t>
+                        <a:t>Run the next cycle on all nine, Bamboo Monday and the rest Tuesday. This cycle closes today with the last three feedbacks</a:t>
                       </a:r>
                       <a:endParaRPr lang="en-US" sz="1150" dirty="0">
                         <a:latin typeface="Calibri" charset="0"/>
@@ -9409,7 +9358,7 @@
                           <a:ea typeface="Calibri" pitchFamily="34" charset="-122"/>
                           <a:cs typeface="Calibri" pitchFamily="34" charset="-120"/>
                         </a:rPr>
-                        <a:t>Y — since Sep 28</a:t>
+                        <a:t>N — new cycle</a:t>
                       </a:r>
                       <a:endParaRPr lang="en-US" sz="1150" dirty="0">
                         <a:latin typeface="Calibri" charset="0"/>

</xml_diff>

<commit_message>
Weekly review: drop the meeting cancellation notes
Co-Authored-By: Claude Opus 5.5 <noreply@anthropic.com>
Claude-Session: https://claude.ai/code/session_017KBX8sQPKzAVHK5pu1jizF
</commit_message>
<xml_diff>
--- a/deliverables/PPC_Weekly_Review_Sep28-Oct2.pptx
+++ b/deliverables/PPC_Weekly_Review_Sep28-Oct2.pptx
@@ -3949,7 +3949,7 @@
                           <a:ea typeface="Calibri" pitchFamily="34" charset="-122"/>
                           <a:cs typeface="Calibri" pitchFamily="34" charset="-120"/>
                         </a:rPr>
-                        <a:t>Daily huddles ran. No spend-check or change-log records posted. Monday meeting dropped; two Joseph calls cancelled</a:t>
+                        <a:t>Daily huddles ran. No spend-check or change-log records posted</a:t>
                       </a:r>
                       <a:endParaRPr lang="en-US" sz="1150" dirty="0">
                         <a:latin typeface="Calibri" charset="0"/>
@@ -12754,7 +12754,7 @@
                 <a:ea typeface="Calibri" pitchFamily="34" charset="-122"/>
                 <a:cs typeface="Calibri" pitchFamily="34" charset="-120"/>
               </a:rPr>
-              <a:t>Run in full for the first time this week.   ·   The Monday meeting was dropped and two Joseph calls were cancelled; Tuesday and Friday are the standing slots.</a:t>
+              <a:t>Run in full for the first time this week.</a:t>
             </a:r>
             <a:endParaRPr lang="en-US" sz="950" dirty="0"/>
           </a:p>

</xml_diff>

<commit_message>
Weekly review: remove the cadence-logging points
Drops the cadence and daily oversight row, the cadence-logged tile on
the cover and the spend-check item in next week's onboarding row.

Co-Authored-By: Claude Opus 5.5 <noreply@anthropic.com>
Claude-Session: https://claude.ai/code/session_017KBX8sQPKzAVHK5pu1jizF
</commit_message>
<xml_diff>
--- a/deliverables/PPC_Weekly_Review_Sep28-Oct2.pptx
+++ b/deliverables/PPC_Weekly_Review_Sep28-Oct2.pptx
@@ -1768,7 +1768,7 @@
                 <a:ea typeface="Cambria" pitchFamily="34" charset="-122"/>
                 <a:cs typeface="Cambria" pitchFamily="34" charset="-120"/>
               </a:rPr>
-              <a:t>6</a:t>
+              <a:t>5</a:t>
             </a:r>
             <a:endParaRPr lang="en-US" sz="3600" dirty="0"/>
           </a:p>
@@ -1821,7 +1821,7 @@
         </p:nvSpPr>
         <p:spPr>
           <a:xfrm>
-            <a:off x="3236976" y="4261104"/>
+            <a:off x="3758184" y="4261104"/>
             <a:ext cx="1783080" cy="548640"/>
           </a:xfrm>
           <a:prstGeom prst="rect">
@@ -1860,7 +1860,7 @@
         </p:nvSpPr>
         <p:spPr>
           <a:xfrm>
-            <a:off x="3236976" y="4846320"/>
+            <a:off x="3758184" y="4846320"/>
             <a:ext cx="1783080" cy="292608"/>
           </a:xfrm>
           <a:prstGeom prst="rect">
@@ -1899,7 +1899,7 @@
         </p:nvSpPr>
         <p:spPr>
           <a:xfrm>
-            <a:off x="2962656" y="4370832"/>
+            <a:off x="3483864" y="4370832"/>
             <a:ext cx="9144" cy="694944"/>
           </a:xfrm>
           <a:prstGeom prst="rect">
@@ -1919,7 +1919,7 @@
         </p:nvSpPr>
         <p:spPr>
           <a:xfrm>
-            <a:off x="5330952" y="4261104"/>
+            <a:off x="6373368" y="4261104"/>
             <a:ext cx="1783080" cy="548640"/>
           </a:xfrm>
           <a:prstGeom prst="rect">
@@ -1958,7 +1958,7 @@
         </p:nvSpPr>
         <p:spPr>
           <a:xfrm>
-            <a:off x="5330952" y="4846320"/>
+            <a:off x="6373368" y="4846320"/>
             <a:ext cx="1783080" cy="292608"/>
           </a:xfrm>
           <a:prstGeom prst="rect">
@@ -1997,7 +1997,7 @@
         </p:nvSpPr>
         <p:spPr>
           <a:xfrm>
-            <a:off x="5056632" y="4370832"/>
+            <a:off x="6099048" y="4370832"/>
             <a:ext cx="9144" cy="694944"/>
           </a:xfrm>
           <a:prstGeom prst="rect">
@@ -2017,7 +2017,7 @@
         </p:nvSpPr>
         <p:spPr>
           <a:xfrm>
-            <a:off x="7424928" y="4261104"/>
+            <a:off x="8988552" y="4261104"/>
             <a:ext cx="1783080" cy="548640"/>
           </a:xfrm>
           <a:prstGeom prst="rect">
@@ -2042,7 +2042,7 @@
                 <a:ea typeface="Cambria" pitchFamily="34" charset="-122"/>
                 <a:cs typeface="Cambria" pitchFamily="34" charset="-120"/>
               </a:rPr>
-              <a:t>1</a:t>
+              <a:t>0</a:t>
             </a:r>
             <a:endParaRPr lang="en-US" sz="3600" dirty="0"/>
           </a:p>
@@ -2056,7 +2056,7 @@
         </p:nvSpPr>
         <p:spPr>
           <a:xfrm>
-            <a:off x="7424928" y="4846320"/>
+            <a:off x="8988552" y="4846320"/>
             <a:ext cx="1783080" cy="292608"/>
           </a:xfrm>
           <a:prstGeom prst="rect">
@@ -2095,7 +2095,7 @@
         </p:nvSpPr>
         <p:spPr>
           <a:xfrm>
-            <a:off x="7150608" y="4370832"/>
+            <a:off x="8714232" y="4370832"/>
             <a:ext cx="9144" cy="694944"/>
           </a:xfrm>
           <a:prstGeom prst="rect">
@@ -2109,105 +2109,7 @@
       </p:sp>
       <p:sp>
         <p:nvSpPr>
-          <p:cNvPr id="20" name="Text 18"/>
-          <p:cNvSpPr txBox="1"/>
-          <p:nvPr/>
-        </p:nvSpPr>
-        <p:spPr>
-          <a:xfrm>
-            <a:off x="9518904" y="4261104"/>
-            <a:ext cx="1783080" cy="548640"/>
-          </a:xfrm>
-          <a:prstGeom prst="rect">
-            <a:avLst/>
-          </a:prstGeom>
-          <a:noFill/>
-          <a:ln/>
-        </p:spPr>
-        <p:txBody>
-          <a:bodyPr wrap="square" lIns="0" tIns="0" rIns="0" bIns="0" rtlCol="0" anchor="ctr"/>
-          <a:lstStyle/>
-          <a:p>
-            <a:pPr indent="0" marL="0">
-              <a:buNone/>
-            </a:pPr>
-            <a:r>
-              <a:rPr lang="en-US" sz="3600" b="1" dirty="0">
-                <a:solidFill>
-                  <a:srgbClr val="C9AEE0"/>
-                </a:solidFill>
-                <a:latin typeface="Cambria" pitchFamily="34" charset="0"/>
-                <a:ea typeface="Cambria" pitchFamily="34" charset="-122"/>
-                <a:cs typeface="Cambria" pitchFamily="34" charset="-120"/>
-              </a:rPr>
-              <a:t>0 of 4</a:t>
-            </a:r>
-            <a:endParaRPr lang="en-US" sz="3600" dirty="0"/>
-          </a:p>
-        </p:txBody>
-      </p:sp>
-      <p:sp>
-        <p:nvSpPr>
-          <p:cNvPr id="21" name="Text 19"/>
-          <p:cNvSpPr txBox="1"/>
-          <p:nvPr/>
-        </p:nvSpPr>
-        <p:spPr>
-          <a:xfrm>
-            <a:off x="9518904" y="4846320"/>
-            <a:ext cx="1783080" cy="292608"/>
-          </a:xfrm>
-          <a:prstGeom prst="rect">
-            <a:avLst/>
-          </a:prstGeom>
-          <a:noFill/>
-          <a:ln/>
-        </p:spPr>
-        <p:txBody>
-          <a:bodyPr wrap="square" lIns="0" tIns="0" rIns="0" bIns="0" rtlCol="0" anchor="ctr"/>
-          <a:lstStyle/>
-          <a:p>
-            <a:pPr indent="0" marL="0">
-              <a:buNone/>
-            </a:pPr>
-            <a:r>
-              <a:rPr lang="en-US" sz="1300" b="1" dirty="0">
-                <a:solidFill>
-                  <a:srgbClr val="C6D3DD"/>
-                </a:solidFill>
-                <a:latin typeface="Calibri" pitchFamily="34" charset="0"/>
-                <a:ea typeface="Calibri" pitchFamily="34" charset="-122"/>
-                <a:cs typeface="Calibri" pitchFamily="34" charset="-120"/>
-              </a:rPr>
-              <a:t>Cadence logged</a:t>
-            </a:r>
-            <a:endParaRPr lang="en-US" sz="1300" dirty="0"/>
-          </a:p>
-        </p:txBody>
-      </p:sp>
-      <p:sp>
-        <p:nvSpPr>
-          <p:cNvPr id="22" name="Shape 20"/>
-          <p:cNvSpPr/>
-          <p:nvPr/>
-        </p:nvSpPr>
-        <p:spPr>
-          <a:xfrm>
-            <a:off x="9244584" y="4370832"/>
-            <a:ext cx="9144" cy="694944"/>
-          </a:xfrm>
-          <a:prstGeom prst="rect">
-            <a:avLst/>
-          </a:prstGeom>
-          <a:solidFill>
-            <a:srgbClr val="2C5A78"/>
-          </a:solidFill>
-          <a:ln/>
-        </p:spPr>
-      </p:sp>
-      <p:sp>
-        <p:nvSpPr>
-          <p:cNvPr id="23" name="Shape 21"/>
+          <p:cNvPr id="20" name="Shape 18"/>
           <p:cNvSpPr/>
           <p:nvPr/>
         </p:nvSpPr>
@@ -2229,7 +2131,7 @@
       </p:sp>
       <p:pic>
         <p:nvPicPr>
-          <p:cNvPr id="24" name="Image 0" descr="preencoded.png">    </p:cNvPr>
+          <p:cNvPr id="21" name="Image 0" descr="preencoded.png">    </p:cNvPr>
           <p:cNvPicPr>
             <a:picLocks noChangeAspect="1"/>
           </p:cNvPicPr>
@@ -2253,7 +2155,7 @@
       </p:pic>
       <p:pic>
         <p:nvPicPr>
-          <p:cNvPr id="25" name="Image 1" descr="preencoded.png">    </p:cNvPr>
+          <p:cNvPr id="22" name="Image 1" descr="preencoded.png">    </p:cNvPr>
           <p:cNvPicPr>
             <a:picLocks noChangeAspect="1"/>
           </p:cNvPicPr>
@@ -2277,7 +2179,7 @@
       </p:pic>
       <p:pic>
         <p:nvPicPr>
-          <p:cNvPr id="26" name="Image 2" descr="preencoded.png">    </p:cNvPr>
+          <p:cNvPr id="23" name="Image 2" descr="preencoded.png">    </p:cNvPr>
           <p:cNvPicPr>
             <a:picLocks noChangeAspect="1"/>
           </p:cNvPicPr>
@@ -2301,7 +2203,7 @@
       </p:pic>
       <p:pic>
         <p:nvPicPr>
-          <p:cNvPr id="27" name="Image 3" descr="preencoded.png">    </p:cNvPr>
+          <p:cNvPr id="24" name="Image 3" descr="preencoded.png">    </p:cNvPr>
           <p:cNvPicPr>
             <a:picLocks noChangeAspect="1"/>
           </p:cNvPicPr>
@@ -2325,7 +2227,7 @@
       </p:pic>
       <p:pic>
         <p:nvPicPr>
-          <p:cNvPr id="28" name="Image 4" descr="preencoded.png">    </p:cNvPr>
+          <p:cNvPr id="25" name="Image 4" descr="preencoded.png">    </p:cNvPr>
           <p:cNvPicPr>
             <a:picLocks noChangeAspect="1"/>
           </p:cNvPicPr>
@@ -2756,7 +2658,7 @@
                         <a:buNone/>
                       </a:pPr>
                       <a:r>
-                        <a:rPr lang="en-US" sz="1150" b="1" dirty="0">
+                        <a:rPr lang="en-US" sz="1250" b="1" dirty="0">
                           <a:solidFill>
                             <a:srgbClr val="111C24"/>
                           </a:solidFill>
@@ -2766,18 +2668,18 @@
                         </a:rPr>
                         <a:t>Nine-product audit cycle</a:t>
                       </a:r>
-                      <a:endParaRPr lang="en-US" sz="1150" dirty="0">
-                        <a:latin typeface="Calibri" charset="0"/>
-                        <a:ea typeface="Calibri" charset="0"/>
-                        <a:cs typeface="Calibri" charset="0"/>
-                      </a:endParaRPr>
-                    </a:p>
-                    <a:p>
-                      <a:pPr indent="0" marL="0">
-                        <a:buNone/>
-                      </a:pPr>
-                      <a:r>
-                        <a:rPr lang="en-US" sz="1050" dirty="0">
+                      <a:endParaRPr lang="en-US" sz="1250" dirty="0">
+                        <a:latin typeface="Calibri" charset="0"/>
+                        <a:ea typeface="Calibri" charset="0"/>
+                        <a:cs typeface="Calibri" charset="0"/>
+                      </a:endParaRPr>
+                    </a:p>
+                    <a:p>
+                      <a:pPr indent="0" marL="0">
+                        <a:buNone/>
+                      </a:pPr>
+                      <a:r>
+                        <a:rPr lang="en-US" sz="1150" dirty="0">
                           <a:solidFill>
                             <a:srgbClr val="4E5A64"/>
                           </a:solidFill>
@@ -2787,44 +2689,44 @@
                         </a:rPr>
                         <a:t>All three · weekly cycle · P0</a:t>
                       </a:r>
-                      <a:endParaRPr lang="en-US" sz="1150" dirty="0">
-                        <a:latin typeface="Calibri" charset="0"/>
-                        <a:ea typeface="Calibri" charset="0"/>
-                        <a:cs typeface="Calibri" charset="0"/>
-                      </a:endParaRPr>
-                    </a:p>
-                  </a:txBody>
-                  <a:tcPr marL="64008" marR="64008" marT="73152" marB="73152" anchor="ctr">
-                    <a:lnL w="0" cap="flat" cmpd="sng" algn="ctr">
-                      <a:noFill/>
-                    </a:lnL>
-                    <a:lnR w="0" cap="flat" cmpd="sng" algn="ctr">
-                      <a:noFill/>
-                    </a:lnR>
-                    <a:lnT w="0" cap="flat" cmpd="sng" algn="ctr">
-                      <a:noFill/>
-                    </a:lnT>
-                    <a:lnB w="9525" cap="flat" cmpd="sng" algn="ctr">
-                      <a:solidFill>
-                        <a:srgbClr val="BFCAD3"/>
-                      </a:solidFill>
-                      <a:prstDash val="solid"/>
-                      <a:round/>
-                      <a:headEnd type="none" w="med" len="med"/>
-                      <a:tailEnd type="none" w="med" len="med"/>
-                    </a:lnB>
-                  </a:tcPr>
-                </a:tc>
-                <a:tc>
-                  <a:txBody>
-                    <a:bodyPr/>
-                    <a:lstStyle/>
-                    <a:p>
-                      <a:pPr indent="0" marL="0">
-                        <a:buNone/>
-                      </a:pPr>
-                      <a:r>
-                        <a:rPr lang="en-US" sz="1150" dirty="0">
+                      <a:endParaRPr lang="en-US" sz="1250" dirty="0">
+                        <a:latin typeface="Calibri" charset="0"/>
+                        <a:ea typeface="Calibri" charset="0"/>
+                        <a:cs typeface="Calibri" charset="0"/>
+                      </a:endParaRPr>
+                    </a:p>
+                  </a:txBody>
+                  <a:tcPr marL="64008" marR="64008" marT="73152" marB="73152" anchor="ctr">
+                    <a:lnL w="0" cap="flat" cmpd="sng" algn="ctr">
+                      <a:noFill/>
+                    </a:lnL>
+                    <a:lnR w="0" cap="flat" cmpd="sng" algn="ctr">
+                      <a:noFill/>
+                    </a:lnR>
+                    <a:lnT w="0" cap="flat" cmpd="sng" algn="ctr">
+                      <a:noFill/>
+                    </a:lnT>
+                    <a:lnB w="9525" cap="flat" cmpd="sng" algn="ctr">
+                      <a:solidFill>
+                        <a:srgbClr val="BFCAD3"/>
+                      </a:solidFill>
+                      <a:prstDash val="solid"/>
+                      <a:round/>
+                      <a:headEnd type="none" w="med" len="med"/>
+                      <a:tailEnd type="none" w="med" len="med"/>
+                    </a:lnB>
+                  </a:tcPr>
+                </a:tc>
+                <a:tc>
+                  <a:txBody>
+                    <a:bodyPr/>
+                    <a:lstStyle/>
+                    <a:p>
+                      <a:pPr indent="0" marL="0">
+                        <a:buNone/>
+                      </a:pPr>
+                      <a:r>
+                        <a:rPr lang="en-US" sz="1250" dirty="0">
                           <a:solidFill>
                             <a:srgbClr val="111C24"/>
                           </a:solidFill>
@@ -2834,44 +2736,44 @@
                         </a:rPr>
                         <a:t>All nine audited, reviewed by all three and executed through the app. Bamboo Monday, the rest Tuesday</a:t>
                       </a:r>
-                      <a:endParaRPr lang="en-US" sz="1150" dirty="0">
-                        <a:latin typeface="Calibri" charset="0"/>
-                        <a:ea typeface="Calibri" charset="0"/>
-                        <a:cs typeface="Calibri" charset="0"/>
-                      </a:endParaRPr>
-                    </a:p>
-                  </a:txBody>
-                  <a:tcPr marL="64008" marR="64008" marT="73152" marB="73152" anchor="ctr">
-                    <a:lnL w="0" cap="flat" cmpd="sng" algn="ctr">
-                      <a:noFill/>
-                    </a:lnL>
-                    <a:lnR w="0" cap="flat" cmpd="sng" algn="ctr">
-                      <a:noFill/>
-                    </a:lnR>
-                    <a:lnT w="0" cap="flat" cmpd="sng" algn="ctr">
-                      <a:noFill/>
-                    </a:lnT>
-                    <a:lnB w="9525" cap="flat" cmpd="sng" algn="ctr">
-                      <a:solidFill>
-                        <a:srgbClr val="BFCAD3"/>
-                      </a:solidFill>
-                      <a:prstDash val="solid"/>
-                      <a:round/>
-                      <a:headEnd type="none" w="med" len="med"/>
-                      <a:tailEnd type="none" w="med" len="med"/>
-                    </a:lnB>
-                  </a:tcPr>
-                </a:tc>
-                <a:tc>
-                  <a:txBody>
-                    <a:bodyPr/>
-                    <a:lstStyle/>
-                    <a:p>
-                      <a:pPr indent="0" marL="0">
-                        <a:buNone/>
-                      </a:pPr>
-                      <a:r>
-                        <a:rPr lang="en-US" sz="1150" dirty="0">
+                      <a:endParaRPr lang="en-US" sz="1250" dirty="0">
+                        <a:latin typeface="Calibri" charset="0"/>
+                        <a:ea typeface="Calibri" charset="0"/>
+                        <a:cs typeface="Calibri" charset="0"/>
+                      </a:endParaRPr>
+                    </a:p>
+                  </a:txBody>
+                  <a:tcPr marL="64008" marR="64008" marT="73152" marB="73152" anchor="ctr">
+                    <a:lnL w="0" cap="flat" cmpd="sng" algn="ctr">
+                      <a:noFill/>
+                    </a:lnL>
+                    <a:lnR w="0" cap="flat" cmpd="sng" algn="ctr">
+                      <a:noFill/>
+                    </a:lnR>
+                    <a:lnT w="0" cap="flat" cmpd="sng" algn="ctr">
+                      <a:noFill/>
+                    </a:lnT>
+                    <a:lnB w="9525" cap="flat" cmpd="sng" algn="ctr">
+                      <a:solidFill>
+                        <a:srgbClr val="BFCAD3"/>
+                      </a:solidFill>
+                      <a:prstDash val="solid"/>
+                      <a:round/>
+                      <a:headEnd type="none" w="med" len="med"/>
+                      <a:tailEnd type="none" w="med" len="med"/>
+                    </a:lnB>
+                  </a:tcPr>
+                </a:tc>
+                <a:tc>
+                  <a:txBody>
+                    <a:bodyPr/>
+                    <a:lstStyle/>
+                    <a:p>
+                      <a:pPr indent="0" marL="0">
+                        <a:buNone/>
+                      </a:pPr>
+                      <a:r>
+                        <a:rPr lang="en-US" sz="1250" dirty="0">
                           <a:solidFill>
                             <a:srgbClr val="111C24"/>
                           </a:solidFill>
@@ -2881,44 +2783,44 @@
                         </a:rPr>
                         <a:t>Feedback posted on six: B4, B6, S4, S6, Satin Fitted, SS-S4. The remaining three, Cooling Sheets 4-PC, Bamboo Fitted and Cooling Fitted, are being completed today</a:t>
                       </a:r>
-                      <a:endParaRPr lang="en-US" sz="1150" dirty="0">
-                        <a:latin typeface="Calibri" charset="0"/>
-                        <a:ea typeface="Calibri" charset="0"/>
-                        <a:cs typeface="Calibri" charset="0"/>
-                      </a:endParaRPr>
-                    </a:p>
-                  </a:txBody>
-                  <a:tcPr marL="64008" marR="64008" marT="73152" marB="73152" anchor="ctr">
-                    <a:lnL w="0" cap="flat" cmpd="sng" algn="ctr">
-                      <a:noFill/>
-                    </a:lnL>
-                    <a:lnR w="0" cap="flat" cmpd="sng" algn="ctr">
-                      <a:noFill/>
-                    </a:lnR>
-                    <a:lnT w="0" cap="flat" cmpd="sng" algn="ctr">
-                      <a:noFill/>
-                    </a:lnT>
-                    <a:lnB w="9525" cap="flat" cmpd="sng" algn="ctr">
-                      <a:solidFill>
-                        <a:srgbClr val="BFCAD3"/>
-                      </a:solidFill>
-                      <a:prstDash val="solid"/>
-                      <a:round/>
-                      <a:headEnd type="none" w="med" len="med"/>
-                      <a:tailEnd type="none" w="med" len="med"/>
-                    </a:lnB>
-                  </a:tcPr>
-                </a:tc>
-                <a:tc>
-                  <a:txBody>
-                    <a:bodyPr/>
-                    <a:lstStyle/>
-                    <a:p>
-                      <a:pPr indent="0" marL="0">
-                        <a:buNone/>
-                      </a:pPr>
-                      <a:r>
-                        <a:rPr lang="en-US" sz="1150" b="1" dirty="0">
+                      <a:endParaRPr lang="en-US" sz="1250" dirty="0">
+                        <a:latin typeface="Calibri" charset="0"/>
+                        <a:ea typeface="Calibri" charset="0"/>
+                        <a:cs typeface="Calibri" charset="0"/>
+                      </a:endParaRPr>
+                    </a:p>
+                  </a:txBody>
+                  <a:tcPr marL="64008" marR="64008" marT="73152" marB="73152" anchor="ctr">
+                    <a:lnL w="0" cap="flat" cmpd="sng" algn="ctr">
+                      <a:noFill/>
+                    </a:lnL>
+                    <a:lnR w="0" cap="flat" cmpd="sng" algn="ctr">
+                      <a:noFill/>
+                    </a:lnR>
+                    <a:lnT w="0" cap="flat" cmpd="sng" algn="ctr">
+                      <a:noFill/>
+                    </a:lnT>
+                    <a:lnB w="9525" cap="flat" cmpd="sng" algn="ctr">
+                      <a:solidFill>
+                        <a:srgbClr val="BFCAD3"/>
+                      </a:solidFill>
+                      <a:prstDash val="solid"/>
+                      <a:round/>
+                      <a:headEnd type="none" w="med" len="med"/>
+                      <a:tailEnd type="none" w="med" len="med"/>
+                    </a:lnB>
+                  </a:tcPr>
+                </a:tc>
+                <a:tc>
+                  <a:txBody>
+                    <a:bodyPr/>
+                    <a:lstStyle/>
+                    <a:p>
+                      <a:pPr indent="0" marL="0">
+                        <a:buNone/>
+                      </a:pPr>
+                      <a:r>
+                        <a:rPr lang="en-US" sz="1250" b="1" dirty="0">
                           <a:solidFill>
                             <a:srgbClr val="6E4A0F"/>
                           </a:solidFill>
@@ -2928,7 +2830,7 @@
                         </a:rPr>
                         <a:t>6 of 9 · 3 today</a:t>
                       </a:r>
-                      <a:endParaRPr lang="en-US" sz="1150" dirty="0">
+                      <a:endParaRPr lang="en-US" sz="1250" dirty="0">
                         <a:latin typeface="Calibri" charset="0"/>
                         <a:ea typeface="Calibri" charset="0"/>
                         <a:cs typeface="Calibri" charset="0"/>
@@ -2970,7 +2872,7 @@
                         <a:buNone/>
                       </a:pPr>
                       <a:r>
-                        <a:rPr lang="en-US" sz="1150" b="1" dirty="0">
+                        <a:rPr lang="en-US" sz="1250" b="1" dirty="0">
                           <a:solidFill>
                             <a:srgbClr val="111C24"/>
                           </a:solidFill>
@@ -2980,18 +2882,18 @@
                         </a:rPr>
                         <a:t>Engine corrections &amp; feedback</a:t>
                       </a:r>
-                      <a:endParaRPr lang="en-US" sz="1150" dirty="0">
-                        <a:latin typeface="Calibri" charset="0"/>
-                        <a:ea typeface="Calibri" charset="0"/>
-                        <a:cs typeface="Calibri" charset="0"/>
-                      </a:endParaRPr>
-                    </a:p>
-                    <a:p>
-                      <a:pPr indent="0" marL="0">
-                        <a:buNone/>
-                      </a:pPr>
-                      <a:r>
-                        <a:rPr lang="en-US" sz="1050" dirty="0">
+                      <a:endParaRPr lang="en-US" sz="1250" dirty="0">
+                        <a:latin typeface="Calibri" charset="0"/>
+                        <a:ea typeface="Calibri" charset="0"/>
+                        <a:cs typeface="Calibri" charset="0"/>
+                      </a:endParaRPr>
+                    </a:p>
+                    <a:p>
+                      <a:pPr indent="0" marL="0">
+                        <a:buNone/>
+                      </a:pPr>
+                      <a:r>
+                        <a:rPr lang="en-US" sz="1150" dirty="0">
                           <a:solidFill>
                             <a:srgbClr val="4E5A64"/>
                           </a:solidFill>
@@ -3001,44 +2903,44 @@
                         </a:rPr>
                         <a:t>Joseph with PPC review · P0</a:t>
                       </a:r>
-                      <a:endParaRPr lang="en-US" sz="1150" dirty="0">
-                        <a:latin typeface="Calibri" charset="0"/>
-                        <a:ea typeface="Calibri" charset="0"/>
-                        <a:cs typeface="Calibri" charset="0"/>
-                      </a:endParaRPr>
-                    </a:p>
-                  </a:txBody>
-                  <a:tcPr marL="64008" marR="64008" marT="73152" marB="73152" anchor="ctr">
-                    <a:lnL w="0" cap="flat" cmpd="sng" algn="ctr">
-                      <a:noFill/>
-                    </a:lnL>
-                    <a:lnR w="0" cap="flat" cmpd="sng" algn="ctr">
-                      <a:noFill/>
-                    </a:lnR>
-                    <a:lnT w="0" cap="flat" cmpd="sng" algn="ctr">
-                      <a:noFill/>
-                    </a:lnT>
-                    <a:lnB w="9525" cap="flat" cmpd="sng" algn="ctr">
-                      <a:solidFill>
-                        <a:srgbClr val="BFCAD3"/>
-                      </a:solidFill>
-                      <a:prstDash val="solid"/>
-                      <a:round/>
-                      <a:headEnd type="none" w="med" len="med"/>
-                      <a:tailEnd type="none" w="med" len="med"/>
-                    </a:lnB>
-                  </a:tcPr>
-                </a:tc>
-                <a:tc>
-                  <a:txBody>
-                    <a:bodyPr/>
-                    <a:lstStyle/>
-                    <a:p>
-                      <a:pPr indent="0" marL="0">
-                        <a:buNone/>
-                      </a:pPr>
-                      <a:r>
-                        <a:rPr lang="en-US" sz="1150" dirty="0">
+                      <a:endParaRPr lang="en-US" sz="1250" dirty="0">
+                        <a:latin typeface="Calibri" charset="0"/>
+                        <a:ea typeface="Calibri" charset="0"/>
+                        <a:cs typeface="Calibri" charset="0"/>
+                      </a:endParaRPr>
+                    </a:p>
+                  </a:txBody>
+                  <a:tcPr marL="64008" marR="64008" marT="73152" marB="73152" anchor="ctr">
+                    <a:lnL w="0" cap="flat" cmpd="sng" algn="ctr">
+                      <a:noFill/>
+                    </a:lnL>
+                    <a:lnR w="0" cap="flat" cmpd="sng" algn="ctr">
+                      <a:noFill/>
+                    </a:lnR>
+                    <a:lnT w="0" cap="flat" cmpd="sng" algn="ctr">
+                      <a:noFill/>
+                    </a:lnT>
+                    <a:lnB w="9525" cap="flat" cmpd="sng" algn="ctr">
+                      <a:solidFill>
+                        <a:srgbClr val="BFCAD3"/>
+                      </a:solidFill>
+                      <a:prstDash val="solid"/>
+                      <a:round/>
+                      <a:headEnd type="none" w="med" len="med"/>
+                      <a:tailEnd type="none" w="med" len="med"/>
+                    </a:lnB>
+                  </a:tcPr>
+                </a:tc>
+                <a:tc>
+                  <a:txBody>
+                    <a:bodyPr/>
+                    <a:lstStyle/>
+                    <a:p>
+                      <a:pPr indent="0" marL="0">
+                        <a:buNone/>
+                      </a:pPr>
+                      <a:r>
+                        <a:rPr lang="en-US" sz="1250" dirty="0">
                           <a:solidFill>
                             <a:srgbClr val="111C24"/>
                           </a:solidFill>
@@ -3048,44 +2950,44 @@
                         </a:rPr>
                         <a:t>One consolidated note per product to Joseph, engine fixed and the audits re-run on the corrections</a:t>
                       </a:r>
-                      <a:endParaRPr lang="en-US" sz="1150" dirty="0">
-                        <a:latin typeface="Calibri" charset="0"/>
-                        <a:ea typeface="Calibri" charset="0"/>
-                        <a:cs typeface="Calibri" charset="0"/>
-                      </a:endParaRPr>
-                    </a:p>
-                  </a:txBody>
-                  <a:tcPr marL="64008" marR="64008" marT="73152" marB="73152" anchor="ctr">
-                    <a:lnL w="0" cap="flat" cmpd="sng" algn="ctr">
-                      <a:noFill/>
-                    </a:lnL>
-                    <a:lnR w="0" cap="flat" cmpd="sng" algn="ctr">
-                      <a:noFill/>
-                    </a:lnR>
-                    <a:lnT w="0" cap="flat" cmpd="sng" algn="ctr">
-                      <a:noFill/>
-                    </a:lnT>
-                    <a:lnB w="9525" cap="flat" cmpd="sng" algn="ctr">
-                      <a:solidFill>
-                        <a:srgbClr val="BFCAD3"/>
-                      </a:solidFill>
-                      <a:prstDash val="solid"/>
-                      <a:round/>
-                      <a:headEnd type="none" w="med" len="med"/>
-                      <a:tailEnd type="none" w="med" len="med"/>
-                    </a:lnB>
-                  </a:tcPr>
-                </a:tc>
-                <a:tc>
-                  <a:txBody>
-                    <a:bodyPr/>
-                    <a:lstStyle/>
-                    <a:p>
-                      <a:pPr indent="0" marL="0">
-                        <a:buNone/>
-                      </a:pPr>
-                      <a:r>
-                        <a:rPr lang="en-US" sz="1150" dirty="0">
+                      <a:endParaRPr lang="en-US" sz="1250" dirty="0">
+                        <a:latin typeface="Calibri" charset="0"/>
+                        <a:ea typeface="Calibri" charset="0"/>
+                        <a:cs typeface="Calibri" charset="0"/>
+                      </a:endParaRPr>
+                    </a:p>
+                  </a:txBody>
+                  <a:tcPr marL="64008" marR="64008" marT="73152" marB="73152" anchor="ctr">
+                    <a:lnL w="0" cap="flat" cmpd="sng" algn="ctr">
+                      <a:noFill/>
+                    </a:lnL>
+                    <a:lnR w="0" cap="flat" cmpd="sng" algn="ctr">
+                      <a:noFill/>
+                    </a:lnR>
+                    <a:lnT w="0" cap="flat" cmpd="sng" algn="ctr">
+                      <a:noFill/>
+                    </a:lnT>
+                    <a:lnB w="9525" cap="flat" cmpd="sng" algn="ctr">
+                      <a:solidFill>
+                        <a:srgbClr val="BFCAD3"/>
+                      </a:solidFill>
+                      <a:prstDash val="solid"/>
+                      <a:round/>
+                      <a:headEnd type="none" w="med" len="med"/>
+                      <a:tailEnd type="none" w="med" len="med"/>
+                    </a:lnB>
+                  </a:tcPr>
+                </a:tc>
+                <a:tc>
+                  <a:txBody>
+                    <a:bodyPr/>
+                    <a:lstStyle/>
+                    <a:p>
+                      <a:pPr indent="0" marL="0">
+                        <a:buNone/>
+                      </a:pPr>
+                      <a:r>
+                        <a:rPr lang="en-US" sz="1250" dirty="0">
                           <a:solidFill>
                             <a:srgbClr val="111C24"/>
                           </a:solidFill>
@@ -3095,44 +2997,44 @@
                         </a:rPr>
                         <a:t>B4 and B6 corrections applied and re-audited 29 Sep, the first clean 218/218 pass. Engine feedback doc and issue register delivered today</a:t>
                       </a:r>
-                      <a:endParaRPr lang="en-US" sz="1150" dirty="0">
-                        <a:latin typeface="Calibri" charset="0"/>
-                        <a:ea typeface="Calibri" charset="0"/>
-                        <a:cs typeface="Calibri" charset="0"/>
-                      </a:endParaRPr>
-                    </a:p>
-                  </a:txBody>
-                  <a:tcPr marL="64008" marR="64008" marT="73152" marB="73152" anchor="ctr">
-                    <a:lnL w="0" cap="flat" cmpd="sng" algn="ctr">
-                      <a:noFill/>
-                    </a:lnL>
-                    <a:lnR w="0" cap="flat" cmpd="sng" algn="ctr">
-                      <a:noFill/>
-                    </a:lnR>
-                    <a:lnT w="0" cap="flat" cmpd="sng" algn="ctr">
-                      <a:noFill/>
-                    </a:lnT>
-                    <a:lnB w="9525" cap="flat" cmpd="sng" algn="ctr">
-                      <a:solidFill>
-                        <a:srgbClr val="BFCAD3"/>
-                      </a:solidFill>
-                      <a:prstDash val="solid"/>
-                      <a:round/>
-                      <a:headEnd type="none" w="med" len="med"/>
-                      <a:tailEnd type="none" w="med" len="med"/>
-                    </a:lnB>
-                  </a:tcPr>
-                </a:tc>
-                <a:tc>
-                  <a:txBody>
-                    <a:bodyPr/>
-                    <a:lstStyle/>
-                    <a:p>
-                      <a:pPr indent="0" marL="0">
-                        <a:buNone/>
-                      </a:pPr>
-                      <a:r>
-                        <a:rPr lang="en-US" sz="1150" b="1" dirty="0">
+                      <a:endParaRPr lang="en-US" sz="1250" dirty="0">
+                        <a:latin typeface="Calibri" charset="0"/>
+                        <a:ea typeface="Calibri" charset="0"/>
+                        <a:cs typeface="Calibri" charset="0"/>
+                      </a:endParaRPr>
+                    </a:p>
+                  </a:txBody>
+                  <a:tcPr marL="64008" marR="64008" marT="73152" marB="73152" anchor="ctr">
+                    <a:lnL w="0" cap="flat" cmpd="sng" algn="ctr">
+                      <a:noFill/>
+                    </a:lnL>
+                    <a:lnR w="0" cap="flat" cmpd="sng" algn="ctr">
+                      <a:noFill/>
+                    </a:lnR>
+                    <a:lnT w="0" cap="flat" cmpd="sng" algn="ctr">
+                      <a:noFill/>
+                    </a:lnT>
+                    <a:lnB w="9525" cap="flat" cmpd="sng" algn="ctr">
+                      <a:solidFill>
+                        <a:srgbClr val="BFCAD3"/>
+                      </a:solidFill>
+                      <a:prstDash val="solid"/>
+                      <a:round/>
+                      <a:headEnd type="none" w="med" len="med"/>
+                      <a:tailEnd type="none" w="med" len="med"/>
+                    </a:lnB>
+                  </a:tcPr>
+                </a:tc>
+                <a:tc>
+                  <a:txBody>
+                    <a:bodyPr/>
+                    <a:lstStyle/>
+                    <a:p>
+                      <a:pPr indent="0" marL="0">
+                        <a:buNone/>
+                      </a:pPr>
+                      <a:r>
+                        <a:rPr lang="en-US" sz="1250" b="1" dirty="0">
                           <a:solidFill>
                             <a:srgbClr val="176B41"/>
                           </a:solidFill>
@@ -3142,7 +3044,7 @@
                         </a:rPr>
                         <a:t>Done</a:t>
                       </a:r>
-                      <a:endParaRPr lang="en-US" sz="1150" dirty="0">
+                      <a:endParaRPr lang="en-US" sz="1250" dirty="0">
                         <a:latin typeface="Calibri" charset="0"/>
                         <a:ea typeface="Calibri" charset="0"/>
                         <a:cs typeface="Calibri" charset="0"/>
@@ -3184,7 +3086,7 @@
                         <a:buNone/>
                       </a:pPr>
                       <a:r>
-                        <a:rPr lang="en-US" sz="1150" b="1" dirty="0">
+                        <a:rPr lang="en-US" sz="1250" b="1" dirty="0">
                           <a:solidFill>
                             <a:srgbClr val="111C24"/>
                           </a:solidFill>
@@ -3194,18 +3096,18 @@
                         </a:rPr>
                         <a:t>Bamboo ranking push (B4, B6)</a:t>
                       </a:r>
-                      <a:endParaRPr lang="en-US" sz="1150" dirty="0">
-                        <a:latin typeface="Calibri" charset="0"/>
-                        <a:ea typeface="Calibri" charset="0"/>
-                        <a:cs typeface="Calibri" charset="0"/>
-                      </a:endParaRPr>
-                    </a:p>
-                    <a:p>
-                      <a:pPr indent="0" marL="0">
-                        <a:buNone/>
-                      </a:pPr>
-                      <a:r>
-                        <a:rPr lang="en-US" sz="1050" dirty="0">
+                      <a:endParaRPr lang="en-US" sz="1250" dirty="0">
+                        <a:latin typeface="Calibri" charset="0"/>
+                        <a:ea typeface="Calibri" charset="0"/>
+                        <a:cs typeface="Calibri" charset="0"/>
+                      </a:endParaRPr>
+                    </a:p>
+                    <a:p>
+                      <a:pPr indent="0" marL="0">
+                        <a:buNone/>
+                      </a:pPr>
+                      <a:r>
+                        <a:rPr lang="en-US" sz="1150" dirty="0">
                           <a:solidFill>
                             <a:srgbClr val="4E5A64"/>
                           </a:solidFill>
@@ -3215,44 +3117,44 @@
                         </a:rPr>
                         <a:t>Shayan T with Joseph · P0</a:t>
                       </a:r>
-                      <a:endParaRPr lang="en-US" sz="1150" dirty="0">
-                        <a:latin typeface="Calibri" charset="0"/>
-                        <a:ea typeface="Calibri" charset="0"/>
-                        <a:cs typeface="Calibri" charset="0"/>
-                      </a:endParaRPr>
-                    </a:p>
-                  </a:txBody>
-                  <a:tcPr marL="64008" marR="64008" marT="73152" marB="73152" anchor="ctr">
-                    <a:lnL w="0" cap="flat" cmpd="sng" algn="ctr">
-                      <a:noFill/>
-                    </a:lnL>
-                    <a:lnR w="0" cap="flat" cmpd="sng" algn="ctr">
-                      <a:noFill/>
-                    </a:lnR>
-                    <a:lnT w="0" cap="flat" cmpd="sng" algn="ctr">
-                      <a:noFill/>
-                    </a:lnT>
-                    <a:lnB w="9525" cap="flat" cmpd="sng" algn="ctr">
-                      <a:solidFill>
-                        <a:srgbClr val="BFCAD3"/>
-                      </a:solidFill>
-                      <a:prstDash val="solid"/>
-                      <a:round/>
-                      <a:headEnd type="none" w="med" len="med"/>
-                      <a:tailEnd type="none" w="med" len="med"/>
-                    </a:lnB>
-                  </a:tcPr>
-                </a:tc>
-                <a:tc>
-                  <a:txBody>
-                    <a:bodyPr/>
-                    <a:lstStyle/>
-                    <a:p>
-                      <a:pPr indent="0" marL="0">
-                        <a:buNone/>
-                      </a:pPr>
-                      <a:r>
-                        <a:rPr lang="en-US" sz="1150" dirty="0">
+                      <a:endParaRPr lang="en-US" sz="1250" dirty="0">
+                        <a:latin typeface="Calibri" charset="0"/>
+                        <a:ea typeface="Calibri" charset="0"/>
+                        <a:cs typeface="Calibri" charset="0"/>
+                      </a:endParaRPr>
+                    </a:p>
+                  </a:txBody>
+                  <a:tcPr marL="64008" marR="64008" marT="73152" marB="73152" anchor="ctr">
+                    <a:lnL w="0" cap="flat" cmpd="sng" algn="ctr">
+                      <a:noFill/>
+                    </a:lnL>
+                    <a:lnR w="0" cap="flat" cmpd="sng" algn="ctr">
+                      <a:noFill/>
+                    </a:lnR>
+                    <a:lnT w="0" cap="flat" cmpd="sng" algn="ctr">
+                      <a:noFill/>
+                    </a:lnT>
+                    <a:lnB w="9525" cap="flat" cmpd="sng" algn="ctr">
+                      <a:solidFill>
+                        <a:srgbClr val="BFCAD3"/>
+                      </a:solidFill>
+                      <a:prstDash val="solid"/>
+                      <a:round/>
+                      <a:headEnd type="none" w="med" len="med"/>
+                      <a:tailEnd type="none" w="med" len="med"/>
+                    </a:lnB>
+                  </a:tcPr>
+                </a:tc>
+                <a:tc>
+                  <a:txBody>
+                    <a:bodyPr/>
+                    <a:lstStyle/>
+                    <a:p>
+                      <a:pPr indent="0" marL="0">
+                        <a:buNone/>
+                      </a:pPr>
+                      <a:r>
+                        <a:rPr lang="en-US" sz="1250" dirty="0">
                           <a:solidFill>
                             <a:srgbClr val="111C24"/>
                           </a:solidFill>
@@ -3262,44 +3164,44 @@
                         </a:rPr>
                         <a:t>One ranking plan per listing, matched to Joseph's keyword story and plan of attack, before the pushes start</a:t>
                       </a:r>
-                      <a:endParaRPr lang="en-US" sz="1150" dirty="0">
-                        <a:latin typeface="Calibri" charset="0"/>
-                        <a:ea typeface="Calibri" charset="0"/>
-                        <a:cs typeface="Calibri" charset="0"/>
-                      </a:endParaRPr>
-                    </a:p>
-                  </a:txBody>
-                  <a:tcPr marL="64008" marR="64008" marT="73152" marB="73152" anchor="ctr">
-                    <a:lnL w="0" cap="flat" cmpd="sng" algn="ctr">
-                      <a:noFill/>
-                    </a:lnL>
-                    <a:lnR w="0" cap="flat" cmpd="sng" algn="ctr">
-                      <a:noFill/>
-                    </a:lnR>
-                    <a:lnT w="0" cap="flat" cmpd="sng" algn="ctr">
-                      <a:noFill/>
-                    </a:lnT>
-                    <a:lnB w="9525" cap="flat" cmpd="sng" algn="ctr">
-                      <a:solidFill>
-                        <a:srgbClr val="BFCAD3"/>
-                      </a:solidFill>
-                      <a:prstDash val="solid"/>
-                      <a:round/>
-                      <a:headEnd type="none" w="med" len="med"/>
-                      <a:tailEnd type="none" w="med" len="med"/>
-                    </a:lnB>
-                  </a:tcPr>
-                </a:tc>
-                <a:tc>
-                  <a:txBody>
-                    <a:bodyPr/>
-                    <a:lstStyle/>
-                    <a:p>
-                      <a:pPr indent="0" marL="0">
-                        <a:buNone/>
-                      </a:pPr>
-                      <a:r>
-                        <a:rPr lang="en-US" sz="1150" dirty="0">
+                      <a:endParaRPr lang="en-US" sz="1250" dirty="0">
+                        <a:latin typeface="Calibri" charset="0"/>
+                        <a:ea typeface="Calibri" charset="0"/>
+                        <a:cs typeface="Calibri" charset="0"/>
+                      </a:endParaRPr>
+                    </a:p>
+                  </a:txBody>
+                  <a:tcPr marL="64008" marR="64008" marT="73152" marB="73152" anchor="ctr">
+                    <a:lnL w="0" cap="flat" cmpd="sng" algn="ctr">
+                      <a:noFill/>
+                    </a:lnL>
+                    <a:lnR w="0" cap="flat" cmpd="sng" algn="ctr">
+                      <a:noFill/>
+                    </a:lnR>
+                    <a:lnT w="0" cap="flat" cmpd="sng" algn="ctr">
+                      <a:noFill/>
+                    </a:lnT>
+                    <a:lnB w="9525" cap="flat" cmpd="sng" algn="ctr">
+                      <a:solidFill>
+                        <a:srgbClr val="BFCAD3"/>
+                      </a:solidFill>
+                      <a:prstDash val="solid"/>
+                      <a:round/>
+                      <a:headEnd type="none" w="med" len="med"/>
+                      <a:tailEnd type="none" w="med" len="med"/>
+                    </a:lnB>
+                  </a:tcPr>
+                </a:tc>
+                <a:tc>
+                  <a:txBody>
+                    <a:bodyPr/>
+                    <a:lstStyle/>
+                    <a:p>
+                      <a:pPr indent="0" marL="0">
+                        <a:buNone/>
+                      </a:pPr>
+                      <a:r>
+                        <a:rPr lang="en-US" sz="1250" dirty="0">
                           <a:solidFill>
                             <a:srgbClr val="111C24"/>
                           </a:solidFill>
@@ -3309,44 +3211,44 @@
                         </a:rPr>
                         <a:t>Plan of attack shared 1 Oct. B4 and B6 plans finalised 2 Oct: B4 follows its start dates and colours by size; B6 replaces the 30 Sep plan. Erik's 2 Oct points built in</a:t>
                       </a:r>
-                      <a:endParaRPr lang="en-US" sz="1150" dirty="0">
-                        <a:latin typeface="Calibri" charset="0"/>
-                        <a:ea typeface="Calibri" charset="0"/>
-                        <a:cs typeface="Calibri" charset="0"/>
-                      </a:endParaRPr>
-                    </a:p>
-                  </a:txBody>
-                  <a:tcPr marL="64008" marR="64008" marT="73152" marB="73152" anchor="ctr">
-                    <a:lnL w="0" cap="flat" cmpd="sng" algn="ctr">
-                      <a:noFill/>
-                    </a:lnL>
-                    <a:lnR w="0" cap="flat" cmpd="sng" algn="ctr">
-                      <a:noFill/>
-                    </a:lnR>
-                    <a:lnT w="0" cap="flat" cmpd="sng" algn="ctr">
-                      <a:noFill/>
-                    </a:lnT>
-                    <a:lnB w="9525" cap="flat" cmpd="sng" algn="ctr">
-                      <a:solidFill>
-                        <a:srgbClr val="BFCAD3"/>
-                      </a:solidFill>
-                      <a:prstDash val="solid"/>
-                      <a:round/>
-                      <a:headEnd type="none" w="med" len="med"/>
-                      <a:tailEnd type="none" w="med" len="med"/>
-                    </a:lnB>
-                  </a:tcPr>
-                </a:tc>
-                <a:tc>
-                  <a:txBody>
-                    <a:bodyPr/>
-                    <a:lstStyle/>
-                    <a:p>
-                      <a:pPr indent="0" marL="0">
-                        <a:buNone/>
-                      </a:pPr>
-                      <a:r>
-                        <a:rPr lang="en-US" sz="1150" b="1" dirty="0">
+                      <a:endParaRPr lang="en-US" sz="1250" dirty="0">
+                        <a:latin typeface="Calibri" charset="0"/>
+                        <a:ea typeface="Calibri" charset="0"/>
+                        <a:cs typeface="Calibri" charset="0"/>
+                      </a:endParaRPr>
+                    </a:p>
+                  </a:txBody>
+                  <a:tcPr marL="64008" marR="64008" marT="73152" marB="73152" anchor="ctr">
+                    <a:lnL w="0" cap="flat" cmpd="sng" algn="ctr">
+                      <a:noFill/>
+                    </a:lnL>
+                    <a:lnR w="0" cap="flat" cmpd="sng" algn="ctr">
+                      <a:noFill/>
+                    </a:lnR>
+                    <a:lnT w="0" cap="flat" cmpd="sng" algn="ctr">
+                      <a:noFill/>
+                    </a:lnT>
+                    <a:lnB w="9525" cap="flat" cmpd="sng" algn="ctr">
+                      <a:solidFill>
+                        <a:srgbClr val="BFCAD3"/>
+                      </a:solidFill>
+                      <a:prstDash val="solid"/>
+                      <a:round/>
+                      <a:headEnd type="none" w="med" len="med"/>
+                      <a:tailEnd type="none" w="med" len="med"/>
+                    </a:lnB>
+                  </a:tcPr>
+                </a:tc>
+                <a:tc>
+                  <a:txBody>
+                    <a:bodyPr/>
+                    <a:lstStyle/>
+                    <a:p>
+                      <a:pPr indent="0" marL="0">
+                        <a:buNone/>
+                      </a:pPr>
+                      <a:r>
+                        <a:rPr lang="en-US" sz="1250" b="1" dirty="0">
                           <a:solidFill>
                             <a:srgbClr val="176B41"/>
                           </a:solidFill>
@@ -3356,7 +3258,7 @@
                         </a:rPr>
                         <a:t>Plans final</a:t>
                       </a:r>
-                      <a:endParaRPr lang="en-US" sz="1150" dirty="0">
+                      <a:endParaRPr lang="en-US" sz="1250" dirty="0">
                         <a:latin typeface="Calibri" charset="0"/>
                         <a:ea typeface="Calibri" charset="0"/>
                         <a:cs typeface="Calibri" charset="0"/>
@@ -3398,7 +3300,7 @@
                         <a:buNone/>
                       </a:pPr>
                       <a:r>
-                        <a:rPr lang="en-US" sz="1150" b="1" dirty="0">
+                        <a:rPr lang="en-US" sz="1250" b="1" dirty="0">
                           <a:solidFill>
                             <a:srgbClr val="111C24"/>
                           </a:solidFill>
@@ -3408,18 +3310,18 @@
                         </a:rPr>
                         <a:t>Process deliverables</a:t>
                       </a:r>
-                      <a:endParaRPr lang="en-US" sz="1150" dirty="0">
-                        <a:latin typeface="Calibri" charset="0"/>
-                        <a:ea typeface="Calibri" charset="0"/>
-                        <a:cs typeface="Calibri" charset="0"/>
-                      </a:endParaRPr>
-                    </a:p>
-                    <a:p>
-                      <a:pPr indent="0" marL="0">
-                        <a:buNone/>
-                      </a:pPr>
-                      <a:r>
-                        <a:rPr lang="en-US" sz="1050" dirty="0">
+                      <a:endParaRPr lang="en-US" sz="1250" dirty="0">
+                        <a:latin typeface="Calibri" charset="0"/>
+                        <a:ea typeface="Calibri" charset="0"/>
+                        <a:cs typeface="Calibri" charset="0"/>
+                      </a:endParaRPr>
+                    </a:p>
+                    <a:p>
+                      <a:pPr indent="0" marL="0">
+                        <a:buNone/>
+                      </a:pPr>
+                      <a:r>
+                        <a:rPr lang="en-US" sz="1150" dirty="0">
                           <a:solidFill>
                             <a:srgbClr val="4E5A64"/>
                           </a:solidFill>
@@ -3429,44 +3331,44 @@
                         </a:rPr>
                         <a:t>Shayan T · one-off · P0</a:t>
                       </a:r>
-                      <a:endParaRPr lang="en-US" sz="1150" dirty="0">
-                        <a:latin typeface="Calibri" charset="0"/>
-                        <a:ea typeface="Calibri" charset="0"/>
-                        <a:cs typeface="Calibri" charset="0"/>
-                      </a:endParaRPr>
-                    </a:p>
-                  </a:txBody>
-                  <a:tcPr marL="64008" marR="64008" marT="73152" marB="73152" anchor="ctr">
-                    <a:lnL w="0" cap="flat" cmpd="sng" algn="ctr">
-                      <a:noFill/>
-                    </a:lnL>
-                    <a:lnR w="0" cap="flat" cmpd="sng" algn="ctr">
-                      <a:noFill/>
-                    </a:lnR>
-                    <a:lnT w="0" cap="flat" cmpd="sng" algn="ctr">
-                      <a:noFill/>
-                    </a:lnT>
-                    <a:lnB w="9525" cap="flat" cmpd="sng" algn="ctr">
-                      <a:solidFill>
-                        <a:srgbClr val="BFCAD3"/>
-                      </a:solidFill>
-                      <a:prstDash val="solid"/>
-                      <a:round/>
-                      <a:headEnd type="none" w="med" len="med"/>
-                      <a:tailEnd type="none" w="med" len="med"/>
-                    </a:lnB>
-                  </a:tcPr>
-                </a:tc>
-                <a:tc>
-                  <a:txBody>
-                    <a:bodyPr/>
-                    <a:lstStyle/>
-                    <a:p>
-                      <a:pPr indent="0" marL="0">
-                        <a:buNone/>
-                      </a:pPr>
-                      <a:r>
-                        <a:rPr lang="en-US" sz="1150" dirty="0">
+                      <a:endParaRPr lang="en-US" sz="1250" dirty="0">
+                        <a:latin typeface="Calibri" charset="0"/>
+                        <a:ea typeface="Calibri" charset="0"/>
+                        <a:cs typeface="Calibri" charset="0"/>
+                      </a:endParaRPr>
+                    </a:p>
+                  </a:txBody>
+                  <a:tcPr marL="64008" marR="64008" marT="73152" marB="73152" anchor="ctr">
+                    <a:lnL w="0" cap="flat" cmpd="sng" algn="ctr">
+                      <a:noFill/>
+                    </a:lnL>
+                    <a:lnR w="0" cap="flat" cmpd="sng" algn="ctr">
+                      <a:noFill/>
+                    </a:lnR>
+                    <a:lnT w="0" cap="flat" cmpd="sng" algn="ctr">
+                      <a:noFill/>
+                    </a:lnT>
+                    <a:lnB w="9525" cap="flat" cmpd="sng" algn="ctr">
+                      <a:solidFill>
+                        <a:srgbClr val="BFCAD3"/>
+                      </a:solidFill>
+                      <a:prstDash val="solid"/>
+                      <a:round/>
+                      <a:headEnd type="none" w="med" len="med"/>
+                      <a:tailEnd type="none" w="med" len="med"/>
+                    </a:lnB>
+                  </a:tcPr>
+                </a:tc>
+                <a:tc>
+                  <a:txBody>
+                    <a:bodyPr/>
+                    <a:lstStyle/>
+                    <a:p>
+                      <a:pPr indent="0" marL="0">
+                        <a:buNone/>
+                      </a:pPr>
+                      <a:r>
+                        <a:rPr lang="en-US" sz="1250" dirty="0">
                           <a:solidFill>
                             <a:srgbClr val="111C24"/>
                           </a:solidFill>
@@ -3476,44 +3378,44 @@
                         </a:rPr>
                         <a:t>Campaign-type list Wednesday, ad-type framework Friday, stabilisation proposal by end of week. Re-set on the 30 Sep call: ranking plan first, the rest by end of week</a:t>
                       </a:r>
-                      <a:endParaRPr lang="en-US" sz="1150" dirty="0">
-                        <a:latin typeface="Calibri" charset="0"/>
-                        <a:ea typeface="Calibri" charset="0"/>
-                        <a:cs typeface="Calibri" charset="0"/>
-                      </a:endParaRPr>
-                    </a:p>
-                  </a:txBody>
-                  <a:tcPr marL="64008" marR="64008" marT="73152" marB="73152" anchor="ctr">
-                    <a:lnL w="0" cap="flat" cmpd="sng" algn="ctr">
-                      <a:noFill/>
-                    </a:lnL>
-                    <a:lnR w="0" cap="flat" cmpd="sng" algn="ctr">
-                      <a:noFill/>
-                    </a:lnR>
-                    <a:lnT w="0" cap="flat" cmpd="sng" algn="ctr">
-                      <a:noFill/>
-                    </a:lnT>
-                    <a:lnB w="9525" cap="flat" cmpd="sng" algn="ctr">
-                      <a:solidFill>
-                        <a:srgbClr val="BFCAD3"/>
-                      </a:solidFill>
-                      <a:prstDash val="solid"/>
-                      <a:round/>
-                      <a:headEnd type="none" w="med" len="med"/>
-                      <a:tailEnd type="none" w="med" len="med"/>
-                    </a:lnB>
-                  </a:tcPr>
-                </a:tc>
-                <a:tc>
-                  <a:txBody>
-                    <a:bodyPr/>
-                    <a:lstStyle/>
-                    <a:p>
-                      <a:pPr indent="0" marL="0">
-                        <a:buNone/>
-                      </a:pPr>
-                      <a:r>
-                        <a:rPr lang="en-US" sz="1150" dirty="0">
+                      <a:endParaRPr lang="en-US" sz="1250" dirty="0">
+                        <a:latin typeface="Calibri" charset="0"/>
+                        <a:ea typeface="Calibri" charset="0"/>
+                        <a:cs typeface="Calibri" charset="0"/>
+                      </a:endParaRPr>
+                    </a:p>
+                  </a:txBody>
+                  <a:tcPr marL="64008" marR="64008" marT="73152" marB="73152" anchor="ctr">
+                    <a:lnL w="0" cap="flat" cmpd="sng" algn="ctr">
+                      <a:noFill/>
+                    </a:lnL>
+                    <a:lnR w="0" cap="flat" cmpd="sng" algn="ctr">
+                      <a:noFill/>
+                    </a:lnR>
+                    <a:lnT w="0" cap="flat" cmpd="sng" algn="ctr">
+                      <a:noFill/>
+                    </a:lnT>
+                    <a:lnB w="9525" cap="flat" cmpd="sng" algn="ctr">
+                      <a:solidFill>
+                        <a:srgbClr val="BFCAD3"/>
+                      </a:solidFill>
+                      <a:prstDash val="solid"/>
+                      <a:round/>
+                      <a:headEnd type="none" w="med" len="med"/>
+                      <a:tailEnd type="none" w="med" len="med"/>
+                    </a:lnB>
+                  </a:tcPr>
+                </a:tc>
+                <a:tc>
+                  <a:txBody>
+                    <a:bodyPr/>
+                    <a:lstStyle/>
+                    <a:p>
+                      <a:pPr indent="0" marL="0">
+                        <a:buNone/>
+                      </a:pPr>
+                      <a:r>
+                        <a:rPr lang="en-US" sz="1250" dirty="0">
                           <a:solidFill>
                             <a:srgbClr val="111C24"/>
                           </a:solidFill>
@@ -3523,44 +3425,44 @@
                         </a:rPr>
                         <a:t>Ranking plan sent 1 Oct as agreed. Campaign-type list, ad-type plan (Bamboo first), frameworks and stabilisation proposal due end of week, 3–4 Oct. SB, SBV and SD held for creative, so the 1 Oct API launch did not happen</a:t>
                       </a:r>
-                      <a:endParaRPr lang="en-US" sz="1150" dirty="0">
-                        <a:latin typeface="Calibri" charset="0"/>
-                        <a:ea typeface="Calibri" charset="0"/>
-                        <a:cs typeface="Calibri" charset="0"/>
-                      </a:endParaRPr>
-                    </a:p>
-                  </a:txBody>
-                  <a:tcPr marL="64008" marR="64008" marT="73152" marB="73152" anchor="ctr">
-                    <a:lnL w="0" cap="flat" cmpd="sng" algn="ctr">
-                      <a:noFill/>
-                    </a:lnL>
-                    <a:lnR w="0" cap="flat" cmpd="sng" algn="ctr">
-                      <a:noFill/>
-                    </a:lnR>
-                    <a:lnT w="0" cap="flat" cmpd="sng" algn="ctr">
-                      <a:noFill/>
-                    </a:lnT>
-                    <a:lnB w="9525" cap="flat" cmpd="sng" algn="ctr">
-                      <a:solidFill>
-                        <a:srgbClr val="BFCAD3"/>
-                      </a:solidFill>
-                      <a:prstDash val="solid"/>
-                      <a:round/>
-                      <a:headEnd type="none" w="med" len="med"/>
-                      <a:tailEnd type="none" w="med" len="med"/>
-                    </a:lnB>
-                  </a:tcPr>
-                </a:tc>
-                <a:tc>
-                  <a:txBody>
-                    <a:bodyPr/>
-                    <a:lstStyle/>
-                    <a:p>
-                      <a:pPr indent="0" marL="0">
-                        <a:buNone/>
-                      </a:pPr>
-                      <a:r>
-                        <a:rPr lang="en-US" sz="1150" b="1" dirty="0">
+                      <a:endParaRPr lang="en-US" sz="1250" dirty="0">
+                        <a:latin typeface="Calibri" charset="0"/>
+                        <a:ea typeface="Calibri" charset="0"/>
+                        <a:cs typeface="Calibri" charset="0"/>
+                      </a:endParaRPr>
+                    </a:p>
+                  </a:txBody>
+                  <a:tcPr marL="64008" marR="64008" marT="73152" marB="73152" anchor="ctr">
+                    <a:lnL w="0" cap="flat" cmpd="sng" algn="ctr">
+                      <a:noFill/>
+                    </a:lnL>
+                    <a:lnR w="0" cap="flat" cmpd="sng" algn="ctr">
+                      <a:noFill/>
+                    </a:lnR>
+                    <a:lnT w="0" cap="flat" cmpd="sng" algn="ctr">
+                      <a:noFill/>
+                    </a:lnT>
+                    <a:lnB w="9525" cap="flat" cmpd="sng" algn="ctr">
+                      <a:solidFill>
+                        <a:srgbClr val="BFCAD3"/>
+                      </a:solidFill>
+                      <a:prstDash val="solid"/>
+                      <a:round/>
+                      <a:headEnd type="none" w="med" len="med"/>
+                      <a:tailEnd type="none" w="med" len="med"/>
+                    </a:lnB>
+                  </a:tcPr>
+                </a:tc>
+                <a:tc>
+                  <a:txBody>
+                    <a:bodyPr/>
+                    <a:lstStyle/>
+                    <a:p>
+                      <a:pPr indent="0" marL="0">
+                        <a:buNone/>
+                      </a:pPr>
+                      <a:r>
+                        <a:rPr lang="en-US" sz="1250" b="1" dirty="0">
                           <a:solidFill>
                             <a:srgbClr val="6E4A0F"/>
                           </a:solidFill>
@@ -3570,7 +3472,7 @@
                         </a:rPr>
                         <a:t>Due end of week</a:t>
                       </a:r>
-                      <a:endParaRPr lang="en-US" sz="1150" dirty="0">
+                      <a:endParaRPr lang="en-US" sz="1250" dirty="0">
                         <a:latin typeface="Calibri" charset="0"/>
                         <a:ea typeface="Calibri" charset="0"/>
                         <a:cs typeface="Calibri" charset="0"/>
@@ -3612,7 +3514,7 @@
                         <a:buNone/>
                       </a:pPr>
                       <a:r>
-                        <a:rPr lang="en-US" sz="1150" b="1" dirty="0">
+                        <a:rPr lang="en-US" sz="1250" b="1" dirty="0">
                           <a:solidFill>
                             <a:srgbClr val="111C24"/>
                           </a:solidFill>
@@ -3622,18 +3524,18 @@
                         </a:rPr>
                         <a:t>CooLinens Pillowcase launch</a:t>
                       </a:r>
-                      <a:endParaRPr lang="en-US" sz="1150" dirty="0">
-                        <a:latin typeface="Calibri" charset="0"/>
-                        <a:ea typeface="Calibri" charset="0"/>
-                        <a:cs typeface="Calibri" charset="0"/>
-                      </a:endParaRPr>
-                    </a:p>
-                    <a:p>
-                      <a:pPr indent="0" marL="0">
-                        <a:buNone/>
-                      </a:pPr>
-                      <a:r>
-                        <a:rPr lang="en-US" sz="1050" dirty="0">
+                      <a:endParaRPr lang="en-US" sz="1250" dirty="0">
+                        <a:latin typeface="Calibri" charset="0"/>
+                        <a:ea typeface="Calibri" charset="0"/>
+                        <a:cs typeface="Calibri" charset="0"/>
+                      </a:endParaRPr>
+                    </a:p>
+                    <a:p>
+                      <a:pPr indent="0" marL="0">
+                        <a:buNone/>
+                      </a:pPr>
+                      <a:r>
+                        <a:rPr lang="en-US" sz="1150" dirty="0">
                           <a:solidFill>
                             <a:srgbClr val="4E5A64"/>
                           </a:solidFill>
@@ -3643,44 +3545,44 @@
                         </a:rPr>
                         <a:t>Shayan T · one-off · P0</a:t>
                       </a:r>
-                      <a:endParaRPr lang="en-US" sz="1150" dirty="0">
-                        <a:latin typeface="Calibri" charset="0"/>
-                        <a:ea typeface="Calibri" charset="0"/>
-                        <a:cs typeface="Calibri" charset="0"/>
-                      </a:endParaRPr>
-                    </a:p>
-                  </a:txBody>
-                  <a:tcPr marL="64008" marR="64008" marT="73152" marB="73152" anchor="ctr">
-                    <a:lnL w="0" cap="flat" cmpd="sng" algn="ctr">
-                      <a:noFill/>
-                    </a:lnL>
-                    <a:lnR w="0" cap="flat" cmpd="sng" algn="ctr">
-                      <a:noFill/>
-                    </a:lnR>
-                    <a:lnT w="0" cap="flat" cmpd="sng" algn="ctr">
-                      <a:noFill/>
-                    </a:lnT>
-                    <a:lnB w="9525" cap="flat" cmpd="sng" algn="ctr">
-                      <a:solidFill>
-                        <a:srgbClr val="BFCAD3"/>
-                      </a:solidFill>
-                      <a:prstDash val="solid"/>
-                      <a:round/>
-                      <a:headEnd type="none" w="med" len="med"/>
-                      <a:tailEnd type="none" w="med" len="med"/>
-                    </a:lnB>
-                  </a:tcPr>
-                </a:tc>
-                <a:tc>
-                  <a:txBody>
-                    <a:bodyPr/>
-                    <a:lstStyle/>
-                    <a:p>
-                      <a:pPr indent="0" marL="0">
-                        <a:buNone/>
-                      </a:pPr>
-                      <a:r>
-                        <a:rPr lang="en-US" sz="1150" dirty="0">
+                      <a:endParaRPr lang="en-US" sz="1250" dirty="0">
+                        <a:latin typeface="Calibri" charset="0"/>
+                        <a:ea typeface="Calibri" charset="0"/>
+                        <a:cs typeface="Calibri" charset="0"/>
+                      </a:endParaRPr>
+                    </a:p>
+                  </a:txBody>
+                  <a:tcPr marL="64008" marR="64008" marT="73152" marB="73152" anchor="ctr">
+                    <a:lnL w="0" cap="flat" cmpd="sng" algn="ctr">
+                      <a:noFill/>
+                    </a:lnL>
+                    <a:lnR w="0" cap="flat" cmpd="sng" algn="ctr">
+                      <a:noFill/>
+                    </a:lnR>
+                    <a:lnT w="0" cap="flat" cmpd="sng" algn="ctr">
+                      <a:noFill/>
+                    </a:lnT>
+                    <a:lnB w="9525" cap="flat" cmpd="sng" algn="ctr">
+                      <a:solidFill>
+                        <a:srgbClr val="BFCAD3"/>
+                      </a:solidFill>
+                      <a:prstDash val="solid"/>
+                      <a:round/>
+                      <a:headEnd type="none" w="med" len="med"/>
+                      <a:tailEnd type="none" w="med" len="med"/>
+                    </a:lnB>
+                  </a:tcPr>
+                </a:tc>
+                <a:tc>
+                  <a:txBody>
+                    <a:bodyPr/>
+                    <a:lstStyle/>
+                    <a:p>
+                      <a:pPr indent="0" marL="0">
+                        <a:buNone/>
+                      </a:pPr>
+                      <a:r>
+                        <a:rPr lang="en-US" sz="1250" dirty="0">
                           <a:solidFill>
                             <a:srgbClr val="111C24"/>
                           </a:solidFill>
@@ -3690,44 +3592,44 @@
                         </a:rPr>
                         <a:t>PPC launch strategy delivered Monday 28 Sep, campaigns live with the listing</a:t>
                       </a:r>
-                      <a:endParaRPr lang="en-US" sz="1150" dirty="0">
-                        <a:latin typeface="Calibri" charset="0"/>
-                        <a:ea typeface="Calibri" charset="0"/>
-                        <a:cs typeface="Calibri" charset="0"/>
-                      </a:endParaRPr>
-                    </a:p>
-                  </a:txBody>
-                  <a:tcPr marL="64008" marR="64008" marT="73152" marB="73152" anchor="ctr">
-                    <a:lnL w="0" cap="flat" cmpd="sng" algn="ctr">
-                      <a:noFill/>
-                    </a:lnL>
-                    <a:lnR w="0" cap="flat" cmpd="sng" algn="ctr">
-                      <a:noFill/>
-                    </a:lnR>
-                    <a:lnT w="0" cap="flat" cmpd="sng" algn="ctr">
-                      <a:noFill/>
-                    </a:lnT>
-                    <a:lnB w="9525" cap="flat" cmpd="sng" algn="ctr">
-                      <a:solidFill>
-                        <a:srgbClr val="BFCAD3"/>
-                      </a:solidFill>
-                      <a:prstDash val="solid"/>
-                      <a:round/>
-                      <a:headEnd type="none" w="med" len="med"/>
-                      <a:tailEnd type="none" w="med" len="med"/>
-                    </a:lnB>
-                  </a:tcPr>
-                </a:tc>
-                <a:tc>
-                  <a:txBody>
-                    <a:bodyPr/>
-                    <a:lstStyle/>
-                    <a:p>
-                      <a:pPr indent="0" marL="0">
-                        <a:buNone/>
-                      </a:pPr>
-                      <a:r>
-                        <a:rPr lang="en-US" sz="1150" dirty="0">
+                      <a:endParaRPr lang="en-US" sz="1250" dirty="0">
+                        <a:latin typeface="Calibri" charset="0"/>
+                        <a:ea typeface="Calibri" charset="0"/>
+                        <a:cs typeface="Calibri" charset="0"/>
+                      </a:endParaRPr>
+                    </a:p>
+                  </a:txBody>
+                  <a:tcPr marL="64008" marR="64008" marT="73152" marB="73152" anchor="ctr">
+                    <a:lnL w="0" cap="flat" cmpd="sng" algn="ctr">
+                      <a:noFill/>
+                    </a:lnL>
+                    <a:lnR w="0" cap="flat" cmpd="sng" algn="ctr">
+                      <a:noFill/>
+                    </a:lnR>
+                    <a:lnT w="0" cap="flat" cmpd="sng" algn="ctr">
+                      <a:noFill/>
+                    </a:lnT>
+                    <a:lnB w="9525" cap="flat" cmpd="sng" algn="ctr">
+                      <a:solidFill>
+                        <a:srgbClr val="BFCAD3"/>
+                      </a:solidFill>
+                      <a:prstDash val="solid"/>
+                      <a:round/>
+                      <a:headEnd type="none" w="med" len="med"/>
+                      <a:tailEnd type="none" w="med" len="med"/>
+                    </a:lnB>
+                  </a:tcPr>
+                </a:tc>
+                <a:tc>
+                  <a:txBody>
+                    <a:bodyPr/>
+                    <a:lstStyle/>
+                    <a:p>
+                      <a:pPr indent="0" marL="0">
+                        <a:buNone/>
+                      </a:pPr>
+                      <a:r>
+                        <a:rPr lang="en-US" sz="1250" dirty="0">
                           <a:solidFill>
                             <a:srgbClr val="111C24"/>
                           </a:solidFill>
@@ -3737,44 +3639,44 @@
                         </a:rPr>
                         <a:t>Launch workbook shared 28 Sep, revised with a strategy doc on Erik's feedback 29 Sep. Listing goes live on Amazon today, 2 Oct, and PPC launches with it</a:t>
                       </a:r>
-                      <a:endParaRPr lang="en-US" sz="1150" dirty="0">
-                        <a:latin typeface="Calibri" charset="0"/>
-                        <a:ea typeface="Calibri" charset="0"/>
-                        <a:cs typeface="Calibri" charset="0"/>
-                      </a:endParaRPr>
-                    </a:p>
-                  </a:txBody>
-                  <a:tcPr marL="64008" marR="64008" marT="73152" marB="73152" anchor="ctr">
-                    <a:lnL w="0" cap="flat" cmpd="sng" algn="ctr">
-                      <a:noFill/>
-                    </a:lnL>
-                    <a:lnR w="0" cap="flat" cmpd="sng" algn="ctr">
-                      <a:noFill/>
-                    </a:lnR>
-                    <a:lnT w="0" cap="flat" cmpd="sng" algn="ctr">
-                      <a:noFill/>
-                    </a:lnT>
-                    <a:lnB w="9525" cap="flat" cmpd="sng" algn="ctr">
-                      <a:solidFill>
-                        <a:srgbClr val="BFCAD3"/>
-                      </a:solidFill>
-                      <a:prstDash val="solid"/>
-                      <a:round/>
-                      <a:headEnd type="none" w="med" len="med"/>
-                      <a:tailEnd type="none" w="med" len="med"/>
-                    </a:lnB>
-                  </a:tcPr>
-                </a:tc>
-                <a:tc>
-                  <a:txBody>
-                    <a:bodyPr/>
-                    <a:lstStyle/>
-                    <a:p>
-                      <a:pPr indent="0" marL="0">
-                        <a:buNone/>
-                      </a:pPr>
-                      <a:r>
-                        <a:rPr lang="en-US" sz="1150" b="1" dirty="0">
+                      <a:endParaRPr lang="en-US" sz="1250" dirty="0">
+                        <a:latin typeface="Calibri" charset="0"/>
+                        <a:ea typeface="Calibri" charset="0"/>
+                        <a:cs typeface="Calibri" charset="0"/>
+                      </a:endParaRPr>
+                    </a:p>
+                  </a:txBody>
+                  <a:tcPr marL="64008" marR="64008" marT="73152" marB="73152" anchor="ctr">
+                    <a:lnL w="0" cap="flat" cmpd="sng" algn="ctr">
+                      <a:noFill/>
+                    </a:lnL>
+                    <a:lnR w="0" cap="flat" cmpd="sng" algn="ctr">
+                      <a:noFill/>
+                    </a:lnR>
+                    <a:lnT w="0" cap="flat" cmpd="sng" algn="ctr">
+                      <a:noFill/>
+                    </a:lnT>
+                    <a:lnB w="9525" cap="flat" cmpd="sng" algn="ctr">
+                      <a:solidFill>
+                        <a:srgbClr val="BFCAD3"/>
+                      </a:solidFill>
+                      <a:prstDash val="solid"/>
+                      <a:round/>
+                      <a:headEnd type="none" w="med" len="med"/>
+                      <a:tailEnd type="none" w="med" len="med"/>
+                    </a:lnB>
+                  </a:tcPr>
+                </a:tc>
+                <a:tc>
+                  <a:txBody>
+                    <a:bodyPr/>
+                    <a:lstStyle/>
+                    <a:p>
+                      <a:pPr indent="0" marL="0">
+                        <a:buNone/>
+                      </a:pPr>
+                      <a:r>
+                        <a:rPr lang="en-US" sz="1250" b="1" dirty="0">
                           <a:solidFill>
                             <a:srgbClr val="176B41"/>
                           </a:solidFill>
@@ -3784,7 +3686,7 @@
                         </a:rPr>
                         <a:t>Launching today</a:t>
                       </a:r>
-                      <a:endParaRPr lang="en-US" sz="1150" dirty="0">
+                      <a:endParaRPr lang="en-US" sz="1250" dirty="0">
                         <a:latin typeface="Calibri" charset="0"/>
                         <a:ea typeface="Calibri" charset="0"/>
                         <a:cs typeface="Calibri" charset="0"/>
@@ -3812,220 +3714,6 @@
                     </a:lnB>
                     <a:solidFill>
                       <a:srgbClr val="E6F4EC"/>
-                    </a:solidFill>
-                  </a:tcPr>
-                </a:tc>
-              </a:tr>
-              <a:tr h="0">
-                <a:tc>
-                  <a:txBody>
-                    <a:bodyPr/>
-                    <a:lstStyle/>
-                    <a:p>
-                      <a:pPr indent="0" marL="0">
-                        <a:buNone/>
-                      </a:pPr>
-                      <a:r>
-                        <a:rPr lang="en-US" sz="1150" b="1" dirty="0">
-                          <a:solidFill>
-                            <a:srgbClr val="111C24"/>
-                          </a:solidFill>
-                          <a:latin typeface="Calibri" pitchFamily="34" charset="0"/>
-                          <a:ea typeface="Calibri" pitchFamily="34" charset="-122"/>
-                          <a:cs typeface="Calibri" pitchFamily="34" charset="-120"/>
-                        </a:rPr>
-                        <a:t>Cadence &amp; daily oversight</a:t>
-                      </a:r>
-                      <a:endParaRPr lang="en-US" sz="1150" dirty="0">
-                        <a:latin typeface="Calibri" charset="0"/>
-                        <a:ea typeface="Calibri" charset="0"/>
-                        <a:cs typeface="Calibri" charset="0"/>
-                      </a:endParaRPr>
-                    </a:p>
-                    <a:p>
-                      <a:pPr indent="0" marL="0">
-                        <a:buNone/>
-                      </a:pPr>
-                      <a:r>
-                        <a:rPr lang="en-US" sz="1050" dirty="0">
-                          <a:solidFill>
-                            <a:srgbClr val="4E5A64"/>
-                          </a:solidFill>
-                          <a:latin typeface="Calibri" pitchFamily="34" charset="0"/>
-                          <a:ea typeface="Calibri" pitchFamily="34" charset="-122"/>
-                          <a:cs typeface="Calibri" pitchFamily="34" charset="-120"/>
-                        </a:rPr>
-                        <a:t>All owners · daily · P1</a:t>
-                      </a:r>
-                      <a:endParaRPr lang="en-US" sz="1150" dirty="0">
-                        <a:latin typeface="Calibri" charset="0"/>
-                        <a:ea typeface="Calibri" charset="0"/>
-                        <a:cs typeface="Calibri" charset="0"/>
-                      </a:endParaRPr>
-                    </a:p>
-                  </a:txBody>
-                  <a:tcPr marL="64008" marR="64008" marT="73152" marB="73152" anchor="ctr">
-                    <a:lnL w="0" cap="flat" cmpd="sng" algn="ctr">
-                      <a:noFill/>
-                    </a:lnL>
-                    <a:lnR w="0" cap="flat" cmpd="sng" algn="ctr">
-                      <a:noFill/>
-                    </a:lnR>
-                    <a:lnT w="0" cap="flat" cmpd="sng" algn="ctr">
-                      <a:noFill/>
-                    </a:lnT>
-                    <a:lnB w="9525" cap="flat" cmpd="sng" algn="ctr">
-                      <a:solidFill>
-                        <a:srgbClr val="BFCAD3"/>
-                      </a:solidFill>
-                      <a:prstDash val="solid"/>
-                      <a:round/>
-                      <a:headEnd type="none" w="med" len="med"/>
-                      <a:tailEnd type="none" w="med" len="med"/>
-                    </a:lnB>
-                  </a:tcPr>
-                </a:tc>
-                <a:tc>
-                  <a:txBody>
-                    <a:bodyPr/>
-                    <a:lstStyle/>
-                    <a:p>
-                      <a:pPr indent="0" marL="0">
-                        <a:buNone/>
-                      </a:pPr>
-                      <a:r>
-                        <a:rPr lang="en-US" sz="1150" dirty="0">
-                          <a:solidFill>
-                            <a:srgbClr val="111C24"/>
-                          </a:solidFill>
-                          <a:latin typeface="Calibri" pitchFamily="34" charset="0"/>
-                          <a:ea typeface="Calibri" pitchFamily="34" charset="-122"/>
-                          <a:cs typeface="Calibri" pitchFamily="34" charset="-120"/>
-                        </a:rPr>
-                        <a:t>Daily spend check on the top 20% of campaigns, Tuesday to Friday</a:t>
-                      </a:r>
-                      <a:endParaRPr lang="en-US" sz="1150" dirty="0">
-                        <a:latin typeface="Calibri" charset="0"/>
-                        <a:ea typeface="Calibri" charset="0"/>
-                        <a:cs typeface="Calibri" charset="0"/>
-                      </a:endParaRPr>
-                    </a:p>
-                  </a:txBody>
-                  <a:tcPr marL="64008" marR="64008" marT="73152" marB="73152" anchor="ctr">
-                    <a:lnL w="0" cap="flat" cmpd="sng" algn="ctr">
-                      <a:noFill/>
-                    </a:lnL>
-                    <a:lnR w="0" cap="flat" cmpd="sng" algn="ctr">
-                      <a:noFill/>
-                    </a:lnR>
-                    <a:lnT w="0" cap="flat" cmpd="sng" algn="ctr">
-                      <a:noFill/>
-                    </a:lnT>
-                    <a:lnB w="9525" cap="flat" cmpd="sng" algn="ctr">
-                      <a:solidFill>
-                        <a:srgbClr val="BFCAD3"/>
-                      </a:solidFill>
-                      <a:prstDash val="solid"/>
-                      <a:round/>
-                      <a:headEnd type="none" w="med" len="med"/>
-                      <a:tailEnd type="none" w="med" len="med"/>
-                    </a:lnB>
-                  </a:tcPr>
-                </a:tc>
-                <a:tc>
-                  <a:txBody>
-                    <a:bodyPr/>
-                    <a:lstStyle/>
-                    <a:p>
-                      <a:pPr indent="0" marL="0">
-                        <a:buNone/>
-                      </a:pPr>
-                      <a:r>
-                        <a:rPr lang="en-US" sz="1150" dirty="0">
-                          <a:solidFill>
-                            <a:srgbClr val="111C24"/>
-                          </a:solidFill>
-                          <a:latin typeface="Calibri" pitchFamily="34" charset="0"/>
-                          <a:ea typeface="Calibri" pitchFamily="34" charset="-122"/>
-                          <a:cs typeface="Calibri" pitchFamily="34" charset="-120"/>
-                        </a:rPr>
-                        <a:t>Daily huddles ran. Manual changes were held because audit execution was delayed, so no spend-check or change-log records were posted</a:t>
-                      </a:r>
-                      <a:endParaRPr lang="en-US" sz="1150" dirty="0">
-                        <a:latin typeface="Calibri" charset="0"/>
-                        <a:ea typeface="Calibri" charset="0"/>
-                        <a:cs typeface="Calibri" charset="0"/>
-                      </a:endParaRPr>
-                    </a:p>
-                  </a:txBody>
-                  <a:tcPr marL="64008" marR="64008" marT="73152" marB="73152" anchor="ctr">
-                    <a:lnL w="0" cap="flat" cmpd="sng" algn="ctr">
-                      <a:noFill/>
-                    </a:lnL>
-                    <a:lnR w="0" cap="flat" cmpd="sng" algn="ctr">
-                      <a:noFill/>
-                    </a:lnR>
-                    <a:lnT w="0" cap="flat" cmpd="sng" algn="ctr">
-                      <a:noFill/>
-                    </a:lnT>
-                    <a:lnB w="9525" cap="flat" cmpd="sng" algn="ctr">
-                      <a:solidFill>
-                        <a:srgbClr val="BFCAD3"/>
-                      </a:solidFill>
-                      <a:prstDash val="solid"/>
-                      <a:round/>
-                      <a:headEnd type="none" w="med" len="med"/>
-                      <a:tailEnd type="none" w="med" len="med"/>
-                    </a:lnB>
-                  </a:tcPr>
-                </a:tc>
-                <a:tc>
-                  <a:txBody>
-                    <a:bodyPr/>
-                    <a:lstStyle/>
-                    <a:p>
-                      <a:pPr indent="0" marL="0">
-                        <a:buNone/>
-                      </a:pPr>
-                      <a:r>
-                        <a:rPr lang="en-US" sz="1150" b="1" dirty="0">
-                          <a:solidFill>
-                            <a:srgbClr val="9C3D31"/>
-                          </a:solidFill>
-                          <a:latin typeface="Calibri" pitchFamily="34" charset="0"/>
-                          <a:ea typeface="Calibri" pitchFamily="34" charset="-122"/>
-                          <a:cs typeface="Calibri" pitchFamily="34" charset="-120"/>
-                        </a:rPr>
-                        <a:t>0 of 4 logged</a:t>
-                      </a:r>
-                      <a:endParaRPr lang="en-US" sz="1150" dirty="0">
-                        <a:latin typeface="Calibri" charset="0"/>
-                        <a:ea typeface="Calibri" charset="0"/>
-                        <a:cs typeface="Calibri" charset="0"/>
-                      </a:endParaRPr>
-                    </a:p>
-                  </a:txBody>
-                  <a:tcPr marL="64008" marR="64008" marT="73152" marB="73152" anchor="ctr">
-                    <a:lnL w="0" cap="flat" cmpd="sng" algn="ctr">
-                      <a:noFill/>
-                    </a:lnL>
-                    <a:lnR w="0" cap="flat" cmpd="sng" algn="ctr">
-                      <a:noFill/>
-                    </a:lnR>
-                    <a:lnT w="0" cap="flat" cmpd="sng" algn="ctr">
-                      <a:noFill/>
-                    </a:lnT>
-                    <a:lnB w="9525" cap="flat" cmpd="sng" algn="ctr">
-                      <a:solidFill>
-                        <a:srgbClr val="BFCAD3"/>
-                      </a:solidFill>
-                      <a:prstDash val="solid"/>
-                      <a:round/>
-                      <a:headEnd type="none" w="med" len="med"/>
-                      <a:tailEnd type="none" w="med" len="med"/>
-                    </a:lnB>
-                    <a:solidFill>
-                      <a:srgbClr val="FAE9E6"/>
                     </a:solidFill>
                   </a:tcPr>
                 </a:tc>
@@ -10181,7 +9869,7 @@
                           <a:ea typeface="Calibri" pitchFamily="34" charset="-122"/>
                           <a:cs typeface="Calibri" pitchFamily="34" charset="-120"/>
                         </a:rPr>
-                        <a:t>Oversight &amp; onboarding</a:t>
+                        <a:t>Onboarding</a:t>
                       </a:r>
                       <a:endParaRPr lang="en-US" sz="1150" dirty="0">
                         <a:latin typeface="Calibri" charset="0"/>
@@ -10202,7 +9890,7 @@
                           <a:ea typeface="Calibri" pitchFamily="34" charset="-122"/>
                           <a:cs typeface="Calibri" pitchFamily="34" charset="-120"/>
                         </a:rPr>
-                        <a:t>All owners</a:t>
+                        <a:t>Shayan T</a:t>
                       </a:r>
                       <a:endParaRPr lang="en-US" sz="1150" dirty="0">
                         <a:latin typeface="Calibri" charset="0"/>
@@ -10249,7 +9937,7 @@
                           <a:ea typeface="Calibri" pitchFamily="34" charset="-122"/>
                           <a:cs typeface="Calibri" pitchFamily="34" charset="-120"/>
                         </a:rPr>
-                        <a:t>Log the daily spend checks, and run Ivan's first full week with EOD outputs</a:t>
+                        <a:t>Run Ivan's first full week with EOD outputs</a:t>
                       </a:r>
                       <a:endParaRPr lang="en-US" sz="1150" dirty="0">
                         <a:latin typeface="Calibri" charset="0"/>

</xml_diff>

<commit_message>
Weekly review: remove Ivan's onboarding from the plan
Co-Authored-By: Claude Opus 5.5 <noreply@anthropic.com>
Claude-Session: https://claude.ai/code/session_017KBX8sQPKzAVHK5pu1jizF
</commit_message>
<xml_diff>
--- a/deliverables/PPC_Weekly_Review_Sep28-Oct2.pptx
+++ b/deliverables/PPC_Weekly_Review_Sep28-Oct2.pptx
@@ -9851,264 +9851,6 @@
                   </a:tcPr>
                 </a:tc>
               </a:tr>
-              <a:tr h="0">
-                <a:tc>
-                  <a:txBody>
-                    <a:bodyPr/>
-                    <a:lstStyle/>
-                    <a:p>
-                      <a:pPr indent="0" marL="0">
-                        <a:buNone/>
-                      </a:pPr>
-                      <a:r>
-                        <a:rPr lang="en-US" sz="1150" b="1" dirty="0">
-                          <a:solidFill>
-                            <a:srgbClr val="111C24"/>
-                          </a:solidFill>
-                          <a:latin typeface="Calibri" pitchFamily="34" charset="0"/>
-                          <a:ea typeface="Calibri" pitchFamily="34" charset="-122"/>
-                          <a:cs typeface="Calibri" pitchFamily="34" charset="-120"/>
-                        </a:rPr>
-                        <a:t>Onboarding</a:t>
-                      </a:r>
-                      <a:endParaRPr lang="en-US" sz="1150" dirty="0">
-                        <a:latin typeface="Calibri" charset="0"/>
-                        <a:ea typeface="Calibri" charset="0"/>
-                        <a:cs typeface="Calibri" charset="0"/>
-                      </a:endParaRPr>
-                    </a:p>
-                    <a:p>
-                      <a:pPr indent="0" marL="0">
-                        <a:buNone/>
-                      </a:pPr>
-                      <a:r>
-                        <a:rPr lang="en-US" sz="1050" dirty="0">
-                          <a:solidFill>
-                            <a:srgbClr val="4E5A64"/>
-                          </a:solidFill>
-                          <a:latin typeface="Calibri" pitchFamily="34" charset="0"/>
-                          <a:ea typeface="Calibri" pitchFamily="34" charset="-122"/>
-                          <a:cs typeface="Calibri" pitchFamily="34" charset="-120"/>
-                        </a:rPr>
-                        <a:t>Shayan T</a:t>
-                      </a:r>
-                      <a:endParaRPr lang="en-US" sz="1150" dirty="0">
-                        <a:latin typeface="Calibri" charset="0"/>
-                        <a:ea typeface="Calibri" charset="0"/>
-                        <a:cs typeface="Calibri" charset="0"/>
-                      </a:endParaRPr>
-                    </a:p>
-                  </a:txBody>
-                  <a:tcPr marL="64008" marR="64008" marT="73152" marB="73152" anchor="ctr">
-                    <a:lnL w="0" cap="flat" cmpd="sng" algn="ctr">
-                      <a:noFill/>
-                    </a:lnL>
-                    <a:lnR w="0" cap="flat" cmpd="sng" algn="ctr">
-                      <a:noFill/>
-                    </a:lnR>
-                    <a:lnT w="0" cap="flat" cmpd="sng" algn="ctr">
-                      <a:noFill/>
-                    </a:lnT>
-                    <a:lnB w="9525" cap="flat" cmpd="sng" algn="ctr">
-                      <a:solidFill>
-                        <a:srgbClr val="BFCAD3"/>
-                      </a:solidFill>
-                      <a:prstDash val="solid"/>
-                      <a:round/>
-                      <a:headEnd type="none" w="med" len="med"/>
-                      <a:tailEnd type="none" w="med" len="med"/>
-                    </a:lnB>
-                  </a:tcPr>
-                </a:tc>
-                <a:tc>
-                  <a:txBody>
-                    <a:bodyPr/>
-                    <a:lstStyle/>
-                    <a:p>
-                      <a:pPr indent="0" marL="0">
-                        <a:buNone/>
-                      </a:pPr>
-                      <a:r>
-                        <a:rPr lang="en-US" sz="1150" dirty="0">
-                          <a:solidFill>
-                            <a:srgbClr val="111C24"/>
-                          </a:solidFill>
-                          <a:latin typeface="Calibri" pitchFamily="34" charset="0"/>
-                          <a:ea typeface="Calibri" pitchFamily="34" charset="-122"/>
-                          <a:cs typeface="Calibri" pitchFamily="34" charset="-120"/>
-                        </a:rPr>
-                        <a:t>Run Ivan's first full week with EOD outputs</a:t>
-                      </a:r>
-                      <a:endParaRPr lang="en-US" sz="1150" dirty="0">
-                        <a:latin typeface="Calibri" charset="0"/>
-                        <a:ea typeface="Calibri" charset="0"/>
-                        <a:cs typeface="Calibri" charset="0"/>
-                      </a:endParaRPr>
-                    </a:p>
-                  </a:txBody>
-                  <a:tcPr marL="64008" marR="64008" marT="73152" marB="73152" anchor="ctr">
-                    <a:lnL w="0" cap="flat" cmpd="sng" algn="ctr">
-                      <a:noFill/>
-                    </a:lnL>
-                    <a:lnR w="0" cap="flat" cmpd="sng" algn="ctr">
-                      <a:noFill/>
-                    </a:lnR>
-                    <a:lnT w="0" cap="flat" cmpd="sng" algn="ctr">
-                      <a:noFill/>
-                    </a:lnT>
-                    <a:lnB w="9525" cap="flat" cmpd="sng" algn="ctr">
-                      <a:solidFill>
-                        <a:srgbClr val="BFCAD3"/>
-                      </a:solidFill>
-                      <a:prstDash val="solid"/>
-                      <a:round/>
-                      <a:headEnd type="none" w="med" len="med"/>
-                      <a:tailEnd type="none" w="med" len="med"/>
-                    </a:lnB>
-                  </a:tcPr>
-                </a:tc>
-                <a:tc>
-                  <a:txBody>
-                    <a:bodyPr/>
-                    <a:lstStyle/>
-                    <a:p>
-                      <a:pPr indent="0" marL="0">
-                        <a:buNone/>
-                      </a:pPr>
-                      <a:r>
-                        <a:rPr lang="en-US" sz="1150" dirty="0">
-                          <a:solidFill>
-                            <a:srgbClr val="111C24"/>
-                          </a:solidFill>
-                          <a:latin typeface="Calibri" pitchFamily="34" charset="0"/>
-                          <a:ea typeface="Calibri" pitchFamily="34" charset="-122"/>
-                          <a:cs typeface="Calibri" pitchFamily="34" charset="-120"/>
-                        </a:rPr>
-                        <a:t>Mon, Oct 5</a:t>
-                      </a:r>
-                      <a:endParaRPr lang="en-US" sz="1150" dirty="0">
-                        <a:latin typeface="Calibri" charset="0"/>
-                        <a:ea typeface="Calibri" charset="0"/>
-                        <a:cs typeface="Calibri" charset="0"/>
-                      </a:endParaRPr>
-                    </a:p>
-                  </a:txBody>
-                  <a:tcPr marL="64008" marR="64008" marT="73152" marB="73152" anchor="ctr">
-                    <a:lnL w="0" cap="flat" cmpd="sng" algn="ctr">
-                      <a:noFill/>
-                    </a:lnL>
-                    <a:lnR w="0" cap="flat" cmpd="sng" algn="ctr">
-                      <a:noFill/>
-                    </a:lnR>
-                    <a:lnT w="0" cap="flat" cmpd="sng" algn="ctr">
-                      <a:noFill/>
-                    </a:lnT>
-                    <a:lnB w="9525" cap="flat" cmpd="sng" algn="ctr">
-                      <a:solidFill>
-                        <a:srgbClr val="BFCAD3"/>
-                      </a:solidFill>
-                      <a:prstDash val="solid"/>
-                      <a:round/>
-                      <a:headEnd type="none" w="med" len="med"/>
-                      <a:tailEnd type="none" w="med" len="med"/>
-                    </a:lnB>
-                  </a:tcPr>
-                </a:tc>
-                <a:tc>
-                  <a:txBody>
-                    <a:bodyPr/>
-                    <a:lstStyle/>
-                    <a:p>
-                      <a:pPr indent="0" marL="0">
-                        <a:buNone/>
-                      </a:pPr>
-                      <a:r>
-                        <a:rPr lang="en-US" sz="1150" dirty="0">
-                          <a:solidFill>
-                            <a:srgbClr val="111C24"/>
-                          </a:solidFill>
-                          <a:latin typeface="Calibri" pitchFamily="34" charset="0"/>
-                          <a:ea typeface="Calibri" pitchFamily="34" charset="-122"/>
-                          <a:cs typeface="Calibri" pitchFamily="34" charset="-120"/>
-                        </a:rPr>
-                        <a:t>P1</a:t>
-                      </a:r>
-                      <a:endParaRPr lang="en-US" sz="1150" dirty="0">
-                        <a:latin typeface="Calibri" charset="0"/>
-                        <a:ea typeface="Calibri" charset="0"/>
-                        <a:cs typeface="Calibri" charset="0"/>
-                      </a:endParaRPr>
-                    </a:p>
-                  </a:txBody>
-                  <a:tcPr marL="64008" marR="64008" marT="73152" marB="73152" anchor="ctr">
-                    <a:lnL w="0" cap="flat" cmpd="sng" algn="ctr">
-                      <a:noFill/>
-                    </a:lnL>
-                    <a:lnR w="0" cap="flat" cmpd="sng" algn="ctr">
-                      <a:noFill/>
-                    </a:lnR>
-                    <a:lnT w="0" cap="flat" cmpd="sng" algn="ctr">
-                      <a:noFill/>
-                    </a:lnT>
-                    <a:lnB w="9525" cap="flat" cmpd="sng" algn="ctr">
-                      <a:solidFill>
-                        <a:srgbClr val="BFCAD3"/>
-                      </a:solidFill>
-                      <a:prstDash val="solid"/>
-                      <a:round/>
-                      <a:headEnd type="none" w="med" len="med"/>
-                      <a:tailEnd type="none" w="med" len="med"/>
-                    </a:lnB>
-                  </a:tcPr>
-                </a:tc>
-                <a:tc>
-                  <a:txBody>
-                    <a:bodyPr/>
-                    <a:lstStyle/>
-                    <a:p>
-                      <a:pPr indent="0" marL="0">
-                        <a:buNone/>
-                      </a:pPr>
-                      <a:r>
-                        <a:rPr lang="en-US" sz="1150" dirty="0">
-                          <a:solidFill>
-                            <a:srgbClr val="111C24"/>
-                          </a:solidFill>
-                          <a:latin typeface="Calibri" pitchFamily="34" charset="0"/>
-                          <a:ea typeface="Calibri" pitchFamily="34" charset="-122"/>
-                          <a:cs typeface="Calibri" pitchFamily="34" charset="-120"/>
-                        </a:rPr>
-                        <a:t>Y — since Sep 29</a:t>
-                      </a:r>
-                      <a:endParaRPr lang="en-US" sz="1150" dirty="0">
-                        <a:latin typeface="Calibri" charset="0"/>
-                        <a:ea typeface="Calibri" charset="0"/>
-                        <a:cs typeface="Calibri" charset="0"/>
-                      </a:endParaRPr>
-                    </a:p>
-                  </a:txBody>
-                  <a:tcPr marL="64008" marR="64008" marT="73152" marB="73152" anchor="ctr">
-                    <a:lnL w="0" cap="flat" cmpd="sng" algn="ctr">
-                      <a:noFill/>
-                    </a:lnL>
-                    <a:lnR w="0" cap="flat" cmpd="sng" algn="ctr">
-                      <a:noFill/>
-                    </a:lnR>
-                    <a:lnT w="0" cap="flat" cmpd="sng" algn="ctr">
-                      <a:noFill/>
-                    </a:lnT>
-                    <a:lnB w="9525" cap="flat" cmpd="sng" algn="ctr">
-                      <a:solidFill>
-                        <a:srgbClr val="BFCAD3"/>
-                      </a:solidFill>
-                      <a:prstDash val="solid"/>
-                      <a:round/>
-                      <a:headEnd type="none" w="med" len="med"/>
-                      <a:tailEnd type="none" w="med" len="med"/>
-                    </a:lnB>
-                  </a:tcPr>
-                </a:tc>
-              </a:tr>
             </a:tbl>
           </a:graphicData>
         </a:graphic>
@@ -13897,264 +13639,6 @@
                           <a:cs typeface="Calibri" pitchFamily="34" charset="-120"/>
                         </a:rPr>
                         <a:t>Erik</a:t>
-                      </a:r>
-                      <a:endParaRPr lang="en-US" sz="1200" dirty="0">
-                        <a:latin typeface="Calibri" charset="0"/>
-                        <a:ea typeface="Calibri" charset="0"/>
-                        <a:cs typeface="Calibri" charset="0"/>
-                      </a:endParaRPr>
-                    </a:p>
-                  </a:txBody>
-                  <a:tcPr marL="64008" marR="64008" marT="73152" marB="73152" anchor="ctr">
-                    <a:lnL w="0" cap="flat" cmpd="sng" algn="ctr">
-                      <a:noFill/>
-                    </a:lnL>
-                    <a:lnR w="0" cap="flat" cmpd="sng" algn="ctr">
-                      <a:noFill/>
-                    </a:lnR>
-                    <a:lnT w="0" cap="flat" cmpd="sng" algn="ctr">
-                      <a:noFill/>
-                    </a:lnT>
-                    <a:lnB w="9525" cap="flat" cmpd="sng" algn="ctr">
-                      <a:solidFill>
-                        <a:srgbClr val="BFCAD3"/>
-                      </a:solidFill>
-                      <a:prstDash val="solid"/>
-                      <a:round/>
-                      <a:headEnd type="none" w="med" len="med"/>
-                      <a:tailEnd type="none" w="med" len="med"/>
-                    </a:lnB>
-                  </a:tcPr>
-                </a:tc>
-              </a:tr>
-              <a:tr h="0">
-                <a:tc>
-                  <a:txBody>
-                    <a:bodyPr/>
-                    <a:lstStyle/>
-                    <a:p>
-                      <a:pPr indent="0" marL="0">
-                        <a:buNone/>
-                      </a:pPr>
-                      <a:r>
-                        <a:rPr lang="en-US" sz="1200" b="1" dirty="0">
-                          <a:solidFill>
-                            <a:srgbClr val="111C24"/>
-                          </a:solidFill>
-                          <a:latin typeface="Calibri" pitchFamily="34" charset="0"/>
-                          <a:ea typeface="Calibri" pitchFamily="34" charset="-122"/>
-                          <a:cs typeface="Calibri" pitchFamily="34" charset="-120"/>
-                        </a:rPr>
-                        <a:t>Ivan</a:t>
-                      </a:r>
-                      <a:endParaRPr lang="en-US" sz="1200" dirty="0">
-                        <a:latin typeface="Calibri" charset="0"/>
-                        <a:ea typeface="Calibri" charset="0"/>
-                        <a:cs typeface="Calibri" charset="0"/>
-                      </a:endParaRPr>
-                    </a:p>
-                    <a:p>
-                      <a:pPr indent="0" marL="0">
-                        <a:buNone/>
-                      </a:pPr>
-                      <a:r>
-                        <a:rPr lang="en-US" sz="1100" dirty="0">
-                          <a:solidFill>
-                            <a:srgbClr val="4E5A64"/>
-                          </a:solidFill>
-                          <a:latin typeface="Calibri" pitchFamily="34" charset="0"/>
-                          <a:ea typeface="Calibri" pitchFamily="34" charset="-122"/>
-                          <a:cs typeface="Calibri" pitchFamily="34" charset="-120"/>
-                        </a:rPr>
-                        <a:t>Onboarding · from 2 Oct</a:t>
-                      </a:r>
-                      <a:endParaRPr lang="en-US" sz="1200" dirty="0">
-                        <a:latin typeface="Calibri" charset="0"/>
-                        <a:ea typeface="Calibri" charset="0"/>
-                        <a:cs typeface="Calibri" charset="0"/>
-                      </a:endParaRPr>
-                    </a:p>
-                  </a:txBody>
-                  <a:tcPr marL="64008" marR="64008" marT="73152" marB="73152" anchor="ctr">
-                    <a:lnL w="0" cap="flat" cmpd="sng" algn="ctr">
-                      <a:noFill/>
-                    </a:lnL>
-                    <a:lnR w="0" cap="flat" cmpd="sng" algn="ctr">
-                      <a:noFill/>
-                    </a:lnR>
-                    <a:lnT w="0" cap="flat" cmpd="sng" algn="ctr">
-                      <a:noFill/>
-                    </a:lnT>
-                    <a:lnB w="9525" cap="flat" cmpd="sng" algn="ctr">
-                      <a:solidFill>
-                        <a:srgbClr val="BFCAD3"/>
-                      </a:solidFill>
-                      <a:prstDash val="solid"/>
-                      <a:round/>
-                      <a:headEnd type="none" w="med" len="med"/>
-                      <a:tailEnd type="none" w="med" len="med"/>
-                    </a:lnB>
-                  </a:tcPr>
-                </a:tc>
-                <a:tc>
-                  <a:txBody>
-                    <a:bodyPr/>
-                    <a:lstStyle/>
-                    <a:p>
-                      <a:pPr indent="0" marL="0">
-                        <a:buNone/>
-                      </a:pPr>
-                      <a:r>
-                        <a:rPr lang="en-US" sz="1200" dirty="0">
-                          <a:solidFill>
-                            <a:srgbClr val="111C24"/>
-                          </a:solidFill>
-                          <a:latin typeface="Calibri" pitchFamily="34" charset="0"/>
-                          <a:ea typeface="Calibri" pitchFamily="34" charset="-122"/>
-                          <a:cs typeface="Calibri" pitchFamily="34" charset="-120"/>
-                        </a:rPr>
-                        <a:t>Foundation on catalog, products and process. EOD output daily: done, next, blockers, questions</a:t>
-                      </a:r>
-                      <a:endParaRPr lang="en-US" sz="1200" dirty="0">
-                        <a:latin typeface="Calibri" charset="0"/>
-                        <a:ea typeface="Calibri" charset="0"/>
-                        <a:cs typeface="Calibri" charset="0"/>
-                      </a:endParaRPr>
-                    </a:p>
-                  </a:txBody>
-                  <a:tcPr marL="64008" marR="64008" marT="73152" marB="73152" anchor="ctr">
-                    <a:lnL w="0" cap="flat" cmpd="sng" algn="ctr">
-                      <a:noFill/>
-                    </a:lnL>
-                    <a:lnR w="0" cap="flat" cmpd="sng" algn="ctr">
-                      <a:noFill/>
-                    </a:lnR>
-                    <a:lnT w="0" cap="flat" cmpd="sng" algn="ctr">
-                      <a:noFill/>
-                    </a:lnT>
-                    <a:lnB w="9525" cap="flat" cmpd="sng" algn="ctr">
-                      <a:solidFill>
-                        <a:srgbClr val="BFCAD3"/>
-                      </a:solidFill>
-                      <a:prstDash val="solid"/>
-                      <a:round/>
-                      <a:headEnd type="none" w="med" len="med"/>
-                      <a:tailEnd type="none" w="med" len="med"/>
-                    </a:lnB>
-                  </a:tcPr>
-                </a:tc>
-                <a:tc>
-                  <a:txBody>
-                    <a:bodyPr/>
-                    <a:lstStyle/>
-                    <a:p>
-                      <a:pPr indent="0" marL="0">
-                        <a:buNone/>
-                      </a:pPr>
-                      <a:r>
-                        <a:rPr lang="en-US" sz="1200" dirty="0">
-                          <a:solidFill>
-                            <a:srgbClr val="111C24"/>
-                          </a:solidFill>
-                          <a:latin typeface="Calibri" pitchFamily="34" charset="0"/>
-                          <a:ea typeface="Calibri" pitchFamily="34" charset="-122"/>
-                          <a:cs typeface="Calibri" pitchFamily="34" charset="-120"/>
-                        </a:rPr>
-                        <a:t>Daily EOD</a:t>
-                      </a:r>
-                      <a:endParaRPr lang="en-US" sz="1200" dirty="0">
-                        <a:latin typeface="Calibri" charset="0"/>
-                        <a:ea typeface="Calibri" charset="0"/>
-                        <a:cs typeface="Calibri" charset="0"/>
-                      </a:endParaRPr>
-                    </a:p>
-                  </a:txBody>
-                  <a:tcPr marL="64008" marR="64008" marT="73152" marB="73152" anchor="ctr">
-                    <a:lnL w="0" cap="flat" cmpd="sng" algn="ctr">
-                      <a:noFill/>
-                    </a:lnL>
-                    <a:lnR w="0" cap="flat" cmpd="sng" algn="ctr">
-                      <a:noFill/>
-                    </a:lnR>
-                    <a:lnT w="0" cap="flat" cmpd="sng" algn="ctr">
-                      <a:noFill/>
-                    </a:lnT>
-                    <a:lnB w="9525" cap="flat" cmpd="sng" algn="ctr">
-                      <a:solidFill>
-                        <a:srgbClr val="BFCAD3"/>
-                      </a:solidFill>
-                      <a:prstDash val="solid"/>
-                      <a:round/>
-                      <a:headEnd type="none" w="med" len="med"/>
-                      <a:tailEnd type="none" w="med" len="med"/>
-                    </a:lnB>
-                  </a:tcPr>
-                </a:tc>
-                <a:tc>
-                  <a:txBody>
-                    <a:bodyPr/>
-                    <a:lstStyle/>
-                    <a:p>
-                      <a:pPr indent="0" marL="0">
-                        <a:buNone/>
-                      </a:pPr>
-                      <a:r>
-                        <a:rPr lang="en-US" sz="1200" dirty="0">
-                          <a:solidFill>
-                            <a:srgbClr val="111C24"/>
-                          </a:solidFill>
-                          <a:latin typeface="Calibri" pitchFamily="34" charset="0"/>
-                          <a:ea typeface="Calibri" pitchFamily="34" charset="-122"/>
-                          <a:cs typeface="Calibri" pitchFamily="34" charset="-120"/>
-                        </a:rPr>
-                        <a:t>Shayan T</a:t>
-                      </a:r>
-                      <a:endParaRPr lang="en-US" sz="1200" dirty="0">
-                        <a:latin typeface="Calibri" charset="0"/>
-                        <a:ea typeface="Calibri" charset="0"/>
-                        <a:cs typeface="Calibri" charset="0"/>
-                      </a:endParaRPr>
-                    </a:p>
-                  </a:txBody>
-                  <a:tcPr marL="64008" marR="64008" marT="73152" marB="73152" anchor="ctr">
-                    <a:lnL w="0" cap="flat" cmpd="sng" algn="ctr">
-                      <a:noFill/>
-                    </a:lnL>
-                    <a:lnR w="0" cap="flat" cmpd="sng" algn="ctr">
-                      <a:noFill/>
-                    </a:lnR>
-                    <a:lnT w="0" cap="flat" cmpd="sng" algn="ctr">
-                      <a:noFill/>
-                    </a:lnT>
-                    <a:lnB w="9525" cap="flat" cmpd="sng" algn="ctr">
-                      <a:solidFill>
-                        <a:srgbClr val="BFCAD3"/>
-                      </a:solidFill>
-                      <a:prstDash val="solid"/>
-                      <a:round/>
-                      <a:headEnd type="none" w="med" len="med"/>
-                      <a:tailEnd type="none" w="med" len="med"/>
-                    </a:lnB>
-                  </a:tcPr>
-                </a:tc>
-                <a:tc>
-                  <a:txBody>
-                    <a:bodyPr/>
-                    <a:lstStyle/>
-                    <a:p>
-                      <a:pPr indent="0" marL="0">
-                        <a:buNone/>
-                      </a:pPr>
-                      <a:r>
-                        <a:rPr lang="en-US" sz="1200" dirty="0">
-                          <a:solidFill>
-                            <a:srgbClr val="111C24"/>
-                          </a:solidFill>
-                          <a:latin typeface="Calibri" pitchFamily="34" charset="0"/>
-                          <a:ea typeface="Calibri" pitchFamily="34" charset="-122"/>
-                          <a:cs typeface="Calibri" pitchFamily="34" charset="-120"/>
-                        </a:rPr>
-                        <a:t>Shayan T</a:t>
                       </a:r>
                       <a:endParaRPr lang="en-US" sz="1200" dirty="0">
                         <a:latin typeface="Calibri" charset="0"/>

</xml_diff>

<commit_message>
Weekly review: engine feedback delivered by Zarlish, in review
The feedback doc and register were delivered by Zarlish; Shayan T
reviews them and Zarlish then shares them with Joseph.

Co-Authored-By: Claude Opus 5.5 <noreply@anthropic.com>
Claude-Session: https://claude.ai/code/session_017KBX8sQPKzAVHK5pu1jizF
</commit_message>
<xml_diff>
--- a/deliverables/PPC_Weekly_Review_Sep28-Oct2.pptx
+++ b/deliverables/PPC_Weekly_Review_Sep28-Oct2.pptx
@@ -2995,7 +2995,7 @@
                           <a:ea typeface="Calibri" pitchFamily="34" charset="-122"/>
                           <a:cs typeface="Calibri" pitchFamily="34" charset="-120"/>
                         </a:rPr>
-                        <a:t>B4 and B6 corrections applied and re-audited 29 Sep, the first clean 218/218 pass. Engine feedback doc and issue register delivered today</a:t>
+                        <a:t>B4 and B6 corrections applied and re-audited 29 Sep, the first clean 218/218 pass. Engine feedback doc and issue register delivered by Zarlish today; Shayan T is reviewing them and Zarlish shares them with Joseph next</a:t>
                       </a:r>
                       <a:endParaRPr lang="en-US" sz="1250" dirty="0">
                         <a:latin typeface="Calibri" charset="0"/>
@@ -3042,7 +3042,7 @@
                           <a:ea typeface="Calibri" pitchFamily="34" charset="-122"/>
                           <a:cs typeface="Calibri" pitchFamily="34" charset="-120"/>
                         </a:rPr>
-                        <a:t>Done</a:t>
+                        <a:t>Delivered · in review</a:t>
                       </a:r>
                       <a:endParaRPr lang="en-US" sz="1250" dirty="0">
                         <a:latin typeface="Calibri" charset="0"/>
@@ -9095,7 +9095,7 @@
                           <a:ea typeface="Calibri" pitchFamily="34" charset="-122"/>
                           <a:cs typeface="Calibri" pitchFamily="34" charset="-120"/>
                         </a:rPr>
-                        <a:t>Engine register</a:t>
+                        <a:t>Engine feedback &amp; register</a:t>
                       </a:r>
                       <a:endParaRPr lang="en-US" sz="1150" dirty="0">
                         <a:latin typeface="Calibri" charset="0"/>
@@ -9116,7 +9116,7 @@
                           <a:ea typeface="Calibri" pitchFamily="34" charset="-122"/>
                           <a:cs typeface="Calibri" pitchFamily="34" charset="-120"/>
                         </a:rPr>
-                        <a:t>Zarlish</a:t>
+                        <a:t>Zarlish with Shayan T</a:t>
                       </a:r>
                       <a:endParaRPr lang="en-US" sz="1150" dirty="0">
                         <a:latin typeface="Calibri" charset="0"/>
@@ -9163,7 +9163,7 @@
                           <a:ea typeface="Calibri" pitchFamily="34" charset="-122"/>
                           <a:cs typeface="Calibri" pitchFamily="34" charset="-120"/>
                         </a:rPr>
-                        <a:t>Move the register to changed-findings-only and get Section 7, Q1 and Q3 signed off</a:t>
+                        <a:t>Shayan T reviews, Zarlish shares the feedback and register with Joseph, then the register moves to changed-findings-only and Section 7, Q1 and Q3 are signed off</a:t>
                       </a:r>
                       <a:endParaRPr lang="en-US" sz="1150" dirty="0">
                         <a:latin typeface="Calibri" charset="0"/>
@@ -9210,7 +9210,7 @@
                           <a:ea typeface="Calibri" pitchFamily="34" charset="-122"/>
                           <a:cs typeface="Calibri" pitchFamily="34" charset="-120"/>
                         </a:rPr>
-                        <a:t>Mon, Oct 5</a:t>
+                        <a:t>Share soon · sign-off Mon, Oct 5</a:t>
                       </a:r>
                       <a:endParaRPr lang="en-US" sz="1150" dirty="0">
                         <a:latin typeface="Calibri" charset="0"/>

</xml_diff>

<commit_message>
Weekly review: Zarlish joins the CooLinens Pillowcase launch
Co-Authored-By: Claude Opus 5.5 <noreply@anthropic.com>
Claude-Session: https://claude.ai/code/session_017KBX8sQPKzAVHK5pu1jizF
</commit_message>
<xml_diff>
--- a/deliverables/PPC_Weekly_Review_Sep28-Oct2.pptx
+++ b/deliverables/PPC_Weekly_Review_Sep28-Oct2.pptx
@@ -2658,7 +2658,7 @@
                         <a:buNone/>
                       </a:pPr>
                       <a:r>
-                        <a:rPr lang="en-US" sz="1250" b="1" dirty="0">
+                        <a:rPr lang="en-US" sz="1200" b="1" dirty="0">
                           <a:solidFill>
                             <a:srgbClr val="111C24"/>
                           </a:solidFill>
@@ -2668,18 +2668,18 @@
                         </a:rPr>
                         <a:t>Nine-product audit cycle</a:t>
                       </a:r>
-                      <a:endParaRPr lang="en-US" sz="1250" dirty="0">
-                        <a:latin typeface="Calibri" charset="0"/>
-                        <a:ea typeface="Calibri" charset="0"/>
-                        <a:cs typeface="Calibri" charset="0"/>
-                      </a:endParaRPr>
-                    </a:p>
-                    <a:p>
-                      <a:pPr indent="0" marL="0">
-                        <a:buNone/>
-                      </a:pPr>
-                      <a:r>
-                        <a:rPr lang="en-US" sz="1150" dirty="0">
+                      <a:endParaRPr lang="en-US" sz="1200" dirty="0">
+                        <a:latin typeface="Calibri" charset="0"/>
+                        <a:ea typeface="Calibri" charset="0"/>
+                        <a:cs typeface="Calibri" charset="0"/>
+                      </a:endParaRPr>
+                    </a:p>
+                    <a:p>
+                      <a:pPr indent="0" marL="0">
+                        <a:buNone/>
+                      </a:pPr>
+                      <a:r>
+                        <a:rPr lang="en-US" sz="1100" dirty="0">
                           <a:solidFill>
                             <a:srgbClr val="4E5A64"/>
                           </a:solidFill>
@@ -2689,7 +2689,7 @@
                         </a:rPr>
                         <a:t>All three · weekly cycle · P0</a:t>
                       </a:r>
-                      <a:endParaRPr lang="en-US" sz="1250" dirty="0">
+                      <a:endParaRPr lang="en-US" sz="1200" dirty="0">
                         <a:latin typeface="Calibri" charset="0"/>
                         <a:ea typeface="Calibri" charset="0"/>
                         <a:cs typeface="Calibri" charset="0"/>
@@ -2726,7 +2726,7 @@
                         <a:buNone/>
                       </a:pPr>
                       <a:r>
-                        <a:rPr lang="en-US" sz="1250" dirty="0">
+                        <a:rPr lang="en-US" sz="1200" dirty="0">
                           <a:solidFill>
                             <a:srgbClr val="111C24"/>
                           </a:solidFill>
@@ -2736,7 +2736,7 @@
                         </a:rPr>
                         <a:t>All nine audited, reviewed by all three and executed through the app. Bamboo Monday, the rest Tuesday</a:t>
                       </a:r>
-                      <a:endParaRPr lang="en-US" sz="1250" dirty="0">
+                      <a:endParaRPr lang="en-US" sz="1200" dirty="0">
                         <a:latin typeface="Calibri" charset="0"/>
                         <a:ea typeface="Calibri" charset="0"/>
                         <a:cs typeface="Calibri" charset="0"/>
@@ -2773,7 +2773,7 @@
                         <a:buNone/>
                       </a:pPr>
                       <a:r>
-                        <a:rPr lang="en-US" sz="1250" dirty="0">
+                        <a:rPr lang="en-US" sz="1200" dirty="0">
                           <a:solidFill>
                             <a:srgbClr val="111C24"/>
                           </a:solidFill>
@@ -2783,7 +2783,7 @@
                         </a:rPr>
                         <a:t>Feedback posted on six: B4, B6, S4, S6, Satin Fitted, SS-S4. The remaining three, Cooling Sheets 4-PC, Bamboo Fitted and Cooling Fitted, are being completed today</a:t>
                       </a:r>
-                      <a:endParaRPr lang="en-US" sz="1250" dirty="0">
+                      <a:endParaRPr lang="en-US" sz="1200" dirty="0">
                         <a:latin typeface="Calibri" charset="0"/>
                         <a:ea typeface="Calibri" charset="0"/>
                         <a:cs typeface="Calibri" charset="0"/>
@@ -2820,7 +2820,7 @@
                         <a:buNone/>
                       </a:pPr>
                       <a:r>
-                        <a:rPr lang="en-US" sz="1250" b="1" dirty="0">
+                        <a:rPr lang="en-US" sz="1200" b="1" dirty="0">
                           <a:solidFill>
                             <a:srgbClr val="6E4A0F"/>
                           </a:solidFill>
@@ -2830,7 +2830,7 @@
                         </a:rPr>
                         <a:t>6 of 9 · 3 today</a:t>
                       </a:r>
-                      <a:endParaRPr lang="en-US" sz="1250" dirty="0">
+                      <a:endParaRPr lang="en-US" sz="1200" dirty="0">
                         <a:latin typeface="Calibri" charset="0"/>
                         <a:ea typeface="Calibri" charset="0"/>
                         <a:cs typeface="Calibri" charset="0"/>
@@ -2872,7 +2872,7 @@
                         <a:buNone/>
                       </a:pPr>
                       <a:r>
-                        <a:rPr lang="en-US" sz="1250" b="1" dirty="0">
+                        <a:rPr lang="en-US" sz="1200" b="1" dirty="0">
                           <a:solidFill>
                             <a:srgbClr val="111C24"/>
                           </a:solidFill>
@@ -2882,18 +2882,18 @@
                         </a:rPr>
                         <a:t>Engine corrections &amp; feedback</a:t>
                       </a:r>
-                      <a:endParaRPr lang="en-US" sz="1250" dirty="0">
-                        <a:latin typeface="Calibri" charset="0"/>
-                        <a:ea typeface="Calibri" charset="0"/>
-                        <a:cs typeface="Calibri" charset="0"/>
-                      </a:endParaRPr>
-                    </a:p>
-                    <a:p>
-                      <a:pPr indent="0" marL="0">
-                        <a:buNone/>
-                      </a:pPr>
-                      <a:r>
-                        <a:rPr lang="en-US" sz="1150" dirty="0">
+                      <a:endParaRPr lang="en-US" sz="1200" dirty="0">
+                        <a:latin typeface="Calibri" charset="0"/>
+                        <a:ea typeface="Calibri" charset="0"/>
+                        <a:cs typeface="Calibri" charset="0"/>
+                      </a:endParaRPr>
+                    </a:p>
+                    <a:p>
+                      <a:pPr indent="0" marL="0">
+                        <a:buNone/>
+                      </a:pPr>
+                      <a:r>
+                        <a:rPr lang="en-US" sz="1100" dirty="0">
                           <a:solidFill>
                             <a:srgbClr val="4E5A64"/>
                           </a:solidFill>
@@ -2903,7 +2903,7 @@
                         </a:rPr>
                         <a:t>Joseph with PPC review · P0</a:t>
                       </a:r>
-                      <a:endParaRPr lang="en-US" sz="1250" dirty="0">
+                      <a:endParaRPr lang="en-US" sz="1200" dirty="0">
                         <a:latin typeface="Calibri" charset="0"/>
                         <a:ea typeface="Calibri" charset="0"/>
                         <a:cs typeface="Calibri" charset="0"/>
@@ -2940,7 +2940,7 @@
                         <a:buNone/>
                       </a:pPr>
                       <a:r>
-                        <a:rPr lang="en-US" sz="1250" dirty="0">
+                        <a:rPr lang="en-US" sz="1200" dirty="0">
                           <a:solidFill>
                             <a:srgbClr val="111C24"/>
                           </a:solidFill>
@@ -2950,7 +2950,7 @@
                         </a:rPr>
                         <a:t>One consolidated note per product to Joseph, engine fixed and the audits re-run on the corrections</a:t>
                       </a:r>
-                      <a:endParaRPr lang="en-US" sz="1250" dirty="0">
+                      <a:endParaRPr lang="en-US" sz="1200" dirty="0">
                         <a:latin typeface="Calibri" charset="0"/>
                         <a:ea typeface="Calibri" charset="0"/>
                         <a:cs typeface="Calibri" charset="0"/>
@@ -2987,7 +2987,7 @@
                         <a:buNone/>
                       </a:pPr>
                       <a:r>
-                        <a:rPr lang="en-US" sz="1250" dirty="0">
+                        <a:rPr lang="en-US" sz="1200" dirty="0">
                           <a:solidFill>
                             <a:srgbClr val="111C24"/>
                           </a:solidFill>
@@ -2997,7 +2997,7 @@
                         </a:rPr>
                         <a:t>B4 and B6 corrections applied and re-audited 29 Sep, the first clean 218/218 pass. Engine feedback doc and issue register delivered by Zarlish today; Shayan T is reviewing them and Zarlish shares them with Joseph next</a:t>
                       </a:r>
-                      <a:endParaRPr lang="en-US" sz="1250" dirty="0">
+                      <a:endParaRPr lang="en-US" sz="1200" dirty="0">
                         <a:latin typeface="Calibri" charset="0"/>
                         <a:ea typeface="Calibri" charset="0"/>
                         <a:cs typeface="Calibri" charset="0"/>
@@ -3034,7 +3034,7 @@
                         <a:buNone/>
                       </a:pPr>
                       <a:r>
-                        <a:rPr lang="en-US" sz="1250" b="1" dirty="0">
+                        <a:rPr lang="en-US" sz="1200" b="1" dirty="0">
                           <a:solidFill>
                             <a:srgbClr val="176B41"/>
                           </a:solidFill>
@@ -3044,7 +3044,7 @@
                         </a:rPr>
                         <a:t>Delivered · in review</a:t>
                       </a:r>
-                      <a:endParaRPr lang="en-US" sz="1250" dirty="0">
+                      <a:endParaRPr lang="en-US" sz="1200" dirty="0">
                         <a:latin typeface="Calibri" charset="0"/>
                         <a:ea typeface="Calibri" charset="0"/>
                         <a:cs typeface="Calibri" charset="0"/>
@@ -3086,7 +3086,7 @@
                         <a:buNone/>
                       </a:pPr>
                       <a:r>
-                        <a:rPr lang="en-US" sz="1250" b="1" dirty="0">
+                        <a:rPr lang="en-US" sz="1200" b="1" dirty="0">
                           <a:solidFill>
                             <a:srgbClr val="111C24"/>
                           </a:solidFill>
@@ -3096,18 +3096,18 @@
                         </a:rPr>
                         <a:t>Bamboo ranking push (B4, B6)</a:t>
                       </a:r>
-                      <a:endParaRPr lang="en-US" sz="1250" dirty="0">
-                        <a:latin typeface="Calibri" charset="0"/>
-                        <a:ea typeface="Calibri" charset="0"/>
-                        <a:cs typeface="Calibri" charset="0"/>
-                      </a:endParaRPr>
-                    </a:p>
-                    <a:p>
-                      <a:pPr indent="0" marL="0">
-                        <a:buNone/>
-                      </a:pPr>
-                      <a:r>
-                        <a:rPr lang="en-US" sz="1150" dirty="0">
+                      <a:endParaRPr lang="en-US" sz="1200" dirty="0">
+                        <a:latin typeface="Calibri" charset="0"/>
+                        <a:ea typeface="Calibri" charset="0"/>
+                        <a:cs typeface="Calibri" charset="0"/>
+                      </a:endParaRPr>
+                    </a:p>
+                    <a:p>
+                      <a:pPr indent="0" marL="0">
+                        <a:buNone/>
+                      </a:pPr>
+                      <a:r>
+                        <a:rPr lang="en-US" sz="1100" dirty="0">
                           <a:solidFill>
                             <a:srgbClr val="4E5A64"/>
                           </a:solidFill>
@@ -3117,7 +3117,7 @@
                         </a:rPr>
                         <a:t>Shayan T with Joseph · P0</a:t>
                       </a:r>
-                      <a:endParaRPr lang="en-US" sz="1250" dirty="0">
+                      <a:endParaRPr lang="en-US" sz="1200" dirty="0">
                         <a:latin typeface="Calibri" charset="0"/>
                         <a:ea typeface="Calibri" charset="0"/>
                         <a:cs typeface="Calibri" charset="0"/>
@@ -3154,7 +3154,7 @@
                         <a:buNone/>
                       </a:pPr>
                       <a:r>
-                        <a:rPr lang="en-US" sz="1250" dirty="0">
+                        <a:rPr lang="en-US" sz="1200" dirty="0">
                           <a:solidFill>
                             <a:srgbClr val="111C24"/>
                           </a:solidFill>
@@ -3164,7 +3164,7 @@
                         </a:rPr>
                         <a:t>One ranking plan per listing, matched to Joseph's keyword story and plan of attack, before the pushes start</a:t>
                       </a:r>
-                      <a:endParaRPr lang="en-US" sz="1250" dirty="0">
+                      <a:endParaRPr lang="en-US" sz="1200" dirty="0">
                         <a:latin typeface="Calibri" charset="0"/>
                         <a:ea typeface="Calibri" charset="0"/>
                         <a:cs typeface="Calibri" charset="0"/>
@@ -3201,7 +3201,7 @@
                         <a:buNone/>
                       </a:pPr>
                       <a:r>
-                        <a:rPr lang="en-US" sz="1250" dirty="0">
+                        <a:rPr lang="en-US" sz="1200" dirty="0">
                           <a:solidFill>
                             <a:srgbClr val="111C24"/>
                           </a:solidFill>
@@ -3211,7 +3211,7 @@
                         </a:rPr>
                         <a:t>Plan of attack shared 1 Oct. B4 and B6 plans finalised 2 Oct: B4 follows its start dates and colours by size; B6 replaces the 30 Sep plan. Erik's 2 Oct points built in</a:t>
                       </a:r>
-                      <a:endParaRPr lang="en-US" sz="1250" dirty="0">
+                      <a:endParaRPr lang="en-US" sz="1200" dirty="0">
                         <a:latin typeface="Calibri" charset="0"/>
                         <a:ea typeface="Calibri" charset="0"/>
                         <a:cs typeface="Calibri" charset="0"/>
@@ -3248,7 +3248,7 @@
                         <a:buNone/>
                       </a:pPr>
                       <a:r>
-                        <a:rPr lang="en-US" sz="1250" b="1" dirty="0">
+                        <a:rPr lang="en-US" sz="1200" b="1" dirty="0">
                           <a:solidFill>
                             <a:srgbClr val="176B41"/>
                           </a:solidFill>
@@ -3258,7 +3258,7 @@
                         </a:rPr>
                         <a:t>Plans final</a:t>
                       </a:r>
-                      <a:endParaRPr lang="en-US" sz="1250" dirty="0">
+                      <a:endParaRPr lang="en-US" sz="1200" dirty="0">
                         <a:latin typeface="Calibri" charset="0"/>
                         <a:ea typeface="Calibri" charset="0"/>
                         <a:cs typeface="Calibri" charset="0"/>
@@ -3300,7 +3300,7 @@
                         <a:buNone/>
                       </a:pPr>
                       <a:r>
-                        <a:rPr lang="en-US" sz="1250" b="1" dirty="0">
+                        <a:rPr lang="en-US" sz="1200" b="1" dirty="0">
                           <a:solidFill>
                             <a:srgbClr val="111C24"/>
                           </a:solidFill>
@@ -3310,18 +3310,18 @@
                         </a:rPr>
                         <a:t>Process deliverables</a:t>
                       </a:r>
-                      <a:endParaRPr lang="en-US" sz="1250" dirty="0">
-                        <a:latin typeface="Calibri" charset="0"/>
-                        <a:ea typeface="Calibri" charset="0"/>
-                        <a:cs typeface="Calibri" charset="0"/>
-                      </a:endParaRPr>
-                    </a:p>
-                    <a:p>
-                      <a:pPr indent="0" marL="0">
-                        <a:buNone/>
-                      </a:pPr>
-                      <a:r>
-                        <a:rPr lang="en-US" sz="1150" dirty="0">
+                      <a:endParaRPr lang="en-US" sz="1200" dirty="0">
+                        <a:latin typeface="Calibri" charset="0"/>
+                        <a:ea typeface="Calibri" charset="0"/>
+                        <a:cs typeface="Calibri" charset="0"/>
+                      </a:endParaRPr>
+                    </a:p>
+                    <a:p>
+                      <a:pPr indent="0" marL="0">
+                        <a:buNone/>
+                      </a:pPr>
+                      <a:r>
+                        <a:rPr lang="en-US" sz="1100" dirty="0">
                           <a:solidFill>
                             <a:srgbClr val="4E5A64"/>
                           </a:solidFill>
@@ -3331,7 +3331,7 @@
                         </a:rPr>
                         <a:t>Shayan T · one-off · P0</a:t>
                       </a:r>
-                      <a:endParaRPr lang="en-US" sz="1250" dirty="0">
+                      <a:endParaRPr lang="en-US" sz="1200" dirty="0">
                         <a:latin typeface="Calibri" charset="0"/>
                         <a:ea typeface="Calibri" charset="0"/>
                         <a:cs typeface="Calibri" charset="0"/>
@@ -3368,7 +3368,7 @@
                         <a:buNone/>
                       </a:pPr>
                       <a:r>
-                        <a:rPr lang="en-US" sz="1250" dirty="0">
+                        <a:rPr lang="en-US" sz="1200" dirty="0">
                           <a:solidFill>
                             <a:srgbClr val="111C24"/>
                           </a:solidFill>
@@ -3378,7 +3378,7 @@
                         </a:rPr>
                         <a:t>Campaign-type list Wednesday, ad-type framework Friday, stabilisation proposal by end of week. Re-set on the 30 Sep call: ranking plan first, the rest by end of week</a:t>
                       </a:r>
-                      <a:endParaRPr lang="en-US" sz="1250" dirty="0">
+                      <a:endParaRPr lang="en-US" sz="1200" dirty="0">
                         <a:latin typeface="Calibri" charset="0"/>
                         <a:ea typeface="Calibri" charset="0"/>
                         <a:cs typeface="Calibri" charset="0"/>
@@ -3415,7 +3415,7 @@
                         <a:buNone/>
                       </a:pPr>
                       <a:r>
-                        <a:rPr lang="en-US" sz="1250" dirty="0">
+                        <a:rPr lang="en-US" sz="1200" dirty="0">
                           <a:solidFill>
                             <a:srgbClr val="111C24"/>
                           </a:solidFill>
@@ -3425,7 +3425,7 @@
                         </a:rPr>
                         <a:t>Ranking plan sent 1 Oct as agreed. Campaign-type list, ad-type plan (Bamboo first), frameworks and stabilisation proposal due end of week, 3–4 Oct. SB, SBV and SD held for creative, so the 1 Oct API launch did not happen</a:t>
                       </a:r>
-                      <a:endParaRPr lang="en-US" sz="1250" dirty="0">
+                      <a:endParaRPr lang="en-US" sz="1200" dirty="0">
                         <a:latin typeface="Calibri" charset="0"/>
                         <a:ea typeface="Calibri" charset="0"/>
                         <a:cs typeface="Calibri" charset="0"/>
@@ -3462,7 +3462,7 @@
                         <a:buNone/>
                       </a:pPr>
                       <a:r>
-                        <a:rPr lang="en-US" sz="1250" b="1" dirty="0">
+                        <a:rPr lang="en-US" sz="1200" b="1" dirty="0">
                           <a:solidFill>
                             <a:srgbClr val="6E4A0F"/>
                           </a:solidFill>
@@ -3472,7 +3472,7 @@
                         </a:rPr>
                         <a:t>Due end of week</a:t>
                       </a:r>
-                      <a:endParaRPr lang="en-US" sz="1250" dirty="0">
+                      <a:endParaRPr lang="en-US" sz="1200" dirty="0">
                         <a:latin typeface="Calibri" charset="0"/>
                         <a:ea typeface="Calibri" charset="0"/>
                         <a:cs typeface="Calibri" charset="0"/>
@@ -3514,7 +3514,7 @@
                         <a:buNone/>
                       </a:pPr>
                       <a:r>
-                        <a:rPr lang="en-US" sz="1250" b="1" dirty="0">
+                        <a:rPr lang="en-US" sz="1200" b="1" dirty="0">
                           <a:solidFill>
                             <a:srgbClr val="111C24"/>
                           </a:solidFill>
@@ -3524,18 +3524,18 @@
                         </a:rPr>
                         <a:t>CooLinens Pillowcase launch</a:t>
                       </a:r>
-                      <a:endParaRPr lang="en-US" sz="1250" dirty="0">
-                        <a:latin typeface="Calibri" charset="0"/>
-                        <a:ea typeface="Calibri" charset="0"/>
-                        <a:cs typeface="Calibri" charset="0"/>
-                      </a:endParaRPr>
-                    </a:p>
-                    <a:p>
-                      <a:pPr indent="0" marL="0">
-                        <a:buNone/>
-                      </a:pPr>
-                      <a:r>
-                        <a:rPr lang="en-US" sz="1150" dirty="0">
+                      <a:endParaRPr lang="en-US" sz="1200" dirty="0">
+                        <a:latin typeface="Calibri" charset="0"/>
+                        <a:ea typeface="Calibri" charset="0"/>
+                        <a:cs typeface="Calibri" charset="0"/>
+                      </a:endParaRPr>
+                    </a:p>
+                    <a:p>
+                      <a:pPr indent="0" marL="0">
+                        <a:buNone/>
+                      </a:pPr>
+                      <a:r>
+                        <a:rPr lang="en-US" sz="1100" dirty="0">
                           <a:solidFill>
                             <a:srgbClr val="4E5A64"/>
                           </a:solidFill>
@@ -3543,9 +3543,9 @@
                           <a:ea typeface="Calibri" pitchFamily="34" charset="-122"/>
                           <a:cs typeface="Calibri" pitchFamily="34" charset="-120"/>
                         </a:rPr>
-                        <a:t>Shayan T · one-off · P0</a:t>
-                      </a:r>
-                      <a:endParaRPr lang="en-US" sz="1250" dirty="0">
+                        <a:t>Shayan T with Zarlish · one-off · P0</a:t>
+                      </a:r>
+                      <a:endParaRPr lang="en-US" sz="1200" dirty="0">
                         <a:latin typeface="Calibri" charset="0"/>
                         <a:ea typeface="Calibri" charset="0"/>
                         <a:cs typeface="Calibri" charset="0"/>
@@ -3582,7 +3582,7 @@
                         <a:buNone/>
                       </a:pPr>
                       <a:r>
-                        <a:rPr lang="en-US" sz="1250" dirty="0">
+                        <a:rPr lang="en-US" sz="1200" dirty="0">
                           <a:solidFill>
                             <a:srgbClr val="111C24"/>
                           </a:solidFill>
@@ -3592,7 +3592,7 @@
                         </a:rPr>
                         <a:t>PPC launch strategy delivered Monday 28 Sep, campaigns live with the listing</a:t>
                       </a:r>
-                      <a:endParaRPr lang="en-US" sz="1250" dirty="0">
+                      <a:endParaRPr lang="en-US" sz="1200" dirty="0">
                         <a:latin typeface="Calibri" charset="0"/>
                         <a:ea typeface="Calibri" charset="0"/>
                         <a:cs typeface="Calibri" charset="0"/>
@@ -3629,7 +3629,7 @@
                         <a:buNone/>
                       </a:pPr>
                       <a:r>
-                        <a:rPr lang="en-US" sz="1250" dirty="0">
+                        <a:rPr lang="en-US" sz="1200" dirty="0">
                           <a:solidFill>
                             <a:srgbClr val="111C24"/>
                           </a:solidFill>
@@ -3637,9 +3637,9 @@
                           <a:ea typeface="Calibri" pitchFamily="34" charset="-122"/>
                           <a:cs typeface="Calibri" pitchFamily="34" charset="-120"/>
                         </a:rPr>
-                        <a:t>Launch workbook shared 28 Sep, revised with a strategy doc on Erik's feedback 29 Sep. Listing goes live on Amazon today, 2 Oct, and PPC launches with it</a:t>
-                      </a:r>
-                      <a:endParaRPr lang="en-US" sz="1250" dirty="0">
+                        <a:t>Launch workbook shared 28 Sep, revised with a strategy doc on Erik's feedback 29 Sep. Listing goes live on Amazon today, 2 Oct; Shayan T and Zarlish launch the campaigns with it</a:t>
+                      </a:r>
+                      <a:endParaRPr lang="en-US" sz="1200" dirty="0">
                         <a:latin typeface="Calibri" charset="0"/>
                         <a:ea typeface="Calibri" charset="0"/>
                         <a:cs typeface="Calibri" charset="0"/>
@@ -3676,7 +3676,7 @@
                         <a:buNone/>
                       </a:pPr>
                       <a:r>
-                        <a:rPr lang="en-US" sz="1250" b="1" dirty="0">
+                        <a:rPr lang="en-US" sz="1200" b="1" dirty="0">
                           <a:solidFill>
                             <a:srgbClr val="176B41"/>
                           </a:solidFill>
@@ -3686,7 +3686,7 @@
                         </a:rPr>
                         <a:t>Launching today</a:t>
                       </a:r>
-                      <a:endParaRPr lang="en-US" sz="1250" dirty="0">
+                      <a:endParaRPr lang="en-US" sz="1200" dirty="0">
                         <a:latin typeface="Calibri" charset="0"/>
                         <a:ea typeface="Calibri" charset="0"/>
                         <a:cs typeface="Calibri" charset="0"/>
@@ -8600,7 +8600,7 @@
                           <a:ea typeface="Calibri" pitchFamily="34" charset="-122"/>
                           <a:cs typeface="Calibri" pitchFamily="34" charset="-120"/>
                         </a:rPr>
-                        <a:t>Shayan T</a:t>
+                        <a:t>Shayan T with Zarlish</a:t>
                       </a:r>
                       <a:endParaRPr lang="en-US" sz="1150" dirty="0">
                         <a:latin typeface="Calibri" charset="0"/>
@@ -13239,7 +13239,7 @@
                           <a:ea typeface="Calibri" pitchFamily="34" charset="-122"/>
                           <a:cs typeface="Calibri" pitchFamily="34" charset="-120"/>
                         </a:rPr>
-                        <a:t>Satin daily work, the consolidated engine register and the Friday read. Register goes changed-only</a:t>
+                        <a:t>Satin daily work, the consolidated engine register and the Friday read, and the CooLinens Pillowcase campaigns with Shayan T. Register goes changed-only</a:t>
                       </a:r>
                       <a:endParaRPr lang="en-US" sz="1200" dirty="0">
                         <a:latin typeface="Calibri" charset="0"/>

</xml_diff>

<commit_message>
Weekly review: add Zarlish's LTSF work; other campaign types end of week
Co-Authored-By: Claude Opus 5.5 <noreply@anthropic.com>
Claude-Session: https://claude.ai/code/session_017KBX8sQPKzAVHK5pu1jizF
</commit_message>
<xml_diff>
--- a/deliverables/PPC_Weekly_Review_Sep28-Oct2.pptx
+++ b/deliverables/PPC_Weekly_Review_Sep28-Oct2.pptx
@@ -1768,7 +1768,7 @@
                 <a:ea typeface="Cambria" pitchFamily="34" charset="-122"/>
                 <a:cs typeface="Cambria" pitchFamily="34" charset="-120"/>
               </a:rPr>
-              <a:t>5</a:t>
+              <a:t>6</a:t>
             </a:r>
             <a:endParaRPr lang="en-US" sz="3600" dirty="0"/>
           </a:p>
@@ -1846,7 +1846,7 @@
                 <a:ea typeface="Cambria" pitchFamily="34" charset="-122"/>
                 <a:cs typeface="Cambria" pitchFamily="34" charset="-120"/>
               </a:rPr>
-              <a:t>3</a:t>
+              <a:t>4</a:t>
             </a:r>
             <a:endParaRPr lang="en-US" sz="3600" dirty="0"/>
           </a:p>
@@ -2658,7 +2658,7 @@
                         <a:buNone/>
                       </a:pPr>
                       <a:r>
-                        <a:rPr lang="en-US" sz="1200" b="1" dirty="0">
+                        <a:rPr lang="en-US" sz="1150" b="1" dirty="0">
                           <a:solidFill>
                             <a:srgbClr val="111C24"/>
                           </a:solidFill>
@@ -2668,18 +2668,18 @@
                         </a:rPr>
                         <a:t>Nine-product audit cycle</a:t>
                       </a:r>
-                      <a:endParaRPr lang="en-US" sz="1200" dirty="0">
-                        <a:latin typeface="Calibri" charset="0"/>
-                        <a:ea typeface="Calibri" charset="0"/>
-                        <a:cs typeface="Calibri" charset="0"/>
-                      </a:endParaRPr>
-                    </a:p>
-                    <a:p>
-                      <a:pPr indent="0" marL="0">
-                        <a:buNone/>
-                      </a:pPr>
-                      <a:r>
-                        <a:rPr lang="en-US" sz="1100" dirty="0">
+                      <a:endParaRPr lang="en-US" sz="1150" dirty="0">
+                        <a:latin typeface="Calibri" charset="0"/>
+                        <a:ea typeface="Calibri" charset="0"/>
+                        <a:cs typeface="Calibri" charset="0"/>
+                      </a:endParaRPr>
+                    </a:p>
+                    <a:p>
+                      <a:pPr indent="0" marL="0">
+                        <a:buNone/>
+                      </a:pPr>
+                      <a:r>
+                        <a:rPr lang="en-US" sz="1050" dirty="0">
                           <a:solidFill>
                             <a:srgbClr val="4E5A64"/>
                           </a:solidFill>
@@ -2689,44 +2689,44 @@
                         </a:rPr>
                         <a:t>All three · weekly cycle · P0</a:t>
                       </a:r>
-                      <a:endParaRPr lang="en-US" sz="1200" dirty="0">
-                        <a:latin typeface="Calibri" charset="0"/>
-                        <a:ea typeface="Calibri" charset="0"/>
-                        <a:cs typeface="Calibri" charset="0"/>
-                      </a:endParaRPr>
-                    </a:p>
-                  </a:txBody>
-                  <a:tcPr marL="64008" marR="64008" marT="73152" marB="73152" anchor="ctr">
-                    <a:lnL w="0" cap="flat" cmpd="sng" algn="ctr">
-                      <a:noFill/>
-                    </a:lnL>
-                    <a:lnR w="0" cap="flat" cmpd="sng" algn="ctr">
-                      <a:noFill/>
-                    </a:lnR>
-                    <a:lnT w="0" cap="flat" cmpd="sng" algn="ctr">
-                      <a:noFill/>
-                    </a:lnT>
-                    <a:lnB w="9525" cap="flat" cmpd="sng" algn="ctr">
-                      <a:solidFill>
-                        <a:srgbClr val="BFCAD3"/>
-                      </a:solidFill>
-                      <a:prstDash val="solid"/>
-                      <a:round/>
-                      <a:headEnd type="none" w="med" len="med"/>
-                      <a:tailEnd type="none" w="med" len="med"/>
-                    </a:lnB>
-                  </a:tcPr>
-                </a:tc>
-                <a:tc>
-                  <a:txBody>
-                    <a:bodyPr/>
-                    <a:lstStyle/>
-                    <a:p>
-                      <a:pPr indent="0" marL="0">
-                        <a:buNone/>
-                      </a:pPr>
-                      <a:r>
-                        <a:rPr lang="en-US" sz="1200" dirty="0">
+                      <a:endParaRPr lang="en-US" sz="1150" dirty="0">
+                        <a:latin typeface="Calibri" charset="0"/>
+                        <a:ea typeface="Calibri" charset="0"/>
+                        <a:cs typeface="Calibri" charset="0"/>
+                      </a:endParaRPr>
+                    </a:p>
+                  </a:txBody>
+                  <a:tcPr marL="64008" marR="64008" marT="73152" marB="73152" anchor="ctr">
+                    <a:lnL w="0" cap="flat" cmpd="sng" algn="ctr">
+                      <a:noFill/>
+                    </a:lnL>
+                    <a:lnR w="0" cap="flat" cmpd="sng" algn="ctr">
+                      <a:noFill/>
+                    </a:lnR>
+                    <a:lnT w="0" cap="flat" cmpd="sng" algn="ctr">
+                      <a:noFill/>
+                    </a:lnT>
+                    <a:lnB w="9525" cap="flat" cmpd="sng" algn="ctr">
+                      <a:solidFill>
+                        <a:srgbClr val="BFCAD3"/>
+                      </a:solidFill>
+                      <a:prstDash val="solid"/>
+                      <a:round/>
+                      <a:headEnd type="none" w="med" len="med"/>
+                      <a:tailEnd type="none" w="med" len="med"/>
+                    </a:lnB>
+                  </a:tcPr>
+                </a:tc>
+                <a:tc>
+                  <a:txBody>
+                    <a:bodyPr/>
+                    <a:lstStyle/>
+                    <a:p>
+                      <a:pPr indent="0" marL="0">
+                        <a:buNone/>
+                      </a:pPr>
+                      <a:r>
+                        <a:rPr lang="en-US" sz="1150" dirty="0">
                           <a:solidFill>
                             <a:srgbClr val="111C24"/>
                           </a:solidFill>
@@ -2736,44 +2736,44 @@
                         </a:rPr>
                         <a:t>All nine audited, reviewed by all three and executed through the app. Bamboo Monday, the rest Tuesday</a:t>
                       </a:r>
-                      <a:endParaRPr lang="en-US" sz="1200" dirty="0">
-                        <a:latin typeface="Calibri" charset="0"/>
-                        <a:ea typeface="Calibri" charset="0"/>
-                        <a:cs typeface="Calibri" charset="0"/>
-                      </a:endParaRPr>
-                    </a:p>
-                  </a:txBody>
-                  <a:tcPr marL="64008" marR="64008" marT="73152" marB="73152" anchor="ctr">
-                    <a:lnL w="0" cap="flat" cmpd="sng" algn="ctr">
-                      <a:noFill/>
-                    </a:lnL>
-                    <a:lnR w="0" cap="flat" cmpd="sng" algn="ctr">
-                      <a:noFill/>
-                    </a:lnR>
-                    <a:lnT w="0" cap="flat" cmpd="sng" algn="ctr">
-                      <a:noFill/>
-                    </a:lnT>
-                    <a:lnB w="9525" cap="flat" cmpd="sng" algn="ctr">
-                      <a:solidFill>
-                        <a:srgbClr val="BFCAD3"/>
-                      </a:solidFill>
-                      <a:prstDash val="solid"/>
-                      <a:round/>
-                      <a:headEnd type="none" w="med" len="med"/>
-                      <a:tailEnd type="none" w="med" len="med"/>
-                    </a:lnB>
-                  </a:tcPr>
-                </a:tc>
-                <a:tc>
-                  <a:txBody>
-                    <a:bodyPr/>
-                    <a:lstStyle/>
-                    <a:p>
-                      <a:pPr indent="0" marL="0">
-                        <a:buNone/>
-                      </a:pPr>
-                      <a:r>
-                        <a:rPr lang="en-US" sz="1200" dirty="0">
+                      <a:endParaRPr lang="en-US" sz="1150" dirty="0">
+                        <a:latin typeface="Calibri" charset="0"/>
+                        <a:ea typeface="Calibri" charset="0"/>
+                        <a:cs typeface="Calibri" charset="0"/>
+                      </a:endParaRPr>
+                    </a:p>
+                  </a:txBody>
+                  <a:tcPr marL="64008" marR="64008" marT="73152" marB="73152" anchor="ctr">
+                    <a:lnL w="0" cap="flat" cmpd="sng" algn="ctr">
+                      <a:noFill/>
+                    </a:lnL>
+                    <a:lnR w="0" cap="flat" cmpd="sng" algn="ctr">
+                      <a:noFill/>
+                    </a:lnR>
+                    <a:lnT w="0" cap="flat" cmpd="sng" algn="ctr">
+                      <a:noFill/>
+                    </a:lnT>
+                    <a:lnB w="9525" cap="flat" cmpd="sng" algn="ctr">
+                      <a:solidFill>
+                        <a:srgbClr val="BFCAD3"/>
+                      </a:solidFill>
+                      <a:prstDash val="solid"/>
+                      <a:round/>
+                      <a:headEnd type="none" w="med" len="med"/>
+                      <a:tailEnd type="none" w="med" len="med"/>
+                    </a:lnB>
+                  </a:tcPr>
+                </a:tc>
+                <a:tc>
+                  <a:txBody>
+                    <a:bodyPr/>
+                    <a:lstStyle/>
+                    <a:p>
+                      <a:pPr indent="0" marL="0">
+                        <a:buNone/>
+                      </a:pPr>
+                      <a:r>
+                        <a:rPr lang="en-US" sz="1150" dirty="0">
                           <a:solidFill>
                             <a:srgbClr val="111C24"/>
                           </a:solidFill>
@@ -2783,44 +2783,44 @@
                         </a:rPr>
                         <a:t>Feedback posted on six: B4, B6, S4, S6, Satin Fitted, SS-S4. The remaining three, Cooling Sheets 4-PC, Bamboo Fitted and Cooling Fitted, are being completed today</a:t>
                       </a:r>
-                      <a:endParaRPr lang="en-US" sz="1200" dirty="0">
-                        <a:latin typeface="Calibri" charset="0"/>
-                        <a:ea typeface="Calibri" charset="0"/>
-                        <a:cs typeface="Calibri" charset="0"/>
-                      </a:endParaRPr>
-                    </a:p>
-                  </a:txBody>
-                  <a:tcPr marL="64008" marR="64008" marT="73152" marB="73152" anchor="ctr">
-                    <a:lnL w="0" cap="flat" cmpd="sng" algn="ctr">
-                      <a:noFill/>
-                    </a:lnL>
-                    <a:lnR w="0" cap="flat" cmpd="sng" algn="ctr">
-                      <a:noFill/>
-                    </a:lnR>
-                    <a:lnT w="0" cap="flat" cmpd="sng" algn="ctr">
-                      <a:noFill/>
-                    </a:lnT>
-                    <a:lnB w="9525" cap="flat" cmpd="sng" algn="ctr">
-                      <a:solidFill>
-                        <a:srgbClr val="BFCAD3"/>
-                      </a:solidFill>
-                      <a:prstDash val="solid"/>
-                      <a:round/>
-                      <a:headEnd type="none" w="med" len="med"/>
-                      <a:tailEnd type="none" w="med" len="med"/>
-                    </a:lnB>
-                  </a:tcPr>
-                </a:tc>
-                <a:tc>
-                  <a:txBody>
-                    <a:bodyPr/>
-                    <a:lstStyle/>
-                    <a:p>
-                      <a:pPr indent="0" marL="0">
-                        <a:buNone/>
-                      </a:pPr>
-                      <a:r>
-                        <a:rPr lang="en-US" sz="1200" b="1" dirty="0">
+                      <a:endParaRPr lang="en-US" sz="1150" dirty="0">
+                        <a:latin typeface="Calibri" charset="0"/>
+                        <a:ea typeface="Calibri" charset="0"/>
+                        <a:cs typeface="Calibri" charset="0"/>
+                      </a:endParaRPr>
+                    </a:p>
+                  </a:txBody>
+                  <a:tcPr marL="64008" marR="64008" marT="73152" marB="73152" anchor="ctr">
+                    <a:lnL w="0" cap="flat" cmpd="sng" algn="ctr">
+                      <a:noFill/>
+                    </a:lnL>
+                    <a:lnR w="0" cap="flat" cmpd="sng" algn="ctr">
+                      <a:noFill/>
+                    </a:lnR>
+                    <a:lnT w="0" cap="flat" cmpd="sng" algn="ctr">
+                      <a:noFill/>
+                    </a:lnT>
+                    <a:lnB w="9525" cap="flat" cmpd="sng" algn="ctr">
+                      <a:solidFill>
+                        <a:srgbClr val="BFCAD3"/>
+                      </a:solidFill>
+                      <a:prstDash val="solid"/>
+                      <a:round/>
+                      <a:headEnd type="none" w="med" len="med"/>
+                      <a:tailEnd type="none" w="med" len="med"/>
+                    </a:lnB>
+                  </a:tcPr>
+                </a:tc>
+                <a:tc>
+                  <a:txBody>
+                    <a:bodyPr/>
+                    <a:lstStyle/>
+                    <a:p>
+                      <a:pPr indent="0" marL="0">
+                        <a:buNone/>
+                      </a:pPr>
+                      <a:r>
+                        <a:rPr lang="en-US" sz="1150" b="1" dirty="0">
                           <a:solidFill>
                             <a:srgbClr val="6E4A0F"/>
                           </a:solidFill>
@@ -2830,7 +2830,7 @@
                         </a:rPr>
                         <a:t>6 of 9 · 3 today</a:t>
                       </a:r>
-                      <a:endParaRPr lang="en-US" sz="1200" dirty="0">
+                      <a:endParaRPr lang="en-US" sz="1150" dirty="0">
                         <a:latin typeface="Calibri" charset="0"/>
                         <a:ea typeface="Calibri" charset="0"/>
                         <a:cs typeface="Calibri" charset="0"/>
@@ -2872,7 +2872,7 @@
                         <a:buNone/>
                       </a:pPr>
                       <a:r>
-                        <a:rPr lang="en-US" sz="1200" b="1" dirty="0">
+                        <a:rPr lang="en-US" sz="1150" b="1" dirty="0">
                           <a:solidFill>
                             <a:srgbClr val="111C24"/>
                           </a:solidFill>
@@ -2882,18 +2882,18 @@
                         </a:rPr>
                         <a:t>Engine corrections &amp; feedback</a:t>
                       </a:r>
-                      <a:endParaRPr lang="en-US" sz="1200" dirty="0">
-                        <a:latin typeface="Calibri" charset="0"/>
-                        <a:ea typeface="Calibri" charset="0"/>
-                        <a:cs typeface="Calibri" charset="0"/>
-                      </a:endParaRPr>
-                    </a:p>
-                    <a:p>
-                      <a:pPr indent="0" marL="0">
-                        <a:buNone/>
-                      </a:pPr>
-                      <a:r>
-                        <a:rPr lang="en-US" sz="1100" dirty="0">
+                      <a:endParaRPr lang="en-US" sz="1150" dirty="0">
+                        <a:latin typeface="Calibri" charset="0"/>
+                        <a:ea typeface="Calibri" charset="0"/>
+                        <a:cs typeface="Calibri" charset="0"/>
+                      </a:endParaRPr>
+                    </a:p>
+                    <a:p>
+                      <a:pPr indent="0" marL="0">
+                        <a:buNone/>
+                      </a:pPr>
+                      <a:r>
+                        <a:rPr lang="en-US" sz="1050" dirty="0">
                           <a:solidFill>
                             <a:srgbClr val="4E5A64"/>
                           </a:solidFill>
@@ -2903,44 +2903,44 @@
                         </a:rPr>
                         <a:t>Joseph with PPC review · P0</a:t>
                       </a:r>
-                      <a:endParaRPr lang="en-US" sz="1200" dirty="0">
-                        <a:latin typeface="Calibri" charset="0"/>
-                        <a:ea typeface="Calibri" charset="0"/>
-                        <a:cs typeface="Calibri" charset="0"/>
-                      </a:endParaRPr>
-                    </a:p>
-                  </a:txBody>
-                  <a:tcPr marL="64008" marR="64008" marT="73152" marB="73152" anchor="ctr">
-                    <a:lnL w="0" cap="flat" cmpd="sng" algn="ctr">
-                      <a:noFill/>
-                    </a:lnL>
-                    <a:lnR w="0" cap="flat" cmpd="sng" algn="ctr">
-                      <a:noFill/>
-                    </a:lnR>
-                    <a:lnT w="0" cap="flat" cmpd="sng" algn="ctr">
-                      <a:noFill/>
-                    </a:lnT>
-                    <a:lnB w="9525" cap="flat" cmpd="sng" algn="ctr">
-                      <a:solidFill>
-                        <a:srgbClr val="BFCAD3"/>
-                      </a:solidFill>
-                      <a:prstDash val="solid"/>
-                      <a:round/>
-                      <a:headEnd type="none" w="med" len="med"/>
-                      <a:tailEnd type="none" w="med" len="med"/>
-                    </a:lnB>
-                  </a:tcPr>
-                </a:tc>
-                <a:tc>
-                  <a:txBody>
-                    <a:bodyPr/>
-                    <a:lstStyle/>
-                    <a:p>
-                      <a:pPr indent="0" marL="0">
-                        <a:buNone/>
-                      </a:pPr>
-                      <a:r>
-                        <a:rPr lang="en-US" sz="1200" dirty="0">
+                      <a:endParaRPr lang="en-US" sz="1150" dirty="0">
+                        <a:latin typeface="Calibri" charset="0"/>
+                        <a:ea typeface="Calibri" charset="0"/>
+                        <a:cs typeface="Calibri" charset="0"/>
+                      </a:endParaRPr>
+                    </a:p>
+                  </a:txBody>
+                  <a:tcPr marL="64008" marR="64008" marT="73152" marB="73152" anchor="ctr">
+                    <a:lnL w="0" cap="flat" cmpd="sng" algn="ctr">
+                      <a:noFill/>
+                    </a:lnL>
+                    <a:lnR w="0" cap="flat" cmpd="sng" algn="ctr">
+                      <a:noFill/>
+                    </a:lnR>
+                    <a:lnT w="0" cap="flat" cmpd="sng" algn="ctr">
+                      <a:noFill/>
+                    </a:lnT>
+                    <a:lnB w="9525" cap="flat" cmpd="sng" algn="ctr">
+                      <a:solidFill>
+                        <a:srgbClr val="BFCAD3"/>
+                      </a:solidFill>
+                      <a:prstDash val="solid"/>
+                      <a:round/>
+                      <a:headEnd type="none" w="med" len="med"/>
+                      <a:tailEnd type="none" w="med" len="med"/>
+                    </a:lnB>
+                  </a:tcPr>
+                </a:tc>
+                <a:tc>
+                  <a:txBody>
+                    <a:bodyPr/>
+                    <a:lstStyle/>
+                    <a:p>
+                      <a:pPr indent="0" marL="0">
+                        <a:buNone/>
+                      </a:pPr>
+                      <a:r>
+                        <a:rPr lang="en-US" sz="1150" dirty="0">
                           <a:solidFill>
                             <a:srgbClr val="111C24"/>
                           </a:solidFill>
@@ -2950,44 +2950,44 @@
                         </a:rPr>
                         <a:t>One consolidated note per product to Joseph, engine fixed and the audits re-run on the corrections</a:t>
                       </a:r>
-                      <a:endParaRPr lang="en-US" sz="1200" dirty="0">
-                        <a:latin typeface="Calibri" charset="0"/>
-                        <a:ea typeface="Calibri" charset="0"/>
-                        <a:cs typeface="Calibri" charset="0"/>
-                      </a:endParaRPr>
-                    </a:p>
-                  </a:txBody>
-                  <a:tcPr marL="64008" marR="64008" marT="73152" marB="73152" anchor="ctr">
-                    <a:lnL w="0" cap="flat" cmpd="sng" algn="ctr">
-                      <a:noFill/>
-                    </a:lnL>
-                    <a:lnR w="0" cap="flat" cmpd="sng" algn="ctr">
-                      <a:noFill/>
-                    </a:lnR>
-                    <a:lnT w="0" cap="flat" cmpd="sng" algn="ctr">
-                      <a:noFill/>
-                    </a:lnT>
-                    <a:lnB w="9525" cap="flat" cmpd="sng" algn="ctr">
-                      <a:solidFill>
-                        <a:srgbClr val="BFCAD3"/>
-                      </a:solidFill>
-                      <a:prstDash val="solid"/>
-                      <a:round/>
-                      <a:headEnd type="none" w="med" len="med"/>
-                      <a:tailEnd type="none" w="med" len="med"/>
-                    </a:lnB>
-                  </a:tcPr>
-                </a:tc>
-                <a:tc>
-                  <a:txBody>
-                    <a:bodyPr/>
-                    <a:lstStyle/>
-                    <a:p>
-                      <a:pPr indent="0" marL="0">
-                        <a:buNone/>
-                      </a:pPr>
-                      <a:r>
-                        <a:rPr lang="en-US" sz="1200" dirty="0">
+                      <a:endParaRPr lang="en-US" sz="1150" dirty="0">
+                        <a:latin typeface="Calibri" charset="0"/>
+                        <a:ea typeface="Calibri" charset="0"/>
+                        <a:cs typeface="Calibri" charset="0"/>
+                      </a:endParaRPr>
+                    </a:p>
+                  </a:txBody>
+                  <a:tcPr marL="64008" marR="64008" marT="73152" marB="73152" anchor="ctr">
+                    <a:lnL w="0" cap="flat" cmpd="sng" algn="ctr">
+                      <a:noFill/>
+                    </a:lnL>
+                    <a:lnR w="0" cap="flat" cmpd="sng" algn="ctr">
+                      <a:noFill/>
+                    </a:lnR>
+                    <a:lnT w="0" cap="flat" cmpd="sng" algn="ctr">
+                      <a:noFill/>
+                    </a:lnT>
+                    <a:lnB w="9525" cap="flat" cmpd="sng" algn="ctr">
+                      <a:solidFill>
+                        <a:srgbClr val="BFCAD3"/>
+                      </a:solidFill>
+                      <a:prstDash val="solid"/>
+                      <a:round/>
+                      <a:headEnd type="none" w="med" len="med"/>
+                      <a:tailEnd type="none" w="med" len="med"/>
+                    </a:lnB>
+                  </a:tcPr>
+                </a:tc>
+                <a:tc>
+                  <a:txBody>
+                    <a:bodyPr/>
+                    <a:lstStyle/>
+                    <a:p>
+                      <a:pPr indent="0" marL="0">
+                        <a:buNone/>
+                      </a:pPr>
+                      <a:r>
+                        <a:rPr lang="en-US" sz="1150" dirty="0">
                           <a:solidFill>
                             <a:srgbClr val="111C24"/>
                           </a:solidFill>
@@ -2997,44 +2997,44 @@
                         </a:rPr>
                         <a:t>B4 and B6 corrections applied and re-audited 29 Sep, the first clean 218/218 pass. Engine feedback doc and issue register delivered by Zarlish today; Shayan T is reviewing them and Zarlish shares them with Joseph next</a:t>
                       </a:r>
-                      <a:endParaRPr lang="en-US" sz="1200" dirty="0">
-                        <a:latin typeface="Calibri" charset="0"/>
-                        <a:ea typeface="Calibri" charset="0"/>
-                        <a:cs typeface="Calibri" charset="0"/>
-                      </a:endParaRPr>
-                    </a:p>
-                  </a:txBody>
-                  <a:tcPr marL="64008" marR="64008" marT="73152" marB="73152" anchor="ctr">
-                    <a:lnL w="0" cap="flat" cmpd="sng" algn="ctr">
-                      <a:noFill/>
-                    </a:lnL>
-                    <a:lnR w="0" cap="flat" cmpd="sng" algn="ctr">
-                      <a:noFill/>
-                    </a:lnR>
-                    <a:lnT w="0" cap="flat" cmpd="sng" algn="ctr">
-                      <a:noFill/>
-                    </a:lnT>
-                    <a:lnB w="9525" cap="flat" cmpd="sng" algn="ctr">
-                      <a:solidFill>
-                        <a:srgbClr val="BFCAD3"/>
-                      </a:solidFill>
-                      <a:prstDash val="solid"/>
-                      <a:round/>
-                      <a:headEnd type="none" w="med" len="med"/>
-                      <a:tailEnd type="none" w="med" len="med"/>
-                    </a:lnB>
-                  </a:tcPr>
-                </a:tc>
-                <a:tc>
-                  <a:txBody>
-                    <a:bodyPr/>
-                    <a:lstStyle/>
-                    <a:p>
-                      <a:pPr indent="0" marL="0">
-                        <a:buNone/>
-                      </a:pPr>
-                      <a:r>
-                        <a:rPr lang="en-US" sz="1200" b="1" dirty="0">
+                      <a:endParaRPr lang="en-US" sz="1150" dirty="0">
+                        <a:latin typeface="Calibri" charset="0"/>
+                        <a:ea typeface="Calibri" charset="0"/>
+                        <a:cs typeface="Calibri" charset="0"/>
+                      </a:endParaRPr>
+                    </a:p>
+                  </a:txBody>
+                  <a:tcPr marL="64008" marR="64008" marT="73152" marB="73152" anchor="ctr">
+                    <a:lnL w="0" cap="flat" cmpd="sng" algn="ctr">
+                      <a:noFill/>
+                    </a:lnL>
+                    <a:lnR w="0" cap="flat" cmpd="sng" algn="ctr">
+                      <a:noFill/>
+                    </a:lnR>
+                    <a:lnT w="0" cap="flat" cmpd="sng" algn="ctr">
+                      <a:noFill/>
+                    </a:lnT>
+                    <a:lnB w="9525" cap="flat" cmpd="sng" algn="ctr">
+                      <a:solidFill>
+                        <a:srgbClr val="BFCAD3"/>
+                      </a:solidFill>
+                      <a:prstDash val="solid"/>
+                      <a:round/>
+                      <a:headEnd type="none" w="med" len="med"/>
+                      <a:tailEnd type="none" w="med" len="med"/>
+                    </a:lnB>
+                  </a:tcPr>
+                </a:tc>
+                <a:tc>
+                  <a:txBody>
+                    <a:bodyPr/>
+                    <a:lstStyle/>
+                    <a:p>
+                      <a:pPr indent="0" marL="0">
+                        <a:buNone/>
+                      </a:pPr>
+                      <a:r>
+                        <a:rPr lang="en-US" sz="1150" b="1" dirty="0">
                           <a:solidFill>
                             <a:srgbClr val="176B41"/>
                           </a:solidFill>
@@ -3044,7 +3044,7 @@
                         </a:rPr>
                         <a:t>Delivered · in review</a:t>
                       </a:r>
-                      <a:endParaRPr lang="en-US" sz="1200" dirty="0">
+                      <a:endParaRPr lang="en-US" sz="1150" dirty="0">
                         <a:latin typeface="Calibri" charset="0"/>
                         <a:ea typeface="Calibri" charset="0"/>
                         <a:cs typeface="Calibri" charset="0"/>
@@ -3086,7 +3086,7 @@
                         <a:buNone/>
                       </a:pPr>
                       <a:r>
-                        <a:rPr lang="en-US" sz="1200" b="1" dirty="0">
+                        <a:rPr lang="en-US" sz="1150" b="1" dirty="0">
                           <a:solidFill>
                             <a:srgbClr val="111C24"/>
                           </a:solidFill>
@@ -3096,18 +3096,18 @@
                         </a:rPr>
                         <a:t>Bamboo ranking push (B4, B6)</a:t>
                       </a:r>
-                      <a:endParaRPr lang="en-US" sz="1200" dirty="0">
-                        <a:latin typeface="Calibri" charset="0"/>
-                        <a:ea typeface="Calibri" charset="0"/>
-                        <a:cs typeface="Calibri" charset="0"/>
-                      </a:endParaRPr>
-                    </a:p>
-                    <a:p>
-                      <a:pPr indent="0" marL="0">
-                        <a:buNone/>
-                      </a:pPr>
-                      <a:r>
-                        <a:rPr lang="en-US" sz="1100" dirty="0">
+                      <a:endParaRPr lang="en-US" sz="1150" dirty="0">
+                        <a:latin typeface="Calibri" charset="0"/>
+                        <a:ea typeface="Calibri" charset="0"/>
+                        <a:cs typeface="Calibri" charset="0"/>
+                      </a:endParaRPr>
+                    </a:p>
+                    <a:p>
+                      <a:pPr indent="0" marL="0">
+                        <a:buNone/>
+                      </a:pPr>
+                      <a:r>
+                        <a:rPr lang="en-US" sz="1050" dirty="0">
                           <a:solidFill>
                             <a:srgbClr val="4E5A64"/>
                           </a:solidFill>
@@ -3117,44 +3117,44 @@
                         </a:rPr>
                         <a:t>Shayan T with Joseph · P0</a:t>
                       </a:r>
-                      <a:endParaRPr lang="en-US" sz="1200" dirty="0">
-                        <a:latin typeface="Calibri" charset="0"/>
-                        <a:ea typeface="Calibri" charset="0"/>
-                        <a:cs typeface="Calibri" charset="0"/>
-                      </a:endParaRPr>
-                    </a:p>
-                  </a:txBody>
-                  <a:tcPr marL="64008" marR="64008" marT="73152" marB="73152" anchor="ctr">
-                    <a:lnL w="0" cap="flat" cmpd="sng" algn="ctr">
-                      <a:noFill/>
-                    </a:lnL>
-                    <a:lnR w="0" cap="flat" cmpd="sng" algn="ctr">
-                      <a:noFill/>
-                    </a:lnR>
-                    <a:lnT w="0" cap="flat" cmpd="sng" algn="ctr">
-                      <a:noFill/>
-                    </a:lnT>
-                    <a:lnB w="9525" cap="flat" cmpd="sng" algn="ctr">
-                      <a:solidFill>
-                        <a:srgbClr val="BFCAD3"/>
-                      </a:solidFill>
-                      <a:prstDash val="solid"/>
-                      <a:round/>
-                      <a:headEnd type="none" w="med" len="med"/>
-                      <a:tailEnd type="none" w="med" len="med"/>
-                    </a:lnB>
-                  </a:tcPr>
-                </a:tc>
-                <a:tc>
-                  <a:txBody>
-                    <a:bodyPr/>
-                    <a:lstStyle/>
-                    <a:p>
-                      <a:pPr indent="0" marL="0">
-                        <a:buNone/>
-                      </a:pPr>
-                      <a:r>
-                        <a:rPr lang="en-US" sz="1200" dirty="0">
+                      <a:endParaRPr lang="en-US" sz="1150" dirty="0">
+                        <a:latin typeface="Calibri" charset="0"/>
+                        <a:ea typeface="Calibri" charset="0"/>
+                        <a:cs typeface="Calibri" charset="0"/>
+                      </a:endParaRPr>
+                    </a:p>
+                  </a:txBody>
+                  <a:tcPr marL="64008" marR="64008" marT="73152" marB="73152" anchor="ctr">
+                    <a:lnL w="0" cap="flat" cmpd="sng" algn="ctr">
+                      <a:noFill/>
+                    </a:lnL>
+                    <a:lnR w="0" cap="flat" cmpd="sng" algn="ctr">
+                      <a:noFill/>
+                    </a:lnR>
+                    <a:lnT w="0" cap="flat" cmpd="sng" algn="ctr">
+                      <a:noFill/>
+                    </a:lnT>
+                    <a:lnB w="9525" cap="flat" cmpd="sng" algn="ctr">
+                      <a:solidFill>
+                        <a:srgbClr val="BFCAD3"/>
+                      </a:solidFill>
+                      <a:prstDash val="solid"/>
+                      <a:round/>
+                      <a:headEnd type="none" w="med" len="med"/>
+                      <a:tailEnd type="none" w="med" len="med"/>
+                    </a:lnB>
+                  </a:tcPr>
+                </a:tc>
+                <a:tc>
+                  <a:txBody>
+                    <a:bodyPr/>
+                    <a:lstStyle/>
+                    <a:p>
+                      <a:pPr indent="0" marL="0">
+                        <a:buNone/>
+                      </a:pPr>
+                      <a:r>
+                        <a:rPr lang="en-US" sz="1150" dirty="0">
                           <a:solidFill>
                             <a:srgbClr val="111C24"/>
                           </a:solidFill>
@@ -3164,44 +3164,44 @@
                         </a:rPr>
                         <a:t>One ranking plan per listing, matched to Joseph's keyword story and plan of attack, before the pushes start</a:t>
                       </a:r>
-                      <a:endParaRPr lang="en-US" sz="1200" dirty="0">
-                        <a:latin typeface="Calibri" charset="0"/>
-                        <a:ea typeface="Calibri" charset="0"/>
-                        <a:cs typeface="Calibri" charset="0"/>
-                      </a:endParaRPr>
-                    </a:p>
-                  </a:txBody>
-                  <a:tcPr marL="64008" marR="64008" marT="73152" marB="73152" anchor="ctr">
-                    <a:lnL w="0" cap="flat" cmpd="sng" algn="ctr">
-                      <a:noFill/>
-                    </a:lnL>
-                    <a:lnR w="0" cap="flat" cmpd="sng" algn="ctr">
-                      <a:noFill/>
-                    </a:lnR>
-                    <a:lnT w="0" cap="flat" cmpd="sng" algn="ctr">
-                      <a:noFill/>
-                    </a:lnT>
-                    <a:lnB w="9525" cap="flat" cmpd="sng" algn="ctr">
-                      <a:solidFill>
-                        <a:srgbClr val="BFCAD3"/>
-                      </a:solidFill>
-                      <a:prstDash val="solid"/>
-                      <a:round/>
-                      <a:headEnd type="none" w="med" len="med"/>
-                      <a:tailEnd type="none" w="med" len="med"/>
-                    </a:lnB>
-                  </a:tcPr>
-                </a:tc>
-                <a:tc>
-                  <a:txBody>
-                    <a:bodyPr/>
-                    <a:lstStyle/>
-                    <a:p>
-                      <a:pPr indent="0" marL="0">
-                        <a:buNone/>
-                      </a:pPr>
-                      <a:r>
-                        <a:rPr lang="en-US" sz="1200" dirty="0">
+                      <a:endParaRPr lang="en-US" sz="1150" dirty="0">
+                        <a:latin typeface="Calibri" charset="0"/>
+                        <a:ea typeface="Calibri" charset="0"/>
+                        <a:cs typeface="Calibri" charset="0"/>
+                      </a:endParaRPr>
+                    </a:p>
+                  </a:txBody>
+                  <a:tcPr marL="64008" marR="64008" marT="73152" marB="73152" anchor="ctr">
+                    <a:lnL w="0" cap="flat" cmpd="sng" algn="ctr">
+                      <a:noFill/>
+                    </a:lnL>
+                    <a:lnR w="0" cap="flat" cmpd="sng" algn="ctr">
+                      <a:noFill/>
+                    </a:lnR>
+                    <a:lnT w="0" cap="flat" cmpd="sng" algn="ctr">
+                      <a:noFill/>
+                    </a:lnT>
+                    <a:lnB w="9525" cap="flat" cmpd="sng" algn="ctr">
+                      <a:solidFill>
+                        <a:srgbClr val="BFCAD3"/>
+                      </a:solidFill>
+                      <a:prstDash val="solid"/>
+                      <a:round/>
+                      <a:headEnd type="none" w="med" len="med"/>
+                      <a:tailEnd type="none" w="med" len="med"/>
+                    </a:lnB>
+                  </a:tcPr>
+                </a:tc>
+                <a:tc>
+                  <a:txBody>
+                    <a:bodyPr/>
+                    <a:lstStyle/>
+                    <a:p>
+                      <a:pPr indent="0" marL="0">
+                        <a:buNone/>
+                      </a:pPr>
+                      <a:r>
+                        <a:rPr lang="en-US" sz="1150" dirty="0">
                           <a:solidFill>
                             <a:srgbClr val="111C24"/>
                           </a:solidFill>
@@ -3211,44 +3211,44 @@
                         </a:rPr>
                         <a:t>Plan of attack shared 1 Oct. B4 and B6 plans finalised 2 Oct: B4 follows its start dates and colours by size; B6 replaces the 30 Sep plan. Erik's 2 Oct points built in</a:t>
                       </a:r>
-                      <a:endParaRPr lang="en-US" sz="1200" dirty="0">
-                        <a:latin typeface="Calibri" charset="0"/>
-                        <a:ea typeface="Calibri" charset="0"/>
-                        <a:cs typeface="Calibri" charset="0"/>
-                      </a:endParaRPr>
-                    </a:p>
-                  </a:txBody>
-                  <a:tcPr marL="64008" marR="64008" marT="73152" marB="73152" anchor="ctr">
-                    <a:lnL w="0" cap="flat" cmpd="sng" algn="ctr">
-                      <a:noFill/>
-                    </a:lnL>
-                    <a:lnR w="0" cap="flat" cmpd="sng" algn="ctr">
-                      <a:noFill/>
-                    </a:lnR>
-                    <a:lnT w="0" cap="flat" cmpd="sng" algn="ctr">
-                      <a:noFill/>
-                    </a:lnT>
-                    <a:lnB w="9525" cap="flat" cmpd="sng" algn="ctr">
-                      <a:solidFill>
-                        <a:srgbClr val="BFCAD3"/>
-                      </a:solidFill>
-                      <a:prstDash val="solid"/>
-                      <a:round/>
-                      <a:headEnd type="none" w="med" len="med"/>
-                      <a:tailEnd type="none" w="med" len="med"/>
-                    </a:lnB>
-                  </a:tcPr>
-                </a:tc>
-                <a:tc>
-                  <a:txBody>
-                    <a:bodyPr/>
-                    <a:lstStyle/>
-                    <a:p>
-                      <a:pPr indent="0" marL="0">
-                        <a:buNone/>
-                      </a:pPr>
-                      <a:r>
-                        <a:rPr lang="en-US" sz="1200" b="1" dirty="0">
+                      <a:endParaRPr lang="en-US" sz="1150" dirty="0">
+                        <a:latin typeface="Calibri" charset="0"/>
+                        <a:ea typeface="Calibri" charset="0"/>
+                        <a:cs typeface="Calibri" charset="0"/>
+                      </a:endParaRPr>
+                    </a:p>
+                  </a:txBody>
+                  <a:tcPr marL="64008" marR="64008" marT="73152" marB="73152" anchor="ctr">
+                    <a:lnL w="0" cap="flat" cmpd="sng" algn="ctr">
+                      <a:noFill/>
+                    </a:lnL>
+                    <a:lnR w="0" cap="flat" cmpd="sng" algn="ctr">
+                      <a:noFill/>
+                    </a:lnR>
+                    <a:lnT w="0" cap="flat" cmpd="sng" algn="ctr">
+                      <a:noFill/>
+                    </a:lnT>
+                    <a:lnB w="9525" cap="flat" cmpd="sng" algn="ctr">
+                      <a:solidFill>
+                        <a:srgbClr val="BFCAD3"/>
+                      </a:solidFill>
+                      <a:prstDash val="solid"/>
+                      <a:round/>
+                      <a:headEnd type="none" w="med" len="med"/>
+                      <a:tailEnd type="none" w="med" len="med"/>
+                    </a:lnB>
+                  </a:tcPr>
+                </a:tc>
+                <a:tc>
+                  <a:txBody>
+                    <a:bodyPr/>
+                    <a:lstStyle/>
+                    <a:p>
+                      <a:pPr indent="0" marL="0">
+                        <a:buNone/>
+                      </a:pPr>
+                      <a:r>
+                        <a:rPr lang="en-US" sz="1150" b="1" dirty="0">
                           <a:solidFill>
                             <a:srgbClr val="176B41"/>
                           </a:solidFill>
@@ -3258,7 +3258,7 @@
                         </a:rPr>
                         <a:t>Plans final</a:t>
                       </a:r>
-                      <a:endParaRPr lang="en-US" sz="1200" dirty="0">
+                      <a:endParaRPr lang="en-US" sz="1150" dirty="0">
                         <a:latin typeface="Calibri" charset="0"/>
                         <a:ea typeface="Calibri" charset="0"/>
                         <a:cs typeface="Calibri" charset="0"/>
@@ -3300,7 +3300,7 @@
                         <a:buNone/>
                       </a:pPr>
                       <a:r>
-                        <a:rPr lang="en-US" sz="1200" b="1" dirty="0">
+                        <a:rPr lang="en-US" sz="1150" b="1" dirty="0">
                           <a:solidFill>
                             <a:srgbClr val="111C24"/>
                           </a:solidFill>
@@ -3310,18 +3310,18 @@
                         </a:rPr>
                         <a:t>Process deliverables</a:t>
                       </a:r>
-                      <a:endParaRPr lang="en-US" sz="1200" dirty="0">
-                        <a:latin typeface="Calibri" charset="0"/>
-                        <a:ea typeface="Calibri" charset="0"/>
-                        <a:cs typeface="Calibri" charset="0"/>
-                      </a:endParaRPr>
-                    </a:p>
-                    <a:p>
-                      <a:pPr indent="0" marL="0">
-                        <a:buNone/>
-                      </a:pPr>
-                      <a:r>
-                        <a:rPr lang="en-US" sz="1100" dirty="0">
+                      <a:endParaRPr lang="en-US" sz="1150" dirty="0">
+                        <a:latin typeface="Calibri" charset="0"/>
+                        <a:ea typeface="Calibri" charset="0"/>
+                        <a:cs typeface="Calibri" charset="0"/>
+                      </a:endParaRPr>
+                    </a:p>
+                    <a:p>
+                      <a:pPr indent="0" marL="0">
+                        <a:buNone/>
+                      </a:pPr>
+                      <a:r>
+                        <a:rPr lang="en-US" sz="1050" dirty="0">
                           <a:solidFill>
                             <a:srgbClr val="4E5A64"/>
                           </a:solidFill>
@@ -3331,44 +3331,44 @@
                         </a:rPr>
                         <a:t>Shayan T · one-off · P0</a:t>
                       </a:r>
-                      <a:endParaRPr lang="en-US" sz="1200" dirty="0">
-                        <a:latin typeface="Calibri" charset="0"/>
-                        <a:ea typeface="Calibri" charset="0"/>
-                        <a:cs typeface="Calibri" charset="0"/>
-                      </a:endParaRPr>
-                    </a:p>
-                  </a:txBody>
-                  <a:tcPr marL="64008" marR="64008" marT="73152" marB="73152" anchor="ctr">
-                    <a:lnL w="0" cap="flat" cmpd="sng" algn="ctr">
-                      <a:noFill/>
-                    </a:lnL>
-                    <a:lnR w="0" cap="flat" cmpd="sng" algn="ctr">
-                      <a:noFill/>
-                    </a:lnR>
-                    <a:lnT w="0" cap="flat" cmpd="sng" algn="ctr">
-                      <a:noFill/>
-                    </a:lnT>
-                    <a:lnB w="9525" cap="flat" cmpd="sng" algn="ctr">
-                      <a:solidFill>
-                        <a:srgbClr val="BFCAD3"/>
-                      </a:solidFill>
-                      <a:prstDash val="solid"/>
-                      <a:round/>
-                      <a:headEnd type="none" w="med" len="med"/>
-                      <a:tailEnd type="none" w="med" len="med"/>
-                    </a:lnB>
-                  </a:tcPr>
-                </a:tc>
-                <a:tc>
-                  <a:txBody>
-                    <a:bodyPr/>
-                    <a:lstStyle/>
-                    <a:p>
-                      <a:pPr indent="0" marL="0">
-                        <a:buNone/>
-                      </a:pPr>
-                      <a:r>
-                        <a:rPr lang="en-US" sz="1200" dirty="0">
+                      <a:endParaRPr lang="en-US" sz="1150" dirty="0">
+                        <a:latin typeface="Calibri" charset="0"/>
+                        <a:ea typeface="Calibri" charset="0"/>
+                        <a:cs typeface="Calibri" charset="0"/>
+                      </a:endParaRPr>
+                    </a:p>
+                  </a:txBody>
+                  <a:tcPr marL="64008" marR="64008" marT="73152" marB="73152" anchor="ctr">
+                    <a:lnL w="0" cap="flat" cmpd="sng" algn="ctr">
+                      <a:noFill/>
+                    </a:lnL>
+                    <a:lnR w="0" cap="flat" cmpd="sng" algn="ctr">
+                      <a:noFill/>
+                    </a:lnR>
+                    <a:lnT w="0" cap="flat" cmpd="sng" algn="ctr">
+                      <a:noFill/>
+                    </a:lnT>
+                    <a:lnB w="9525" cap="flat" cmpd="sng" algn="ctr">
+                      <a:solidFill>
+                        <a:srgbClr val="BFCAD3"/>
+                      </a:solidFill>
+                      <a:prstDash val="solid"/>
+                      <a:round/>
+                      <a:headEnd type="none" w="med" len="med"/>
+                      <a:tailEnd type="none" w="med" len="med"/>
+                    </a:lnB>
+                  </a:tcPr>
+                </a:tc>
+                <a:tc>
+                  <a:txBody>
+                    <a:bodyPr/>
+                    <a:lstStyle/>
+                    <a:p>
+                      <a:pPr indent="0" marL="0">
+                        <a:buNone/>
+                      </a:pPr>
+                      <a:r>
+                        <a:rPr lang="en-US" sz="1150" dirty="0">
                           <a:solidFill>
                             <a:srgbClr val="111C24"/>
                           </a:solidFill>
@@ -3378,44 +3378,44 @@
                         </a:rPr>
                         <a:t>Campaign-type list Wednesday, ad-type framework Friday, stabilisation proposal by end of week. Re-set on the 30 Sep call: ranking plan first, the rest by end of week</a:t>
                       </a:r>
-                      <a:endParaRPr lang="en-US" sz="1200" dirty="0">
-                        <a:latin typeface="Calibri" charset="0"/>
-                        <a:ea typeface="Calibri" charset="0"/>
-                        <a:cs typeface="Calibri" charset="0"/>
-                      </a:endParaRPr>
-                    </a:p>
-                  </a:txBody>
-                  <a:tcPr marL="64008" marR="64008" marT="73152" marB="73152" anchor="ctr">
-                    <a:lnL w="0" cap="flat" cmpd="sng" algn="ctr">
-                      <a:noFill/>
-                    </a:lnL>
-                    <a:lnR w="0" cap="flat" cmpd="sng" algn="ctr">
-                      <a:noFill/>
-                    </a:lnR>
-                    <a:lnT w="0" cap="flat" cmpd="sng" algn="ctr">
-                      <a:noFill/>
-                    </a:lnT>
-                    <a:lnB w="9525" cap="flat" cmpd="sng" algn="ctr">
-                      <a:solidFill>
-                        <a:srgbClr val="BFCAD3"/>
-                      </a:solidFill>
-                      <a:prstDash val="solid"/>
-                      <a:round/>
-                      <a:headEnd type="none" w="med" len="med"/>
-                      <a:tailEnd type="none" w="med" len="med"/>
-                    </a:lnB>
-                  </a:tcPr>
-                </a:tc>
-                <a:tc>
-                  <a:txBody>
-                    <a:bodyPr/>
-                    <a:lstStyle/>
-                    <a:p>
-                      <a:pPr indent="0" marL="0">
-                        <a:buNone/>
-                      </a:pPr>
-                      <a:r>
-                        <a:rPr lang="en-US" sz="1200" dirty="0">
+                      <a:endParaRPr lang="en-US" sz="1150" dirty="0">
+                        <a:latin typeface="Calibri" charset="0"/>
+                        <a:ea typeface="Calibri" charset="0"/>
+                        <a:cs typeface="Calibri" charset="0"/>
+                      </a:endParaRPr>
+                    </a:p>
+                  </a:txBody>
+                  <a:tcPr marL="64008" marR="64008" marT="73152" marB="73152" anchor="ctr">
+                    <a:lnL w="0" cap="flat" cmpd="sng" algn="ctr">
+                      <a:noFill/>
+                    </a:lnL>
+                    <a:lnR w="0" cap="flat" cmpd="sng" algn="ctr">
+                      <a:noFill/>
+                    </a:lnR>
+                    <a:lnT w="0" cap="flat" cmpd="sng" algn="ctr">
+                      <a:noFill/>
+                    </a:lnT>
+                    <a:lnB w="9525" cap="flat" cmpd="sng" algn="ctr">
+                      <a:solidFill>
+                        <a:srgbClr val="BFCAD3"/>
+                      </a:solidFill>
+                      <a:prstDash val="solid"/>
+                      <a:round/>
+                      <a:headEnd type="none" w="med" len="med"/>
+                      <a:tailEnd type="none" w="med" len="med"/>
+                    </a:lnB>
+                  </a:tcPr>
+                </a:tc>
+                <a:tc>
+                  <a:txBody>
+                    <a:bodyPr/>
+                    <a:lstStyle/>
+                    <a:p>
+                      <a:pPr indent="0" marL="0">
+                        <a:buNone/>
+                      </a:pPr>
+                      <a:r>
+                        <a:rPr lang="en-US" sz="1150" dirty="0">
                           <a:solidFill>
                             <a:srgbClr val="111C24"/>
                           </a:solidFill>
@@ -3425,44 +3425,44 @@
                         </a:rPr>
                         <a:t>Ranking plan sent 1 Oct as agreed. Campaign-type list, ad-type plan (Bamboo first), frameworks and stabilisation proposal due end of week, 3–4 Oct. SB, SBV and SD held for creative, so the 1 Oct API launch did not happen</a:t>
                       </a:r>
-                      <a:endParaRPr lang="en-US" sz="1200" dirty="0">
-                        <a:latin typeface="Calibri" charset="0"/>
-                        <a:ea typeface="Calibri" charset="0"/>
-                        <a:cs typeface="Calibri" charset="0"/>
-                      </a:endParaRPr>
-                    </a:p>
-                  </a:txBody>
-                  <a:tcPr marL="64008" marR="64008" marT="73152" marB="73152" anchor="ctr">
-                    <a:lnL w="0" cap="flat" cmpd="sng" algn="ctr">
-                      <a:noFill/>
-                    </a:lnL>
-                    <a:lnR w="0" cap="flat" cmpd="sng" algn="ctr">
-                      <a:noFill/>
-                    </a:lnR>
-                    <a:lnT w="0" cap="flat" cmpd="sng" algn="ctr">
-                      <a:noFill/>
-                    </a:lnT>
-                    <a:lnB w="9525" cap="flat" cmpd="sng" algn="ctr">
-                      <a:solidFill>
-                        <a:srgbClr val="BFCAD3"/>
-                      </a:solidFill>
-                      <a:prstDash val="solid"/>
-                      <a:round/>
-                      <a:headEnd type="none" w="med" len="med"/>
-                      <a:tailEnd type="none" w="med" len="med"/>
-                    </a:lnB>
-                  </a:tcPr>
-                </a:tc>
-                <a:tc>
-                  <a:txBody>
-                    <a:bodyPr/>
-                    <a:lstStyle/>
-                    <a:p>
-                      <a:pPr indent="0" marL="0">
-                        <a:buNone/>
-                      </a:pPr>
-                      <a:r>
-                        <a:rPr lang="en-US" sz="1200" b="1" dirty="0">
+                      <a:endParaRPr lang="en-US" sz="1150" dirty="0">
+                        <a:latin typeface="Calibri" charset="0"/>
+                        <a:ea typeface="Calibri" charset="0"/>
+                        <a:cs typeface="Calibri" charset="0"/>
+                      </a:endParaRPr>
+                    </a:p>
+                  </a:txBody>
+                  <a:tcPr marL="64008" marR="64008" marT="73152" marB="73152" anchor="ctr">
+                    <a:lnL w="0" cap="flat" cmpd="sng" algn="ctr">
+                      <a:noFill/>
+                    </a:lnL>
+                    <a:lnR w="0" cap="flat" cmpd="sng" algn="ctr">
+                      <a:noFill/>
+                    </a:lnR>
+                    <a:lnT w="0" cap="flat" cmpd="sng" algn="ctr">
+                      <a:noFill/>
+                    </a:lnT>
+                    <a:lnB w="9525" cap="flat" cmpd="sng" algn="ctr">
+                      <a:solidFill>
+                        <a:srgbClr val="BFCAD3"/>
+                      </a:solidFill>
+                      <a:prstDash val="solid"/>
+                      <a:round/>
+                      <a:headEnd type="none" w="med" len="med"/>
+                      <a:tailEnd type="none" w="med" len="med"/>
+                    </a:lnB>
+                  </a:tcPr>
+                </a:tc>
+                <a:tc>
+                  <a:txBody>
+                    <a:bodyPr/>
+                    <a:lstStyle/>
+                    <a:p>
+                      <a:pPr indent="0" marL="0">
+                        <a:buNone/>
+                      </a:pPr>
+                      <a:r>
+                        <a:rPr lang="en-US" sz="1150" b="1" dirty="0">
                           <a:solidFill>
                             <a:srgbClr val="6E4A0F"/>
                           </a:solidFill>
@@ -3472,7 +3472,7 @@
                         </a:rPr>
                         <a:t>Due end of week</a:t>
                       </a:r>
-                      <a:endParaRPr lang="en-US" sz="1200" dirty="0">
+                      <a:endParaRPr lang="en-US" sz="1150" dirty="0">
                         <a:latin typeface="Calibri" charset="0"/>
                         <a:ea typeface="Calibri" charset="0"/>
                         <a:cs typeface="Calibri" charset="0"/>
@@ -3514,7 +3514,7 @@
                         <a:buNone/>
                       </a:pPr>
                       <a:r>
-                        <a:rPr lang="en-US" sz="1200" b="1" dirty="0">
+                        <a:rPr lang="en-US" sz="1150" b="1" dirty="0">
                           <a:solidFill>
                             <a:srgbClr val="111C24"/>
                           </a:solidFill>
@@ -3522,20 +3522,234 @@
                           <a:ea typeface="Calibri" pitchFamily="34" charset="-122"/>
                           <a:cs typeface="Calibri" pitchFamily="34" charset="-120"/>
                         </a:rPr>
+                        <a:t>LTSF products</a:t>
+                      </a:r>
+                      <a:endParaRPr lang="en-US" sz="1150" dirty="0">
+                        <a:latin typeface="Calibri" charset="0"/>
+                        <a:ea typeface="Calibri" charset="0"/>
+                        <a:cs typeface="Calibri" charset="0"/>
+                      </a:endParaRPr>
+                    </a:p>
+                    <a:p>
+                      <a:pPr indent="0" marL="0">
+                        <a:buNone/>
+                      </a:pPr>
+                      <a:r>
+                        <a:rPr lang="en-US" sz="1050" dirty="0">
+                          <a:solidFill>
+                            <a:srgbClr val="4E5A64"/>
+                          </a:solidFill>
+                          <a:latin typeface="Calibri" pitchFamily="34" charset="0"/>
+                          <a:ea typeface="Calibri" pitchFamily="34" charset="-122"/>
+                          <a:cs typeface="Calibri" pitchFamily="34" charset="-120"/>
+                        </a:rPr>
+                        <a:t>Zarlish · ongoing · P1</a:t>
+                      </a:r>
+                      <a:endParaRPr lang="en-US" sz="1150" dirty="0">
+                        <a:latin typeface="Calibri" charset="0"/>
+                        <a:ea typeface="Calibri" charset="0"/>
+                        <a:cs typeface="Calibri" charset="0"/>
+                      </a:endParaRPr>
+                    </a:p>
+                  </a:txBody>
+                  <a:tcPr marL="64008" marR="64008" marT="73152" marB="73152" anchor="ctr">
+                    <a:lnL w="0" cap="flat" cmpd="sng" algn="ctr">
+                      <a:noFill/>
+                    </a:lnL>
+                    <a:lnR w="0" cap="flat" cmpd="sng" algn="ctr">
+                      <a:noFill/>
+                    </a:lnR>
+                    <a:lnT w="0" cap="flat" cmpd="sng" algn="ctr">
+                      <a:noFill/>
+                    </a:lnT>
+                    <a:lnB w="9525" cap="flat" cmpd="sng" algn="ctr">
+                      <a:solidFill>
+                        <a:srgbClr val="BFCAD3"/>
+                      </a:solidFill>
+                      <a:prstDash val="solid"/>
+                      <a:round/>
+                      <a:headEnd type="none" w="med" len="med"/>
+                      <a:tailEnd type="none" w="med" len="med"/>
+                    </a:lnB>
+                  </a:tcPr>
+                </a:tc>
+                <a:tc>
+                  <a:txBody>
+                    <a:bodyPr/>
+                    <a:lstStyle/>
+                    <a:p>
+                      <a:pPr indent="0" marL="0">
+                        <a:buNone/>
+                      </a:pPr>
+                      <a:r>
+                        <a:rPr lang="en-US" sz="1150" dirty="0">
+                          <a:solidFill>
+                            <a:srgbClr val="111C24"/>
+                          </a:solidFill>
+                          <a:latin typeface="Calibri" pitchFamily="34" charset="0"/>
+                          <a:ea typeface="Calibri" pitchFamily="34" charset="-122"/>
+                          <a:cs typeface="Calibri" pitchFamily="34" charset="-120"/>
+                        </a:rPr>
+                        <a:t>Per-SKU PPC actions on the products carrying long-term storage fees, alongside the audit cycle</a:t>
+                      </a:r>
+                      <a:endParaRPr lang="en-US" sz="1150" dirty="0">
+                        <a:latin typeface="Calibri" charset="0"/>
+                        <a:ea typeface="Calibri" charset="0"/>
+                        <a:cs typeface="Calibri" charset="0"/>
+                      </a:endParaRPr>
+                    </a:p>
+                  </a:txBody>
+                  <a:tcPr marL="64008" marR="64008" marT="73152" marB="73152" anchor="ctr">
+                    <a:lnL w="0" cap="flat" cmpd="sng" algn="ctr">
+                      <a:noFill/>
+                    </a:lnL>
+                    <a:lnR w="0" cap="flat" cmpd="sng" algn="ctr">
+                      <a:noFill/>
+                    </a:lnR>
+                    <a:lnT w="0" cap="flat" cmpd="sng" algn="ctr">
+                      <a:noFill/>
+                    </a:lnT>
+                    <a:lnB w="9525" cap="flat" cmpd="sng" algn="ctr">
+                      <a:solidFill>
+                        <a:srgbClr val="BFCAD3"/>
+                      </a:solidFill>
+                      <a:prstDash val="solid"/>
+                      <a:round/>
+                      <a:headEnd type="none" w="med" len="med"/>
+                      <a:tailEnd type="none" w="med" len="med"/>
+                    </a:lnB>
+                  </a:tcPr>
+                </a:tc>
+                <a:tc>
+                  <a:txBody>
+                    <a:bodyPr/>
+                    <a:lstStyle/>
+                    <a:p>
+                      <a:pPr indent="0" marL="0">
+                        <a:buNone/>
+                      </a:pPr>
+                      <a:r>
+                        <a:rPr lang="en-US" sz="1150" dirty="0">
+                          <a:solidFill>
+                            <a:srgbClr val="111C24"/>
+                          </a:solidFill>
+                          <a:latin typeface="Calibri" pitchFamily="34" charset="0"/>
+                          <a:ea typeface="Calibri" pitchFamily="34" charset="-122"/>
+                          <a:cs typeface="Calibri" pitchFamily="34" charset="-120"/>
+                        </a:rPr>
+                        <a:t>LTSF update sent to Erik on 30 Sep, alongside the S6 review and the engine feedback</a:t>
+                      </a:r>
+                      <a:endParaRPr lang="en-US" sz="1150" dirty="0">
+                        <a:latin typeface="Calibri" charset="0"/>
+                        <a:ea typeface="Calibri" charset="0"/>
+                        <a:cs typeface="Calibri" charset="0"/>
+                      </a:endParaRPr>
+                    </a:p>
+                  </a:txBody>
+                  <a:tcPr marL="64008" marR="64008" marT="73152" marB="73152" anchor="ctr">
+                    <a:lnL w="0" cap="flat" cmpd="sng" algn="ctr">
+                      <a:noFill/>
+                    </a:lnL>
+                    <a:lnR w="0" cap="flat" cmpd="sng" algn="ctr">
+                      <a:noFill/>
+                    </a:lnR>
+                    <a:lnT w="0" cap="flat" cmpd="sng" algn="ctr">
+                      <a:noFill/>
+                    </a:lnT>
+                    <a:lnB w="9525" cap="flat" cmpd="sng" algn="ctr">
+                      <a:solidFill>
+                        <a:srgbClr val="BFCAD3"/>
+                      </a:solidFill>
+                      <a:prstDash val="solid"/>
+                      <a:round/>
+                      <a:headEnd type="none" w="med" len="med"/>
+                      <a:tailEnd type="none" w="med" len="med"/>
+                    </a:lnB>
+                  </a:tcPr>
+                </a:tc>
+                <a:tc>
+                  <a:txBody>
+                    <a:bodyPr/>
+                    <a:lstStyle/>
+                    <a:p>
+                      <a:pPr indent="0" marL="0">
+                        <a:buNone/>
+                      </a:pPr>
+                      <a:r>
+                        <a:rPr lang="en-US" sz="1150" b="1" dirty="0">
+                          <a:solidFill>
+                            <a:srgbClr val="176B41"/>
+                          </a:solidFill>
+                          <a:latin typeface="Calibri" pitchFamily="34" charset="0"/>
+                          <a:ea typeface="Calibri" pitchFamily="34" charset="-122"/>
+                          <a:cs typeface="Calibri" pitchFamily="34" charset="-120"/>
+                        </a:rPr>
+                        <a:t>Update sent</a:t>
+                      </a:r>
+                      <a:endParaRPr lang="en-US" sz="1150" dirty="0">
+                        <a:latin typeface="Calibri" charset="0"/>
+                        <a:ea typeface="Calibri" charset="0"/>
+                        <a:cs typeface="Calibri" charset="0"/>
+                      </a:endParaRPr>
+                    </a:p>
+                  </a:txBody>
+                  <a:tcPr marL="64008" marR="64008" marT="73152" marB="73152" anchor="ctr">
+                    <a:lnL w="0" cap="flat" cmpd="sng" algn="ctr">
+                      <a:noFill/>
+                    </a:lnL>
+                    <a:lnR w="0" cap="flat" cmpd="sng" algn="ctr">
+                      <a:noFill/>
+                    </a:lnR>
+                    <a:lnT w="0" cap="flat" cmpd="sng" algn="ctr">
+                      <a:noFill/>
+                    </a:lnT>
+                    <a:lnB w="9525" cap="flat" cmpd="sng" algn="ctr">
+                      <a:solidFill>
+                        <a:srgbClr val="BFCAD3"/>
+                      </a:solidFill>
+                      <a:prstDash val="solid"/>
+                      <a:round/>
+                      <a:headEnd type="none" w="med" len="med"/>
+                      <a:tailEnd type="none" w="med" len="med"/>
+                    </a:lnB>
+                    <a:solidFill>
+                      <a:srgbClr val="E6F4EC"/>
+                    </a:solidFill>
+                  </a:tcPr>
+                </a:tc>
+              </a:tr>
+              <a:tr h="0">
+                <a:tc>
+                  <a:txBody>
+                    <a:bodyPr/>
+                    <a:lstStyle/>
+                    <a:p>
+                      <a:pPr indent="0" marL="0">
+                        <a:buNone/>
+                      </a:pPr>
+                      <a:r>
+                        <a:rPr lang="en-US" sz="1150" b="1" dirty="0">
+                          <a:solidFill>
+                            <a:srgbClr val="111C24"/>
+                          </a:solidFill>
+                          <a:latin typeface="Calibri" pitchFamily="34" charset="0"/>
+                          <a:ea typeface="Calibri" pitchFamily="34" charset="-122"/>
+                          <a:cs typeface="Calibri" pitchFamily="34" charset="-120"/>
+                        </a:rPr>
                         <a:t>CooLinens Pillowcase launch</a:t>
                       </a:r>
-                      <a:endParaRPr lang="en-US" sz="1200" dirty="0">
-                        <a:latin typeface="Calibri" charset="0"/>
-                        <a:ea typeface="Calibri" charset="0"/>
-                        <a:cs typeface="Calibri" charset="0"/>
-                      </a:endParaRPr>
-                    </a:p>
-                    <a:p>
-                      <a:pPr indent="0" marL="0">
-                        <a:buNone/>
-                      </a:pPr>
-                      <a:r>
-                        <a:rPr lang="en-US" sz="1100" dirty="0">
+                      <a:endParaRPr lang="en-US" sz="1150" dirty="0">
+                        <a:latin typeface="Calibri" charset="0"/>
+                        <a:ea typeface="Calibri" charset="0"/>
+                        <a:cs typeface="Calibri" charset="0"/>
+                      </a:endParaRPr>
+                    </a:p>
+                    <a:p>
+                      <a:pPr indent="0" marL="0">
+                        <a:buNone/>
+                      </a:pPr>
+                      <a:r>
+                        <a:rPr lang="en-US" sz="1050" dirty="0">
                           <a:solidFill>
                             <a:srgbClr val="4E5A64"/>
                           </a:solidFill>
@@ -3545,44 +3759,44 @@
                         </a:rPr>
                         <a:t>Shayan T with Zarlish · one-off · P0</a:t>
                       </a:r>
-                      <a:endParaRPr lang="en-US" sz="1200" dirty="0">
-                        <a:latin typeface="Calibri" charset="0"/>
-                        <a:ea typeface="Calibri" charset="0"/>
-                        <a:cs typeface="Calibri" charset="0"/>
-                      </a:endParaRPr>
-                    </a:p>
-                  </a:txBody>
-                  <a:tcPr marL="64008" marR="64008" marT="73152" marB="73152" anchor="ctr">
-                    <a:lnL w="0" cap="flat" cmpd="sng" algn="ctr">
-                      <a:noFill/>
-                    </a:lnL>
-                    <a:lnR w="0" cap="flat" cmpd="sng" algn="ctr">
-                      <a:noFill/>
-                    </a:lnR>
-                    <a:lnT w="0" cap="flat" cmpd="sng" algn="ctr">
-                      <a:noFill/>
-                    </a:lnT>
-                    <a:lnB w="9525" cap="flat" cmpd="sng" algn="ctr">
-                      <a:solidFill>
-                        <a:srgbClr val="BFCAD3"/>
-                      </a:solidFill>
-                      <a:prstDash val="solid"/>
-                      <a:round/>
-                      <a:headEnd type="none" w="med" len="med"/>
-                      <a:tailEnd type="none" w="med" len="med"/>
-                    </a:lnB>
-                  </a:tcPr>
-                </a:tc>
-                <a:tc>
-                  <a:txBody>
-                    <a:bodyPr/>
-                    <a:lstStyle/>
-                    <a:p>
-                      <a:pPr indent="0" marL="0">
-                        <a:buNone/>
-                      </a:pPr>
-                      <a:r>
-                        <a:rPr lang="en-US" sz="1200" dirty="0">
+                      <a:endParaRPr lang="en-US" sz="1150" dirty="0">
+                        <a:latin typeface="Calibri" charset="0"/>
+                        <a:ea typeface="Calibri" charset="0"/>
+                        <a:cs typeface="Calibri" charset="0"/>
+                      </a:endParaRPr>
+                    </a:p>
+                  </a:txBody>
+                  <a:tcPr marL="64008" marR="64008" marT="73152" marB="73152" anchor="ctr">
+                    <a:lnL w="0" cap="flat" cmpd="sng" algn="ctr">
+                      <a:noFill/>
+                    </a:lnL>
+                    <a:lnR w="0" cap="flat" cmpd="sng" algn="ctr">
+                      <a:noFill/>
+                    </a:lnR>
+                    <a:lnT w="0" cap="flat" cmpd="sng" algn="ctr">
+                      <a:noFill/>
+                    </a:lnT>
+                    <a:lnB w="9525" cap="flat" cmpd="sng" algn="ctr">
+                      <a:solidFill>
+                        <a:srgbClr val="BFCAD3"/>
+                      </a:solidFill>
+                      <a:prstDash val="solid"/>
+                      <a:round/>
+                      <a:headEnd type="none" w="med" len="med"/>
+                      <a:tailEnd type="none" w="med" len="med"/>
+                    </a:lnB>
+                  </a:tcPr>
+                </a:tc>
+                <a:tc>
+                  <a:txBody>
+                    <a:bodyPr/>
+                    <a:lstStyle/>
+                    <a:p>
+                      <a:pPr indent="0" marL="0">
+                        <a:buNone/>
+                      </a:pPr>
+                      <a:r>
+                        <a:rPr lang="en-US" sz="1150" dirty="0">
                           <a:solidFill>
                             <a:srgbClr val="111C24"/>
                           </a:solidFill>
@@ -3592,44 +3806,44 @@
                         </a:rPr>
                         <a:t>PPC launch strategy delivered Monday 28 Sep, campaigns live with the listing</a:t>
                       </a:r>
-                      <a:endParaRPr lang="en-US" sz="1200" dirty="0">
-                        <a:latin typeface="Calibri" charset="0"/>
-                        <a:ea typeface="Calibri" charset="0"/>
-                        <a:cs typeface="Calibri" charset="0"/>
-                      </a:endParaRPr>
-                    </a:p>
-                  </a:txBody>
-                  <a:tcPr marL="64008" marR="64008" marT="73152" marB="73152" anchor="ctr">
-                    <a:lnL w="0" cap="flat" cmpd="sng" algn="ctr">
-                      <a:noFill/>
-                    </a:lnL>
-                    <a:lnR w="0" cap="flat" cmpd="sng" algn="ctr">
-                      <a:noFill/>
-                    </a:lnR>
-                    <a:lnT w="0" cap="flat" cmpd="sng" algn="ctr">
-                      <a:noFill/>
-                    </a:lnT>
-                    <a:lnB w="9525" cap="flat" cmpd="sng" algn="ctr">
-                      <a:solidFill>
-                        <a:srgbClr val="BFCAD3"/>
-                      </a:solidFill>
-                      <a:prstDash val="solid"/>
-                      <a:round/>
-                      <a:headEnd type="none" w="med" len="med"/>
-                      <a:tailEnd type="none" w="med" len="med"/>
-                    </a:lnB>
-                  </a:tcPr>
-                </a:tc>
-                <a:tc>
-                  <a:txBody>
-                    <a:bodyPr/>
-                    <a:lstStyle/>
-                    <a:p>
-                      <a:pPr indent="0" marL="0">
-                        <a:buNone/>
-                      </a:pPr>
-                      <a:r>
-                        <a:rPr lang="en-US" sz="1200" dirty="0">
+                      <a:endParaRPr lang="en-US" sz="1150" dirty="0">
+                        <a:latin typeface="Calibri" charset="0"/>
+                        <a:ea typeface="Calibri" charset="0"/>
+                        <a:cs typeface="Calibri" charset="0"/>
+                      </a:endParaRPr>
+                    </a:p>
+                  </a:txBody>
+                  <a:tcPr marL="64008" marR="64008" marT="73152" marB="73152" anchor="ctr">
+                    <a:lnL w="0" cap="flat" cmpd="sng" algn="ctr">
+                      <a:noFill/>
+                    </a:lnL>
+                    <a:lnR w="0" cap="flat" cmpd="sng" algn="ctr">
+                      <a:noFill/>
+                    </a:lnR>
+                    <a:lnT w="0" cap="flat" cmpd="sng" algn="ctr">
+                      <a:noFill/>
+                    </a:lnT>
+                    <a:lnB w="9525" cap="flat" cmpd="sng" algn="ctr">
+                      <a:solidFill>
+                        <a:srgbClr val="BFCAD3"/>
+                      </a:solidFill>
+                      <a:prstDash val="solid"/>
+                      <a:round/>
+                      <a:headEnd type="none" w="med" len="med"/>
+                      <a:tailEnd type="none" w="med" len="med"/>
+                    </a:lnB>
+                  </a:tcPr>
+                </a:tc>
+                <a:tc>
+                  <a:txBody>
+                    <a:bodyPr/>
+                    <a:lstStyle/>
+                    <a:p>
+                      <a:pPr indent="0" marL="0">
+                        <a:buNone/>
+                      </a:pPr>
+                      <a:r>
+                        <a:rPr lang="en-US" sz="1150" dirty="0">
                           <a:solidFill>
                             <a:srgbClr val="111C24"/>
                           </a:solidFill>
@@ -3639,44 +3853,44 @@
                         </a:rPr>
                         <a:t>Launch workbook shared 28 Sep, revised with a strategy doc on Erik's feedback 29 Sep. Listing goes live on Amazon today, 2 Oct; Shayan T and Zarlish launch the campaigns with it</a:t>
                       </a:r>
-                      <a:endParaRPr lang="en-US" sz="1200" dirty="0">
-                        <a:latin typeface="Calibri" charset="0"/>
-                        <a:ea typeface="Calibri" charset="0"/>
-                        <a:cs typeface="Calibri" charset="0"/>
-                      </a:endParaRPr>
-                    </a:p>
-                  </a:txBody>
-                  <a:tcPr marL="64008" marR="64008" marT="73152" marB="73152" anchor="ctr">
-                    <a:lnL w="0" cap="flat" cmpd="sng" algn="ctr">
-                      <a:noFill/>
-                    </a:lnL>
-                    <a:lnR w="0" cap="flat" cmpd="sng" algn="ctr">
-                      <a:noFill/>
-                    </a:lnR>
-                    <a:lnT w="0" cap="flat" cmpd="sng" algn="ctr">
-                      <a:noFill/>
-                    </a:lnT>
-                    <a:lnB w="9525" cap="flat" cmpd="sng" algn="ctr">
-                      <a:solidFill>
-                        <a:srgbClr val="BFCAD3"/>
-                      </a:solidFill>
-                      <a:prstDash val="solid"/>
-                      <a:round/>
-                      <a:headEnd type="none" w="med" len="med"/>
-                      <a:tailEnd type="none" w="med" len="med"/>
-                    </a:lnB>
-                  </a:tcPr>
-                </a:tc>
-                <a:tc>
-                  <a:txBody>
-                    <a:bodyPr/>
-                    <a:lstStyle/>
-                    <a:p>
-                      <a:pPr indent="0" marL="0">
-                        <a:buNone/>
-                      </a:pPr>
-                      <a:r>
-                        <a:rPr lang="en-US" sz="1200" b="1" dirty="0">
+                      <a:endParaRPr lang="en-US" sz="1150" dirty="0">
+                        <a:latin typeface="Calibri" charset="0"/>
+                        <a:ea typeface="Calibri" charset="0"/>
+                        <a:cs typeface="Calibri" charset="0"/>
+                      </a:endParaRPr>
+                    </a:p>
+                  </a:txBody>
+                  <a:tcPr marL="64008" marR="64008" marT="73152" marB="73152" anchor="ctr">
+                    <a:lnL w="0" cap="flat" cmpd="sng" algn="ctr">
+                      <a:noFill/>
+                    </a:lnL>
+                    <a:lnR w="0" cap="flat" cmpd="sng" algn="ctr">
+                      <a:noFill/>
+                    </a:lnR>
+                    <a:lnT w="0" cap="flat" cmpd="sng" algn="ctr">
+                      <a:noFill/>
+                    </a:lnT>
+                    <a:lnB w="9525" cap="flat" cmpd="sng" algn="ctr">
+                      <a:solidFill>
+                        <a:srgbClr val="BFCAD3"/>
+                      </a:solidFill>
+                      <a:prstDash val="solid"/>
+                      <a:round/>
+                      <a:headEnd type="none" w="med" len="med"/>
+                      <a:tailEnd type="none" w="med" len="med"/>
+                    </a:lnB>
+                  </a:tcPr>
+                </a:tc>
+                <a:tc>
+                  <a:txBody>
+                    <a:bodyPr/>
+                    <a:lstStyle/>
+                    <a:p>
+                      <a:pPr indent="0" marL="0">
+                        <a:buNone/>
+                      </a:pPr>
+                      <a:r>
+                        <a:rPr lang="en-US" sz="1150" b="1" dirty="0">
                           <a:solidFill>
                             <a:srgbClr val="176B41"/>
                           </a:solidFill>
@@ -3686,7 +3900,7 @@
                         </a:rPr>
                         <a:t>Launching today</a:t>
                       </a:r>
-                      <a:endParaRPr lang="en-US" sz="1200" dirty="0">
+                      <a:endParaRPr lang="en-US" sz="1150" dirty="0">
                         <a:latin typeface="Calibri" charset="0"/>
                         <a:ea typeface="Calibri" charset="0"/>
                         <a:cs typeface="Calibri" charset="0"/>
@@ -8055,7 +8269,7 @@
                         <a:buNone/>
                       </a:pPr>
                       <a:r>
-                        <a:rPr lang="en-US" sz="1150" b="1" dirty="0">
+                        <a:rPr lang="en-US" sz="1100" b="1" dirty="0">
                           <a:solidFill>
                             <a:srgbClr val="111C24"/>
                           </a:solidFill>
@@ -8065,18 +8279,18 @@
                         </a:rPr>
                         <a:t>Prime Big Deal Days</a:t>
                       </a:r>
-                      <a:endParaRPr lang="en-US" sz="1150" dirty="0">
-                        <a:latin typeface="Calibri" charset="0"/>
-                        <a:ea typeface="Calibri" charset="0"/>
-                        <a:cs typeface="Calibri" charset="0"/>
-                      </a:endParaRPr>
-                    </a:p>
-                    <a:p>
-                      <a:pPr indent="0" marL="0">
-                        <a:buNone/>
-                      </a:pPr>
-                      <a:r>
-                        <a:rPr lang="en-US" sz="1050" dirty="0">
+                      <a:endParaRPr lang="en-US" sz="1100" dirty="0">
+                        <a:latin typeface="Calibri" charset="0"/>
+                        <a:ea typeface="Calibri" charset="0"/>
+                        <a:cs typeface="Calibri" charset="0"/>
+                      </a:endParaRPr>
+                    </a:p>
+                    <a:p>
+                      <a:pPr indent="0" marL="0">
+                        <a:buNone/>
+                      </a:pPr>
+                      <a:r>
+                        <a:rPr lang="en-US" sz="1000" dirty="0">
                           <a:solidFill>
                             <a:srgbClr val="4E5A64"/>
                           </a:solidFill>
@@ -8086,44 +8300,44 @@
                         </a:rPr>
                         <a:t>Shayan T</a:t>
                       </a:r>
-                      <a:endParaRPr lang="en-US" sz="1150" dirty="0">
-                        <a:latin typeface="Calibri" charset="0"/>
-                        <a:ea typeface="Calibri" charset="0"/>
-                        <a:cs typeface="Calibri" charset="0"/>
-                      </a:endParaRPr>
-                    </a:p>
-                  </a:txBody>
-                  <a:tcPr marL="64008" marR="64008" marT="73152" marB="73152" anchor="ctr">
-                    <a:lnL w="0" cap="flat" cmpd="sng" algn="ctr">
-                      <a:noFill/>
-                    </a:lnL>
-                    <a:lnR w="0" cap="flat" cmpd="sng" algn="ctr">
-                      <a:noFill/>
-                    </a:lnR>
-                    <a:lnT w="0" cap="flat" cmpd="sng" algn="ctr">
-                      <a:noFill/>
-                    </a:lnT>
-                    <a:lnB w="9525" cap="flat" cmpd="sng" algn="ctr">
-                      <a:solidFill>
-                        <a:srgbClr val="BFCAD3"/>
-                      </a:solidFill>
-                      <a:prstDash val="solid"/>
-                      <a:round/>
-                      <a:headEnd type="none" w="med" len="med"/>
-                      <a:tailEnd type="none" w="med" len="med"/>
-                    </a:lnB>
-                  </a:tcPr>
-                </a:tc>
-                <a:tc>
-                  <a:txBody>
-                    <a:bodyPr/>
-                    <a:lstStyle/>
-                    <a:p>
-                      <a:pPr indent="0" marL="0">
-                        <a:buNone/>
-                      </a:pPr>
-                      <a:r>
-                        <a:rPr lang="en-US" sz="1150" dirty="0">
+                      <a:endParaRPr lang="en-US" sz="1100" dirty="0">
+                        <a:latin typeface="Calibri" charset="0"/>
+                        <a:ea typeface="Calibri" charset="0"/>
+                        <a:cs typeface="Calibri" charset="0"/>
+                      </a:endParaRPr>
+                    </a:p>
+                  </a:txBody>
+                  <a:tcPr marL="64008" marR="64008" marT="73152" marB="73152" anchor="ctr">
+                    <a:lnL w="0" cap="flat" cmpd="sng" algn="ctr">
+                      <a:noFill/>
+                    </a:lnL>
+                    <a:lnR w="0" cap="flat" cmpd="sng" algn="ctr">
+                      <a:noFill/>
+                    </a:lnR>
+                    <a:lnT w="0" cap="flat" cmpd="sng" algn="ctr">
+                      <a:noFill/>
+                    </a:lnT>
+                    <a:lnB w="9525" cap="flat" cmpd="sng" algn="ctr">
+                      <a:solidFill>
+                        <a:srgbClr val="BFCAD3"/>
+                      </a:solidFill>
+                      <a:prstDash val="solid"/>
+                      <a:round/>
+                      <a:headEnd type="none" w="med" len="med"/>
+                      <a:tailEnd type="none" w="med" len="med"/>
+                    </a:lnB>
+                  </a:tcPr>
+                </a:tc>
+                <a:tc>
+                  <a:txBody>
+                    <a:bodyPr/>
+                    <a:lstStyle/>
+                    <a:p>
+                      <a:pPr indent="0" marL="0">
+                        <a:buNone/>
+                      </a:pPr>
+                      <a:r>
+                        <a:rPr lang="en-US" sz="1100" dirty="0">
                           <a:solidFill>
                             <a:srgbClr val="111C24"/>
                           </a:solidFill>
@@ -8133,44 +8347,44 @@
                         </a:rPr>
                         <a:t>Run the Oct 6–7 event: deal-day budgets live, Amazon's own budget rules stripped, S4 deal issues cleared</a:t>
                       </a:r>
-                      <a:endParaRPr lang="en-US" sz="1150" dirty="0">
-                        <a:latin typeface="Calibri" charset="0"/>
-                        <a:ea typeface="Calibri" charset="0"/>
-                        <a:cs typeface="Calibri" charset="0"/>
-                      </a:endParaRPr>
-                    </a:p>
-                  </a:txBody>
-                  <a:tcPr marL="64008" marR="64008" marT="73152" marB="73152" anchor="ctr">
-                    <a:lnL w="0" cap="flat" cmpd="sng" algn="ctr">
-                      <a:noFill/>
-                    </a:lnL>
-                    <a:lnR w="0" cap="flat" cmpd="sng" algn="ctr">
-                      <a:noFill/>
-                    </a:lnR>
-                    <a:lnT w="0" cap="flat" cmpd="sng" algn="ctr">
-                      <a:noFill/>
-                    </a:lnT>
-                    <a:lnB w="9525" cap="flat" cmpd="sng" algn="ctr">
-                      <a:solidFill>
-                        <a:srgbClr val="BFCAD3"/>
-                      </a:solidFill>
-                      <a:prstDash val="solid"/>
-                      <a:round/>
-                      <a:headEnd type="none" w="med" len="med"/>
-                      <a:tailEnd type="none" w="med" len="med"/>
-                    </a:lnB>
-                  </a:tcPr>
-                </a:tc>
-                <a:tc>
-                  <a:txBody>
-                    <a:bodyPr/>
-                    <a:lstStyle/>
-                    <a:p>
-                      <a:pPr indent="0" marL="0">
-                        <a:buNone/>
-                      </a:pPr>
-                      <a:r>
-                        <a:rPr lang="en-US" sz="1150" dirty="0">
+                      <a:endParaRPr lang="en-US" sz="1100" dirty="0">
+                        <a:latin typeface="Calibri" charset="0"/>
+                        <a:ea typeface="Calibri" charset="0"/>
+                        <a:cs typeface="Calibri" charset="0"/>
+                      </a:endParaRPr>
+                    </a:p>
+                  </a:txBody>
+                  <a:tcPr marL="64008" marR="64008" marT="73152" marB="73152" anchor="ctr">
+                    <a:lnL w="0" cap="flat" cmpd="sng" algn="ctr">
+                      <a:noFill/>
+                    </a:lnL>
+                    <a:lnR w="0" cap="flat" cmpd="sng" algn="ctr">
+                      <a:noFill/>
+                    </a:lnR>
+                    <a:lnT w="0" cap="flat" cmpd="sng" algn="ctr">
+                      <a:noFill/>
+                    </a:lnT>
+                    <a:lnB w="9525" cap="flat" cmpd="sng" algn="ctr">
+                      <a:solidFill>
+                        <a:srgbClr val="BFCAD3"/>
+                      </a:solidFill>
+                      <a:prstDash val="solid"/>
+                      <a:round/>
+                      <a:headEnd type="none" w="med" len="med"/>
+                      <a:tailEnd type="none" w="med" len="med"/>
+                    </a:lnB>
+                  </a:tcPr>
+                </a:tc>
+                <a:tc>
+                  <a:txBody>
+                    <a:bodyPr/>
+                    <a:lstStyle/>
+                    <a:p>
+                      <a:pPr indent="0" marL="0">
+                        <a:buNone/>
+                      </a:pPr>
+                      <a:r>
+                        <a:rPr lang="en-US" sz="1100" dirty="0">
                           <a:solidFill>
                             <a:srgbClr val="111C24"/>
                           </a:solidFill>
@@ -8180,44 +8394,44 @@
                         </a:rPr>
                         <a:t>Mon, Oct 5</a:t>
                       </a:r>
-                      <a:endParaRPr lang="en-US" sz="1150" dirty="0">
-                        <a:latin typeface="Calibri" charset="0"/>
-                        <a:ea typeface="Calibri" charset="0"/>
-                        <a:cs typeface="Calibri" charset="0"/>
-                      </a:endParaRPr>
-                    </a:p>
-                  </a:txBody>
-                  <a:tcPr marL="64008" marR="64008" marT="73152" marB="73152" anchor="ctr">
-                    <a:lnL w="0" cap="flat" cmpd="sng" algn="ctr">
-                      <a:noFill/>
-                    </a:lnL>
-                    <a:lnR w="0" cap="flat" cmpd="sng" algn="ctr">
-                      <a:noFill/>
-                    </a:lnR>
-                    <a:lnT w="0" cap="flat" cmpd="sng" algn="ctr">
-                      <a:noFill/>
-                    </a:lnT>
-                    <a:lnB w="9525" cap="flat" cmpd="sng" algn="ctr">
-                      <a:solidFill>
-                        <a:srgbClr val="BFCAD3"/>
-                      </a:solidFill>
-                      <a:prstDash val="solid"/>
-                      <a:round/>
-                      <a:headEnd type="none" w="med" len="med"/>
-                      <a:tailEnd type="none" w="med" len="med"/>
-                    </a:lnB>
-                  </a:tcPr>
-                </a:tc>
-                <a:tc>
-                  <a:txBody>
-                    <a:bodyPr/>
-                    <a:lstStyle/>
-                    <a:p>
-                      <a:pPr indent="0" marL="0">
-                        <a:buNone/>
-                      </a:pPr>
-                      <a:r>
-                        <a:rPr lang="en-US" sz="1150" dirty="0">
+                      <a:endParaRPr lang="en-US" sz="1100" dirty="0">
+                        <a:latin typeface="Calibri" charset="0"/>
+                        <a:ea typeface="Calibri" charset="0"/>
+                        <a:cs typeface="Calibri" charset="0"/>
+                      </a:endParaRPr>
+                    </a:p>
+                  </a:txBody>
+                  <a:tcPr marL="64008" marR="64008" marT="73152" marB="73152" anchor="ctr">
+                    <a:lnL w="0" cap="flat" cmpd="sng" algn="ctr">
+                      <a:noFill/>
+                    </a:lnL>
+                    <a:lnR w="0" cap="flat" cmpd="sng" algn="ctr">
+                      <a:noFill/>
+                    </a:lnR>
+                    <a:lnT w="0" cap="flat" cmpd="sng" algn="ctr">
+                      <a:noFill/>
+                    </a:lnT>
+                    <a:lnB w="9525" cap="flat" cmpd="sng" algn="ctr">
+                      <a:solidFill>
+                        <a:srgbClr val="BFCAD3"/>
+                      </a:solidFill>
+                      <a:prstDash val="solid"/>
+                      <a:round/>
+                      <a:headEnd type="none" w="med" len="med"/>
+                      <a:tailEnd type="none" w="med" len="med"/>
+                    </a:lnB>
+                  </a:tcPr>
+                </a:tc>
+                <a:tc>
+                  <a:txBody>
+                    <a:bodyPr/>
+                    <a:lstStyle/>
+                    <a:p>
+                      <a:pPr indent="0" marL="0">
+                        <a:buNone/>
+                      </a:pPr>
+                      <a:r>
+                        <a:rPr lang="en-US" sz="1100" dirty="0">
                           <a:solidFill>
                             <a:srgbClr val="111C24"/>
                           </a:solidFill>
@@ -8227,44 +8441,44 @@
                         </a:rPr>
                         <a:t>P0</a:t>
                       </a:r>
-                      <a:endParaRPr lang="en-US" sz="1150" dirty="0">
-                        <a:latin typeface="Calibri" charset="0"/>
-                        <a:ea typeface="Calibri" charset="0"/>
-                        <a:cs typeface="Calibri" charset="0"/>
-                      </a:endParaRPr>
-                    </a:p>
-                  </a:txBody>
-                  <a:tcPr marL="64008" marR="64008" marT="73152" marB="73152" anchor="ctr">
-                    <a:lnL w="0" cap="flat" cmpd="sng" algn="ctr">
-                      <a:noFill/>
-                    </a:lnL>
-                    <a:lnR w="0" cap="flat" cmpd="sng" algn="ctr">
-                      <a:noFill/>
-                    </a:lnR>
-                    <a:lnT w="0" cap="flat" cmpd="sng" algn="ctr">
-                      <a:noFill/>
-                    </a:lnT>
-                    <a:lnB w="9525" cap="flat" cmpd="sng" algn="ctr">
-                      <a:solidFill>
-                        <a:srgbClr val="BFCAD3"/>
-                      </a:solidFill>
-                      <a:prstDash val="solid"/>
-                      <a:round/>
-                      <a:headEnd type="none" w="med" len="med"/>
-                      <a:tailEnd type="none" w="med" len="med"/>
-                    </a:lnB>
-                  </a:tcPr>
-                </a:tc>
-                <a:tc>
-                  <a:txBody>
-                    <a:bodyPr/>
-                    <a:lstStyle/>
-                    <a:p>
-                      <a:pPr indent="0" marL="0">
-                        <a:buNone/>
-                      </a:pPr>
-                      <a:r>
-                        <a:rPr lang="en-US" sz="1150" dirty="0">
+                      <a:endParaRPr lang="en-US" sz="1100" dirty="0">
+                        <a:latin typeface="Calibri" charset="0"/>
+                        <a:ea typeface="Calibri" charset="0"/>
+                        <a:cs typeface="Calibri" charset="0"/>
+                      </a:endParaRPr>
+                    </a:p>
+                  </a:txBody>
+                  <a:tcPr marL="64008" marR="64008" marT="73152" marB="73152" anchor="ctr">
+                    <a:lnL w="0" cap="flat" cmpd="sng" algn="ctr">
+                      <a:noFill/>
+                    </a:lnL>
+                    <a:lnR w="0" cap="flat" cmpd="sng" algn="ctr">
+                      <a:noFill/>
+                    </a:lnR>
+                    <a:lnT w="0" cap="flat" cmpd="sng" algn="ctr">
+                      <a:noFill/>
+                    </a:lnT>
+                    <a:lnB w="9525" cap="flat" cmpd="sng" algn="ctr">
+                      <a:solidFill>
+                        <a:srgbClr val="BFCAD3"/>
+                      </a:solidFill>
+                      <a:prstDash val="solid"/>
+                      <a:round/>
+                      <a:headEnd type="none" w="med" len="med"/>
+                      <a:tailEnd type="none" w="med" len="med"/>
+                    </a:lnB>
+                  </a:tcPr>
+                </a:tc>
+                <a:tc>
+                  <a:txBody>
+                    <a:bodyPr/>
+                    <a:lstStyle/>
+                    <a:p>
+                      <a:pPr indent="0" marL="0">
+                        <a:buNone/>
+                      </a:pPr>
+                      <a:r>
+                        <a:rPr lang="en-US" sz="1100" dirty="0">
                           <a:solidFill>
                             <a:srgbClr val="111C24"/>
                           </a:solidFill>
@@ -8274,7 +8488,7 @@
                         </a:rPr>
                         <a:t>N — new</a:t>
                       </a:r>
-                      <a:endParaRPr lang="en-US" sz="1150" dirty="0">
+                      <a:endParaRPr lang="en-US" sz="1100" dirty="0">
                         <a:latin typeface="Calibri" charset="0"/>
                         <a:ea typeface="Calibri" charset="0"/>
                         <a:cs typeface="Calibri" charset="0"/>
@@ -8313,7 +8527,7 @@
                         <a:buNone/>
                       </a:pPr>
                       <a:r>
-                        <a:rPr lang="en-US" sz="1150" b="1" dirty="0">
+                        <a:rPr lang="en-US" sz="1100" b="1" dirty="0">
                           <a:solidFill>
                             <a:srgbClr val="111C24"/>
                           </a:solidFill>
@@ -8323,18 +8537,18 @@
                         </a:rPr>
                         <a:t>Bamboo ranking push</a:t>
                       </a:r>
-                      <a:endParaRPr lang="en-US" sz="1150" dirty="0">
-                        <a:latin typeface="Calibri" charset="0"/>
-                        <a:ea typeface="Calibri" charset="0"/>
-                        <a:cs typeface="Calibri" charset="0"/>
-                      </a:endParaRPr>
-                    </a:p>
-                    <a:p>
-                      <a:pPr indent="0" marL="0">
-                        <a:buNone/>
-                      </a:pPr>
-                      <a:r>
-                        <a:rPr lang="en-US" sz="1050" dirty="0">
+                      <a:endParaRPr lang="en-US" sz="1100" dirty="0">
+                        <a:latin typeface="Calibri" charset="0"/>
+                        <a:ea typeface="Calibri" charset="0"/>
+                        <a:cs typeface="Calibri" charset="0"/>
+                      </a:endParaRPr>
+                    </a:p>
+                    <a:p>
+                      <a:pPr indent="0" marL="0">
+                        <a:buNone/>
+                      </a:pPr>
+                      <a:r>
+                        <a:rPr lang="en-US" sz="1000" dirty="0">
                           <a:solidFill>
                             <a:srgbClr val="4E5A64"/>
                           </a:solidFill>
@@ -8344,44 +8558,44 @@
                         </a:rPr>
                         <a:t>Shayan T with Joseph</a:t>
                       </a:r>
-                      <a:endParaRPr lang="en-US" sz="1150" dirty="0">
-                        <a:latin typeface="Calibri" charset="0"/>
-                        <a:ea typeface="Calibri" charset="0"/>
-                        <a:cs typeface="Calibri" charset="0"/>
-                      </a:endParaRPr>
-                    </a:p>
-                  </a:txBody>
-                  <a:tcPr marL="64008" marR="64008" marT="73152" marB="73152" anchor="ctr">
-                    <a:lnL w="0" cap="flat" cmpd="sng" algn="ctr">
-                      <a:noFill/>
-                    </a:lnL>
-                    <a:lnR w="0" cap="flat" cmpd="sng" algn="ctr">
-                      <a:noFill/>
-                    </a:lnR>
-                    <a:lnT w="0" cap="flat" cmpd="sng" algn="ctr">
-                      <a:noFill/>
-                    </a:lnT>
-                    <a:lnB w="9525" cap="flat" cmpd="sng" algn="ctr">
-                      <a:solidFill>
-                        <a:srgbClr val="BFCAD3"/>
-                      </a:solidFill>
-                      <a:prstDash val="solid"/>
-                      <a:round/>
-                      <a:headEnd type="none" w="med" len="med"/>
-                      <a:tailEnd type="none" w="med" len="med"/>
-                    </a:lnB>
-                  </a:tcPr>
-                </a:tc>
-                <a:tc>
-                  <a:txBody>
-                    <a:bodyPr/>
-                    <a:lstStyle/>
-                    <a:p>
-                      <a:pPr indent="0" marL="0">
-                        <a:buNone/>
-                      </a:pPr>
-                      <a:r>
-                        <a:rPr lang="en-US" sz="1150" dirty="0">
+                      <a:endParaRPr lang="en-US" sz="1100" dirty="0">
+                        <a:latin typeface="Calibri" charset="0"/>
+                        <a:ea typeface="Calibri" charset="0"/>
+                        <a:cs typeface="Calibri" charset="0"/>
+                      </a:endParaRPr>
+                    </a:p>
+                  </a:txBody>
+                  <a:tcPr marL="64008" marR="64008" marT="73152" marB="73152" anchor="ctr">
+                    <a:lnL w="0" cap="flat" cmpd="sng" algn="ctr">
+                      <a:noFill/>
+                    </a:lnL>
+                    <a:lnR w="0" cap="flat" cmpd="sng" algn="ctr">
+                      <a:noFill/>
+                    </a:lnR>
+                    <a:lnT w="0" cap="flat" cmpd="sng" algn="ctr">
+                      <a:noFill/>
+                    </a:lnT>
+                    <a:lnB w="9525" cap="flat" cmpd="sng" algn="ctr">
+                      <a:solidFill>
+                        <a:srgbClr val="BFCAD3"/>
+                      </a:solidFill>
+                      <a:prstDash val="solid"/>
+                      <a:round/>
+                      <a:headEnd type="none" w="med" len="med"/>
+                      <a:tailEnd type="none" w="med" len="med"/>
+                    </a:lnB>
+                  </a:tcPr>
+                </a:tc>
+                <a:tc>
+                  <a:txBody>
+                    <a:bodyPr/>
+                    <a:lstStyle/>
+                    <a:p>
+                      <a:pPr indent="0" marL="0">
+                        <a:buNone/>
+                      </a:pPr>
+                      <a:r>
+                        <a:rPr lang="en-US" sz="1100" dirty="0">
                           <a:solidFill>
                             <a:srgbClr val="111C24"/>
                           </a:solidFill>
@@ -8391,44 +8605,44 @@
                         </a:rPr>
                         <a:t>Get the sign-offs, write the rank goals to Target Setting and go live; day-7 reads 10 Oct (B6) and 11 Oct (B4), first 60-click trial reads 14 Oct</a:t>
                       </a:r>
-                      <a:endParaRPr lang="en-US" sz="1150" dirty="0">
-                        <a:latin typeface="Calibri" charset="0"/>
-                        <a:ea typeface="Calibri" charset="0"/>
-                        <a:cs typeface="Calibri" charset="0"/>
-                      </a:endParaRPr>
-                    </a:p>
-                  </a:txBody>
-                  <a:tcPr marL="64008" marR="64008" marT="73152" marB="73152" anchor="ctr">
-                    <a:lnL w="0" cap="flat" cmpd="sng" algn="ctr">
-                      <a:noFill/>
-                    </a:lnL>
-                    <a:lnR w="0" cap="flat" cmpd="sng" algn="ctr">
-                      <a:noFill/>
-                    </a:lnR>
-                    <a:lnT w="0" cap="flat" cmpd="sng" algn="ctr">
-                      <a:noFill/>
-                    </a:lnT>
-                    <a:lnB w="9525" cap="flat" cmpd="sng" algn="ctr">
-                      <a:solidFill>
-                        <a:srgbClr val="BFCAD3"/>
-                      </a:solidFill>
-                      <a:prstDash val="solid"/>
-                      <a:round/>
-                      <a:headEnd type="none" w="med" len="med"/>
-                      <a:tailEnd type="none" w="med" len="med"/>
-                    </a:lnB>
-                  </a:tcPr>
-                </a:tc>
-                <a:tc>
-                  <a:txBody>
-                    <a:bodyPr/>
-                    <a:lstStyle/>
-                    <a:p>
-                      <a:pPr indent="0" marL="0">
-                        <a:buNone/>
-                      </a:pPr>
-                      <a:r>
-                        <a:rPr lang="en-US" sz="1150" dirty="0">
+                      <a:endParaRPr lang="en-US" sz="1100" dirty="0">
+                        <a:latin typeface="Calibri" charset="0"/>
+                        <a:ea typeface="Calibri" charset="0"/>
+                        <a:cs typeface="Calibri" charset="0"/>
+                      </a:endParaRPr>
+                    </a:p>
+                  </a:txBody>
+                  <a:tcPr marL="64008" marR="64008" marT="73152" marB="73152" anchor="ctr">
+                    <a:lnL w="0" cap="flat" cmpd="sng" algn="ctr">
+                      <a:noFill/>
+                    </a:lnL>
+                    <a:lnR w="0" cap="flat" cmpd="sng" algn="ctr">
+                      <a:noFill/>
+                    </a:lnR>
+                    <a:lnT w="0" cap="flat" cmpd="sng" algn="ctr">
+                      <a:noFill/>
+                    </a:lnT>
+                    <a:lnB w="9525" cap="flat" cmpd="sng" algn="ctr">
+                      <a:solidFill>
+                        <a:srgbClr val="BFCAD3"/>
+                      </a:solidFill>
+                      <a:prstDash val="solid"/>
+                      <a:round/>
+                      <a:headEnd type="none" w="med" len="med"/>
+                      <a:tailEnd type="none" w="med" len="med"/>
+                    </a:lnB>
+                  </a:tcPr>
+                </a:tc>
+                <a:tc>
+                  <a:txBody>
+                    <a:bodyPr/>
+                    <a:lstStyle/>
+                    <a:p>
+                      <a:pPr indent="0" marL="0">
+                        <a:buNone/>
+                      </a:pPr>
+                      <a:r>
+                        <a:rPr lang="en-US" sz="1100" dirty="0">
                           <a:solidFill>
                             <a:srgbClr val="111C24"/>
                           </a:solidFill>
@@ -8438,44 +8652,44 @@
                         </a:rPr>
                         <a:t>Mon, Oct 5 · reads 10–14 Oct</a:t>
                       </a:r>
-                      <a:endParaRPr lang="en-US" sz="1150" dirty="0">
-                        <a:latin typeface="Calibri" charset="0"/>
-                        <a:ea typeface="Calibri" charset="0"/>
-                        <a:cs typeface="Calibri" charset="0"/>
-                      </a:endParaRPr>
-                    </a:p>
-                  </a:txBody>
-                  <a:tcPr marL="64008" marR="64008" marT="73152" marB="73152" anchor="ctr">
-                    <a:lnL w="0" cap="flat" cmpd="sng" algn="ctr">
-                      <a:noFill/>
-                    </a:lnL>
-                    <a:lnR w="0" cap="flat" cmpd="sng" algn="ctr">
-                      <a:noFill/>
-                    </a:lnR>
-                    <a:lnT w="0" cap="flat" cmpd="sng" algn="ctr">
-                      <a:noFill/>
-                    </a:lnT>
-                    <a:lnB w="9525" cap="flat" cmpd="sng" algn="ctr">
-                      <a:solidFill>
-                        <a:srgbClr val="BFCAD3"/>
-                      </a:solidFill>
-                      <a:prstDash val="solid"/>
-                      <a:round/>
-                      <a:headEnd type="none" w="med" len="med"/>
-                      <a:tailEnd type="none" w="med" len="med"/>
-                    </a:lnB>
-                  </a:tcPr>
-                </a:tc>
-                <a:tc>
-                  <a:txBody>
-                    <a:bodyPr/>
-                    <a:lstStyle/>
-                    <a:p>
-                      <a:pPr indent="0" marL="0">
-                        <a:buNone/>
-                      </a:pPr>
-                      <a:r>
-                        <a:rPr lang="en-US" sz="1150" dirty="0">
+                      <a:endParaRPr lang="en-US" sz="1100" dirty="0">
+                        <a:latin typeface="Calibri" charset="0"/>
+                        <a:ea typeface="Calibri" charset="0"/>
+                        <a:cs typeface="Calibri" charset="0"/>
+                      </a:endParaRPr>
+                    </a:p>
+                  </a:txBody>
+                  <a:tcPr marL="64008" marR="64008" marT="73152" marB="73152" anchor="ctr">
+                    <a:lnL w="0" cap="flat" cmpd="sng" algn="ctr">
+                      <a:noFill/>
+                    </a:lnL>
+                    <a:lnR w="0" cap="flat" cmpd="sng" algn="ctr">
+                      <a:noFill/>
+                    </a:lnR>
+                    <a:lnT w="0" cap="flat" cmpd="sng" algn="ctr">
+                      <a:noFill/>
+                    </a:lnT>
+                    <a:lnB w="9525" cap="flat" cmpd="sng" algn="ctr">
+                      <a:solidFill>
+                        <a:srgbClr val="BFCAD3"/>
+                      </a:solidFill>
+                      <a:prstDash val="solid"/>
+                      <a:round/>
+                      <a:headEnd type="none" w="med" len="med"/>
+                      <a:tailEnd type="none" w="med" len="med"/>
+                    </a:lnB>
+                  </a:tcPr>
+                </a:tc>
+                <a:tc>
+                  <a:txBody>
+                    <a:bodyPr/>
+                    <a:lstStyle/>
+                    <a:p>
+                      <a:pPr indent="0" marL="0">
+                        <a:buNone/>
+                      </a:pPr>
+                      <a:r>
+                        <a:rPr lang="en-US" sz="1100" dirty="0">
                           <a:solidFill>
                             <a:srgbClr val="111C24"/>
                           </a:solidFill>
@@ -8485,44 +8699,44 @@
                         </a:rPr>
                         <a:t>P0</a:t>
                       </a:r>
-                      <a:endParaRPr lang="en-US" sz="1150" dirty="0">
-                        <a:latin typeface="Calibri" charset="0"/>
-                        <a:ea typeface="Calibri" charset="0"/>
-                        <a:cs typeface="Calibri" charset="0"/>
-                      </a:endParaRPr>
-                    </a:p>
-                  </a:txBody>
-                  <a:tcPr marL="64008" marR="64008" marT="73152" marB="73152" anchor="ctr">
-                    <a:lnL w="0" cap="flat" cmpd="sng" algn="ctr">
-                      <a:noFill/>
-                    </a:lnL>
-                    <a:lnR w="0" cap="flat" cmpd="sng" algn="ctr">
-                      <a:noFill/>
-                    </a:lnR>
-                    <a:lnT w="0" cap="flat" cmpd="sng" algn="ctr">
-                      <a:noFill/>
-                    </a:lnT>
-                    <a:lnB w="9525" cap="flat" cmpd="sng" algn="ctr">
-                      <a:solidFill>
-                        <a:srgbClr val="BFCAD3"/>
-                      </a:solidFill>
-                      <a:prstDash val="solid"/>
-                      <a:round/>
-                      <a:headEnd type="none" w="med" len="med"/>
-                      <a:tailEnd type="none" w="med" len="med"/>
-                    </a:lnB>
-                  </a:tcPr>
-                </a:tc>
-                <a:tc>
-                  <a:txBody>
-                    <a:bodyPr/>
-                    <a:lstStyle/>
-                    <a:p>
-                      <a:pPr indent="0" marL="0">
-                        <a:buNone/>
-                      </a:pPr>
-                      <a:r>
-                        <a:rPr lang="en-US" sz="1150" dirty="0">
+                      <a:endParaRPr lang="en-US" sz="1100" dirty="0">
+                        <a:latin typeface="Calibri" charset="0"/>
+                        <a:ea typeface="Calibri" charset="0"/>
+                        <a:cs typeface="Calibri" charset="0"/>
+                      </a:endParaRPr>
+                    </a:p>
+                  </a:txBody>
+                  <a:tcPr marL="64008" marR="64008" marT="73152" marB="73152" anchor="ctr">
+                    <a:lnL w="0" cap="flat" cmpd="sng" algn="ctr">
+                      <a:noFill/>
+                    </a:lnL>
+                    <a:lnR w="0" cap="flat" cmpd="sng" algn="ctr">
+                      <a:noFill/>
+                    </a:lnR>
+                    <a:lnT w="0" cap="flat" cmpd="sng" algn="ctr">
+                      <a:noFill/>
+                    </a:lnT>
+                    <a:lnB w="9525" cap="flat" cmpd="sng" algn="ctr">
+                      <a:solidFill>
+                        <a:srgbClr val="BFCAD3"/>
+                      </a:solidFill>
+                      <a:prstDash val="solid"/>
+                      <a:round/>
+                      <a:headEnd type="none" w="med" len="med"/>
+                      <a:tailEnd type="none" w="med" len="med"/>
+                    </a:lnB>
+                  </a:tcPr>
+                </a:tc>
+                <a:tc>
+                  <a:txBody>
+                    <a:bodyPr/>
+                    <a:lstStyle/>
+                    <a:p>
+                      <a:pPr indent="0" marL="0">
+                        <a:buNone/>
+                      </a:pPr>
+                      <a:r>
+                        <a:rPr lang="en-US" sz="1100" dirty="0">
                           <a:solidFill>
                             <a:srgbClr val="111C24"/>
                           </a:solidFill>
@@ -8532,7 +8746,7 @@
                         </a:rPr>
                         <a:t>N — new</a:t>
                       </a:r>
-                      <a:endParaRPr lang="en-US" sz="1150" dirty="0">
+                      <a:endParaRPr lang="en-US" sz="1100" dirty="0">
                         <a:latin typeface="Calibri" charset="0"/>
                         <a:ea typeface="Calibri" charset="0"/>
                         <a:cs typeface="Calibri" charset="0"/>
@@ -8571,7 +8785,7 @@
                         <a:buNone/>
                       </a:pPr>
                       <a:r>
-                        <a:rPr lang="en-US" sz="1150" b="1" dirty="0">
+                        <a:rPr lang="en-US" sz="1100" b="1" dirty="0">
                           <a:solidFill>
                             <a:srgbClr val="111C24"/>
                           </a:solidFill>
@@ -8581,18 +8795,18 @@
                         </a:rPr>
                         <a:t>CooLinens Pillowcase</a:t>
                       </a:r>
-                      <a:endParaRPr lang="en-US" sz="1150" dirty="0">
-                        <a:latin typeface="Calibri" charset="0"/>
-                        <a:ea typeface="Calibri" charset="0"/>
-                        <a:cs typeface="Calibri" charset="0"/>
-                      </a:endParaRPr>
-                    </a:p>
-                    <a:p>
-                      <a:pPr indent="0" marL="0">
-                        <a:buNone/>
-                      </a:pPr>
-                      <a:r>
-                        <a:rPr lang="en-US" sz="1050" dirty="0">
+                      <a:endParaRPr lang="en-US" sz="1100" dirty="0">
+                        <a:latin typeface="Calibri" charset="0"/>
+                        <a:ea typeface="Calibri" charset="0"/>
+                        <a:cs typeface="Calibri" charset="0"/>
+                      </a:endParaRPr>
+                    </a:p>
+                    <a:p>
+                      <a:pPr indent="0" marL="0">
+                        <a:buNone/>
+                      </a:pPr>
+                      <a:r>
+                        <a:rPr lang="en-US" sz="1000" dirty="0">
                           <a:solidFill>
                             <a:srgbClr val="4E5A64"/>
                           </a:solidFill>
@@ -8602,44 +8816,44 @@
                         </a:rPr>
                         <a:t>Shayan T with Zarlish</a:t>
                       </a:r>
-                      <a:endParaRPr lang="en-US" sz="1150" dirty="0">
-                        <a:latin typeface="Calibri" charset="0"/>
-                        <a:ea typeface="Calibri" charset="0"/>
-                        <a:cs typeface="Calibri" charset="0"/>
-                      </a:endParaRPr>
-                    </a:p>
-                  </a:txBody>
-                  <a:tcPr marL="64008" marR="64008" marT="73152" marB="73152" anchor="ctr">
-                    <a:lnL w="0" cap="flat" cmpd="sng" algn="ctr">
-                      <a:noFill/>
-                    </a:lnL>
-                    <a:lnR w="0" cap="flat" cmpd="sng" algn="ctr">
-                      <a:noFill/>
-                    </a:lnR>
-                    <a:lnT w="0" cap="flat" cmpd="sng" algn="ctr">
-                      <a:noFill/>
-                    </a:lnT>
-                    <a:lnB w="9525" cap="flat" cmpd="sng" algn="ctr">
-                      <a:solidFill>
-                        <a:srgbClr val="BFCAD3"/>
-                      </a:solidFill>
-                      <a:prstDash val="solid"/>
-                      <a:round/>
-                      <a:headEnd type="none" w="med" len="med"/>
-                      <a:tailEnd type="none" w="med" len="med"/>
-                    </a:lnB>
-                  </a:tcPr>
-                </a:tc>
-                <a:tc>
-                  <a:txBody>
-                    <a:bodyPr/>
-                    <a:lstStyle/>
-                    <a:p>
-                      <a:pPr indent="0" marL="0">
-                        <a:buNone/>
-                      </a:pPr>
-                      <a:r>
-                        <a:rPr lang="en-US" sz="1150" dirty="0">
+                      <a:endParaRPr lang="en-US" sz="1100" dirty="0">
+                        <a:latin typeface="Calibri" charset="0"/>
+                        <a:ea typeface="Calibri" charset="0"/>
+                        <a:cs typeface="Calibri" charset="0"/>
+                      </a:endParaRPr>
+                    </a:p>
+                  </a:txBody>
+                  <a:tcPr marL="64008" marR="64008" marT="73152" marB="73152" anchor="ctr">
+                    <a:lnL w="0" cap="flat" cmpd="sng" algn="ctr">
+                      <a:noFill/>
+                    </a:lnL>
+                    <a:lnR w="0" cap="flat" cmpd="sng" algn="ctr">
+                      <a:noFill/>
+                    </a:lnR>
+                    <a:lnT w="0" cap="flat" cmpd="sng" algn="ctr">
+                      <a:noFill/>
+                    </a:lnT>
+                    <a:lnB w="9525" cap="flat" cmpd="sng" algn="ctr">
+                      <a:solidFill>
+                        <a:srgbClr val="BFCAD3"/>
+                      </a:solidFill>
+                      <a:prstDash val="solid"/>
+                      <a:round/>
+                      <a:headEnd type="none" w="med" len="med"/>
+                      <a:tailEnd type="none" w="med" len="med"/>
+                    </a:lnB>
+                  </a:tcPr>
+                </a:tc>
+                <a:tc>
+                  <a:txBody>
+                    <a:bodyPr/>
+                    <a:lstStyle/>
+                    <a:p>
+                      <a:pPr indent="0" marL="0">
+                        <a:buNone/>
+                      </a:pPr>
+                      <a:r>
+                        <a:rPr lang="en-US" sz="1100" dirty="0">
                           <a:solidFill>
                             <a:srgbClr val="111C24"/>
                           </a:solidFill>
@@ -8649,44 +8863,44 @@
                         </a:rPr>
                         <a:t>First live week: daily spend, search-term and conversion checks, PAT additions from Shayan R, launch read at the Friday close</a:t>
                       </a:r>
-                      <a:endParaRPr lang="en-US" sz="1150" dirty="0">
-                        <a:latin typeface="Calibri" charset="0"/>
-                        <a:ea typeface="Calibri" charset="0"/>
-                        <a:cs typeface="Calibri" charset="0"/>
-                      </a:endParaRPr>
-                    </a:p>
-                  </a:txBody>
-                  <a:tcPr marL="64008" marR="64008" marT="73152" marB="73152" anchor="ctr">
-                    <a:lnL w="0" cap="flat" cmpd="sng" algn="ctr">
-                      <a:noFill/>
-                    </a:lnL>
-                    <a:lnR w="0" cap="flat" cmpd="sng" algn="ctr">
-                      <a:noFill/>
-                    </a:lnR>
-                    <a:lnT w="0" cap="flat" cmpd="sng" algn="ctr">
-                      <a:noFill/>
-                    </a:lnT>
-                    <a:lnB w="9525" cap="flat" cmpd="sng" algn="ctr">
-                      <a:solidFill>
-                        <a:srgbClr val="BFCAD3"/>
-                      </a:solidFill>
-                      <a:prstDash val="solid"/>
-                      <a:round/>
-                      <a:headEnd type="none" w="med" len="med"/>
-                      <a:tailEnd type="none" w="med" len="med"/>
-                    </a:lnB>
-                  </a:tcPr>
-                </a:tc>
-                <a:tc>
-                  <a:txBody>
-                    <a:bodyPr/>
-                    <a:lstStyle/>
-                    <a:p>
-                      <a:pPr indent="0" marL="0">
-                        <a:buNone/>
-                      </a:pPr>
-                      <a:r>
-                        <a:rPr lang="en-US" sz="1150" dirty="0">
+                      <a:endParaRPr lang="en-US" sz="1100" dirty="0">
+                        <a:latin typeface="Calibri" charset="0"/>
+                        <a:ea typeface="Calibri" charset="0"/>
+                        <a:cs typeface="Calibri" charset="0"/>
+                      </a:endParaRPr>
+                    </a:p>
+                  </a:txBody>
+                  <a:tcPr marL="64008" marR="64008" marT="73152" marB="73152" anchor="ctr">
+                    <a:lnL w="0" cap="flat" cmpd="sng" algn="ctr">
+                      <a:noFill/>
+                    </a:lnL>
+                    <a:lnR w="0" cap="flat" cmpd="sng" algn="ctr">
+                      <a:noFill/>
+                    </a:lnR>
+                    <a:lnT w="0" cap="flat" cmpd="sng" algn="ctr">
+                      <a:noFill/>
+                    </a:lnT>
+                    <a:lnB w="9525" cap="flat" cmpd="sng" algn="ctr">
+                      <a:solidFill>
+                        <a:srgbClr val="BFCAD3"/>
+                      </a:solidFill>
+                      <a:prstDash val="solid"/>
+                      <a:round/>
+                      <a:headEnd type="none" w="med" len="med"/>
+                      <a:tailEnd type="none" w="med" len="med"/>
+                    </a:lnB>
+                  </a:tcPr>
+                </a:tc>
+                <a:tc>
+                  <a:txBody>
+                    <a:bodyPr/>
+                    <a:lstStyle/>
+                    <a:p>
+                      <a:pPr indent="0" marL="0">
+                        <a:buNone/>
+                      </a:pPr>
+                      <a:r>
+                        <a:rPr lang="en-US" sz="1100" dirty="0">
                           <a:solidFill>
                             <a:srgbClr val="111C24"/>
                           </a:solidFill>
@@ -8696,44 +8910,44 @@
                         </a:rPr>
                         <a:t>Daily · read Fri, Oct 9</a:t>
                       </a:r>
-                      <a:endParaRPr lang="en-US" sz="1150" dirty="0">
-                        <a:latin typeface="Calibri" charset="0"/>
-                        <a:ea typeface="Calibri" charset="0"/>
-                        <a:cs typeface="Calibri" charset="0"/>
-                      </a:endParaRPr>
-                    </a:p>
-                  </a:txBody>
-                  <a:tcPr marL="64008" marR="64008" marT="73152" marB="73152" anchor="ctr">
-                    <a:lnL w="0" cap="flat" cmpd="sng" algn="ctr">
-                      <a:noFill/>
-                    </a:lnL>
-                    <a:lnR w="0" cap="flat" cmpd="sng" algn="ctr">
-                      <a:noFill/>
-                    </a:lnR>
-                    <a:lnT w="0" cap="flat" cmpd="sng" algn="ctr">
-                      <a:noFill/>
-                    </a:lnT>
-                    <a:lnB w="9525" cap="flat" cmpd="sng" algn="ctr">
-                      <a:solidFill>
-                        <a:srgbClr val="BFCAD3"/>
-                      </a:solidFill>
-                      <a:prstDash val="solid"/>
-                      <a:round/>
-                      <a:headEnd type="none" w="med" len="med"/>
-                      <a:tailEnd type="none" w="med" len="med"/>
-                    </a:lnB>
-                  </a:tcPr>
-                </a:tc>
-                <a:tc>
-                  <a:txBody>
-                    <a:bodyPr/>
-                    <a:lstStyle/>
-                    <a:p>
-                      <a:pPr indent="0" marL="0">
-                        <a:buNone/>
-                      </a:pPr>
-                      <a:r>
-                        <a:rPr lang="en-US" sz="1150" dirty="0">
+                      <a:endParaRPr lang="en-US" sz="1100" dirty="0">
+                        <a:latin typeface="Calibri" charset="0"/>
+                        <a:ea typeface="Calibri" charset="0"/>
+                        <a:cs typeface="Calibri" charset="0"/>
+                      </a:endParaRPr>
+                    </a:p>
+                  </a:txBody>
+                  <a:tcPr marL="64008" marR="64008" marT="73152" marB="73152" anchor="ctr">
+                    <a:lnL w="0" cap="flat" cmpd="sng" algn="ctr">
+                      <a:noFill/>
+                    </a:lnL>
+                    <a:lnR w="0" cap="flat" cmpd="sng" algn="ctr">
+                      <a:noFill/>
+                    </a:lnR>
+                    <a:lnT w="0" cap="flat" cmpd="sng" algn="ctr">
+                      <a:noFill/>
+                    </a:lnT>
+                    <a:lnB w="9525" cap="flat" cmpd="sng" algn="ctr">
+                      <a:solidFill>
+                        <a:srgbClr val="BFCAD3"/>
+                      </a:solidFill>
+                      <a:prstDash val="solid"/>
+                      <a:round/>
+                      <a:headEnd type="none" w="med" len="med"/>
+                      <a:tailEnd type="none" w="med" len="med"/>
+                    </a:lnB>
+                  </a:tcPr>
+                </a:tc>
+                <a:tc>
+                  <a:txBody>
+                    <a:bodyPr/>
+                    <a:lstStyle/>
+                    <a:p>
+                      <a:pPr indent="0" marL="0">
+                        <a:buNone/>
+                      </a:pPr>
+                      <a:r>
+                        <a:rPr lang="en-US" sz="1100" dirty="0">
                           <a:solidFill>
                             <a:srgbClr val="111C24"/>
                           </a:solidFill>
@@ -8743,44 +8957,44 @@
                         </a:rPr>
                         <a:t>P0</a:t>
                       </a:r>
-                      <a:endParaRPr lang="en-US" sz="1150" dirty="0">
-                        <a:latin typeface="Calibri" charset="0"/>
-                        <a:ea typeface="Calibri" charset="0"/>
-                        <a:cs typeface="Calibri" charset="0"/>
-                      </a:endParaRPr>
-                    </a:p>
-                  </a:txBody>
-                  <a:tcPr marL="64008" marR="64008" marT="73152" marB="73152" anchor="ctr">
-                    <a:lnL w="0" cap="flat" cmpd="sng" algn="ctr">
-                      <a:noFill/>
-                    </a:lnL>
-                    <a:lnR w="0" cap="flat" cmpd="sng" algn="ctr">
-                      <a:noFill/>
-                    </a:lnR>
-                    <a:lnT w="0" cap="flat" cmpd="sng" algn="ctr">
-                      <a:noFill/>
-                    </a:lnT>
-                    <a:lnB w="9525" cap="flat" cmpd="sng" algn="ctr">
-                      <a:solidFill>
-                        <a:srgbClr val="BFCAD3"/>
-                      </a:solidFill>
-                      <a:prstDash val="solid"/>
-                      <a:round/>
-                      <a:headEnd type="none" w="med" len="med"/>
-                      <a:tailEnd type="none" w="med" len="med"/>
-                    </a:lnB>
-                  </a:tcPr>
-                </a:tc>
-                <a:tc>
-                  <a:txBody>
-                    <a:bodyPr/>
-                    <a:lstStyle/>
-                    <a:p>
-                      <a:pPr indent="0" marL="0">
-                        <a:buNone/>
-                      </a:pPr>
-                      <a:r>
-                        <a:rPr lang="en-US" sz="1150" dirty="0">
+                      <a:endParaRPr lang="en-US" sz="1100" dirty="0">
+                        <a:latin typeface="Calibri" charset="0"/>
+                        <a:ea typeface="Calibri" charset="0"/>
+                        <a:cs typeface="Calibri" charset="0"/>
+                      </a:endParaRPr>
+                    </a:p>
+                  </a:txBody>
+                  <a:tcPr marL="64008" marR="64008" marT="73152" marB="73152" anchor="ctr">
+                    <a:lnL w="0" cap="flat" cmpd="sng" algn="ctr">
+                      <a:noFill/>
+                    </a:lnL>
+                    <a:lnR w="0" cap="flat" cmpd="sng" algn="ctr">
+                      <a:noFill/>
+                    </a:lnR>
+                    <a:lnT w="0" cap="flat" cmpd="sng" algn="ctr">
+                      <a:noFill/>
+                    </a:lnT>
+                    <a:lnB w="9525" cap="flat" cmpd="sng" algn="ctr">
+                      <a:solidFill>
+                        <a:srgbClr val="BFCAD3"/>
+                      </a:solidFill>
+                      <a:prstDash val="solid"/>
+                      <a:round/>
+                      <a:headEnd type="none" w="med" len="med"/>
+                      <a:tailEnd type="none" w="med" len="med"/>
+                    </a:lnB>
+                  </a:tcPr>
+                </a:tc>
+                <a:tc>
+                  <a:txBody>
+                    <a:bodyPr/>
+                    <a:lstStyle/>
+                    <a:p>
+                      <a:pPr indent="0" marL="0">
+                        <a:buNone/>
+                      </a:pPr>
+                      <a:r>
+                        <a:rPr lang="en-US" sz="1100" dirty="0">
                           <a:solidFill>
                             <a:srgbClr val="111C24"/>
                           </a:solidFill>
@@ -8790,7 +9004,7 @@
                         </a:rPr>
                         <a:t>N — new</a:t>
                       </a:r>
-                      <a:endParaRPr lang="en-US" sz="1150" dirty="0">
+                      <a:endParaRPr lang="en-US" sz="1100" dirty="0">
                         <a:latin typeface="Calibri" charset="0"/>
                         <a:ea typeface="Calibri" charset="0"/>
                         <a:cs typeface="Calibri" charset="0"/>
@@ -8829,7 +9043,7 @@
                         <a:buNone/>
                       </a:pPr>
                       <a:r>
-                        <a:rPr lang="en-US" sz="1150" b="1" dirty="0">
+                        <a:rPr lang="en-US" sz="1100" b="1" dirty="0">
                           <a:solidFill>
                             <a:srgbClr val="111C24"/>
                           </a:solidFill>
@@ -8839,18 +9053,18 @@
                         </a:rPr>
                         <a:t>Audit cycle</a:t>
                       </a:r>
-                      <a:endParaRPr lang="en-US" sz="1150" dirty="0">
-                        <a:latin typeface="Calibri" charset="0"/>
-                        <a:ea typeface="Calibri" charset="0"/>
-                        <a:cs typeface="Calibri" charset="0"/>
-                      </a:endParaRPr>
-                    </a:p>
-                    <a:p>
-                      <a:pPr indent="0" marL="0">
-                        <a:buNone/>
-                      </a:pPr>
-                      <a:r>
-                        <a:rPr lang="en-US" sz="1050" dirty="0">
+                      <a:endParaRPr lang="en-US" sz="1100" dirty="0">
+                        <a:latin typeface="Calibri" charset="0"/>
+                        <a:ea typeface="Calibri" charset="0"/>
+                        <a:cs typeface="Calibri" charset="0"/>
+                      </a:endParaRPr>
+                    </a:p>
+                    <a:p>
+                      <a:pPr indent="0" marL="0">
+                        <a:buNone/>
+                      </a:pPr>
+                      <a:r>
+                        <a:rPr lang="en-US" sz="1000" dirty="0">
                           <a:solidFill>
                             <a:srgbClr val="4E5A64"/>
                           </a:solidFill>
@@ -8860,44 +9074,44 @@
                         </a:rPr>
                         <a:t>All three</a:t>
                       </a:r>
-                      <a:endParaRPr lang="en-US" sz="1150" dirty="0">
-                        <a:latin typeface="Calibri" charset="0"/>
-                        <a:ea typeface="Calibri" charset="0"/>
-                        <a:cs typeface="Calibri" charset="0"/>
-                      </a:endParaRPr>
-                    </a:p>
-                  </a:txBody>
-                  <a:tcPr marL="64008" marR="64008" marT="73152" marB="73152" anchor="ctr">
-                    <a:lnL w="0" cap="flat" cmpd="sng" algn="ctr">
-                      <a:noFill/>
-                    </a:lnL>
-                    <a:lnR w="0" cap="flat" cmpd="sng" algn="ctr">
-                      <a:noFill/>
-                    </a:lnR>
-                    <a:lnT w="0" cap="flat" cmpd="sng" algn="ctr">
-                      <a:noFill/>
-                    </a:lnT>
-                    <a:lnB w="9525" cap="flat" cmpd="sng" algn="ctr">
-                      <a:solidFill>
-                        <a:srgbClr val="BFCAD3"/>
-                      </a:solidFill>
-                      <a:prstDash val="solid"/>
-                      <a:round/>
-                      <a:headEnd type="none" w="med" len="med"/>
-                      <a:tailEnd type="none" w="med" len="med"/>
-                    </a:lnB>
-                  </a:tcPr>
-                </a:tc>
-                <a:tc>
-                  <a:txBody>
-                    <a:bodyPr/>
-                    <a:lstStyle/>
-                    <a:p>
-                      <a:pPr indent="0" marL="0">
-                        <a:buNone/>
-                      </a:pPr>
-                      <a:r>
-                        <a:rPr lang="en-US" sz="1150" dirty="0">
+                      <a:endParaRPr lang="en-US" sz="1100" dirty="0">
+                        <a:latin typeface="Calibri" charset="0"/>
+                        <a:ea typeface="Calibri" charset="0"/>
+                        <a:cs typeface="Calibri" charset="0"/>
+                      </a:endParaRPr>
+                    </a:p>
+                  </a:txBody>
+                  <a:tcPr marL="64008" marR="64008" marT="73152" marB="73152" anchor="ctr">
+                    <a:lnL w="0" cap="flat" cmpd="sng" algn="ctr">
+                      <a:noFill/>
+                    </a:lnL>
+                    <a:lnR w="0" cap="flat" cmpd="sng" algn="ctr">
+                      <a:noFill/>
+                    </a:lnR>
+                    <a:lnT w="0" cap="flat" cmpd="sng" algn="ctr">
+                      <a:noFill/>
+                    </a:lnT>
+                    <a:lnB w="9525" cap="flat" cmpd="sng" algn="ctr">
+                      <a:solidFill>
+                        <a:srgbClr val="BFCAD3"/>
+                      </a:solidFill>
+                      <a:prstDash val="solid"/>
+                      <a:round/>
+                      <a:headEnd type="none" w="med" len="med"/>
+                      <a:tailEnd type="none" w="med" len="med"/>
+                    </a:lnB>
+                  </a:tcPr>
+                </a:tc>
+                <a:tc>
+                  <a:txBody>
+                    <a:bodyPr/>
+                    <a:lstStyle/>
+                    <a:p>
+                      <a:pPr indent="0" marL="0">
+                        <a:buNone/>
+                      </a:pPr>
+                      <a:r>
+                        <a:rPr lang="en-US" sz="1100" dirty="0">
                           <a:solidFill>
                             <a:srgbClr val="111C24"/>
                           </a:solidFill>
@@ -8907,44 +9121,44 @@
                         </a:rPr>
                         <a:t>Run the next cycle on all nine, Bamboo Monday and the rest Tuesday. This cycle closes today with the last three feedbacks</a:t>
                       </a:r>
-                      <a:endParaRPr lang="en-US" sz="1150" dirty="0">
-                        <a:latin typeface="Calibri" charset="0"/>
-                        <a:ea typeface="Calibri" charset="0"/>
-                        <a:cs typeface="Calibri" charset="0"/>
-                      </a:endParaRPr>
-                    </a:p>
-                  </a:txBody>
-                  <a:tcPr marL="64008" marR="64008" marT="73152" marB="73152" anchor="ctr">
-                    <a:lnL w="0" cap="flat" cmpd="sng" algn="ctr">
-                      <a:noFill/>
-                    </a:lnL>
-                    <a:lnR w="0" cap="flat" cmpd="sng" algn="ctr">
-                      <a:noFill/>
-                    </a:lnR>
-                    <a:lnT w="0" cap="flat" cmpd="sng" algn="ctr">
-                      <a:noFill/>
-                    </a:lnT>
-                    <a:lnB w="9525" cap="flat" cmpd="sng" algn="ctr">
-                      <a:solidFill>
-                        <a:srgbClr val="BFCAD3"/>
-                      </a:solidFill>
-                      <a:prstDash val="solid"/>
-                      <a:round/>
-                      <a:headEnd type="none" w="med" len="med"/>
-                      <a:tailEnd type="none" w="med" len="med"/>
-                    </a:lnB>
-                  </a:tcPr>
-                </a:tc>
-                <a:tc>
-                  <a:txBody>
-                    <a:bodyPr/>
-                    <a:lstStyle/>
-                    <a:p>
-                      <a:pPr indent="0" marL="0">
-                        <a:buNone/>
-                      </a:pPr>
-                      <a:r>
-                        <a:rPr lang="en-US" sz="1150" dirty="0">
+                      <a:endParaRPr lang="en-US" sz="1100" dirty="0">
+                        <a:latin typeface="Calibri" charset="0"/>
+                        <a:ea typeface="Calibri" charset="0"/>
+                        <a:cs typeface="Calibri" charset="0"/>
+                      </a:endParaRPr>
+                    </a:p>
+                  </a:txBody>
+                  <a:tcPr marL="64008" marR="64008" marT="73152" marB="73152" anchor="ctr">
+                    <a:lnL w="0" cap="flat" cmpd="sng" algn="ctr">
+                      <a:noFill/>
+                    </a:lnL>
+                    <a:lnR w="0" cap="flat" cmpd="sng" algn="ctr">
+                      <a:noFill/>
+                    </a:lnR>
+                    <a:lnT w="0" cap="flat" cmpd="sng" algn="ctr">
+                      <a:noFill/>
+                    </a:lnT>
+                    <a:lnB w="9525" cap="flat" cmpd="sng" algn="ctr">
+                      <a:solidFill>
+                        <a:srgbClr val="BFCAD3"/>
+                      </a:solidFill>
+                      <a:prstDash val="solid"/>
+                      <a:round/>
+                      <a:headEnd type="none" w="med" len="med"/>
+                      <a:tailEnd type="none" w="med" len="med"/>
+                    </a:lnB>
+                  </a:tcPr>
+                </a:tc>
+                <a:tc>
+                  <a:txBody>
+                    <a:bodyPr/>
+                    <a:lstStyle/>
+                    <a:p>
+                      <a:pPr indent="0" marL="0">
+                        <a:buNone/>
+                      </a:pPr>
+                      <a:r>
+                        <a:rPr lang="en-US" sz="1100" dirty="0">
                           <a:solidFill>
                             <a:srgbClr val="111C24"/>
                           </a:solidFill>
@@ -8954,44 +9168,44 @@
                         </a:rPr>
                         <a:t>Mon, Oct 5</a:t>
                       </a:r>
-                      <a:endParaRPr lang="en-US" sz="1150" dirty="0">
-                        <a:latin typeface="Calibri" charset="0"/>
-                        <a:ea typeface="Calibri" charset="0"/>
-                        <a:cs typeface="Calibri" charset="0"/>
-                      </a:endParaRPr>
-                    </a:p>
-                  </a:txBody>
-                  <a:tcPr marL="64008" marR="64008" marT="73152" marB="73152" anchor="ctr">
-                    <a:lnL w="0" cap="flat" cmpd="sng" algn="ctr">
-                      <a:noFill/>
-                    </a:lnL>
-                    <a:lnR w="0" cap="flat" cmpd="sng" algn="ctr">
-                      <a:noFill/>
-                    </a:lnR>
-                    <a:lnT w="0" cap="flat" cmpd="sng" algn="ctr">
-                      <a:noFill/>
-                    </a:lnT>
-                    <a:lnB w="9525" cap="flat" cmpd="sng" algn="ctr">
-                      <a:solidFill>
-                        <a:srgbClr val="BFCAD3"/>
-                      </a:solidFill>
-                      <a:prstDash val="solid"/>
-                      <a:round/>
-                      <a:headEnd type="none" w="med" len="med"/>
-                      <a:tailEnd type="none" w="med" len="med"/>
-                    </a:lnB>
-                  </a:tcPr>
-                </a:tc>
-                <a:tc>
-                  <a:txBody>
-                    <a:bodyPr/>
-                    <a:lstStyle/>
-                    <a:p>
-                      <a:pPr indent="0" marL="0">
-                        <a:buNone/>
-                      </a:pPr>
-                      <a:r>
-                        <a:rPr lang="en-US" sz="1150" dirty="0">
+                      <a:endParaRPr lang="en-US" sz="1100" dirty="0">
+                        <a:latin typeface="Calibri" charset="0"/>
+                        <a:ea typeface="Calibri" charset="0"/>
+                        <a:cs typeface="Calibri" charset="0"/>
+                      </a:endParaRPr>
+                    </a:p>
+                  </a:txBody>
+                  <a:tcPr marL="64008" marR="64008" marT="73152" marB="73152" anchor="ctr">
+                    <a:lnL w="0" cap="flat" cmpd="sng" algn="ctr">
+                      <a:noFill/>
+                    </a:lnL>
+                    <a:lnR w="0" cap="flat" cmpd="sng" algn="ctr">
+                      <a:noFill/>
+                    </a:lnR>
+                    <a:lnT w="0" cap="flat" cmpd="sng" algn="ctr">
+                      <a:noFill/>
+                    </a:lnT>
+                    <a:lnB w="9525" cap="flat" cmpd="sng" algn="ctr">
+                      <a:solidFill>
+                        <a:srgbClr val="BFCAD3"/>
+                      </a:solidFill>
+                      <a:prstDash val="solid"/>
+                      <a:round/>
+                      <a:headEnd type="none" w="med" len="med"/>
+                      <a:tailEnd type="none" w="med" len="med"/>
+                    </a:lnB>
+                  </a:tcPr>
+                </a:tc>
+                <a:tc>
+                  <a:txBody>
+                    <a:bodyPr/>
+                    <a:lstStyle/>
+                    <a:p>
+                      <a:pPr indent="0" marL="0">
+                        <a:buNone/>
+                      </a:pPr>
+                      <a:r>
+                        <a:rPr lang="en-US" sz="1100" dirty="0">
                           <a:solidFill>
                             <a:srgbClr val="111C24"/>
                           </a:solidFill>
@@ -9001,44 +9215,44 @@
                         </a:rPr>
                         <a:t>P0</a:t>
                       </a:r>
-                      <a:endParaRPr lang="en-US" sz="1150" dirty="0">
-                        <a:latin typeface="Calibri" charset="0"/>
-                        <a:ea typeface="Calibri" charset="0"/>
-                        <a:cs typeface="Calibri" charset="0"/>
-                      </a:endParaRPr>
-                    </a:p>
-                  </a:txBody>
-                  <a:tcPr marL="64008" marR="64008" marT="73152" marB="73152" anchor="ctr">
-                    <a:lnL w="0" cap="flat" cmpd="sng" algn="ctr">
-                      <a:noFill/>
-                    </a:lnL>
-                    <a:lnR w="0" cap="flat" cmpd="sng" algn="ctr">
-                      <a:noFill/>
-                    </a:lnR>
-                    <a:lnT w="0" cap="flat" cmpd="sng" algn="ctr">
-                      <a:noFill/>
-                    </a:lnT>
-                    <a:lnB w="9525" cap="flat" cmpd="sng" algn="ctr">
-                      <a:solidFill>
-                        <a:srgbClr val="BFCAD3"/>
-                      </a:solidFill>
-                      <a:prstDash val="solid"/>
-                      <a:round/>
-                      <a:headEnd type="none" w="med" len="med"/>
-                      <a:tailEnd type="none" w="med" len="med"/>
-                    </a:lnB>
-                  </a:tcPr>
-                </a:tc>
-                <a:tc>
-                  <a:txBody>
-                    <a:bodyPr/>
-                    <a:lstStyle/>
-                    <a:p>
-                      <a:pPr indent="0" marL="0">
-                        <a:buNone/>
-                      </a:pPr>
-                      <a:r>
-                        <a:rPr lang="en-US" sz="1150" dirty="0">
+                      <a:endParaRPr lang="en-US" sz="1100" dirty="0">
+                        <a:latin typeface="Calibri" charset="0"/>
+                        <a:ea typeface="Calibri" charset="0"/>
+                        <a:cs typeface="Calibri" charset="0"/>
+                      </a:endParaRPr>
+                    </a:p>
+                  </a:txBody>
+                  <a:tcPr marL="64008" marR="64008" marT="73152" marB="73152" anchor="ctr">
+                    <a:lnL w="0" cap="flat" cmpd="sng" algn="ctr">
+                      <a:noFill/>
+                    </a:lnL>
+                    <a:lnR w="0" cap="flat" cmpd="sng" algn="ctr">
+                      <a:noFill/>
+                    </a:lnR>
+                    <a:lnT w="0" cap="flat" cmpd="sng" algn="ctr">
+                      <a:noFill/>
+                    </a:lnT>
+                    <a:lnB w="9525" cap="flat" cmpd="sng" algn="ctr">
+                      <a:solidFill>
+                        <a:srgbClr val="BFCAD3"/>
+                      </a:solidFill>
+                      <a:prstDash val="solid"/>
+                      <a:round/>
+                      <a:headEnd type="none" w="med" len="med"/>
+                      <a:tailEnd type="none" w="med" len="med"/>
+                    </a:lnB>
+                  </a:tcPr>
+                </a:tc>
+                <a:tc>
+                  <a:txBody>
+                    <a:bodyPr/>
+                    <a:lstStyle/>
+                    <a:p>
+                      <a:pPr indent="0" marL="0">
+                        <a:buNone/>
+                      </a:pPr>
+                      <a:r>
+                        <a:rPr lang="en-US" sz="1100" dirty="0">
                           <a:solidFill>
                             <a:srgbClr val="111C24"/>
                           </a:solidFill>
@@ -9048,7 +9262,7 @@
                         </a:rPr>
                         <a:t>N — new cycle</a:t>
                       </a:r>
-                      <a:endParaRPr lang="en-US" sz="1150" dirty="0">
+                      <a:endParaRPr lang="en-US" sz="1100" dirty="0">
                         <a:latin typeface="Calibri" charset="0"/>
                         <a:ea typeface="Calibri" charset="0"/>
                         <a:cs typeface="Calibri" charset="0"/>
@@ -9087,7 +9301,7 @@
                         <a:buNone/>
                       </a:pPr>
                       <a:r>
-                        <a:rPr lang="en-US" sz="1150" b="1" dirty="0">
+                        <a:rPr lang="en-US" sz="1100" b="1" dirty="0">
                           <a:solidFill>
                             <a:srgbClr val="111C24"/>
                           </a:solidFill>
@@ -9097,18 +9311,18 @@
                         </a:rPr>
                         <a:t>Engine feedback &amp; register</a:t>
                       </a:r>
-                      <a:endParaRPr lang="en-US" sz="1150" dirty="0">
-                        <a:latin typeface="Calibri" charset="0"/>
-                        <a:ea typeface="Calibri" charset="0"/>
-                        <a:cs typeface="Calibri" charset="0"/>
-                      </a:endParaRPr>
-                    </a:p>
-                    <a:p>
-                      <a:pPr indent="0" marL="0">
-                        <a:buNone/>
-                      </a:pPr>
-                      <a:r>
-                        <a:rPr lang="en-US" sz="1050" dirty="0">
+                      <a:endParaRPr lang="en-US" sz="1100" dirty="0">
+                        <a:latin typeface="Calibri" charset="0"/>
+                        <a:ea typeface="Calibri" charset="0"/>
+                        <a:cs typeface="Calibri" charset="0"/>
+                      </a:endParaRPr>
+                    </a:p>
+                    <a:p>
+                      <a:pPr indent="0" marL="0">
+                        <a:buNone/>
+                      </a:pPr>
+                      <a:r>
+                        <a:rPr lang="en-US" sz="1000" dirty="0">
                           <a:solidFill>
                             <a:srgbClr val="4E5A64"/>
                           </a:solidFill>
@@ -9118,44 +9332,44 @@
                         </a:rPr>
                         <a:t>Zarlish with Shayan T</a:t>
                       </a:r>
-                      <a:endParaRPr lang="en-US" sz="1150" dirty="0">
-                        <a:latin typeface="Calibri" charset="0"/>
-                        <a:ea typeface="Calibri" charset="0"/>
-                        <a:cs typeface="Calibri" charset="0"/>
-                      </a:endParaRPr>
-                    </a:p>
-                  </a:txBody>
-                  <a:tcPr marL="64008" marR="64008" marT="73152" marB="73152" anchor="ctr">
-                    <a:lnL w="0" cap="flat" cmpd="sng" algn="ctr">
-                      <a:noFill/>
-                    </a:lnL>
-                    <a:lnR w="0" cap="flat" cmpd="sng" algn="ctr">
-                      <a:noFill/>
-                    </a:lnR>
-                    <a:lnT w="0" cap="flat" cmpd="sng" algn="ctr">
-                      <a:noFill/>
-                    </a:lnT>
-                    <a:lnB w="9525" cap="flat" cmpd="sng" algn="ctr">
-                      <a:solidFill>
-                        <a:srgbClr val="BFCAD3"/>
-                      </a:solidFill>
-                      <a:prstDash val="solid"/>
-                      <a:round/>
-                      <a:headEnd type="none" w="med" len="med"/>
-                      <a:tailEnd type="none" w="med" len="med"/>
-                    </a:lnB>
-                  </a:tcPr>
-                </a:tc>
-                <a:tc>
-                  <a:txBody>
-                    <a:bodyPr/>
-                    <a:lstStyle/>
-                    <a:p>
-                      <a:pPr indent="0" marL="0">
-                        <a:buNone/>
-                      </a:pPr>
-                      <a:r>
-                        <a:rPr lang="en-US" sz="1150" dirty="0">
+                      <a:endParaRPr lang="en-US" sz="1100" dirty="0">
+                        <a:latin typeface="Calibri" charset="0"/>
+                        <a:ea typeface="Calibri" charset="0"/>
+                        <a:cs typeface="Calibri" charset="0"/>
+                      </a:endParaRPr>
+                    </a:p>
+                  </a:txBody>
+                  <a:tcPr marL="64008" marR="64008" marT="73152" marB="73152" anchor="ctr">
+                    <a:lnL w="0" cap="flat" cmpd="sng" algn="ctr">
+                      <a:noFill/>
+                    </a:lnL>
+                    <a:lnR w="0" cap="flat" cmpd="sng" algn="ctr">
+                      <a:noFill/>
+                    </a:lnR>
+                    <a:lnT w="0" cap="flat" cmpd="sng" algn="ctr">
+                      <a:noFill/>
+                    </a:lnT>
+                    <a:lnB w="9525" cap="flat" cmpd="sng" algn="ctr">
+                      <a:solidFill>
+                        <a:srgbClr val="BFCAD3"/>
+                      </a:solidFill>
+                      <a:prstDash val="solid"/>
+                      <a:round/>
+                      <a:headEnd type="none" w="med" len="med"/>
+                      <a:tailEnd type="none" w="med" len="med"/>
+                    </a:lnB>
+                  </a:tcPr>
+                </a:tc>
+                <a:tc>
+                  <a:txBody>
+                    <a:bodyPr/>
+                    <a:lstStyle/>
+                    <a:p>
+                      <a:pPr indent="0" marL="0">
+                        <a:buNone/>
+                      </a:pPr>
+                      <a:r>
+                        <a:rPr lang="en-US" sz="1100" dirty="0">
                           <a:solidFill>
                             <a:srgbClr val="111C24"/>
                           </a:solidFill>
@@ -9165,44 +9379,44 @@
                         </a:rPr>
                         <a:t>Shayan T reviews, Zarlish shares the feedback and register with Joseph, then the register moves to changed-findings-only and Section 7, Q1 and Q3 are signed off</a:t>
                       </a:r>
-                      <a:endParaRPr lang="en-US" sz="1150" dirty="0">
-                        <a:latin typeface="Calibri" charset="0"/>
-                        <a:ea typeface="Calibri" charset="0"/>
-                        <a:cs typeface="Calibri" charset="0"/>
-                      </a:endParaRPr>
-                    </a:p>
-                  </a:txBody>
-                  <a:tcPr marL="64008" marR="64008" marT="73152" marB="73152" anchor="ctr">
-                    <a:lnL w="0" cap="flat" cmpd="sng" algn="ctr">
-                      <a:noFill/>
-                    </a:lnL>
-                    <a:lnR w="0" cap="flat" cmpd="sng" algn="ctr">
-                      <a:noFill/>
-                    </a:lnR>
-                    <a:lnT w="0" cap="flat" cmpd="sng" algn="ctr">
-                      <a:noFill/>
-                    </a:lnT>
-                    <a:lnB w="9525" cap="flat" cmpd="sng" algn="ctr">
-                      <a:solidFill>
-                        <a:srgbClr val="BFCAD3"/>
-                      </a:solidFill>
-                      <a:prstDash val="solid"/>
-                      <a:round/>
-                      <a:headEnd type="none" w="med" len="med"/>
-                      <a:tailEnd type="none" w="med" len="med"/>
-                    </a:lnB>
-                  </a:tcPr>
-                </a:tc>
-                <a:tc>
-                  <a:txBody>
-                    <a:bodyPr/>
-                    <a:lstStyle/>
-                    <a:p>
-                      <a:pPr indent="0" marL="0">
-                        <a:buNone/>
-                      </a:pPr>
-                      <a:r>
-                        <a:rPr lang="en-US" sz="1150" dirty="0">
+                      <a:endParaRPr lang="en-US" sz="1100" dirty="0">
+                        <a:latin typeface="Calibri" charset="0"/>
+                        <a:ea typeface="Calibri" charset="0"/>
+                        <a:cs typeface="Calibri" charset="0"/>
+                      </a:endParaRPr>
+                    </a:p>
+                  </a:txBody>
+                  <a:tcPr marL="64008" marR="64008" marT="73152" marB="73152" anchor="ctr">
+                    <a:lnL w="0" cap="flat" cmpd="sng" algn="ctr">
+                      <a:noFill/>
+                    </a:lnL>
+                    <a:lnR w="0" cap="flat" cmpd="sng" algn="ctr">
+                      <a:noFill/>
+                    </a:lnR>
+                    <a:lnT w="0" cap="flat" cmpd="sng" algn="ctr">
+                      <a:noFill/>
+                    </a:lnT>
+                    <a:lnB w="9525" cap="flat" cmpd="sng" algn="ctr">
+                      <a:solidFill>
+                        <a:srgbClr val="BFCAD3"/>
+                      </a:solidFill>
+                      <a:prstDash val="solid"/>
+                      <a:round/>
+                      <a:headEnd type="none" w="med" len="med"/>
+                      <a:tailEnd type="none" w="med" len="med"/>
+                    </a:lnB>
+                  </a:tcPr>
+                </a:tc>
+                <a:tc>
+                  <a:txBody>
+                    <a:bodyPr/>
+                    <a:lstStyle/>
+                    <a:p>
+                      <a:pPr indent="0" marL="0">
+                        <a:buNone/>
+                      </a:pPr>
+                      <a:r>
+                        <a:rPr lang="en-US" sz="1100" dirty="0">
                           <a:solidFill>
                             <a:srgbClr val="111C24"/>
                           </a:solidFill>
@@ -9212,44 +9426,44 @@
                         </a:rPr>
                         <a:t>Share soon · sign-off Mon, Oct 5</a:t>
                       </a:r>
-                      <a:endParaRPr lang="en-US" sz="1150" dirty="0">
-                        <a:latin typeface="Calibri" charset="0"/>
-                        <a:ea typeface="Calibri" charset="0"/>
-                        <a:cs typeface="Calibri" charset="0"/>
-                      </a:endParaRPr>
-                    </a:p>
-                  </a:txBody>
-                  <a:tcPr marL="64008" marR="64008" marT="73152" marB="73152" anchor="ctr">
-                    <a:lnL w="0" cap="flat" cmpd="sng" algn="ctr">
-                      <a:noFill/>
-                    </a:lnL>
-                    <a:lnR w="0" cap="flat" cmpd="sng" algn="ctr">
-                      <a:noFill/>
-                    </a:lnR>
-                    <a:lnT w="0" cap="flat" cmpd="sng" algn="ctr">
-                      <a:noFill/>
-                    </a:lnT>
-                    <a:lnB w="9525" cap="flat" cmpd="sng" algn="ctr">
-                      <a:solidFill>
-                        <a:srgbClr val="BFCAD3"/>
-                      </a:solidFill>
-                      <a:prstDash val="solid"/>
-                      <a:round/>
-                      <a:headEnd type="none" w="med" len="med"/>
-                      <a:tailEnd type="none" w="med" len="med"/>
-                    </a:lnB>
-                  </a:tcPr>
-                </a:tc>
-                <a:tc>
-                  <a:txBody>
-                    <a:bodyPr/>
-                    <a:lstStyle/>
-                    <a:p>
-                      <a:pPr indent="0" marL="0">
-                        <a:buNone/>
-                      </a:pPr>
-                      <a:r>
-                        <a:rPr lang="en-US" sz="1150" dirty="0">
+                      <a:endParaRPr lang="en-US" sz="1100" dirty="0">
+                        <a:latin typeface="Calibri" charset="0"/>
+                        <a:ea typeface="Calibri" charset="0"/>
+                        <a:cs typeface="Calibri" charset="0"/>
+                      </a:endParaRPr>
+                    </a:p>
+                  </a:txBody>
+                  <a:tcPr marL="64008" marR="64008" marT="73152" marB="73152" anchor="ctr">
+                    <a:lnL w="0" cap="flat" cmpd="sng" algn="ctr">
+                      <a:noFill/>
+                    </a:lnL>
+                    <a:lnR w="0" cap="flat" cmpd="sng" algn="ctr">
+                      <a:noFill/>
+                    </a:lnR>
+                    <a:lnT w="0" cap="flat" cmpd="sng" algn="ctr">
+                      <a:noFill/>
+                    </a:lnT>
+                    <a:lnB w="9525" cap="flat" cmpd="sng" algn="ctr">
+                      <a:solidFill>
+                        <a:srgbClr val="BFCAD3"/>
+                      </a:solidFill>
+                      <a:prstDash val="solid"/>
+                      <a:round/>
+                      <a:headEnd type="none" w="med" len="med"/>
+                      <a:tailEnd type="none" w="med" len="med"/>
+                    </a:lnB>
+                  </a:tcPr>
+                </a:tc>
+                <a:tc>
+                  <a:txBody>
+                    <a:bodyPr/>
+                    <a:lstStyle/>
+                    <a:p>
+                      <a:pPr indent="0" marL="0">
+                        <a:buNone/>
+                      </a:pPr>
+                      <a:r>
+                        <a:rPr lang="en-US" sz="1100" dirty="0">
                           <a:solidFill>
                             <a:srgbClr val="111C24"/>
                           </a:solidFill>
@@ -9259,44 +9473,44 @@
                         </a:rPr>
                         <a:t>P0</a:t>
                       </a:r>
-                      <a:endParaRPr lang="en-US" sz="1150" dirty="0">
-                        <a:latin typeface="Calibri" charset="0"/>
-                        <a:ea typeface="Calibri" charset="0"/>
-                        <a:cs typeface="Calibri" charset="0"/>
-                      </a:endParaRPr>
-                    </a:p>
-                  </a:txBody>
-                  <a:tcPr marL="64008" marR="64008" marT="73152" marB="73152" anchor="ctr">
-                    <a:lnL w="0" cap="flat" cmpd="sng" algn="ctr">
-                      <a:noFill/>
-                    </a:lnL>
-                    <a:lnR w="0" cap="flat" cmpd="sng" algn="ctr">
-                      <a:noFill/>
-                    </a:lnR>
-                    <a:lnT w="0" cap="flat" cmpd="sng" algn="ctr">
-                      <a:noFill/>
-                    </a:lnT>
-                    <a:lnB w="9525" cap="flat" cmpd="sng" algn="ctr">
-                      <a:solidFill>
-                        <a:srgbClr val="BFCAD3"/>
-                      </a:solidFill>
-                      <a:prstDash val="solid"/>
-                      <a:round/>
-                      <a:headEnd type="none" w="med" len="med"/>
-                      <a:tailEnd type="none" w="med" len="med"/>
-                    </a:lnB>
-                  </a:tcPr>
-                </a:tc>
-                <a:tc>
-                  <a:txBody>
-                    <a:bodyPr/>
-                    <a:lstStyle/>
-                    <a:p>
-                      <a:pPr indent="0" marL="0">
-                        <a:buNone/>
-                      </a:pPr>
-                      <a:r>
-                        <a:rPr lang="en-US" sz="1150" dirty="0">
+                      <a:endParaRPr lang="en-US" sz="1100" dirty="0">
+                        <a:latin typeface="Calibri" charset="0"/>
+                        <a:ea typeface="Calibri" charset="0"/>
+                        <a:cs typeface="Calibri" charset="0"/>
+                      </a:endParaRPr>
+                    </a:p>
+                  </a:txBody>
+                  <a:tcPr marL="64008" marR="64008" marT="73152" marB="73152" anchor="ctr">
+                    <a:lnL w="0" cap="flat" cmpd="sng" algn="ctr">
+                      <a:noFill/>
+                    </a:lnL>
+                    <a:lnR w="0" cap="flat" cmpd="sng" algn="ctr">
+                      <a:noFill/>
+                    </a:lnR>
+                    <a:lnT w="0" cap="flat" cmpd="sng" algn="ctr">
+                      <a:noFill/>
+                    </a:lnT>
+                    <a:lnB w="9525" cap="flat" cmpd="sng" algn="ctr">
+                      <a:solidFill>
+                        <a:srgbClr val="BFCAD3"/>
+                      </a:solidFill>
+                      <a:prstDash val="solid"/>
+                      <a:round/>
+                      <a:headEnd type="none" w="med" len="med"/>
+                      <a:tailEnd type="none" w="med" len="med"/>
+                    </a:lnB>
+                  </a:tcPr>
+                </a:tc>
+                <a:tc>
+                  <a:txBody>
+                    <a:bodyPr/>
+                    <a:lstStyle/>
+                    <a:p>
+                      <a:pPr indent="0" marL="0">
+                        <a:buNone/>
+                      </a:pPr>
+                      <a:r>
+                        <a:rPr lang="en-US" sz="1100" dirty="0">
                           <a:solidFill>
                             <a:srgbClr val="111C24"/>
                           </a:solidFill>
@@ -9306,7 +9520,7 @@
                         </a:rPr>
                         <a:t>Y — since Oct 2</a:t>
                       </a:r>
-                      <a:endParaRPr lang="en-US" sz="1150" dirty="0">
+                      <a:endParaRPr lang="en-US" sz="1100" dirty="0">
                         <a:latin typeface="Calibri" charset="0"/>
                         <a:ea typeface="Calibri" charset="0"/>
                         <a:cs typeface="Calibri" charset="0"/>
@@ -9345,7 +9559,7 @@
                         <a:buNone/>
                       </a:pPr>
                       <a:r>
-                        <a:rPr lang="en-US" sz="1150" b="1" dirty="0">
+                        <a:rPr lang="en-US" sz="1100" b="1" dirty="0">
                           <a:solidFill>
                             <a:srgbClr val="111C24"/>
                           </a:solidFill>
@@ -9355,18 +9569,18 @@
                         </a:rPr>
                         <a:t>Other campaign types</a:t>
                       </a:r>
-                      <a:endParaRPr lang="en-US" sz="1150" dirty="0">
-                        <a:latin typeface="Calibri" charset="0"/>
-                        <a:ea typeface="Calibri" charset="0"/>
-                        <a:cs typeface="Calibri" charset="0"/>
-                      </a:endParaRPr>
-                    </a:p>
-                    <a:p>
-                      <a:pPr indent="0" marL="0">
-                        <a:buNone/>
-                      </a:pPr>
-                      <a:r>
-                        <a:rPr lang="en-US" sz="1050" dirty="0">
+                      <a:endParaRPr lang="en-US" sz="1100" dirty="0">
+                        <a:latin typeface="Calibri" charset="0"/>
+                        <a:ea typeface="Calibri" charset="0"/>
+                        <a:cs typeface="Calibri" charset="0"/>
+                      </a:endParaRPr>
+                    </a:p>
+                    <a:p>
+                      <a:pPr indent="0" marL="0">
+                        <a:buNone/>
+                      </a:pPr>
+                      <a:r>
+                        <a:rPr lang="en-US" sz="1000" dirty="0">
                           <a:solidFill>
                             <a:srgbClr val="4E5A64"/>
                           </a:solidFill>
@@ -9376,44 +9590,44 @@
                         </a:rPr>
                         <a:t>Shayan T</a:t>
                       </a:r>
-                      <a:endParaRPr lang="en-US" sz="1150" dirty="0">
-                        <a:latin typeface="Calibri" charset="0"/>
-                        <a:ea typeface="Calibri" charset="0"/>
-                        <a:cs typeface="Calibri" charset="0"/>
-                      </a:endParaRPr>
-                    </a:p>
-                  </a:txBody>
-                  <a:tcPr marL="64008" marR="64008" marT="73152" marB="73152" anchor="ctr">
-                    <a:lnL w="0" cap="flat" cmpd="sng" algn="ctr">
-                      <a:noFill/>
-                    </a:lnL>
-                    <a:lnR w="0" cap="flat" cmpd="sng" algn="ctr">
-                      <a:noFill/>
-                    </a:lnR>
-                    <a:lnT w="0" cap="flat" cmpd="sng" algn="ctr">
-                      <a:noFill/>
-                    </a:lnT>
-                    <a:lnB w="9525" cap="flat" cmpd="sng" algn="ctr">
-                      <a:solidFill>
-                        <a:srgbClr val="BFCAD3"/>
-                      </a:solidFill>
-                      <a:prstDash val="solid"/>
-                      <a:round/>
-                      <a:headEnd type="none" w="med" len="med"/>
-                      <a:tailEnd type="none" w="med" len="med"/>
-                    </a:lnB>
-                  </a:tcPr>
-                </a:tc>
-                <a:tc>
-                  <a:txBody>
-                    <a:bodyPr/>
-                    <a:lstStyle/>
-                    <a:p>
-                      <a:pPr indent="0" marL="0">
-                        <a:buNone/>
-                      </a:pPr>
-                      <a:r>
-                        <a:rPr lang="en-US" sz="1150" dirty="0">
+                      <a:endParaRPr lang="en-US" sz="1100" dirty="0">
+                        <a:latin typeface="Calibri" charset="0"/>
+                        <a:ea typeface="Calibri" charset="0"/>
+                        <a:cs typeface="Calibri" charset="0"/>
+                      </a:endParaRPr>
+                    </a:p>
+                  </a:txBody>
+                  <a:tcPr marL="64008" marR="64008" marT="73152" marB="73152" anchor="ctr">
+                    <a:lnL w="0" cap="flat" cmpd="sng" algn="ctr">
+                      <a:noFill/>
+                    </a:lnL>
+                    <a:lnR w="0" cap="flat" cmpd="sng" algn="ctr">
+                      <a:noFill/>
+                    </a:lnR>
+                    <a:lnT w="0" cap="flat" cmpd="sng" algn="ctr">
+                      <a:noFill/>
+                    </a:lnT>
+                    <a:lnB w="9525" cap="flat" cmpd="sng" algn="ctr">
+                      <a:solidFill>
+                        <a:srgbClr val="BFCAD3"/>
+                      </a:solidFill>
+                      <a:prstDash val="solid"/>
+                      <a:round/>
+                      <a:headEnd type="none" w="med" len="med"/>
+                      <a:tailEnd type="none" w="med" len="med"/>
+                    </a:lnB>
+                  </a:tcPr>
+                </a:tc>
+                <a:tc>
+                  <a:txBody>
+                    <a:bodyPr/>
+                    <a:lstStyle/>
+                    <a:p>
+                      <a:pPr indent="0" marL="0">
+                        <a:buNone/>
+                      </a:pPr>
+                      <a:r>
+                        <a:rPr lang="en-US" sz="1100" dirty="0">
                           <a:solidFill>
                             <a:srgbClr val="111C24"/>
                           </a:solidFill>
@@ -9423,44 +9637,44 @@
                         </a:rPr>
                         <a:t>Send the campaign-type list, the ad-type plan for Bamboo and the frameworks for the other products (agreed on the 30 Sep call), brief creative for the held SB, SBV and SD campaigns, then launch them through the API</a:t>
                       </a:r>
-                      <a:endParaRPr lang="en-US" sz="1150" dirty="0">
-                        <a:latin typeface="Calibri" charset="0"/>
-                        <a:ea typeface="Calibri" charset="0"/>
-                        <a:cs typeface="Calibri" charset="0"/>
-                      </a:endParaRPr>
-                    </a:p>
-                  </a:txBody>
-                  <a:tcPr marL="64008" marR="64008" marT="73152" marB="73152" anchor="ctr">
-                    <a:lnL w="0" cap="flat" cmpd="sng" algn="ctr">
-                      <a:noFill/>
-                    </a:lnL>
-                    <a:lnR w="0" cap="flat" cmpd="sng" algn="ctr">
-                      <a:noFill/>
-                    </a:lnR>
-                    <a:lnT w="0" cap="flat" cmpd="sng" algn="ctr">
-                      <a:noFill/>
-                    </a:lnT>
-                    <a:lnB w="9525" cap="flat" cmpd="sng" algn="ctr">
-                      <a:solidFill>
-                        <a:srgbClr val="BFCAD3"/>
-                      </a:solidFill>
-                      <a:prstDash val="solid"/>
-                      <a:round/>
-                      <a:headEnd type="none" w="med" len="med"/>
-                      <a:tailEnd type="none" w="med" len="med"/>
-                    </a:lnB>
-                  </a:tcPr>
-                </a:tc>
-                <a:tc>
-                  <a:txBody>
-                    <a:bodyPr/>
-                    <a:lstStyle/>
-                    <a:p>
-                      <a:pPr indent="0" marL="0">
-                        <a:buNone/>
-                      </a:pPr>
-                      <a:r>
-                        <a:rPr lang="en-US" sz="1150" dirty="0">
+                      <a:endParaRPr lang="en-US" sz="1100" dirty="0">
+                        <a:latin typeface="Calibri" charset="0"/>
+                        <a:ea typeface="Calibri" charset="0"/>
+                        <a:cs typeface="Calibri" charset="0"/>
+                      </a:endParaRPr>
+                    </a:p>
+                  </a:txBody>
+                  <a:tcPr marL="64008" marR="64008" marT="73152" marB="73152" anchor="ctr">
+                    <a:lnL w="0" cap="flat" cmpd="sng" algn="ctr">
+                      <a:noFill/>
+                    </a:lnL>
+                    <a:lnR w="0" cap="flat" cmpd="sng" algn="ctr">
+                      <a:noFill/>
+                    </a:lnR>
+                    <a:lnT w="0" cap="flat" cmpd="sng" algn="ctr">
+                      <a:noFill/>
+                    </a:lnT>
+                    <a:lnB w="9525" cap="flat" cmpd="sng" algn="ctr">
+                      <a:solidFill>
+                        <a:srgbClr val="BFCAD3"/>
+                      </a:solidFill>
+                      <a:prstDash val="solid"/>
+                      <a:round/>
+                      <a:headEnd type="none" w="med" len="med"/>
+                      <a:tailEnd type="none" w="med" len="med"/>
+                    </a:lnB>
+                  </a:tcPr>
+                </a:tc>
+                <a:tc>
+                  <a:txBody>
+                    <a:bodyPr/>
+                    <a:lstStyle/>
+                    <a:p>
+                      <a:pPr indent="0" marL="0">
+                        <a:buNone/>
+                      </a:pPr>
+                      <a:r>
+                        <a:rPr lang="en-US" sz="1100" dirty="0">
                           <a:solidFill>
                             <a:srgbClr val="111C24"/>
                           </a:solidFill>
@@ -9468,46 +9682,46 @@
                           <a:ea typeface="Calibri" pitchFamily="34" charset="-122"/>
                           <a:cs typeface="Calibri" pitchFamily="34" charset="-120"/>
                         </a:rPr>
-                        <a:t>End of week, Oct 3–4 · launch TBC Mon</a:t>
-                      </a:r>
-                      <a:endParaRPr lang="en-US" sz="1150" dirty="0">
-                        <a:latin typeface="Calibri" charset="0"/>
-                        <a:ea typeface="Calibri" charset="0"/>
-                        <a:cs typeface="Calibri" charset="0"/>
-                      </a:endParaRPr>
-                    </a:p>
-                  </a:txBody>
-                  <a:tcPr marL="64008" marR="64008" marT="73152" marB="73152" anchor="ctr">
-                    <a:lnL w="0" cap="flat" cmpd="sng" algn="ctr">
-                      <a:noFill/>
-                    </a:lnL>
-                    <a:lnR w="0" cap="flat" cmpd="sng" algn="ctr">
-                      <a:noFill/>
-                    </a:lnR>
-                    <a:lnT w="0" cap="flat" cmpd="sng" algn="ctr">
-                      <a:noFill/>
-                    </a:lnT>
-                    <a:lnB w="9525" cap="flat" cmpd="sng" algn="ctr">
-                      <a:solidFill>
-                        <a:srgbClr val="BFCAD3"/>
-                      </a:solidFill>
-                      <a:prstDash val="solid"/>
-                      <a:round/>
-                      <a:headEnd type="none" w="med" len="med"/>
-                      <a:tailEnd type="none" w="med" len="med"/>
-                    </a:lnB>
-                  </a:tcPr>
-                </a:tc>
-                <a:tc>
-                  <a:txBody>
-                    <a:bodyPr/>
-                    <a:lstStyle/>
-                    <a:p>
-                      <a:pPr indent="0" marL="0">
-                        <a:buNone/>
-                      </a:pPr>
-                      <a:r>
-                        <a:rPr lang="en-US" sz="1150" dirty="0">
+                        <a:t>End of week, Oct 3–4</a:t>
+                      </a:r>
+                      <a:endParaRPr lang="en-US" sz="1100" dirty="0">
+                        <a:latin typeface="Calibri" charset="0"/>
+                        <a:ea typeface="Calibri" charset="0"/>
+                        <a:cs typeface="Calibri" charset="0"/>
+                      </a:endParaRPr>
+                    </a:p>
+                  </a:txBody>
+                  <a:tcPr marL="64008" marR="64008" marT="73152" marB="73152" anchor="ctr">
+                    <a:lnL w="0" cap="flat" cmpd="sng" algn="ctr">
+                      <a:noFill/>
+                    </a:lnL>
+                    <a:lnR w="0" cap="flat" cmpd="sng" algn="ctr">
+                      <a:noFill/>
+                    </a:lnR>
+                    <a:lnT w="0" cap="flat" cmpd="sng" algn="ctr">
+                      <a:noFill/>
+                    </a:lnT>
+                    <a:lnB w="9525" cap="flat" cmpd="sng" algn="ctr">
+                      <a:solidFill>
+                        <a:srgbClr val="BFCAD3"/>
+                      </a:solidFill>
+                      <a:prstDash val="solid"/>
+                      <a:round/>
+                      <a:headEnd type="none" w="med" len="med"/>
+                      <a:tailEnd type="none" w="med" len="med"/>
+                    </a:lnB>
+                  </a:tcPr>
+                </a:tc>
+                <a:tc>
+                  <a:txBody>
+                    <a:bodyPr/>
+                    <a:lstStyle/>
+                    <a:p>
+                      <a:pPr indent="0" marL="0">
+                        <a:buNone/>
+                      </a:pPr>
+                      <a:r>
+                        <a:rPr lang="en-US" sz="1100" dirty="0">
                           <a:solidFill>
                             <a:srgbClr val="111C24"/>
                           </a:solidFill>
@@ -9517,44 +9731,44 @@
                         </a:rPr>
                         <a:t>P0</a:t>
                       </a:r>
-                      <a:endParaRPr lang="en-US" sz="1150" dirty="0">
-                        <a:latin typeface="Calibri" charset="0"/>
-                        <a:ea typeface="Calibri" charset="0"/>
-                        <a:cs typeface="Calibri" charset="0"/>
-                      </a:endParaRPr>
-                    </a:p>
-                  </a:txBody>
-                  <a:tcPr marL="64008" marR="64008" marT="73152" marB="73152" anchor="ctr">
-                    <a:lnL w="0" cap="flat" cmpd="sng" algn="ctr">
-                      <a:noFill/>
-                    </a:lnL>
-                    <a:lnR w="0" cap="flat" cmpd="sng" algn="ctr">
-                      <a:noFill/>
-                    </a:lnR>
-                    <a:lnT w="0" cap="flat" cmpd="sng" algn="ctr">
-                      <a:noFill/>
-                    </a:lnT>
-                    <a:lnB w="9525" cap="flat" cmpd="sng" algn="ctr">
-                      <a:solidFill>
-                        <a:srgbClr val="BFCAD3"/>
-                      </a:solidFill>
-                      <a:prstDash val="solid"/>
-                      <a:round/>
-                      <a:headEnd type="none" w="med" len="med"/>
-                      <a:tailEnd type="none" w="med" len="med"/>
-                    </a:lnB>
-                  </a:tcPr>
-                </a:tc>
-                <a:tc>
-                  <a:txBody>
-                    <a:bodyPr/>
-                    <a:lstStyle/>
-                    <a:p>
-                      <a:pPr indent="0" marL="0">
-                        <a:buNone/>
-                      </a:pPr>
-                      <a:r>
-                        <a:rPr lang="en-US" sz="1150" dirty="0">
+                      <a:endParaRPr lang="en-US" sz="1100" dirty="0">
+                        <a:latin typeface="Calibri" charset="0"/>
+                        <a:ea typeface="Calibri" charset="0"/>
+                        <a:cs typeface="Calibri" charset="0"/>
+                      </a:endParaRPr>
+                    </a:p>
+                  </a:txBody>
+                  <a:tcPr marL="64008" marR="64008" marT="73152" marB="73152" anchor="ctr">
+                    <a:lnL w="0" cap="flat" cmpd="sng" algn="ctr">
+                      <a:noFill/>
+                    </a:lnL>
+                    <a:lnR w="0" cap="flat" cmpd="sng" algn="ctr">
+                      <a:noFill/>
+                    </a:lnR>
+                    <a:lnT w="0" cap="flat" cmpd="sng" algn="ctr">
+                      <a:noFill/>
+                    </a:lnT>
+                    <a:lnB w="9525" cap="flat" cmpd="sng" algn="ctr">
+                      <a:solidFill>
+                        <a:srgbClr val="BFCAD3"/>
+                      </a:solidFill>
+                      <a:prstDash val="solid"/>
+                      <a:round/>
+                      <a:headEnd type="none" w="med" len="med"/>
+                      <a:tailEnd type="none" w="med" len="med"/>
+                    </a:lnB>
+                  </a:tcPr>
+                </a:tc>
+                <a:tc>
+                  <a:txBody>
+                    <a:bodyPr/>
+                    <a:lstStyle/>
+                    <a:p>
+                      <a:pPr indent="0" marL="0">
+                        <a:buNone/>
+                      </a:pPr>
+                      <a:r>
+                        <a:rPr lang="en-US" sz="1100" dirty="0">
                           <a:solidFill>
                             <a:srgbClr val="111C24"/>
                           </a:solidFill>
@@ -9564,7 +9778,7 @@
                         </a:rPr>
                         <a:t>Y — since Sep 30</a:t>
                       </a:r>
-                      <a:endParaRPr lang="en-US" sz="1150" dirty="0">
+                      <a:endParaRPr lang="en-US" sz="1100" dirty="0">
                         <a:latin typeface="Calibri" charset="0"/>
                         <a:ea typeface="Calibri" charset="0"/>
                         <a:cs typeface="Calibri" charset="0"/>
@@ -9603,7 +9817,7 @@
                         <a:buNone/>
                       </a:pPr>
                       <a:r>
-                        <a:rPr lang="en-US" sz="1150" b="1" dirty="0">
+                        <a:rPr lang="en-US" sz="1100" b="1" dirty="0">
                           <a:solidFill>
                             <a:srgbClr val="111C24"/>
                           </a:solidFill>
@@ -9611,20 +9825,278 @@
                           <a:ea typeface="Calibri" pitchFamily="34" charset="-122"/>
                           <a:cs typeface="Calibri" pitchFamily="34" charset="-120"/>
                         </a:rPr>
+                        <a:t>LTSF products</a:t>
+                      </a:r>
+                      <a:endParaRPr lang="en-US" sz="1100" dirty="0">
+                        <a:latin typeface="Calibri" charset="0"/>
+                        <a:ea typeface="Calibri" charset="0"/>
+                        <a:cs typeface="Calibri" charset="0"/>
+                      </a:endParaRPr>
+                    </a:p>
+                    <a:p>
+                      <a:pPr indent="0" marL="0">
+                        <a:buNone/>
+                      </a:pPr>
+                      <a:r>
+                        <a:rPr lang="en-US" sz="1000" dirty="0">
+                          <a:solidFill>
+                            <a:srgbClr val="4E5A64"/>
+                          </a:solidFill>
+                          <a:latin typeface="Calibri" pitchFamily="34" charset="0"/>
+                          <a:ea typeface="Calibri" pitchFamily="34" charset="-122"/>
+                          <a:cs typeface="Calibri" pitchFamily="34" charset="-120"/>
+                        </a:rPr>
+                        <a:t>Zarlish</a:t>
+                      </a:r>
+                      <a:endParaRPr lang="en-US" sz="1100" dirty="0">
+                        <a:latin typeface="Calibri" charset="0"/>
+                        <a:ea typeface="Calibri" charset="0"/>
+                        <a:cs typeface="Calibri" charset="0"/>
+                      </a:endParaRPr>
+                    </a:p>
+                  </a:txBody>
+                  <a:tcPr marL="64008" marR="64008" marT="73152" marB="73152" anchor="ctr">
+                    <a:lnL w="0" cap="flat" cmpd="sng" algn="ctr">
+                      <a:noFill/>
+                    </a:lnL>
+                    <a:lnR w="0" cap="flat" cmpd="sng" algn="ctr">
+                      <a:noFill/>
+                    </a:lnR>
+                    <a:lnT w="0" cap="flat" cmpd="sng" algn="ctr">
+                      <a:noFill/>
+                    </a:lnT>
+                    <a:lnB w="9525" cap="flat" cmpd="sng" algn="ctr">
+                      <a:solidFill>
+                        <a:srgbClr val="BFCAD3"/>
+                      </a:solidFill>
+                      <a:prstDash val="solid"/>
+                      <a:round/>
+                      <a:headEnd type="none" w="med" len="med"/>
+                      <a:tailEnd type="none" w="med" len="med"/>
+                    </a:lnB>
+                  </a:tcPr>
+                </a:tc>
+                <a:tc>
+                  <a:txBody>
+                    <a:bodyPr/>
+                    <a:lstStyle/>
+                    <a:p>
+                      <a:pPr indent="0" marL="0">
+                        <a:buNone/>
+                      </a:pPr>
+                      <a:r>
+                        <a:rPr lang="en-US" sz="1100" dirty="0">
+                          <a:solidFill>
+                            <a:srgbClr val="111C24"/>
+                          </a:solidFill>
+                          <a:latin typeface="Calibri" pitchFamily="34" charset="0"/>
+                          <a:ea typeface="Calibri" pitchFamily="34" charset="-122"/>
+                          <a:cs typeface="Calibri" pitchFamily="34" charset="-120"/>
+                        </a:rPr>
+                        <a:t>Act on Erik's reply to the 30 Sep LTSF update and keep the per-SKU actions running on the LTSF products</a:t>
+                      </a:r>
+                      <a:endParaRPr lang="en-US" sz="1100" dirty="0">
+                        <a:latin typeface="Calibri" charset="0"/>
+                        <a:ea typeface="Calibri" charset="0"/>
+                        <a:cs typeface="Calibri" charset="0"/>
+                      </a:endParaRPr>
+                    </a:p>
+                  </a:txBody>
+                  <a:tcPr marL="64008" marR="64008" marT="73152" marB="73152" anchor="ctr">
+                    <a:lnL w="0" cap="flat" cmpd="sng" algn="ctr">
+                      <a:noFill/>
+                    </a:lnL>
+                    <a:lnR w="0" cap="flat" cmpd="sng" algn="ctr">
+                      <a:noFill/>
+                    </a:lnR>
+                    <a:lnT w="0" cap="flat" cmpd="sng" algn="ctr">
+                      <a:noFill/>
+                    </a:lnT>
+                    <a:lnB w="9525" cap="flat" cmpd="sng" algn="ctr">
+                      <a:solidFill>
+                        <a:srgbClr val="BFCAD3"/>
+                      </a:solidFill>
+                      <a:prstDash val="solid"/>
+                      <a:round/>
+                      <a:headEnd type="none" w="med" len="med"/>
+                      <a:tailEnd type="none" w="med" len="med"/>
+                    </a:lnB>
+                  </a:tcPr>
+                </a:tc>
+                <a:tc>
+                  <a:txBody>
+                    <a:bodyPr/>
+                    <a:lstStyle/>
+                    <a:p>
+                      <a:pPr indent="0" marL="0">
+                        <a:buNone/>
+                      </a:pPr>
+                      <a:r>
+                        <a:rPr lang="en-US" sz="1100" dirty="0">
+                          <a:solidFill>
+                            <a:srgbClr val="111C24"/>
+                          </a:solidFill>
+                          <a:latin typeface="Calibri" pitchFamily="34" charset="0"/>
+                          <a:ea typeface="Calibri" pitchFamily="34" charset="-122"/>
+                          <a:cs typeface="Calibri" pitchFamily="34" charset="-120"/>
+                        </a:rPr>
+                        <a:t>Ongoing</a:t>
+                      </a:r>
+                      <a:endParaRPr lang="en-US" sz="1100" dirty="0">
+                        <a:latin typeface="Calibri" charset="0"/>
+                        <a:ea typeface="Calibri" charset="0"/>
+                        <a:cs typeface="Calibri" charset="0"/>
+                      </a:endParaRPr>
+                    </a:p>
+                  </a:txBody>
+                  <a:tcPr marL="64008" marR="64008" marT="73152" marB="73152" anchor="ctr">
+                    <a:lnL w="0" cap="flat" cmpd="sng" algn="ctr">
+                      <a:noFill/>
+                    </a:lnL>
+                    <a:lnR w="0" cap="flat" cmpd="sng" algn="ctr">
+                      <a:noFill/>
+                    </a:lnR>
+                    <a:lnT w="0" cap="flat" cmpd="sng" algn="ctr">
+                      <a:noFill/>
+                    </a:lnT>
+                    <a:lnB w="9525" cap="flat" cmpd="sng" algn="ctr">
+                      <a:solidFill>
+                        <a:srgbClr val="BFCAD3"/>
+                      </a:solidFill>
+                      <a:prstDash val="solid"/>
+                      <a:round/>
+                      <a:headEnd type="none" w="med" len="med"/>
+                      <a:tailEnd type="none" w="med" len="med"/>
+                    </a:lnB>
+                  </a:tcPr>
+                </a:tc>
+                <a:tc>
+                  <a:txBody>
+                    <a:bodyPr/>
+                    <a:lstStyle/>
+                    <a:p>
+                      <a:pPr indent="0" marL="0">
+                        <a:buNone/>
+                      </a:pPr>
+                      <a:r>
+                        <a:rPr lang="en-US" sz="1100" dirty="0">
+                          <a:solidFill>
+                            <a:srgbClr val="111C24"/>
+                          </a:solidFill>
+                          <a:latin typeface="Calibri" pitchFamily="34" charset="0"/>
+                          <a:ea typeface="Calibri" pitchFamily="34" charset="-122"/>
+                          <a:cs typeface="Calibri" pitchFamily="34" charset="-120"/>
+                        </a:rPr>
+                        <a:t>P1</a:t>
+                      </a:r>
+                      <a:endParaRPr lang="en-US" sz="1100" dirty="0">
+                        <a:latin typeface="Calibri" charset="0"/>
+                        <a:ea typeface="Calibri" charset="0"/>
+                        <a:cs typeface="Calibri" charset="0"/>
+                      </a:endParaRPr>
+                    </a:p>
+                  </a:txBody>
+                  <a:tcPr marL="64008" marR="64008" marT="73152" marB="73152" anchor="ctr">
+                    <a:lnL w="0" cap="flat" cmpd="sng" algn="ctr">
+                      <a:noFill/>
+                    </a:lnL>
+                    <a:lnR w="0" cap="flat" cmpd="sng" algn="ctr">
+                      <a:noFill/>
+                    </a:lnR>
+                    <a:lnT w="0" cap="flat" cmpd="sng" algn="ctr">
+                      <a:noFill/>
+                    </a:lnT>
+                    <a:lnB w="9525" cap="flat" cmpd="sng" algn="ctr">
+                      <a:solidFill>
+                        <a:srgbClr val="BFCAD3"/>
+                      </a:solidFill>
+                      <a:prstDash val="solid"/>
+                      <a:round/>
+                      <a:headEnd type="none" w="med" len="med"/>
+                      <a:tailEnd type="none" w="med" len="med"/>
+                    </a:lnB>
+                  </a:tcPr>
+                </a:tc>
+                <a:tc>
+                  <a:txBody>
+                    <a:bodyPr/>
+                    <a:lstStyle/>
+                    <a:p>
+                      <a:pPr indent="0" marL="0">
+                        <a:buNone/>
+                      </a:pPr>
+                      <a:r>
+                        <a:rPr lang="en-US" sz="1100" dirty="0">
+                          <a:solidFill>
+                            <a:srgbClr val="111C24"/>
+                          </a:solidFill>
+                          <a:latin typeface="Calibri" pitchFamily="34" charset="0"/>
+                          <a:ea typeface="Calibri" pitchFamily="34" charset="-122"/>
+                          <a:cs typeface="Calibri" pitchFamily="34" charset="-120"/>
+                        </a:rPr>
+                        <a:t>Y — since Sep 30</a:t>
+                      </a:r>
+                      <a:endParaRPr lang="en-US" sz="1100" dirty="0">
+                        <a:latin typeface="Calibri" charset="0"/>
+                        <a:ea typeface="Calibri" charset="0"/>
+                        <a:cs typeface="Calibri" charset="0"/>
+                      </a:endParaRPr>
+                    </a:p>
+                  </a:txBody>
+                  <a:tcPr marL="64008" marR="64008" marT="73152" marB="73152" anchor="ctr">
+                    <a:lnL w="0" cap="flat" cmpd="sng" algn="ctr">
+                      <a:noFill/>
+                    </a:lnL>
+                    <a:lnR w="0" cap="flat" cmpd="sng" algn="ctr">
+                      <a:noFill/>
+                    </a:lnR>
+                    <a:lnT w="0" cap="flat" cmpd="sng" algn="ctr">
+                      <a:noFill/>
+                    </a:lnT>
+                    <a:lnB w="9525" cap="flat" cmpd="sng" algn="ctr">
+                      <a:solidFill>
+                        <a:srgbClr val="BFCAD3"/>
+                      </a:solidFill>
+                      <a:prstDash val="solid"/>
+                      <a:round/>
+                      <a:headEnd type="none" w="med" len="med"/>
+                      <a:tailEnd type="none" w="med" len="med"/>
+                    </a:lnB>
+                  </a:tcPr>
+                </a:tc>
+              </a:tr>
+              <a:tr h="0">
+                <a:tc>
+                  <a:txBody>
+                    <a:bodyPr/>
+                    <a:lstStyle/>
+                    <a:p>
+                      <a:pPr indent="0" marL="0">
+                        <a:buNone/>
+                      </a:pPr>
+                      <a:r>
+                        <a:rPr lang="en-US" sz="1100" b="1" dirty="0">
+                          <a:solidFill>
+                            <a:srgbClr val="111C24"/>
+                          </a:solidFill>
+                          <a:latin typeface="Calibri" pitchFamily="34" charset="0"/>
+                          <a:ea typeface="Calibri" pitchFamily="34" charset="-122"/>
+                          <a:cs typeface="Calibri" pitchFamily="34" charset="-120"/>
+                        </a:rPr>
                         <a:t>Stabilisation proposal</a:t>
                       </a:r>
-                      <a:endParaRPr lang="en-US" sz="1150" dirty="0">
-                        <a:latin typeface="Calibri" charset="0"/>
-                        <a:ea typeface="Calibri" charset="0"/>
-                        <a:cs typeface="Calibri" charset="0"/>
-                      </a:endParaRPr>
-                    </a:p>
-                    <a:p>
-                      <a:pPr indent="0" marL="0">
-                        <a:buNone/>
-                      </a:pPr>
-                      <a:r>
-                        <a:rPr lang="en-US" sz="1050" dirty="0">
+                      <a:endParaRPr lang="en-US" sz="1100" dirty="0">
+                        <a:latin typeface="Calibri" charset="0"/>
+                        <a:ea typeface="Calibri" charset="0"/>
+                        <a:cs typeface="Calibri" charset="0"/>
+                      </a:endParaRPr>
+                    </a:p>
+                    <a:p>
+                      <a:pPr indent="0" marL="0">
+                        <a:buNone/>
+                      </a:pPr>
+                      <a:r>
+                        <a:rPr lang="en-US" sz="1000" dirty="0">
                           <a:solidFill>
                             <a:srgbClr val="4E5A64"/>
                           </a:solidFill>
@@ -9634,44 +10106,44 @@
                         </a:rPr>
                         <a:t>Shayan T</a:t>
                       </a:r>
-                      <a:endParaRPr lang="en-US" sz="1150" dirty="0">
-                        <a:latin typeface="Calibri" charset="0"/>
-                        <a:ea typeface="Calibri" charset="0"/>
-                        <a:cs typeface="Calibri" charset="0"/>
-                      </a:endParaRPr>
-                    </a:p>
-                  </a:txBody>
-                  <a:tcPr marL="64008" marR="64008" marT="73152" marB="73152" anchor="ctr">
-                    <a:lnL w="0" cap="flat" cmpd="sng" algn="ctr">
-                      <a:noFill/>
-                    </a:lnL>
-                    <a:lnR w="0" cap="flat" cmpd="sng" algn="ctr">
-                      <a:noFill/>
-                    </a:lnR>
-                    <a:lnT w="0" cap="flat" cmpd="sng" algn="ctr">
-                      <a:noFill/>
-                    </a:lnT>
-                    <a:lnB w="9525" cap="flat" cmpd="sng" algn="ctr">
-                      <a:solidFill>
-                        <a:srgbClr val="BFCAD3"/>
-                      </a:solidFill>
-                      <a:prstDash val="solid"/>
-                      <a:round/>
-                      <a:headEnd type="none" w="med" len="med"/>
-                      <a:tailEnd type="none" w="med" len="med"/>
-                    </a:lnB>
-                  </a:tcPr>
-                </a:tc>
-                <a:tc>
-                  <a:txBody>
-                    <a:bodyPr/>
-                    <a:lstStyle/>
-                    <a:p>
-                      <a:pPr indent="0" marL="0">
-                        <a:buNone/>
-                      </a:pPr>
-                      <a:r>
-                        <a:rPr lang="en-US" sz="1150" dirty="0">
+                      <a:endParaRPr lang="en-US" sz="1100" dirty="0">
+                        <a:latin typeface="Calibri" charset="0"/>
+                        <a:ea typeface="Calibri" charset="0"/>
+                        <a:cs typeface="Calibri" charset="0"/>
+                      </a:endParaRPr>
+                    </a:p>
+                  </a:txBody>
+                  <a:tcPr marL="64008" marR="64008" marT="73152" marB="73152" anchor="ctr">
+                    <a:lnL w="0" cap="flat" cmpd="sng" algn="ctr">
+                      <a:noFill/>
+                    </a:lnL>
+                    <a:lnR w="0" cap="flat" cmpd="sng" algn="ctr">
+                      <a:noFill/>
+                    </a:lnR>
+                    <a:lnT w="0" cap="flat" cmpd="sng" algn="ctr">
+                      <a:noFill/>
+                    </a:lnT>
+                    <a:lnB w="9525" cap="flat" cmpd="sng" algn="ctr">
+                      <a:solidFill>
+                        <a:srgbClr val="BFCAD3"/>
+                      </a:solidFill>
+                      <a:prstDash val="solid"/>
+                      <a:round/>
+                      <a:headEnd type="none" w="med" len="med"/>
+                      <a:tailEnd type="none" w="med" len="med"/>
+                    </a:lnB>
+                  </a:tcPr>
+                </a:tc>
+                <a:tc>
+                  <a:txBody>
+                    <a:bodyPr/>
+                    <a:lstStyle/>
+                    <a:p>
+                      <a:pPr indent="0" marL="0">
+                        <a:buNone/>
+                      </a:pPr>
+                      <a:r>
+                        <a:rPr lang="en-US" sz="1100" dirty="0">
                           <a:solidFill>
                             <a:srgbClr val="111C24"/>
                           </a:solidFill>
@@ -9681,44 +10153,44 @@
                         </a:rPr>
                         <a:t>Deliver catalog prioritisation, team structure, the finalised cadence and the development list, with priorities and due dates as Erik asked on 30 Sep</a:t>
                       </a:r>
-                      <a:endParaRPr lang="en-US" sz="1150" dirty="0">
-                        <a:latin typeface="Calibri" charset="0"/>
-                        <a:ea typeface="Calibri" charset="0"/>
-                        <a:cs typeface="Calibri" charset="0"/>
-                      </a:endParaRPr>
-                    </a:p>
-                  </a:txBody>
-                  <a:tcPr marL="64008" marR="64008" marT="73152" marB="73152" anchor="ctr">
-                    <a:lnL w="0" cap="flat" cmpd="sng" algn="ctr">
-                      <a:noFill/>
-                    </a:lnL>
-                    <a:lnR w="0" cap="flat" cmpd="sng" algn="ctr">
-                      <a:noFill/>
-                    </a:lnR>
-                    <a:lnT w="0" cap="flat" cmpd="sng" algn="ctr">
-                      <a:noFill/>
-                    </a:lnT>
-                    <a:lnB w="9525" cap="flat" cmpd="sng" algn="ctr">
-                      <a:solidFill>
-                        <a:srgbClr val="BFCAD3"/>
-                      </a:solidFill>
-                      <a:prstDash val="solid"/>
-                      <a:round/>
-                      <a:headEnd type="none" w="med" len="med"/>
-                      <a:tailEnd type="none" w="med" len="med"/>
-                    </a:lnB>
-                  </a:tcPr>
-                </a:tc>
-                <a:tc>
-                  <a:txBody>
-                    <a:bodyPr/>
-                    <a:lstStyle/>
-                    <a:p>
-                      <a:pPr indent="0" marL="0">
-                        <a:buNone/>
-                      </a:pPr>
-                      <a:r>
-                        <a:rPr lang="en-US" sz="1150" dirty="0">
+                      <a:endParaRPr lang="en-US" sz="1100" dirty="0">
+                        <a:latin typeface="Calibri" charset="0"/>
+                        <a:ea typeface="Calibri" charset="0"/>
+                        <a:cs typeface="Calibri" charset="0"/>
+                      </a:endParaRPr>
+                    </a:p>
+                  </a:txBody>
+                  <a:tcPr marL="64008" marR="64008" marT="73152" marB="73152" anchor="ctr">
+                    <a:lnL w="0" cap="flat" cmpd="sng" algn="ctr">
+                      <a:noFill/>
+                    </a:lnL>
+                    <a:lnR w="0" cap="flat" cmpd="sng" algn="ctr">
+                      <a:noFill/>
+                    </a:lnR>
+                    <a:lnT w="0" cap="flat" cmpd="sng" algn="ctr">
+                      <a:noFill/>
+                    </a:lnT>
+                    <a:lnB w="9525" cap="flat" cmpd="sng" algn="ctr">
+                      <a:solidFill>
+                        <a:srgbClr val="BFCAD3"/>
+                      </a:solidFill>
+                      <a:prstDash val="solid"/>
+                      <a:round/>
+                      <a:headEnd type="none" w="med" len="med"/>
+                      <a:tailEnd type="none" w="med" len="med"/>
+                    </a:lnB>
+                  </a:tcPr>
+                </a:tc>
+                <a:tc>
+                  <a:txBody>
+                    <a:bodyPr/>
+                    <a:lstStyle/>
+                    <a:p>
+                      <a:pPr indent="0" marL="0">
+                        <a:buNone/>
+                      </a:pPr>
+                      <a:r>
+                        <a:rPr lang="en-US" sz="1100" dirty="0">
                           <a:solidFill>
                             <a:srgbClr val="111C24"/>
                           </a:solidFill>
@@ -9728,44 +10200,44 @@
                         </a:rPr>
                         <a:t>End of week, Oct 3–4</a:t>
                       </a:r>
-                      <a:endParaRPr lang="en-US" sz="1150" dirty="0">
-                        <a:latin typeface="Calibri" charset="0"/>
-                        <a:ea typeface="Calibri" charset="0"/>
-                        <a:cs typeface="Calibri" charset="0"/>
-                      </a:endParaRPr>
-                    </a:p>
-                  </a:txBody>
-                  <a:tcPr marL="64008" marR="64008" marT="73152" marB="73152" anchor="ctr">
-                    <a:lnL w="0" cap="flat" cmpd="sng" algn="ctr">
-                      <a:noFill/>
-                    </a:lnL>
-                    <a:lnR w="0" cap="flat" cmpd="sng" algn="ctr">
-                      <a:noFill/>
-                    </a:lnR>
-                    <a:lnT w="0" cap="flat" cmpd="sng" algn="ctr">
-                      <a:noFill/>
-                    </a:lnT>
-                    <a:lnB w="9525" cap="flat" cmpd="sng" algn="ctr">
-                      <a:solidFill>
-                        <a:srgbClr val="BFCAD3"/>
-                      </a:solidFill>
-                      <a:prstDash val="solid"/>
-                      <a:round/>
-                      <a:headEnd type="none" w="med" len="med"/>
-                      <a:tailEnd type="none" w="med" len="med"/>
-                    </a:lnB>
-                  </a:tcPr>
-                </a:tc>
-                <a:tc>
-                  <a:txBody>
-                    <a:bodyPr/>
-                    <a:lstStyle/>
-                    <a:p>
-                      <a:pPr indent="0" marL="0">
-                        <a:buNone/>
-                      </a:pPr>
-                      <a:r>
-                        <a:rPr lang="en-US" sz="1150" dirty="0">
+                      <a:endParaRPr lang="en-US" sz="1100" dirty="0">
+                        <a:latin typeface="Calibri" charset="0"/>
+                        <a:ea typeface="Calibri" charset="0"/>
+                        <a:cs typeface="Calibri" charset="0"/>
+                      </a:endParaRPr>
+                    </a:p>
+                  </a:txBody>
+                  <a:tcPr marL="64008" marR="64008" marT="73152" marB="73152" anchor="ctr">
+                    <a:lnL w="0" cap="flat" cmpd="sng" algn="ctr">
+                      <a:noFill/>
+                    </a:lnL>
+                    <a:lnR w="0" cap="flat" cmpd="sng" algn="ctr">
+                      <a:noFill/>
+                    </a:lnR>
+                    <a:lnT w="0" cap="flat" cmpd="sng" algn="ctr">
+                      <a:noFill/>
+                    </a:lnT>
+                    <a:lnB w="9525" cap="flat" cmpd="sng" algn="ctr">
+                      <a:solidFill>
+                        <a:srgbClr val="BFCAD3"/>
+                      </a:solidFill>
+                      <a:prstDash val="solid"/>
+                      <a:round/>
+                      <a:headEnd type="none" w="med" len="med"/>
+                      <a:tailEnd type="none" w="med" len="med"/>
+                    </a:lnB>
+                  </a:tcPr>
+                </a:tc>
+                <a:tc>
+                  <a:txBody>
+                    <a:bodyPr/>
+                    <a:lstStyle/>
+                    <a:p>
+                      <a:pPr indent="0" marL="0">
+                        <a:buNone/>
+                      </a:pPr>
+                      <a:r>
+                        <a:rPr lang="en-US" sz="1100" dirty="0">
                           <a:solidFill>
                             <a:srgbClr val="111C24"/>
                           </a:solidFill>
@@ -9775,44 +10247,44 @@
                         </a:rPr>
                         <a:t>P0</a:t>
                       </a:r>
-                      <a:endParaRPr lang="en-US" sz="1150" dirty="0">
-                        <a:latin typeface="Calibri" charset="0"/>
-                        <a:ea typeface="Calibri" charset="0"/>
-                        <a:cs typeface="Calibri" charset="0"/>
-                      </a:endParaRPr>
-                    </a:p>
-                  </a:txBody>
-                  <a:tcPr marL="64008" marR="64008" marT="73152" marB="73152" anchor="ctr">
-                    <a:lnL w="0" cap="flat" cmpd="sng" algn="ctr">
-                      <a:noFill/>
-                    </a:lnL>
-                    <a:lnR w="0" cap="flat" cmpd="sng" algn="ctr">
-                      <a:noFill/>
-                    </a:lnR>
-                    <a:lnT w="0" cap="flat" cmpd="sng" algn="ctr">
-                      <a:noFill/>
-                    </a:lnT>
-                    <a:lnB w="9525" cap="flat" cmpd="sng" algn="ctr">
-                      <a:solidFill>
-                        <a:srgbClr val="BFCAD3"/>
-                      </a:solidFill>
-                      <a:prstDash val="solid"/>
-                      <a:round/>
-                      <a:headEnd type="none" w="med" len="med"/>
-                      <a:tailEnd type="none" w="med" len="med"/>
-                    </a:lnB>
-                  </a:tcPr>
-                </a:tc>
-                <a:tc>
-                  <a:txBody>
-                    <a:bodyPr/>
-                    <a:lstStyle/>
-                    <a:p>
-                      <a:pPr indent="0" marL="0">
-                        <a:buNone/>
-                      </a:pPr>
-                      <a:r>
-                        <a:rPr lang="en-US" sz="1150" dirty="0">
+                      <a:endParaRPr lang="en-US" sz="1100" dirty="0">
+                        <a:latin typeface="Calibri" charset="0"/>
+                        <a:ea typeface="Calibri" charset="0"/>
+                        <a:cs typeface="Calibri" charset="0"/>
+                      </a:endParaRPr>
+                    </a:p>
+                  </a:txBody>
+                  <a:tcPr marL="64008" marR="64008" marT="73152" marB="73152" anchor="ctr">
+                    <a:lnL w="0" cap="flat" cmpd="sng" algn="ctr">
+                      <a:noFill/>
+                    </a:lnL>
+                    <a:lnR w="0" cap="flat" cmpd="sng" algn="ctr">
+                      <a:noFill/>
+                    </a:lnR>
+                    <a:lnT w="0" cap="flat" cmpd="sng" algn="ctr">
+                      <a:noFill/>
+                    </a:lnT>
+                    <a:lnB w="9525" cap="flat" cmpd="sng" algn="ctr">
+                      <a:solidFill>
+                        <a:srgbClr val="BFCAD3"/>
+                      </a:solidFill>
+                      <a:prstDash val="solid"/>
+                      <a:round/>
+                      <a:headEnd type="none" w="med" len="med"/>
+                      <a:tailEnd type="none" w="med" len="med"/>
+                    </a:lnB>
+                  </a:tcPr>
+                </a:tc>
+                <a:tc>
+                  <a:txBody>
+                    <a:bodyPr/>
+                    <a:lstStyle/>
+                    <a:p>
+                      <a:pPr indent="0" marL="0">
+                        <a:buNone/>
+                      </a:pPr>
+                      <a:r>
+                        <a:rPr lang="en-US" sz="1100" dirty="0">
                           <a:solidFill>
                             <a:srgbClr val="111C24"/>
                           </a:solidFill>
@@ -9822,7 +10294,7 @@
                         </a:rPr>
                         <a:t>Y — since Oct 2</a:t>
                       </a:r>
-                      <a:endParaRPr lang="en-US" sz="1150" dirty="0">
+                      <a:endParaRPr lang="en-US" sz="1100" dirty="0">
                         <a:latin typeface="Calibri" charset="0"/>
                         <a:ea typeface="Calibri" charset="0"/>
                         <a:cs typeface="Calibri" charset="0"/>
@@ -13239,7 +13711,7 @@
                           <a:ea typeface="Calibri" pitchFamily="34" charset="-122"/>
                           <a:cs typeface="Calibri" pitchFamily="34" charset="-120"/>
                         </a:rPr>
-                        <a:t>Satin daily work, the consolidated engine register and the Friday read, and the CooLinens Pillowcase campaigns with Shayan T. Register goes changed-only</a:t>
+                        <a:t>Satin daily work, the LTSF products, the consolidated engine register and the Friday read, and the CooLinens Pillowcase campaigns with Shayan T. Register goes changed-only</a:t>
                       </a:r>
                       <a:endParaRPr lang="en-US" sz="1200" dirty="0">
                         <a:latin typeface="Calibri" charset="0"/>

</xml_diff>

<commit_message>
Weekly review: Prime Big Deal Days plan due end of week and Monday
Co-Authored-By: Claude Opus 5.5 <noreply@anthropic.com>
Claude-Session: https://claude.ai/code/session_017KBX8sQPKzAVHK5pu1jizF
</commit_message>
<xml_diff>
--- a/deliverables/PPC_Weekly_Review_Sep28-Oct2.pptx
+++ b/deliverables/PPC_Weekly_Review_Sep28-Oct2.pptx
@@ -6334,7 +6334,7 @@
                           <a:ea typeface="Calibri" pitchFamily="34" charset="-122"/>
                           <a:cs typeface="Calibri" pitchFamily="34" charset="-120"/>
                         </a:rPr>
-                        <a:t>Set the deal-day budget today and clear the S4 deal issues</a:t>
+                        <a:t>Set the deal-day budget by end of week and clear the S4 deal issues by Monday</a:t>
                       </a:r>
                       <a:endParaRPr lang="en-US" sz="1100" dirty="0">
                         <a:latin typeface="Calibri" charset="0"/>
@@ -6381,7 +6381,7 @@
                           <a:ea typeface="Calibri" pitchFamily="34" charset="-122"/>
                           <a:cs typeface="Calibri" pitchFamily="34" charset="-120"/>
                         </a:rPr>
-                        <a:t>Today, Oct 2</a:t>
+                        <a:t>End of week · Mon, Oct 5</a:t>
                       </a:r>
                       <a:endParaRPr lang="en-US" sz="1100" dirty="0">
                         <a:latin typeface="Calibri" charset="0"/>
@@ -8345,7 +8345,7 @@
                           <a:ea typeface="Calibri" pitchFamily="34" charset="-122"/>
                           <a:cs typeface="Calibri" pitchFamily="34" charset="-120"/>
                         </a:rPr>
-                        <a:t>Run the Oct 6–7 event: deal-day budgets live, Amazon's own budget rules stripped, S4 deal issues cleared</a:t>
+                        <a:t>Deal-day plan and budgets set by end of week; S4 deal issues cleared and budgets live by Monday; run the Oct 6–7 event with Amazon's own budget rules stripped</a:t>
                       </a:r>
                       <a:endParaRPr lang="en-US" sz="1100" dirty="0">
                         <a:latin typeface="Calibri" charset="0"/>
@@ -8392,7 +8392,7 @@
                           <a:ea typeface="Calibri" pitchFamily="34" charset="-122"/>
                           <a:cs typeface="Calibri" pitchFamily="34" charset="-120"/>
                         </a:rPr>
-                        <a:t>Mon, Oct 5</a:t>
+                        <a:t>End of week · Mon, Oct 5</a:t>
                       </a:r>
                       <a:endParaRPr lang="en-US" sz="1100" dirty="0">
                         <a:latin typeface="Calibri" charset="0"/>

</xml_diff>

<commit_message>
Weekly review: fix open-item count, owner casing, footnote and cover line
Co-Authored-By: Claude Opus 5.5 <noreply@anthropic.com>
Claude-Session: https://claude.ai/code/session_017KBX8sQPKzAVHK5pu1jizF
</commit_message>
<xml_diff>
--- a/deliverables/PPC_Weekly_Review_Sep28-Oct2.pptx
+++ b/deliverables/PPC_Weekly_Review_Sep28-Oct2.pptx
@@ -301,7 +301,7 @@
           </a:p>
           <a:p>
             <a:r>
-              <a:t>2. The B4 and B6 bamboo ranking plans are final. They are waiting on three sign-offs before the pushes go live.</a:t>
+              <a:t>2. The B4 and B6 bamboo ranking plans are final.</a:t>
             </a:r>
           </a:p>
           <a:p>
@@ -550,7 +550,7 @@
           <a:p/>
           <a:p>
             <a:r>
-              <a:t>Open items carried into next week: the ad-type framework document, the stabilisation proposal, the Canada Bamboo audits, the Prime Day plan, and the daily manual changes.</a:t>
+              <a:t>Five open items carry into next week: the ad-type framework document, the stabilisation proposal, the Canada Bamboo audits, the Prime Day plan, and the daily manual changes.</a:t>
             </a:r>
           </a:p>
           <a:p/>
@@ -696,7 +696,7 @@
           <a:p/>
           <a:p>
             <a:r>
-              <a:t>[Close] To recap what we need: the Prime Big Deal Days plan from Shayan T and Joseph by end of week and Monday, and the Bamboo sign-offs so the pushes can go live. Thanks, everyone. Questions?</a:t>
+              <a:t>[Close] To recap what we need: the Prime Big Deal Days plan from Shayan T and Joseph by end of week and Monday. Thanks, everyone. Questions?</a:t>
             </a:r>
           </a:p>
         </p:txBody>
@@ -1375,7 +1375,7 @@
                 <a:ea typeface="Calibri" pitchFamily="34" charset="-122"/>
                 <a:cs typeface="Calibri" pitchFamily="34" charset="-120"/>
               </a:rPr>
-              <a:t>CooLinens Cooling Pillowcase goes live on Amazon today with its PPC launch. Bamboo ranking plans for B4 and B6 are final and wait on three sign-offs. Prime Big Deal Days on 6–7 Oct is the first test of the week ahead.</a:t>
+              <a:t>CooLinens Cooling Pillowcase goes live on Amazon today with its PPC launch. Bamboo ranking plans for B4 and B6 are final. Prime Big Deal Days on 6–7 Oct is the first test of the week ahead.</a:t>
             </a:r>
             <a:endParaRPr lang="en-US" sz="1600" dirty="0"/>
           </a:p>
@@ -1400,6 +1400,10 @@
           </a:solidFill>
           <a:ln/>
         </p:spPr>
+        <p:txBody>
+          <a:bodyPr/>
+          <a:p/>
+        </p:txBody>
       </p:sp>
       <p:sp>
         <p:nvSpPr>
@@ -1576,6 +1580,10 @@
           </a:solidFill>
           <a:ln/>
         </p:spPr>
+        <p:txBody>
+          <a:bodyPr/>
+          <a:p/>
+        </p:txBody>
       </p:sp>
       <p:sp>
         <p:nvSpPr>
@@ -1674,6 +1682,10 @@
           </a:solidFill>
           <a:ln/>
         </p:spPr>
+        <p:txBody>
+          <a:bodyPr/>
+          <a:p/>
+        </p:txBody>
       </p:sp>
       <p:sp>
         <p:nvSpPr>
@@ -1772,6 +1784,10 @@
           </a:solidFill>
           <a:ln/>
         </p:spPr>
+        <p:txBody>
+          <a:bodyPr/>
+          <a:p/>
+        </p:txBody>
       </p:sp>
       <p:sp>
         <p:nvSpPr>
@@ -1794,6 +1810,10 @@
           </a:solidFill>
           <a:ln/>
         </p:spPr>
+        <p:txBody>
+          <a:bodyPr/>
+          <a:p/>
+        </p:txBody>
       </p:sp>
       <p:pic>
         <p:nvPicPr>
@@ -4628,6 +4648,10 @@
             <a:prstDash val="solid"/>
           </a:ln>
         </p:spPr>
+        <p:txBody>
+          <a:bodyPr/>
+          <a:p/>
+        </p:txBody>
       </p:sp>
       <p:sp>
         <p:nvSpPr>
@@ -4662,7 +4686,7 @@
                 <a:ea typeface="Calibri" pitchFamily="34" charset="-122"/>
                 <a:cs typeface="Calibri" pitchFamily="34" charset="-120"/>
               </a:rPr>
-              <a:t>THE 15 OPEN ITEMS CARRIED INTO NEXT WEEK</a:t>
+              <a:t>THE 5 OPEN ITEMS CARRIED INTO NEXT WEEK</a:t>
             </a:r>
             <a:endParaRPr lang="en-US" sz="1050" dirty="0"/>
           </a:p>
@@ -5296,7 +5320,7 @@
                           <a:ea typeface="Calibri" pitchFamily="34" charset="-122"/>
                           <a:cs typeface="Calibri" pitchFamily="34" charset="-120"/>
                         </a:rPr>
-                        <a:t>All three With Joseph</a:t>
+                        <a:t>All three with Joseph</a:t>
                       </a:r>
                       <a:endParaRPr lang="en-US" sz="1100" dirty="0">
                         <a:latin typeface="Calibri" charset="0"/>
@@ -7345,7 +7369,7 @@
                 <a:ea typeface="Calibri" pitchFamily="34" charset="-122"/>
                 <a:cs typeface="Calibri" pitchFamily="34" charset="-120"/>
               </a:rPr>
-              <a:t>P0 fails the cycle if it slips.   ·   Dates marked TBC are set at Monday's alignment, not assumed here.   ·   Bamboo plan start dates of 1–2 Oct move to the sign-off date; reads move with them.</a:t>
+              <a:t>P0 fails the cycle if it slips.</a:t>
             </a:r>
             <a:endParaRPr lang="en-US" sz="950" dirty="0"/>
           </a:p>

</xml_diff>